<commit_message>
update docs and presentation materials
</commit_message>
<xml_diff>
--- a/docs/AskTube_AI_Presentation.pptx
+++ b/docs/AskTube_AI_Presentation.pptx
@@ -4,20 +4,23 @@
   <p:sldMasterIdLst>
     <p:sldMasterId id="2147483648" r:id="rId1"/>
   </p:sldMasterIdLst>
+  <p:notesMasterIdLst>
+    <p:notesMasterId r:id="rId17"/>
+  </p:notesMasterIdLst>
   <p:sldIdLst>
-    <p:sldId id="256" r:id="rId7"/>
-    <p:sldId id="257" r:id="rId8"/>
-    <p:sldId id="258" r:id="rId9"/>
-    <p:sldId id="259" r:id="rId10"/>
-    <p:sldId id="260" r:id="rId11"/>
-    <p:sldId id="261" r:id="rId12"/>
-    <p:sldId id="262" r:id="rId13"/>
-    <p:sldId id="263" r:id="rId14"/>
-    <p:sldId id="264" r:id="rId15"/>
-    <p:sldId id="265" r:id="rId16"/>
-    <p:sldId id="266" r:id="rId17"/>
+    <p:sldId id="256" r:id="rId2"/>
+    <p:sldId id="257" r:id="rId3"/>
+    <p:sldId id="258" r:id="rId4"/>
+    <p:sldId id="259" r:id="rId5"/>
+    <p:sldId id="260" r:id="rId6"/>
+    <p:sldId id="261" r:id="rId7"/>
+    <p:sldId id="262" r:id="rId8"/>
+    <p:sldId id="263" r:id="rId9"/>
+    <p:sldId id="264" r:id="rId10"/>
+    <p:sldId id="265" r:id="rId11"/>
+    <p:sldId id="266" r:id="rId12"/>
   </p:sldIdLst>
-  <p:sldSz cx="12191695" cy="6858000" type="screen4x3"/>
+  <p:sldSz cx="12192000" cy="6858000"/>
   <p:notesSz cx="6858000" cy="9144000"/>
   <p:defaultTextStyle>
     <a:defPPr>
@@ -114,7 +117,1066 @@
       </a:defRPr>
     </a:lvl9pPr>
   </p:defaultTextStyle>
+  <p:extLst>
+    <p:ext uri="{EFAFB233-063F-42B5-8137-9DF3F51BA10A}">
+      <p15:sldGuideLst xmlns:p15="http://schemas.microsoft.com/office/powerpoint/2012/main">
+        <p15:guide id="1" orient="horz" pos="2160">
+          <p15:clr>
+            <a:srgbClr val="A4A3A4"/>
+          </p15:clr>
+        </p15:guide>
+        <p15:guide id="2" pos="2880">
+          <p15:clr>
+            <a:srgbClr val="A4A3A4"/>
+          </p15:clr>
+        </p15:guide>
+      </p15:sldGuideLst>
+    </p:ext>
+  </p:extLst>
 </p:presentation>
+</file>
+
+<file path=ppt/notesMasters/notesMaster1.xml><?xml version="1.0" encoding="utf-8"?>
+<p:notesMaster xmlns:p="http://schemas.openxmlformats.org/presentationml/2006/main" xmlns:a="http://schemas.openxmlformats.org/drawingml/2006/main" xmlns:r="http://schemas.openxmlformats.org/officeDocument/2006/relationships">
+  <p:cSld>
+    <p:spTree>
+      <p:nvGrpSpPr>
+        <p:cNvPr id="1" name=""/>
+        <p:cNvGrpSpPr/>
+        <p:nvPr/>
+      </p:nvGrpSpPr>
+      <p:grpSpPr>
+        <a:xfrm>
+          <a:off x="0" y="0"/>
+          <a:ext cx="0" cy="0"/>
+          <a:chOff x="0" y="0"/>
+          <a:chExt cx="0" cy="0"/>
+        </a:xfrm>
+      </p:grpSpPr>
+    </p:spTree>
+  </p:cSld>
+  <p:clrMap bg1="lt1" tx1="dk1" bg2="lt2" tx2="dk2" accent1="accent1" accent2="accent2" accent3="accent3" accent4="accent4" accent5="accent5" accent6="accent6" hlink="hlink" folHlink="folHlink"/>
+  <p:hf/>
+  <p:notesStyle>
+    <a:lvl1pPr marL="0" algn="l" defTabSz="457200">
+      <a:defRPr sz="1500">
+        <a:latin typeface="Arial"/>
+      </a:defRPr>
+    </a:lvl1pPr>
+  </p:notesStyle>
+  <p:clrMapOvr>
+    <a:masterClrMapping/>
+  </p:clrMapOvr>
+</p:notesMaster>
+</file>
+
+<file path=ppt/notesSlides/notesSlide1.xml><?xml version="1.0" encoding="utf-8"?>
+<p:notes xmlns:p="http://schemas.openxmlformats.org/presentationml/2006/main" xmlns:a="http://schemas.openxmlformats.org/drawingml/2006/main" xmlns:r="http://schemas.openxmlformats.org/officeDocument/2006/relationships">
+  <p:cSld>
+    <p:spTree>
+      <p:nvGrpSpPr>
+        <p:cNvPr id="1" name=""/>
+        <p:cNvGrpSpPr/>
+        <p:nvPr/>
+      </p:nvGrpSpPr>
+      <p:grpSpPr>
+        <a:xfrm>
+          <a:off x="0" y="0"/>
+          <a:ext cx="0" cy="0"/>
+          <a:chOff x="0" y="0"/>
+          <a:chExt cx="0" cy="0"/>
+        </a:xfrm>
+      </p:grpSpPr>
+      <p:sp>
+        <p:nvSpPr>
+          <p:cNvPr id="2" name="Slide Image Placeholder 1"/>
+          <p:cNvSpPr>
+            <a:spLocks noGrp="1"/>
+          </p:cNvSpPr>
+          <p:nvPr>
+            <p:ph type="sldImg" idx="2"/>
+          </p:nvPr>
+        </p:nvSpPr>
+        <p:spPr>
+          <a:xfrm>
+            <a:off x="685800" y="685800"/>
+            <a:ext cx="5486400" cy="3086100"/>
+          </a:xfrm>
+          <a:prstGeom prst="rect"/>
+        </p:spPr>
+      </p:sp>
+      <p:sp>
+        <p:nvSpPr>
+          <p:cNvPr id="3" name="Notes Placeholder 2"/>
+          <p:cNvSpPr>
+            <a:spLocks noGrp="1"/>
+          </p:cNvSpPr>
+          <p:nvPr>
+            <p:ph type="body" sz="quarter" idx="1"/>
+          </p:nvPr>
+        </p:nvSpPr>
+        <p:spPr>
+          <a:xfrm>
+            <a:off x="685800" y="4114800"/>
+            <a:ext cx="5486400" cy="4114800"/>
+          </a:xfrm>
+          <a:prstGeom prst="rect"/>
+        </p:spPr>
+        <p:txBody>
+          <a:bodyPr/>
+          <a:lstStyle/>
+          <a:p>
+            <a:r>
+              <a:rPr lang="en-US" sz="1500"/>
+              <a:t>AskTube AI is my final project: a learning assistant for YouTube videos.</a:t>
+            </a:r>
+          </a:p>
+          <a:p>
+            <a:r>
+              <a:rPr lang="en-US" sz="1500"/>
+              <a:t>The user searches, selects a video, the app processes the transcript, and then the user chats with the video content.</a:t>
+            </a:r>
+          </a:p>
+          <a:p>
+            <a:r>
+              <a:rPr lang="en-US" sz="1500"/>
+              <a:t>The important part is trust: answers are grounded in the transcript and include timestamp citations.</a:t>
+            </a:r>
+          </a:p>
+          <a:p>
+            <a:r>
+              <a:rPr lang="en-US" sz="1500"/>
+              <a:t>Key message: this is not a generic chatbot; it is a transcript-grounded learning workflow.</a:t>
+            </a:r>
+          </a:p>
+        </p:txBody>
+      </p:sp>
+    </p:spTree>
+  </p:cSld>
+  <p:clrMapOvr>
+    <a:masterClrMapping/>
+  </p:clrMapOvr>
+</p:notes>
+</file>
+
+<file path=ppt/notesSlides/notesSlide10.xml><?xml version="1.0" encoding="utf-8"?>
+<p:notes xmlns:p="http://schemas.openxmlformats.org/presentationml/2006/main" xmlns:a="http://schemas.openxmlformats.org/drawingml/2006/main" xmlns:r="http://schemas.openxmlformats.org/officeDocument/2006/relationships">
+  <p:cSld>
+    <p:spTree>
+      <p:nvGrpSpPr>
+        <p:cNvPr id="1" name=""/>
+        <p:cNvGrpSpPr/>
+        <p:nvPr/>
+      </p:nvGrpSpPr>
+      <p:grpSpPr>
+        <a:xfrm>
+          <a:off x="0" y="0"/>
+          <a:ext cx="0" cy="0"/>
+          <a:chOff x="0" y="0"/>
+          <a:chExt cx="0" cy="0"/>
+        </a:xfrm>
+      </p:grpSpPr>
+      <p:sp>
+        <p:nvSpPr>
+          <p:cNvPr id="2" name="Slide Image Placeholder 1"/>
+          <p:cNvSpPr>
+            <a:spLocks noGrp="1"/>
+          </p:cNvSpPr>
+          <p:nvPr>
+            <p:ph type="sldImg" idx="2"/>
+          </p:nvPr>
+        </p:nvSpPr>
+        <p:spPr>
+          <a:xfrm>
+            <a:off x="685800" y="685800"/>
+            <a:ext cx="5486400" cy="3086100"/>
+          </a:xfrm>
+          <a:prstGeom prst="rect"/>
+        </p:spPr>
+      </p:sp>
+      <p:sp>
+        <p:nvSpPr>
+          <p:cNvPr id="3" name="Notes Placeholder 2"/>
+          <p:cNvSpPr>
+            <a:spLocks noGrp="1"/>
+          </p:cNvSpPr>
+          <p:nvPr>
+            <p:ph type="body" sz="quarter" idx="1"/>
+          </p:nvPr>
+        </p:nvSpPr>
+        <p:spPr>
+          <a:xfrm>
+            <a:off x="685800" y="4114800"/>
+            <a:ext cx="5486400" cy="4114800"/>
+          </a:xfrm>
+          <a:prstGeom prst="rect"/>
+        </p:spPr>
+        <p:txBody>
+          <a:bodyPr/>
+          <a:lstStyle/>
+          <a:p>
+            <a:r>
+              <a:rPr lang="en-US" sz="1500"/>
+              <a:t>The live demo path is: search, prepare, ask, and verify.</a:t>
+            </a:r>
+          </a:p>
+          <a:p>
+            <a:r>
+              <a:rPr lang="en-US" sz="1500"/>
+              <a:t>I can show EC2 to prove Docker deployment: frontend on port 3001 and backend health on port 8000.</a:t>
+            </a:r>
+          </a:p>
+          <a:p>
+            <a:r>
+              <a:rPr lang="en-US" sz="1500"/>
+              <a:t>For the most reliable full transcript/RAG demo, local Docker is better because YouTube often blocks transcript access from cloud IPs.</a:t>
+            </a:r>
+          </a:p>
+          <a:p>
+            <a:r>
+              <a:rPr lang="en-US" sz="1500"/>
+              <a:t>This is an infrastructure limitation of YouTube transcript access, not a broken RAG pipeline.</a:t>
+            </a:r>
+          </a:p>
+          <a:p>
+            <a:r>
+              <a:rPr lang="en-US" sz="1500"/>
+              <a:t>Keep the demo focused on trust: every useful answer links back to transcript timestamps.</a:t>
+            </a:r>
+          </a:p>
+        </p:txBody>
+      </p:sp>
+    </p:spTree>
+  </p:cSld>
+  <p:clrMapOvr>
+    <a:masterClrMapping/>
+  </p:clrMapOvr>
+</p:notes>
+</file>
+
+<file path=ppt/notesSlides/notesSlide11.xml><?xml version="1.0" encoding="utf-8"?>
+<p:notes xmlns:p="http://schemas.openxmlformats.org/presentationml/2006/main" xmlns:a="http://schemas.openxmlformats.org/drawingml/2006/main" xmlns:r="http://schemas.openxmlformats.org/officeDocument/2006/relationships">
+  <p:cSld>
+    <p:spTree>
+      <p:nvGrpSpPr>
+        <p:cNvPr id="1" name=""/>
+        <p:cNvGrpSpPr/>
+        <p:nvPr/>
+      </p:nvGrpSpPr>
+      <p:grpSpPr>
+        <a:xfrm>
+          <a:off x="0" y="0"/>
+          <a:ext cx="0" cy="0"/>
+          <a:chOff x="0" y="0"/>
+          <a:chExt cx="0" cy="0"/>
+        </a:xfrm>
+      </p:grpSpPr>
+      <p:sp>
+        <p:nvSpPr>
+          <p:cNvPr id="2" name="Slide Image Placeholder 1"/>
+          <p:cNvSpPr>
+            <a:spLocks noGrp="1"/>
+          </p:cNvSpPr>
+          <p:nvPr>
+            <p:ph type="sldImg" idx="2"/>
+          </p:nvPr>
+        </p:nvSpPr>
+        <p:spPr>
+          <a:xfrm>
+            <a:off x="685800" y="685800"/>
+            <a:ext cx="5486400" cy="3086100"/>
+          </a:xfrm>
+          <a:prstGeom prst="rect"/>
+        </p:spPr>
+      </p:sp>
+      <p:sp>
+        <p:nvSpPr>
+          <p:cNvPr id="3" name="Notes Placeholder 2"/>
+          <p:cNvSpPr>
+            <a:spLocks noGrp="1"/>
+          </p:cNvSpPr>
+          <p:nvPr>
+            <p:ph type="body" sz="quarter" idx="1"/>
+          </p:nvPr>
+        </p:nvSpPr>
+        <p:spPr>
+          <a:xfrm>
+            <a:off x="685800" y="4114800"/>
+            <a:ext cx="5486400" cy="4114800"/>
+          </a:xfrm>
+          <a:prstGeom prst="rect"/>
+        </p:spPr>
+        <p:txBody>
+          <a:bodyPr/>
+          <a:lstStyle/>
+          <a:p>
+            <a:r>
+              <a:rPr lang="en-US" sz="1500"/>
+              <a:t>To close: AskTube AI covers the mandatory requirements: LLM chatbot, tools, memory, vector database, text processing, UI, tests, evaluation, and deployment.</a:t>
+            </a:r>
+          </a:p>
+          <a:p>
+            <a:r>
+              <a:rPr lang="en-US" sz="1500"/>
+              <a:t>It also includes optional features: voice input, Whisper fallback, streaming, TTS, 3D assistant, and LangSmith tracing.</a:t>
+            </a:r>
+          </a:p>
+          <a:p>
+            <a:r>
+              <a:rPr lang="en-US" sz="1500"/>
+              <a:t>Future improvements are persistent user accounts, multi-video comparison, HTTPS custom domain, and a stronger production transcript proxy.</a:t>
+            </a:r>
+          </a:p>
+          <a:p>
+            <a:r>
+              <a:rPr lang="en-US" sz="1500"/>
+              <a:t>Final sentence: AskTube AI makes YouTube videos learnable by conversation while keeping answers grounded in the original transcript.</a:t>
+            </a:r>
+          </a:p>
+        </p:txBody>
+      </p:sp>
+    </p:spTree>
+  </p:cSld>
+  <p:clrMapOvr>
+    <a:masterClrMapping/>
+  </p:clrMapOvr>
+</p:notes>
+</file>
+
+<file path=ppt/notesSlides/notesSlide2.xml><?xml version="1.0" encoding="utf-8"?>
+<p:notes xmlns:p="http://schemas.openxmlformats.org/presentationml/2006/main" xmlns:a="http://schemas.openxmlformats.org/drawingml/2006/main" xmlns:r="http://schemas.openxmlformats.org/officeDocument/2006/relationships">
+  <p:cSld>
+    <p:spTree>
+      <p:nvGrpSpPr>
+        <p:cNvPr id="1" name=""/>
+        <p:cNvGrpSpPr/>
+        <p:nvPr/>
+      </p:nvGrpSpPr>
+      <p:grpSpPr>
+        <a:xfrm>
+          <a:off x="0" y="0"/>
+          <a:ext cx="0" cy="0"/>
+          <a:chOff x="0" y="0"/>
+          <a:chExt cx="0" cy="0"/>
+        </a:xfrm>
+      </p:grpSpPr>
+      <p:sp>
+        <p:nvSpPr>
+          <p:cNvPr id="2" name="Slide Image Placeholder 1"/>
+          <p:cNvSpPr>
+            <a:spLocks noGrp="1"/>
+          </p:cNvSpPr>
+          <p:nvPr>
+            <p:ph type="sldImg" idx="2"/>
+          </p:nvPr>
+        </p:nvSpPr>
+        <p:spPr>
+          <a:xfrm>
+            <a:off x="685800" y="685800"/>
+            <a:ext cx="5486400" cy="3086100"/>
+          </a:xfrm>
+          <a:prstGeom prst="rect"/>
+        </p:spPr>
+      </p:sp>
+      <p:sp>
+        <p:nvSpPr>
+          <p:cNvPr id="3" name="Notes Placeholder 2"/>
+          <p:cNvSpPr>
+            <a:spLocks noGrp="1"/>
+          </p:cNvSpPr>
+          <p:nvPr>
+            <p:ph type="body" sz="quarter" idx="1"/>
+          </p:nvPr>
+        </p:nvSpPr>
+        <p:spPr>
+          <a:xfrm>
+            <a:off x="685800" y="4114800"/>
+            <a:ext cx="5486400" cy="4114800"/>
+          </a:xfrm>
+          <a:prstGeom prst="rect"/>
+        </p:spPr>
+        <p:txBody>
+          <a:bodyPr/>
+          <a:lstStyle/>
+          <a:p>
+            <a:r>
+              <a:rPr lang="en-US" sz="1500"/>
+              <a:t>The problem is that YouTube has a lot of good learning content, but long videos are hard to search inside.</a:t>
+            </a:r>
+          </a:p>
+          <a:p>
+            <a:r>
+              <a:rPr lang="en-US" sz="1500"/>
+              <a:t>AskTube AI turns the transcript into a searchable knowledge base.</a:t>
+            </a:r>
+          </a:p>
+          <a:p>
+            <a:r>
+              <a:rPr lang="en-US" sz="1500"/>
+              <a:t>The trust rule is central: if the transcript cannot answer, the assistant should refuse instead of inventing.</a:t>
+            </a:r>
+          </a:p>
+          <a:p>
+            <a:r>
+              <a:rPr lang="en-US" sz="1500"/>
+              <a:t>Key message: the project combines speed with verifiable answers.</a:t>
+            </a:r>
+          </a:p>
+        </p:txBody>
+      </p:sp>
+    </p:spTree>
+  </p:cSld>
+  <p:clrMapOvr>
+    <a:masterClrMapping/>
+  </p:clrMapOvr>
+</p:notes>
+</file>
+
+<file path=ppt/notesSlides/notesSlide3.xml><?xml version="1.0" encoding="utf-8"?>
+<p:notes xmlns:p="http://schemas.openxmlformats.org/presentationml/2006/main" xmlns:a="http://schemas.openxmlformats.org/drawingml/2006/main" xmlns:r="http://schemas.openxmlformats.org/officeDocument/2006/relationships">
+  <p:cSld>
+    <p:spTree>
+      <p:nvGrpSpPr>
+        <p:cNvPr id="1" name=""/>
+        <p:cNvGrpSpPr/>
+        <p:nvPr/>
+      </p:nvGrpSpPr>
+      <p:grpSpPr>
+        <a:xfrm>
+          <a:off x="0" y="0"/>
+          <a:ext cx="0" cy="0"/>
+          <a:chOff x="0" y="0"/>
+          <a:chExt cx="0" cy="0"/>
+        </a:xfrm>
+      </p:grpSpPr>
+      <p:sp>
+        <p:nvSpPr>
+          <p:cNvPr id="2" name="Slide Image Placeholder 1"/>
+          <p:cNvSpPr>
+            <a:spLocks noGrp="1"/>
+          </p:cNvSpPr>
+          <p:nvPr>
+            <p:ph type="sldImg" idx="2"/>
+          </p:nvPr>
+        </p:nvSpPr>
+        <p:spPr>
+          <a:xfrm>
+            <a:off x="685800" y="685800"/>
+            <a:ext cx="5486400" cy="3086100"/>
+          </a:xfrm>
+          <a:prstGeom prst="rect"/>
+        </p:spPr>
+      </p:sp>
+      <p:sp>
+        <p:nvSpPr>
+          <p:cNvPr id="3" name="Notes Placeholder 2"/>
+          <p:cNvSpPr>
+            <a:spLocks noGrp="1"/>
+          </p:cNvSpPr>
+          <p:nvPr>
+            <p:ph type="body" sz="quarter" idx="1"/>
+          </p:nvPr>
+        </p:nvSpPr>
+        <p:spPr>
+          <a:xfrm>
+            <a:off x="685800" y="4114800"/>
+            <a:ext cx="5486400" cy="4114800"/>
+          </a:xfrm>
+          <a:prstGeom prst="rect"/>
+        </p:spPr>
+        <p:txBody>
+          <a:bodyPr/>
+          <a:lstStyle/>
+          <a:p>
+            <a:r>
+              <a:rPr lang="en-US" sz="1500"/>
+              <a:t>The user journey has four steps: search, choose, process, and chat.</a:t>
+            </a:r>
+          </a:p>
+          <a:p>
+            <a:r>
+              <a:rPr lang="en-US" sz="1500"/>
+              <a:t>Search can be text or voice, with optional duration filters.</a:t>
+            </a:r>
+          </a:p>
+          <a:p>
+            <a:r>
+              <a:rPr lang="en-US" sz="1500"/>
+              <a:t>After a video is selected, the backend extracts the transcript, chunks it, embeds it, and stores it in ChromaDB.</a:t>
+            </a:r>
+          </a:p>
+          <a:p>
+            <a:r>
+              <a:rPr lang="en-US" sz="1500"/>
+              <a:t>The technical pipeline is hidden behind a simple product flow.</a:t>
+            </a:r>
+          </a:p>
+        </p:txBody>
+      </p:sp>
+    </p:spTree>
+  </p:cSld>
+  <p:clrMapOvr>
+    <a:masterClrMapping/>
+  </p:clrMapOvr>
+</p:notes>
+</file>
+
+<file path=ppt/notesSlides/notesSlide4.xml><?xml version="1.0" encoding="utf-8"?>
+<p:notes xmlns:p="http://schemas.openxmlformats.org/presentationml/2006/main" xmlns:a="http://schemas.openxmlformats.org/drawingml/2006/main" xmlns:r="http://schemas.openxmlformats.org/officeDocument/2006/relationships">
+  <p:cSld>
+    <p:spTree>
+      <p:nvGrpSpPr>
+        <p:cNvPr id="1" name=""/>
+        <p:cNvGrpSpPr/>
+        <p:nvPr/>
+      </p:nvGrpSpPr>
+      <p:grpSpPr>
+        <a:xfrm>
+          <a:off x="0" y="0"/>
+          <a:ext cx="0" cy="0"/>
+          <a:chOff x="0" y="0"/>
+          <a:chExt cx="0" cy="0"/>
+        </a:xfrm>
+      </p:grpSpPr>
+      <p:sp>
+        <p:nvSpPr>
+          <p:cNvPr id="2" name="Slide Image Placeholder 1"/>
+          <p:cNvSpPr>
+            <a:spLocks noGrp="1"/>
+          </p:cNvSpPr>
+          <p:nvPr>
+            <p:ph type="sldImg" idx="2"/>
+          </p:nvPr>
+        </p:nvSpPr>
+        <p:spPr>
+          <a:xfrm>
+            <a:off x="685800" y="685800"/>
+            <a:ext cx="5486400" cy="3086100"/>
+          </a:xfrm>
+          <a:prstGeom prst="rect"/>
+        </p:spPr>
+      </p:sp>
+      <p:sp>
+        <p:nvSpPr>
+          <p:cNvPr id="3" name="Notes Placeholder 2"/>
+          <p:cNvSpPr>
+            <a:spLocks noGrp="1"/>
+          </p:cNvSpPr>
+          <p:nvPr>
+            <p:ph type="body" sz="quarter" idx="1"/>
+          </p:nvPr>
+        </p:nvSpPr>
+        <p:spPr>
+          <a:xfrm>
+            <a:off x="685800" y="4114800"/>
+            <a:ext cx="5486400" cy="4114800"/>
+          </a:xfrm>
+          <a:prstGeom prst="rect"/>
+        </p:spPr>
+        <p:txBody>
+          <a:bodyPr/>
+          <a:lstStyle/>
+          <a:p>
+            <a:r>
+              <a:rPr lang="en-US" sz="1500"/>
+              <a:t>The architecture has three layers: frontend, backend API, and AI/data.</a:t>
+            </a:r>
+          </a:p>
+          <a:p>
+            <a:r>
+              <a:rPr lang="en-US" sz="1500"/>
+              <a:t>The frontend is Next.js with TypeScript, Tailwind, Framer Motion, Embla, and Three.js.</a:t>
+            </a:r>
+          </a:p>
+          <a:p>
+            <a:r>
+              <a:rPr lang="en-US" sz="1500"/>
+              <a:t>The backend is FastAPI with async routes for search, transcripts, chunking, vector storage, chat, agent chat, speech, and evaluations.</a:t>
+            </a:r>
+          </a:p>
+          <a:p>
+            <a:r>
+              <a:rPr lang="en-US" sz="1500"/>
+              <a:t>The AI layer uses LangChain, OpenAI models, ChromaDB, Whisper fallback, and optional LangSmith tracing.</a:t>
+            </a:r>
+          </a:p>
+          <a:p>
+            <a:r>
+              <a:rPr lang="en-US" sz="1500"/>
+              <a:t>Everything runs through Docker Compose.</a:t>
+            </a:r>
+          </a:p>
+        </p:txBody>
+      </p:sp>
+    </p:spTree>
+  </p:cSld>
+  <p:clrMapOvr>
+    <a:masterClrMapping/>
+  </p:clrMapOvr>
+</p:notes>
+</file>
+
+<file path=ppt/notesSlides/notesSlide5.xml><?xml version="1.0" encoding="utf-8"?>
+<p:notes xmlns:p="http://schemas.openxmlformats.org/presentationml/2006/main" xmlns:a="http://schemas.openxmlformats.org/drawingml/2006/main" xmlns:r="http://schemas.openxmlformats.org/officeDocument/2006/relationships">
+  <p:cSld>
+    <p:spTree>
+      <p:nvGrpSpPr>
+        <p:cNvPr id="1" name=""/>
+        <p:cNvGrpSpPr/>
+        <p:nvPr/>
+      </p:nvGrpSpPr>
+      <p:grpSpPr>
+        <a:xfrm>
+          <a:off x="0" y="0"/>
+          <a:ext cx="0" cy="0"/>
+          <a:chOff x="0" y="0"/>
+          <a:chExt cx="0" cy="0"/>
+        </a:xfrm>
+      </p:grpSpPr>
+      <p:sp>
+        <p:nvSpPr>
+          <p:cNvPr id="2" name="Slide Image Placeholder 1"/>
+          <p:cNvSpPr>
+            <a:spLocks noGrp="1"/>
+          </p:cNvSpPr>
+          <p:nvPr>
+            <p:ph type="sldImg" idx="2"/>
+          </p:nvPr>
+        </p:nvSpPr>
+        <p:spPr>
+          <a:xfrm>
+            <a:off x="685800" y="685800"/>
+            <a:ext cx="5486400" cy="3086100"/>
+          </a:xfrm>
+          <a:prstGeom prst="rect"/>
+        </p:spPr>
+      </p:sp>
+      <p:sp>
+        <p:nvSpPr>
+          <p:cNvPr id="3" name="Notes Placeholder 2"/>
+          <p:cNvSpPr>
+            <a:spLocks noGrp="1"/>
+          </p:cNvSpPr>
+          <p:nvPr>
+            <p:ph type="body" sz="quarter" idx="1"/>
+          </p:nvPr>
+        </p:nvSpPr>
+        <p:spPr>
+          <a:xfrm>
+            <a:off x="685800" y="4114800"/>
+            <a:ext cx="5486400" cy="4114800"/>
+          </a:xfrm>
+          <a:prstGeom prst="rect"/>
+        </p:spPr>
+        <p:txBody>
+          <a:bodyPr/>
+          <a:lstStyle/>
+          <a:p>
+            <a:r>
+              <a:rPr lang="en-US" sz="1500"/>
+              <a:t>This is the key backend pipeline.</a:t>
+            </a:r>
+          </a:p>
+          <a:p>
+            <a:r>
+              <a:rPr lang="en-US" sz="1500"/>
+              <a:t>First, YouTube Data API gets metadata like title, thumbnail, duration, and channel.</a:t>
+            </a:r>
+          </a:p>
+          <a:p>
+            <a:r>
+              <a:rPr lang="en-US" sz="1500"/>
+              <a:t>Then youtube-transcript-api fetches public captions. This follows Carlos's recommendation to avoid downloading full videos.</a:t>
+            </a:r>
+          </a:p>
+          <a:p>
+            <a:r>
+              <a:rPr lang="en-US" sz="1500"/>
+              <a:t>The transcript is split into chunks, and each chunk keeps timestamp metadata.</a:t>
+            </a:r>
+          </a:p>
+          <a:p>
+            <a:r>
+              <a:rPr lang="en-US" sz="1500"/>
+              <a:t>OpenAI embeddings are stored in ChromaDB. Whisper and yt-dlp are fallback only when captions are unavailable.</a:t>
+            </a:r>
+          </a:p>
+        </p:txBody>
+      </p:sp>
+    </p:spTree>
+  </p:cSld>
+  <p:clrMapOvr>
+    <a:masterClrMapping/>
+  </p:clrMapOvr>
+</p:notes>
+</file>
+
+<file path=ppt/notesSlides/notesSlide6.xml><?xml version="1.0" encoding="utf-8"?>
+<p:notes xmlns:p="http://schemas.openxmlformats.org/presentationml/2006/main" xmlns:a="http://schemas.openxmlformats.org/drawingml/2006/main" xmlns:r="http://schemas.openxmlformats.org/officeDocument/2006/relationships">
+  <p:cSld>
+    <p:spTree>
+      <p:nvGrpSpPr>
+        <p:cNvPr id="1" name=""/>
+        <p:cNvGrpSpPr/>
+        <p:nvPr/>
+      </p:nvGrpSpPr>
+      <p:grpSpPr>
+        <a:xfrm>
+          <a:off x="0" y="0"/>
+          <a:ext cx="0" cy="0"/>
+          <a:chOff x="0" y="0"/>
+          <a:chExt cx="0" cy="0"/>
+        </a:xfrm>
+      </p:grpSpPr>
+      <p:sp>
+        <p:nvSpPr>
+          <p:cNvPr id="2" name="Slide Image Placeholder 1"/>
+          <p:cNvSpPr>
+            <a:spLocks noGrp="1"/>
+          </p:cNvSpPr>
+          <p:nvPr>
+            <p:ph type="sldImg" idx="2"/>
+          </p:nvPr>
+        </p:nvSpPr>
+        <p:spPr>
+          <a:xfrm>
+            <a:off x="685800" y="685800"/>
+            <a:ext cx="5486400" cy="3086100"/>
+          </a:xfrm>
+          <a:prstGeom prst="rect"/>
+        </p:spPr>
+      </p:sp>
+      <p:sp>
+        <p:nvSpPr>
+          <p:cNvPr id="3" name="Notes Placeholder 2"/>
+          <p:cNvSpPr>
+            <a:spLocks noGrp="1"/>
+          </p:cNvSpPr>
+          <p:nvPr>
+            <p:ph type="body" sz="quarter" idx="1"/>
+          </p:nvPr>
+        </p:nvSpPr>
+        <p:spPr>
+          <a:xfrm>
+            <a:off x="685800" y="4114800"/>
+            <a:ext cx="5486400" cy="4114800"/>
+          </a:xfrm>
+          <a:prstGeom prst="rect"/>
+        </p:spPr>
+        <p:txBody>
+          <a:bodyPr/>
+          <a:lstStyle/>
+          <a:p>
+            <a:r>
+              <a:rPr lang="en-US" sz="1500"/>
+              <a:t>This slide shows how I covered the tools requirement.</a:t>
+            </a:r>
+          </a:p>
+          <a:p>
+            <a:r>
+              <a:rPr lang="en-US" sz="1500"/>
+              <a:t>Each LangChain tool wraps an existing backend service instead of duplicating logic.</a:t>
+            </a:r>
+          </a:p>
+          <a:p>
+            <a:r>
+              <a:rPr lang="en-US" sz="1500"/>
+              <a:t>The AgentService binds these tools to the model and returns the answer, citations, tool steps, and session_id.</a:t>
+            </a:r>
+          </a:p>
+          <a:p>
+            <a:r>
+              <a:rPr lang="en-US" sz="1500"/>
+              <a:t>Memory keeps follow-up questions coherent inside the same session.</a:t>
+            </a:r>
+          </a:p>
+          <a:p>
+            <a:r>
+              <a:rPr lang="en-US" sz="1500"/>
+              <a:t>Key message: this is an LLM with tools and memory, not one big prompt.</a:t>
+            </a:r>
+          </a:p>
+        </p:txBody>
+      </p:sp>
+    </p:spTree>
+  </p:cSld>
+  <p:clrMapOvr>
+    <a:masterClrMapping/>
+  </p:clrMapOvr>
+</p:notes>
+</file>
+
+<file path=ppt/notesSlides/notesSlide7.xml><?xml version="1.0" encoding="utf-8"?>
+<p:notes xmlns:p="http://schemas.openxmlformats.org/presentationml/2006/main" xmlns:a="http://schemas.openxmlformats.org/drawingml/2006/main" xmlns:r="http://schemas.openxmlformats.org/officeDocument/2006/relationships">
+  <p:cSld>
+    <p:spTree>
+      <p:nvGrpSpPr>
+        <p:cNvPr id="1" name=""/>
+        <p:cNvGrpSpPr/>
+        <p:nvPr/>
+      </p:nvGrpSpPr>
+      <p:grpSpPr>
+        <a:xfrm>
+          <a:off x="0" y="0"/>
+          <a:ext cx="0" cy="0"/>
+          <a:chOff x="0" y="0"/>
+          <a:chExt cx="0" cy="0"/>
+        </a:xfrm>
+      </p:grpSpPr>
+      <p:sp>
+        <p:nvSpPr>
+          <p:cNvPr id="2" name="Slide Image Placeholder 1"/>
+          <p:cNvSpPr>
+            <a:spLocks noGrp="1"/>
+          </p:cNvSpPr>
+          <p:nvPr>
+            <p:ph type="sldImg" idx="2"/>
+          </p:nvPr>
+        </p:nvSpPr>
+        <p:spPr>
+          <a:xfrm>
+            <a:off x="685800" y="685800"/>
+            <a:ext cx="5486400" cy="3086100"/>
+          </a:xfrm>
+          <a:prstGeom prst="rect"/>
+        </p:spPr>
+      </p:sp>
+      <p:sp>
+        <p:nvSpPr>
+          <p:cNvPr id="3" name="Notes Placeholder 2"/>
+          <p:cNvSpPr>
+            <a:spLocks noGrp="1"/>
+          </p:cNvSpPr>
+          <p:nvPr>
+            <p:ph type="body" sz="quarter" idx="1"/>
+          </p:nvPr>
+        </p:nvSpPr>
+        <p:spPr>
+          <a:xfrm>
+            <a:off x="685800" y="4114800"/>
+            <a:ext cx="5486400" cy="4114800"/>
+          </a:xfrm>
+          <a:prstGeom prst="rect"/>
+        </p:spPr>
+        <p:txBody>
+          <a:bodyPr/>
+          <a:lstStyle/>
+          <a:p>
+            <a:r>
+              <a:rPr lang="en-US" sz="1500"/>
+              <a:t>The RAG flow has four steps: retrieve, inject, generate, and cite.</a:t>
+            </a:r>
+          </a:p>
+          <a:p>
+            <a:r>
+              <a:rPr lang="en-US" sz="1500"/>
+              <a:t>The question is matched against ChromaDB transcript chunks.</a:t>
+            </a:r>
+          </a:p>
+          <a:p>
+            <a:r>
+              <a:rPr lang="en-US" sz="1500"/>
+              <a:t>Only the retrieved transcript context, memory, and rules are passed to the model.</a:t>
+            </a:r>
+          </a:p>
+          <a:p>
+            <a:r>
+              <a:rPr lang="en-US" sz="1500"/>
+              <a:t>GPT-4o-mini writes from retrieved context, and the UI shows timestamp citations.</a:t>
+            </a:r>
+          </a:p>
+          <a:p>
+            <a:r>
+              <a:rPr lang="en-US" sz="1500"/>
+              <a:t>If the transcript does not contain the answer, the system should refuse. That is the anti-hallucination behavior.</a:t>
+            </a:r>
+          </a:p>
+        </p:txBody>
+      </p:sp>
+    </p:spTree>
+  </p:cSld>
+  <p:clrMapOvr>
+    <a:masterClrMapping/>
+  </p:clrMapOvr>
+</p:notes>
+</file>
+
+<file path=ppt/notesSlides/notesSlide8.xml><?xml version="1.0" encoding="utf-8"?>
+<p:notes xmlns:p="http://schemas.openxmlformats.org/presentationml/2006/main" xmlns:a="http://schemas.openxmlformats.org/drawingml/2006/main" xmlns:r="http://schemas.openxmlformats.org/officeDocument/2006/relationships">
+  <p:cSld>
+    <p:spTree>
+      <p:nvGrpSpPr>
+        <p:cNvPr id="1" name=""/>
+        <p:cNvGrpSpPr/>
+        <p:nvPr/>
+      </p:nvGrpSpPr>
+      <p:grpSpPr>
+        <a:xfrm>
+          <a:off x="0" y="0"/>
+          <a:ext cx="0" cy="0"/>
+          <a:chOff x="0" y="0"/>
+          <a:chExt cx="0" cy="0"/>
+        </a:xfrm>
+      </p:grpSpPr>
+      <p:sp>
+        <p:nvSpPr>
+          <p:cNvPr id="2" name="Slide Image Placeholder 1"/>
+          <p:cNvSpPr>
+            <a:spLocks noGrp="1"/>
+          </p:cNvSpPr>
+          <p:nvPr>
+            <p:ph type="sldImg" idx="2"/>
+          </p:nvPr>
+        </p:nvSpPr>
+        <p:spPr>
+          <a:xfrm>
+            <a:off x="685800" y="685800"/>
+            <a:ext cx="5486400" cy="3086100"/>
+          </a:xfrm>
+          <a:prstGeom prst="rect"/>
+        </p:spPr>
+      </p:sp>
+      <p:sp>
+        <p:nvSpPr>
+          <p:cNvPr id="3" name="Notes Placeholder 2"/>
+          <p:cNvSpPr>
+            <a:spLocks noGrp="1"/>
+          </p:cNvSpPr>
+          <p:nvPr>
+            <p:ph type="body" sz="quarter" idx="1"/>
+          </p:nvPr>
+        </p:nvSpPr>
+        <p:spPr>
+          <a:xfrm>
+            <a:off x="685800" y="4114800"/>
+            <a:ext cx="5486400" cy="4114800"/>
+          </a:xfrm>
+          <a:prstGeom prst="rect"/>
+        </p:spPr>
+        <p:txBody>
+          <a:bodyPr/>
+          <a:lstStyle/>
+          <a:p>
+            <a:r>
+              <a:rPr lang="en-US" sz="1500"/>
+              <a:t>These are optional UX features that make the project feel like a real learning product.</a:t>
+            </a:r>
+          </a:p>
+          <a:p>
+            <a:r>
+              <a:rPr lang="en-US" sz="1500"/>
+              <a:t>Voice search uses the browser Web Speech API first, then Whisper fallback if needed.</a:t>
+            </a:r>
+          </a:p>
+          <a:p>
+            <a:r>
+              <a:rPr lang="en-US" sz="1500"/>
+              <a:t>There is a 3D assistant, loading skeletons, retry states, text-to-speech for answers, responsive layouts, and accessibility work.</a:t>
+            </a:r>
+          </a:p>
+          <a:p>
+            <a:r>
+              <a:rPr lang="en-US" sz="1500"/>
+              <a:t>Key message: the UX supports the learning flow, but the core project remains RAG.</a:t>
+            </a:r>
+          </a:p>
+        </p:txBody>
+      </p:sp>
+    </p:spTree>
+  </p:cSld>
+  <p:clrMapOvr>
+    <a:masterClrMapping/>
+  </p:clrMapOvr>
+</p:notes>
+</file>
+
+<file path=ppt/notesSlides/notesSlide9.xml><?xml version="1.0" encoding="utf-8"?>
+<p:notes xmlns:p="http://schemas.openxmlformats.org/presentationml/2006/main" xmlns:a="http://schemas.openxmlformats.org/drawingml/2006/main" xmlns:r="http://schemas.openxmlformats.org/officeDocument/2006/relationships">
+  <p:cSld>
+    <p:spTree>
+      <p:nvGrpSpPr>
+        <p:cNvPr id="1" name=""/>
+        <p:cNvGrpSpPr/>
+        <p:nvPr/>
+      </p:nvGrpSpPr>
+      <p:grpSpPr>
+        <a:xfrm>
+          <a:off x="0" y="0"/>
+          <a:ext cx="0" cy="0"/>
+          <a:chOff x="0" y="0"/>
+          <a:chExt cx="0" cy="0"/>
+        </a:xfrm>
+      </p:grpSpPr>
+      <p:sp>
+        <p:nvSpPr>
+          <p:cNvPr id="2" name="Slide Image Placeholder 1"/>
+          <p:cNvSpPr>
+            <a:spLocks noGrp="1"/>
+          </p:cNvSpPr>
+          <p:nvPr>
+            <p:ph type="sldImg" idx="2"/>
+          </p:nvPr>
+        </p:nvSpPr>
+        <p:spPr>
+          <a:xfrm>
+            <a:off x="685800" y="685800"/>
+            <a:ext cx="5486400" cy="3086100"/>
+          </a:xfrm>
+          <a:prstGeom prst="rect"/>
+        </p:spPr>
+      </p:sp>
+      <p:sp>
+        <p:nvSpPr>
+          <p:cNvPr id="3" name="Notes Placeholder 2"/>
+          <p:cNvSpPr>
+            <a:spLocks noGrp="1"/>
+          </p:cNvSpPr>
+          <p:nvPr>
+            <p:ph type="body" sz="quarter" idx="1"/>
+          </p:nvPr>
+        </p:nvSpPr>
+        <p:spPr>
+          <a:xfrm>
+            <a:off x="685800" y="4114800"/>
+            <a:ext cx="5486400" cy="4114800"/>
+          </a:xfrm>
+          <a:prstGeom prst="rect"/>
+        </p:spPr>
+        <p:txBody>
+          <a:bodyPr/>
+          <a:lstStyle/>
+          <a:p>
+            <a:r>
+              <a:rPr lang="en-US" sz="1500"/>
+              <a:t>The backend has 98 pytest tests covering routes, services, tools, WebSocket ingestion, speech, memory, vector storage, and RAG behavior.</a:t>
+            </a:r>
+          </a:p>
+          <a:p>
+            <a:r>
+              <a:rPr lang="en-US" sz="1500"/>
+              <a:t>There is also a 17-case RAG evaluation dataset.</a:t>
+            </a:r>
+          </a:p>
+          <a:p>
+            <a:r>
+              <a:rPr lang="en-US" sz="1500"/>
+              <a:t>The evaluation cases check answerable questions, refusals, citation accuracy, summaries, memory, and hallucination prevention.</a:t>
+            </a:r>
+          </a:p>
+          <a:p>
+            <a:r>
+              <a:rPr lang="en-US" sz="1500"/>
+              <a:t>LangSmith tracing can inspect latency, context, tool calls, and answer quality.</a:t>
+            </a:r>
+          </a:p>
+        </p:txBody>
+      </p:sp>
+    </p:spTree>
+  </p:cSld>
+  <p:clrMapOvr>
+    <a:masterClrMapping/>
+  </p:clrMapOvr>
+</p:notes>
 </file>
 
 <file path=ppt/slideLayouts/slideLayout1.xml><?xml version="1.0" encoding="utf-8"?>
@@ -155,10 +1217,9 @@
           <a:lstStyle/>
           <a:p>
             <a:r>
-              <a:rPr lang="en-US" smtClean="0"/>
+              <a:rPr lang="en-US"/>
               <a:t>Click to edit Master title style</a:t>
             </a:r>
-            <a:endParaRPr lang="en-US"/>
           </a:p>
         </p:txBody>
       </p:sp>
@@ -274,10 +1335,9 @@
           </a:lstStyle>
           <a:p>
             <a:r>
-              <a:rPr lang="en-US" smtClean="0"/>
+              <a:rPr lang="en-US"/>
               <a:t>Click to edit Master subtitle style</a:t>
             </a:r>
-            <a:endParaRPr lang="en-US"/>
           </a:p>
         </p:txBody>
       </p:sp>
@@ -298,7 +1358,7 @@
           <a:p>
             <a:fld id="{5BCAD085-E8A6-8845-BD4E-CB4CCA059FC4}" type="datetimeFigureOut">
               <a:rPr lang="en-US" smtClean="0"/>
-              <a:t>1/27/13</a:t>
+              <a:t>5/26/2026</a:t>
             </a:fld>
             <a:endParaRPr lang="en-US"/>
           </a:p>
@@ -392,10 +1452,9 @@
           <a:lstStyle/>
           <a:p>
             <a:r>
-              <a:rPr lang="en-US" smtClean="0"/>
+              <a:rPr lang="en-US"/>
               <a:t>Click to edit Master title style</a:t>
             </a:r>
-            <a:endParaRPr lang="en-US"/>
           </a:p>
         </p:txBody>
       </p:sp>
@@ -416,38 +1475,37 @@
           <a:p>
             <a:pPr lvl="0"/>
             <a:r>
-              <a:rPr lang="en-US" smtClean="0"/>
+              <a:rPr lang="en-US"/>
               <a:t>Click to edit Master text styles</a:t>
             </a:r>
           </a:p>
           <a:p>
             <a:pPr lvl="1"/>
             <a:r>
-              <a:rPr lang="en-US" smtClean="0"/>
+              <a:rPr lang="en-US"/>
               <a:t>Second level</a:t>
             </a:r>
           </a:p>
           <a:p>
             <a:pPr lvl="2"/>
             <a:r>
-              <a:rPr lang="en-US" smtClean="0"/>
+              <a:rPr lang="en-US"/>
               <a:t>Third level</a:t>
             </a:r>
           </a:p>
           <a:p>
             <a:pPr lvl="3"/>
             <a:r>
-              <a:rPr lang="en-US" smtClean="0"/>
+              <a:rPr lang="en-US"/>
               <a:t>Fourth level</a:t>
             </a:r>
           </a:p>
           <a:p>
             <a:pPr lvl="4"/>
             <a:r>
-              <a:rPr lang="en-US" smtClean="0"/>
+              <a:rPr lang="en-US"/>
               <a:t>Fifth level</a:t>
             </a:r>
-            <a:endParaRPr lang="en-US"/>
           </a:p>
         </p:txBody>
       </p:sp>
@@ -468,7 +1526,7 @@
           <a:p>
             <a:fld id="{5BCAD085-E8A6-8845-BD4E-CB4CCA059FC4}" type="datetimeFigureOut">
               <a:rPr lang="en-US" smtClean="0"/>
-              <a:t>1/27/13</a:t>
+              <a:t>5/26/2026</a:t>
             </a:fld>
             <a:endParaRPr lang="en-US"/>
           </a:p>
@@ -567,10 +1625,9 @@
           <a:lstStyle/>
           <a:p>
             <a:r>
-              <a:rPr lang="en-US" smtClean="0"/>
+              <a:rPr lang="en-US"/>
               <a:t>Click to edit Master title style</a:t>
             </a:r>
-            <a:endParaRPr lang="en-US"/>
           </a:p>
         </p:txBody>
       </p:sp>
@@ -596,38 +1653,37 @@
           <a:p>
             <a:pPr lvl="0"/>
             <a:r>
-              <a:rPr lang="en-US" smtClean="0"/>
+              <a:rPr lang="en-US"/>
               <a:t>Click to edit Master text styles</a:t>
             </a:r>
           </a:p>
           <a:p>
             <a:pPr lvl="1"/>
             <a:r>
-              <a:rPr lang="en-US" smtClean="0"/>
+              <a:rPr lang="en-US"/>
               <a:t>Second level</a:t>
             </a:r>
           </a:p>
           <a:p>
             <a:pPr lvl="2"/>
             <a:r>
-              <a:rPr lang="en-US" smtClean="0"/>
+              <a:rPr lang="en-US"/>
               <a:t>Third level</a:t>
             </a:r>
           </a:p>
           <a:p>
             <a:pPr lvl="3"/>
             <a:r>
-              <a:rPr lang="en-US" smtClean="0"/>
+              <a:rPr lang="en-US"/>
               <a:t>Fourth level</a:t>
             </a:r>
           </a:p>
           <a:p>
             <a:pPr lvl="4"/>
             <a:r>
-              <a:rPr lang="en-US" smtClean="0"/>
+              <a:rPr lang="en-US"/>
               <a:t>Fifth level</a:t>
             </a:r>
-            <a:endParaRPr lang="en-US"/>
           </a:p>
         </p:txBody>
       </p:sp>
@@ -648,7 +1704,7 @@
           <a:p>
             <a:fld id="{5BCAD085-E8A6-8845-BD4E-CB4CCA059FC4}" type="datetimeFigureOut">
               <a:rPr lang="en-US" smtClean="0"/>
-              <a:t>1/27/13</a:t>
+              <a:t>5/26/2026</a:t>
             </a:fld>
             <a:endParaRPr lang="en-US"/>
           </a:p>
@@ -742,10 +1798,9 @@
           <a:lstStyle/>
           <a:p>
             <a:r>
-              <a:rPr lang="en-US" smtClean="0"/>
+              <a:rPr lang="en-US"/>
               <a:t>Click to edit Master title style</a:t>
             </a:r>
-            <a:endParaRPr lang="en-US"/>
           </a:p>
         </p:txBody>
       </p:sp>
@@ -766,38 +1821,37 @@
           <a:p>
             <a:pPr lvl="0"/>
             <a:r>
-              <a:rPr lang="en-US" smtClean="0"/>
+              <a:rPr lang="en-US"/>
               <a:t>Click to edit Master text styles</a:t>
             </a:r>
           </a:p>
           <a:p>
             <a:pPr lvl="1"/>
             <a:r>
-              <a:rPr lang="en-US" smtClean="0"/>
+              <a:rPr lang="en-US"/>
               <a:t>Second level</a:t>
             </a:r>
           </a:p>
           <a:p>
             <a:pPr lvl="2"/>
             <a:r>
-              <a:rPr lang="en-US" smtClean="0"/>
+              <a:rPr lang="en-US"/>
               <a:t>Third level</a:t>
             </a:r>
           </a:p>
           <a:p>
             <a:pPr lvl="3"/>
             <a:r>
-              <a:rPr lang="en-US" smtClean="0"/>
+              <a:rPr lang="en-US"/>
               <a:t>Fourth level</a:t>
             </a:r>
           </a:p>
           <a:p>
             <a:pPr lvl="4"/>
             <a:r>
-              <a:rPr lang="en-US" smtClean="0"/>
+              <a:rPr lang="en-US"/>
               <a:t>Fifth level</a:t>
             </a:r>
-            <a:endParaRPr lang="en-US"/>
           </a:p>
         </p:txBody>
       </p:sp>
@@ -818,7 +1872,7 @@
           <a:p>
             <a:fld id="{5BCAD085-E8A6-8845-BD4E-CB4CCA059FC4}" type="datetimeFigureOut">
               <a:rPr lang="en-US" smtClean="0"/>
-              <a:t>1/27/13</a:t>
+              <a:t>5/26/2026</a:t>
             </a:fld>
             <a:endParaRPr lang="en-US"/>
           </a:p>
@@ -921,10 +1975,9 @@
           </a:lstStyle>
           <a:p>
             <a:r>
-              <a:rPr lang="en-US" smtClean="0"/>
+              <a:rPr lang="en-US"/>
               <a:t>Click to edit Master title style</a:t>
             </a:r>
-            <a:endParaRPr lang="en-US"/>
           </a:p>
         </p:txBody>
       </p:sp>
@@ -1041,7 +2094,7 @@
           <a:p>
             <a:pPr lvl="0"/>
             <a:r>
-              <a:rPr lang="en-US" smtClean="0"/>
+              <a:rPr lang="en-US"/>
               <a:t>Click to edit Master text styles</a:t>
             </a:r>
           </a:p>
@@ -1064,7 +2117,7 @@
           <a:p>
             <a:fld id="{5BCAD085-E8A6-8845-BD4E-CB4CCA059FC4}" type="datetimeFigureOut">
               <a:rPr lang="en-US" smtClean="0"/>
-              <a:t>1/27/13</a:t>
+              <a:t>5/26/2026</a:t>
             </a:fld>
             <a:endParaRPr lang="en-US"/>
           </a:p>
@@ -1158,10 +2211,9 @@
           <a:lstStyle/>
           <a:p>
             <a:r>
-              <a:rPr lang="en-US" smtClean="0"/>
+              <a:rPr lang="en-US"/>
               <a:t>Click to edit Master title style</a:t>
             </a:r>
-            <a:endParaRPr lang="en-US"/>
           </a:p>
         </p:txBody>
       </p:sp>
@@ -1215,38 +2267,37 @@
           <a:p>
             <a:pPr lvl="0"/>
             <a:r>
-              <a:rPr lang="en-US" smtClean="0"/>
+              <a:rPr lang="en-US"/>
               <a:t>Click to edit Master text styles</a:t>
             </a:r>
           </a:p>
           <a:p>
             <a:pPr lvl="1"/>
             <a:r>
-              <a:rPr lang="en-US" smtClean="0"/>
+              <a:rPr lang="en-US"/>
               <a:t>Second level</a:t>
             </a:r>
           </a:p>
           <a:p>
             <a:pPr lvl="2"/>
             <a:r>
-              <a:rPr lang="en-US" smtClean="0"/>
+              <a:rPr lang="en-US"/>
               <a:t>Third level</a:t>
             </a:r>
           </a:p>
           <a:p>
             <a:pPr lvl="3"/>
             <a:r>
-              <a:rPr lang="en-US" smtClean="0"/>
+              <a:rPr lang="en-US"/>
               <a:t>Fourth level</a:t>
             </a:r>
           </a:p>
           <a:p>
             <a:pPr lvl="4"/>
             <a:r>
-              <a:rPr lang="en-US" smtClean="0"/>
+              <a:rPr lang="en-US"/>
               <a:t>Fifth level</a:t>
             </a:r>
-            <a:endParaRPr lang="en-US"/>
           </a:p>
         </p:txBody>
       </p:sp>
@@ -1300,38 +2351,37 @@
           <a:p>
             <a:pPr lvl="0"/>
             <a:r>
-              <a:rPr lang="en-US" smtClean="0"/>
+              <a:rPr lang="en-US"/>
               <a:t>Click to edit Master text styles</a:t>
             </a:r>
           </a:p>
           <a:p>
             <a:pPr lvl="1"/>
             <a:r>
-              <a:rPr lang="en-US" smtClean="0"/>
+              <a:rPr lang="en-US"/>
               <a:t>Second level</a:t>
             </a:r>
           </a:p>
           <a:p>
             <a:pPr lvl="2"/>
             <a:r>
-              <a:rPr lang="en-US" smtClean="0"/>
+              <a:rPr lang="en-US"/>
               <a:t>Third level</a:t>
             </a:r>
           </a:p>
           <a:p>
             <a:pPr lvl="3"/>
             <a:r>
-              <a:rPr lang="en-US" smtClean="0"/>
+              <a:rPr lang="en-US"/>
               <a:t>Fourth level</a:t>
             </a:r>
           </a:p>
           <a:p>
             <a:pPr lvl="4"/>
             <a:r>
-              <a:rPr lang="en-US" smtClean="0"/>
+              <a:rPr lang="en-US"/>
               <a:t>Fifth level</a:t>
             </a:r>
-            <a:endParaRPr lang="en-US"/>
           </a:p>
         </p:txBody>
       </p:sp>
@@ -1352,7 +2402,7 @@
           <a:p>
             <a:fld id="{5BCAD085-E8A6-8845-BD4E-CB4CCA059FC4}" type="datetimeFigureOut">
               <a:rPr lang="en-US" smtClean="0"/>
-              <a:t>1/27/13</a:t>
+              <a:t>5/26/2026</a:t>
             </a:fld>
             <a:endParaRPr lang="en-US"/>
           </a:p>
@@ -1450,10 +2500,9 @@
           </a:lstStyle>
           <a:p>
             <a:r>
-              <a:rPr lang="en-US" smtClean="0"/>
+              <a:rPr lang="en-US"/>
               <a:t>Click to edit Master title style</a:t>
             </a:r>
-            <a:endParaRPr lang="en-US"/>
           </a:p>
         </p:txBody>
       </p:sp>
@@ -1516,7 +2565,7 @@
           <a:p>
             <a:pPr lvl="0"/>
             <a:r>
-              <a:rPr lang="en-US" smtClean="0"/>
+              <a:rPr lang="en-US"/>
               <a:t>Click to edit Master text styles</a:t>
             </a:r>
           </a:p>
@@ -1572,38 +2621,37 @@
           <a:p>
             <a:pPr lvl="0"/>
             <a:r>
-              <a:rPr lang="en-US" smtClean="0"/>
+              <a:rPr lang="en-US"/>
               <a:t>Click to edit Master text styles</a:t>
             </a:r>
           </a:p>
           <a:p>
             <a:pPr lvl="1"/>
             <a:r>
-              <a:rPr lang="en-US" smtClean="0"/>
+              <a:rPr lang="en-US"/>
               <a:t>Second level</a:t>
             </a:r>
           </a:p>
           <a:p>
             <a:pPr lvl="2"/>
             <a:r>
-              <a:rPr lang="en-US" smtClean="0"/>
+              <a:rPr lang="en-US"/>
               <a:t>Third level</a:t>
             </a:r>
           </a:p>
           <a:p>
             <a:pPr lvl="3"/>
             <a:r>
-              <a:rPr lang="en-US" smtClean="0"/>
+              <a:rPr lang="en-US"/>
               <a:t>Fourth level</a:t>
             </a:r>
           </a:p>
           <a:p>
             <a:pPr lvl="4"/>
             <a:r>
-              <a:rPr lang="en-US" smtClean="0"/>
+              <a:rPr lang="en-US"/>
               <a:t>Fifth level</a:t>
             </a:r>
-            <a:endParaRPr lang="en-US"/>
           </a:p>
         </p:txBody>
       </p:sp>
@@ -1666,7 +2714,7 @@
           <a:p>
             <a:pPr lvl="0"/>
             <a:r>
-              <a:rPr lang="en-US" smtClean="0"/>
+              <a:rPr lang="en-US"/>
               <a:t>Click to edit Master text styles</a:t>
             </a:r>
           </a:p>
@@ -1722,38 +2770,37 @@
           <a:p>
             <a:pPr lvl="0"/>
             <a:r>
-              <a:rPr lang="en-US" smtClean="0"/>
+              <a:rPr lang="en-US"/>
               <a:t>Click to edit Master text styles</a:t>
             </a:r>
           </a:p>
           <a:p>
             <a:pPr lvl="1"/>
             <a:r>
-              <a:rPr lang="en-US" smtClean="0"/>
+              <a:rPr lang="en-US"/>
               <a:t>Second level</a:t>
             </a:r>
           </a:p>
           <a:p>
             <a:pPr lvl="2"/>
             <a:r>
-              <a:rPr lang="en-US" smtClean="0"/>
+              <a:rPr lang="en-US"/>
               <a:t>Third level</a:t>
             </a:r>
           </a:p>
           <a:p>
             <a:pPr lvl="3"/>
             <a:r>
-              <a:rPr lang="en-US" smtClean="0"/>
+              <a:rPr lang="en-US"/>
               <a:t>Fourth level</a:t>
             </a:r>
           </a:p>
           <a:p>
             <a:pPr lvl="4"/>
             <a:r>
-              <a:rPr lang="en-US" smtClean="0"/>
+              <a:rPr lang="en-US"/>
               <a:t>Fifth level</a:t>
             </a:r>
-            <a:endParaRPr lang="en-US"/>
           </a:p>
         </p:txBody>
       </p:sp>
@@ -1774,7 +2821,7 @@
           <a:p>
             <a:fld id="{5BCAD085-E8A6-8845-BD4E-CB4CCA059FC4}" type="datetimeFigureOut">
               <a:rPr lang="en-US" smtClean="0"/>
-              <a:t>1/27/13</a:t>
+              <a:t>5/26/2026</a:t>
             </a:fld>
             <a:endParaRPr lang="en-US"/>
           </a:p>
@@ -1868,10 +2915,9 @@
           <a:lstStyle/>
           <a:p>
             <a:r>
-              <a:rPr lang="en-US" smtClean="0"/>
+              <a:rPr lang="en-US"/>
               <a:t>Click to edit Master title style</a:t>
             </a:r>
-            <a:endParaRPr lang="en-US"/>
           </a:p>
         </p:txBody>
       </p:sp>
@@ -1892,7 +2938,7 @@
           <a:p>
             <a:fld id="{5BCAD085-E8A6-8845-BD4E-CB4CCA059FC4}" type="datetimeFigureOut">
               <a:rPr lang="en-US" smtClean="0"/>
-              <a:t>1/27/13</a:t>
+              <a:t>5/26/2026</a:t>
             </a:fld>
             <a:endParaRPr lang="en-US"/>
           </a:p>
@@ -1987,7 +3033,7 @@
           <a:p>
             <a:fld id="{5BCAD085-E8A6-8845-BD4E-CB4CCA059FC4}" type="datetimeFigureOut">
               <a:rPr lang="en-US" smtClean="0"/>
-              <a:t>1/27/13</a:t>
+              <a:t>5/26/2026</a:t>
             </a:fld>
             <a:endParaRPr lang="en-US"/>
           </a:p>
@@ -2090,10 +3136,9 @@
           </a:lstStyle>
           <a:p>
             <a:r>
-              <a:rPr lang="en-US" smtClean="0"/>
+              <a:rPr lang="en-US"/>
               <a:t>Click to edit Master title style</a:t>
             </a:r>
-            <a:endParaRPr lang="en-US"/>
           </a:p>
         </p:txBody>
       </p:sp>
@@ -2147,38 +3192,37 @@
           <a:p>
             <a:pPr lvl="0"/>
             <a:r>
-              <a:rPr lang="en-US" smtClean="0"/>
+              <a:rPr lang="en-US"/>
               <a:t>Click to edit Master text styles</a:t>
             </a:r>
           </a:p>
           <a:p>
             <a:pPr lvl="1"/>
             <a:r>
-              <a:rPr lang="en-US" smtClean="0"/>
+              <a:rPr lang="en-US"/>
               <a:t>Second level</a:t>
             </a:r>
           </a:p>
           <a:p>
             <a:pPr lvl="2"/>
             <a:r>
-              <a:rPr lang="en-US" smtClean="0"/>
+              <a:rPr lang="en-US"/>
               <a:t>Third level</a:t>
             </a:r>
           </a:p>
           <a:p>
             <a:pPr lvl="3"/>
             <a:r>
-              <a:rPr lang="en-US" smtClean="0"/>
+              <a:rPr lang="en-US"/>
               <a:t>Fourth level</a:t>
             </a:r>
           </a:p>
           <a:p>
             <a:pPr lvl="4"/>
             <a:r>
-              <a:rPr lang="en-US" smtClean="0"/>
+              <a:rPr lang="en-US"/>
               <a:t>Fifth level</a:t>
             </a:r>
-            <a:endParaRPr lang="en-US"/>
           </a:p>
         </p:txBody>
       </p:sp>
@@ -2241,7 +3285,7 @@
           <a:p>
             <a:pPr lvl="0"/>
             <a:r>
-              <a:rPr lang="en-US" smtClean="0"/>
+              <a:rPr lang="en-US"/>
               <a:t>Click to edit Master text styles</a:t>
             </a:r>
           </a:p>
@@ -2264,7 +3308,7 @@
           <a:p>
             <a:fld id="{5BCAD085-E8A6-8845-BD4E-CB4CCA059FC4}" type="datetimeFigureOut">
               <a:rPr lang="en-US" smtClean="0"/>
-              <a:t>1/27/13</a:t>
+              <a:t>5/26/2026</a:t>
             </a:fld>
             <a:endParaRPr lang="en-US"/>
           </a:p>
@@ -2367,10 +3411,9 @@
           </a:lstStyle>
           <a:p>
             <a:r>
-              <a:rPr lang="en-US" smtClean="0"/>
+              <a:rPr lang="en-US"/>
               <a:t>Click to edit Master title style</a:t>
             </a:r>
-            <a:endParaRPr lang="en-US"/>
           </a:p>
         </p:txBody>
       </p:sp>
@@ -2494,7 +3537,7 @@
           <a:p>
             <a:pPr lvl="0"/>
             <a:r>
-              <a:rPr lang="en-US" smtClean="0"/>
+              <a:rPr lang="en-US"/>
               <a:t>Click to edit Master text styles</a:t>
             </a:r>
           </a:p>
@@ -2517,7 +3560,7 @@
           <a:p>
             <a:fld id="{5BCAD085-E8A6-8845-BD4E-CB4CCA059FC4}" type="datetimeFigureOut">
               <a:rPr lang="en-US" smtClean="0"/>
-              <a:t>1/27/13</a:t>
+              <a:t>5/26/2026</a:t>
             </a:fld>
             <a:endParaRPr lang="en-US"/>
           </a:p>
@@ -2626,10 +3669,9 @@
           <a:lstStyle/>
           <a:p>
             <a:r>
-              <a:rPr lang="en-US" smtClean="0"/>
+              <a:rPr lang="en-US"/>
               <a:t>Click to edit Master title style</a:t>
             </a:r>
-            <a:endParaRPr lang="en-US"/>
           </a:p>
         </p:txBody>
       </p:sp>
@@ -2660,38 +3702,37 @@
           <a:p>
             <a:pPr lvl="0"/>
             <a:r>
-              <a:rPr lang="en-US" smtClean="0"/>
+              <a:rPr lang="en-US"/>
               <a:t>Click to edit Master text styles</a:t>
             </a:r>
           </a:p>
           <a:p>
             <a:pPr lvl="1"/>
             <a:r>
-              <a:rPr lang="en-US" smtClean="0"/>
+              <a:rPr lang="en-US"/>
               <a:t>Second level</a:t>
             </a:r>
           </a:p>
           <a:p>
             <a:pPr lvl="2"/>
             <a:r>
-              <a:rPr lang="en-US" smtClean="0"/>
+              <a:rPr lang="en-US"/>
               <a:t>Third level</a:t>
             </a:r>
           </a:p>
           <a:p>
             <a:pPr lvl="3"/>
             <a:r>
-              <a:rPr lang="en-US" smtClean="0"/>
+              <a:rPr lang="en-US"/>
               <a:t>Fourth level</a:t>
             </a:r>
           </a:p>
           <a:p>
             <a:pPr lvl="4"/>
             <a:r>
-              <a:rPr lang="en-US" smtClean="0"/>
+              <a:rPr lang="en-US"/>
               <a:t>Fifth level</a:t>
             </a:r>
-            <a:endParaRPr lang="en-US"/>
           </a:p>
         </p:txBody>
       </p:sp>
@@ -2730,7 +3771,7 @@
           <a:p>
             <a:fld id="{5BCAD085-E8A6-8845-BD4E-CB4CCA059FC4}" type="datetimeFigureOut">
               <a:rPr lang="en-US" smtClean="0"/>
-              <a:t>1/27/13</a:t>
+              <a:t>5/26/2026</a:t>
             </a:fld>
             <a:endParaRPr lang="en-US"/>
           </a:p>
@@ -3089,7 +4130,7 @@
 </file>
 
 <file path=ppt/slides/slide1.xml><?xml version="1.0" encoding="utf-8"?>
-<p:sld xmlns:a="http://schemas.openxmlformats.org/drawingml/2006/main" xmlns:p="http://schemas.openxmlformats.org/presentationml/2006/main" xmlns:r="http://schemas.openxmlformats.org/officeDocument/2006/relationships">
+<p:sld xmlns:a="http://schemas.openxmlformats.org/drawingml/2006/main" xmlns:r="http://schemas.openxmlformats.org/officeDocument/2006/relationships" xmlns:p="http://schemas.openxmlformats.org/presentationml/2006/main">
   <p:cSld>
     <p:bg>
       <p:bgPr>
@@ -3105,7 +4146,14 @@
         <p:cNvGrpSpPr/>
         <p:nvPr/>
       </p:nvGrpSpPr>
-      <p:grpSpPr/>
+      <p:grpSpPr>
+        <a:xfrm>
+          <a:off x="0" y="0"/>
+          <a:ext cx="0" cy="0"/>
+          <a:chOff x="0" y="0"/>
+          <a:chExt cx="0" cy="0"/>
+        </a:xfrm>
+      </p:grpSpPr>
       <p:sp>
         <p:nvSpPr>
           <p:cNvPr id="2" name="Rounded Rectangle 1"/>
@@ -3146,6 +4194,7 @@
           <a:lstStyle/>
           <a:p>
             <a:pPr algn="ctr"/>
+            <a:endParaRPr/>
           </a:p>
         </p:txBody>
       </p:sp>
@@ -3189,6 +4238,7 @@
           <a:lstStyle/>
           <a:p>
             <a:pPr algn="ctr"/>
+            <a:endParaRPr/>
           </a:p>
         </p:txBody>
       </p:sp>
@@ -3232,6 +4282,7 @@
           <a:lstStyle/>
           <a:p>
             <a:pPr algn="ctr"/>
+            <a:endParaRPr/>
           </a:p>
         </p:txBody>
       </p:sp>
@@ -3314,7 +4365,7 @@
         <p:spPr>
           <a:xfrm>
             <a:off x="713232" y="6199632"/>
-            <a:ext cx="5669280" cy="256032"/>
+            <a:ext cx="6035040" cy="256032"/>
           </a:xfrm>
           <a:prstGeom prst="rect">
             <a:avLst/>
@@ -3335,7 +4386,7 @@
                 </a:solidFill>
                 <a:latin typeface="Aptos"/>
               </a:rPr>
-              <a:t>Final Project | Sabeur Zarai | IronHack</a:t>
+              <a:t>Final Project | Sabeur Zarai | IronHack | Docker + EC2</a:t>
             </a:r>
           </a:p>
         </p:txBody>
@@ -3382,6 +4433,7 @@
           <a:lstStyle/>
           <a:p>
             <a:pPr algn="ctr"/>
+            <a:endParaRPr/>
           </a:p>
         </p:txBody>
       </p:sp>
@@ -3590,7 +4642,7 @@
                 </a:solidFill>
                 <a:latin typeface="Aptos"/>
               </a:rPr>
-              <a:t>Netflix-inspired UI + FastAPI + LangChain + ChromaDB</a:t>
+              <a:t>Netflix-inspired UI + FastAPI + LangChain + ChromaDB + EC2</a:t>
             </a:r>
           </a:p>
         </p:txBody>
@@ -3604,7 +4656,7 @@
 </file>
 
 <file path=ppt/slides/slide10.xml><?xml version="1.0" encoding="utf-8"?>
-<p:sld xmlns:a="http://schemas.openxmlformats.org/drawingml/2006/main" xmlns:p="http://schemas.openxmlformats.org/presentationml/2006/main" xmlns:r="http://schemas.openxmlformats.org/officeDocument/2006/relationships">
+<p:sld xmlns:a="http://schemas.openxmlformats.org/drawingml/2006/main" xmlns:r="http://schemas.openxmlformats.org/officeDocument/2006/relationships" xmlns:p="http://schemas.openxmlformats.org/presentationml/2006/main">
   <p:cSld>
     <p:bg>
       <p:bgPr>
@@ -3620,7 +4672,14 @@
         <p:cNvGrpSpPr/>
         <p:nvPr/>
       </p:nvGrpSpPr>
-      <p:grpSpPr/>
+      <p:grpSpPr>
+        <a:xfrm>
+          <a:off x="0" y="0"/>
+          <a:ext cx="0" cy="0"/>
+          <a:chOff x="0" y="0"/>
+          <a:chExt cx="0" cy="0"/>
+        </a:xfrm>
+      </p:grpSpPr>
       <p:sp>
         <p:nvSpPr>
           <p:cNvPr id="2" name="Rounded Rectangle 1"/>
@@ -3661,6 +4720,7 @@
           <a:lstStyle/>
           <a:p>
             <a:pPr algn="ctr"/>
+            <a:endParaRPr/>
           </a:p>
         </p:txBody>
       </p:sp>
@@ -3704,6 +4764,7 @@
           <a:lstStyle/>
           <a:p>
             <a:pPr algn="ctr"/>
+            <a:endParaRPr/>
           </a:p>
         </p:txBody>
       </p:sp>
@@ -3747,6 +4808,7 @@
           <a:lstStyle/>
           <a:p>
             <a:pPr algn="ctr"/>
+            <a:endParaRPr/>
           </a:p>
         </p:txBody>
       </p:sp>
@@ -3864,7 +4926,7 @@
         <p:spPr>
           <a:xfrm>
             <a:off x="868680" y="1828800"/>
-            <a:ext cx="5577840" cy="3931920"/>
+            <a:ext cx="6409944" cy="4201086"/>
           </a:xfrm>
           <a:prstGeom prst="rect">
             <a:avLst/>
@@ -3886,7 +4948,7 @@
               </a:spcAft>
             </a:pPr>
             <a:r>
-              <a:rPr sz="1700" b="1">
+              <a:rPr sz="1700" b="1" dirty="0">
                 <a:solidFill>
                   <a:srgbClr val="22D3EE"/>
                 </a:solidFill>
@@ -3895,13 +4957,13 @@
               <a:t>- </a:t>
             </a:r>
             <a:r>
-              <a:rPr sz="1700">
+              <a:rPr sz="1700" dirty="0">
                 <a:solidFill>
                   <a:srgbClr val="F6F8FF"/>
                 </a:solidFill>
                 <a:latin typeface="Aptos"/>
               </a:rPr>
-              <a:t>Open localhost:3000 and search: python tutorial for beginners.</a:t>
+              <a:t>Open localhost:3000 for the full RAG demo, or EC2 :3001 to show deployment.</a:t>
             </a:r>
           </a:p>
           <a:p>
@@ -3914,7 +4976,7 @@
               </a:spcAft>
             </a:pPr>
             <a:r>
-              <a:rPr sz="1700" b="1">
+              <a:rPr sz="1700" b="1" dirty="0">
                 <a:solidFill>
                   <a:srgbClr val="22D3EE"/>
                 </a:solidFill>
@@ -3923,13 +4985,13 @@
               <a:t>- </a:t>
             </a:r>
             <a:r>
-              <a:rPr sz="1700">
+              <a:rPr sz="1700" dirty="0">
                 <a:solidFill>
                   <a:srgbClr val="F6F8FF"/>
                 </a:solidFill>
                 <a:latin typeface="Aptos"/>
               </a:rPr>
-              <a:t>Pick a video and click Prepare to show real ingestion progress.</a:t>
+              <a:t>Search with a duration filter, for example: python tutorial for beginners under 10 minutes.</a:t>
             </a:r>
           </a:p>
           <a:p>
@@ -3942,7 +5004,7 @@
               </a:spcAft>
             </a:pPr>
             <a:r>
-              <a:rPr sz="1700" b="1">
+              <a:rPr sz="1700" b="1" dirty="0">
                 <a:solidFill>
                   <a:srgbClr val="22D3EE"/>
                 </a:solidFill>
@@ -3951,13 +5013,13 @@
               <a:t>- </a:t>
             </a:r>
             <a:r>
-              <a:rPr sz="1700">
+              <a:rPr sz="1700" dirty="0">
                 <a:solidFill>
                   <a:srgbClr val="F6F8FF"/>
                 </a:solidFill>
                 <a:latin typeface="Aptos"/>
               </a:rPr>
-              <a:t>Ask: What is Python used for?</a:t>
+              <a:t>Pick a video and click Prepare to show real ingestion progress.</a:t>
             </a:r>
           </a:p>
           <a:p>
@@ -3970,7 +5032,7 @@
               </a:spcAft>
             </a:pPr>
             <a:r>
-              <a:rPr sz="1700" b="1">
+              <a:rPr sz="1700" b="1" dirty="0">
                 <a:solidFill>
                   <a:srgbClr val="22D3EE"/>
                 </a:solidFill>
@@ -3979,13 +5041,13 @@
               <a:t>- </a:t>
             </a:r>
             <a:r>
-              <a:rPr sz="1700">
+              <a:rPr sz="1700" dirty="0">
                 <a:solidFill>
                   <a:srgbClr val="F6F8FF"/>
                 </a:solidFill>
                 <a:latin typeface="Aptos"/>
               </a:rPr>
-              <a:t>Show timestamp citations and the tool breadcrumb.</a:t>
+              <a:t>Ask: What is Python used for?</a:t>
             </a:r>
           </a:p>
           <a:p>
@@ -3998,7 +5060,7 @@
               </a:spcAft>
             </a:pPr>
             <a:r>
-              <a:rPr sz="1700" b="1">
+              <a:rPr sz="1700" b="1" dirty="0">
                 <a:solidFill>
                   <a:srgbClr val="22D3EE"/>
                 </a:solidFill>
@@ -4007,13 +5069,13 @@
               <a:t>- </a:t>
             </a:r>
             <a:r>
-              <a:rPr sz="1700">
+              <a:rPr sz="1700" dirty="0">
                 <a:solidFill>
                   <a:srgbClr val="F6F8FF"/>
                 </a:solidFill>
                 <a:latin typeface="Aptos"/>
               </a:rPr>
-              <a:t>Ask a follow-up to demonstrate memory.</a:t>
+              <a:t>Show timestamp citations and the tool breadcrumb.</a:t>
             </a:r>
           </a:p>
           <a:p>
@@ -4026,7 +5088,7 @@
               </a:spcAft>
             </a:pPr>
             <a:r>
-              <a:rPr sz="1700" b="1">
+              <a:rPr sz="1700" b="1" dirty="0">
                 <a:solidFill>
                   <a:srgbClr val="22D3EE"/>
                 </a:solidFill>
@@ -4035,13 +5097,13 @@
               <a:t>- </a:t>
             </a:r>
             <a:r>
-              <a:rPr sz="1700">
+              <a:rPr sz="1700" dirty="0">
                 <a:solidFill>
                   <a:srgbClr val="F6F8FF"/>
                 </a:solidFill>
                 <a:latin typeface="Aptos"/>
               </a:rPr>
-              <a:t>Ask an unrelated question to show refusal behavior.</a:t>
+              <a:t>Ask a follow-up to demonstrate memory.</a:t>
             </a:r>
           </a:p>
           <a:p>
@@ -4054,7 +5116,7 @@
               </a:spcAft>
             </a:pPr>
             <a:r>
-              <a:rPr sz="1700" b="1">
+              <a:rPr sz="1700" b="1" dirty="0">
                 <a:solidFill>
                   <a:srgbClr val="22D3EE"/>
                 </a:solidFill>
@@ -4063,13 +5125,69 @@
               <a:t>- </a:t>
             </a:r>
             <a:r>
-              <a:rPr sz="1700">
+              <a:rPr sz="1700" dirty="0">
                 <a:solidFill>
                   <a:srgbClr val="F6F8FF"/>
                 </a:solidFill>
                 <a:latin typeface="Aptos"/>
               </a:rPr>
+              <a:t>Ask an unrelated question to show refusal behavior.</a:t>
+            </a:r>
+          </a:p>
+          <a:p>
+            <a:pPr>
+              <a:lnSpc>
+                <a:spcPct val="105000"/>
+              </a:lnSpc>
+              <a:spcAft>
+                <a:spcPts val="800"/>
+              </a:spcAft>
+            </a:pPr>
+            <a:r>
+              <a:rPr sz="1700" b="1" dirty="0">
+                <a:solidFill>
+                  <a:srgbClr val="22D3EE"/>
+                </a:solidFill>
+                <a:latin typeface="Aptos"/>
+              </a:rPr>
+              <a:t>- </a:t>
+            </a:r>
+            <a:r>
+              <a:rPr sz="1700" dirty="0">
+                <a:solidFill>
+                  <a:srgbClr val="F6F8FF"/>
+                </a:solidFill>
+                <a:latin typeface="Aptos"/>
+              </a:rPr>
               <a:t>Use mic input and Read aloud if time allows.</a:t>
+            </a:r>
+          </a:p>
+          <a:p>
+            <a:pPr>
+              <a:lnSpc>
+                <a:spcPct val="105000"/>
+              </a:lnSpc>
+              <a:spcAft>
+                <a:spcPts val="800"/>
+              </a:spcAft>
+            </a:pPr>
+            <a:r>
+              <a:rPr sz="1700" b="1" dirty="0">
+                <a:solidFill>
+                  <a:srgbClr val="22D3EE"/>
+                </a:solidFill>
+                <a:latin typeface="Aptos"/>
+              </a:rPr>
+              <a:t>- </a:t>
+            </a:r>
+            <a:r>
+              <a:rPr sz="1700" dirty="0">
+                <a:solidFill>
+                  <a:srgbClr val="F6F8FF"/>
+                </a:solidFill>
+                <a:latin typeface="Aptos"/>
+              </a:rPr>
+              <a:t>Show EC2 health endpoint and explain the YouTube cloud-IP transcript limitation.</a:t>
             </a:r>
           </a:p>
         </p:txBody>
@@ -4116,6 +5234,7 @@
           <a:lstStyle/>
           <a:p>
             <a:pPr algn="ctr"/>
+            <a:endParaRPr/>
           </a:p>
         </p:txBody>
       </p:sp>
@@ -4197,8 +5316,8 @@
         </p:nvSpPr>
         <p:spPr>
           <a:xfrm>
-            <a:off x="7662672" y="4480560"/>
-            <a:ext cx="2834640" cy="502920"/>
+            <a:off x="7662672" y="4251960"/>
+            <a:ext cx="2834640" cy="822960"/>
           </a:xfrm>
           <a:prstGeom prst="rect">
             <a:avLst/>
@@ -4213,13 +5332,13 @@
           <a:p>
             <a:pPr algn="l"/>
             <a:r>
-              <a:rPr sz="1200" b="0">
+              <a:rPr sz="1100" b="0">
                 <a:solidFill>
                   <a:srgbClr val="94A3B8"/>
                 </a:solidFill>
                 <a:latin typeface="Aptos"/>
               </a:rPr>
-              <a:t>Keep the demo focused on trust: every answer links back to the video.</a:t>
+              <a:t>Keep the demo focused on trust: every answer links back to the video. EC2 proves deployment; local run proves full transcript access when YouTube blocks cloud IPs.</a:t>
             </a:r>
           </a:p>
         </p:txBody>
@@ -4233,7 +5352,7 @@
 </file>
 
 <file path=ppt/slides/slide11.xml><?xml version="1.0" encoding="utf-8"?>
-<p:sld xmlns:a="http://schemas.openxmlformats.org/drawingml/2006/main" xmlns:p="http://schemas.openxmlformats.org/presentationml/2006/main" xmlns:r="http://schemas.openxmlformats.org/officeDocument/2006/relationships">
+<p:sld xmlns:a="http://schemas.openxmlformats.org/drawingml/2006/main" xmlns:r="http://schemas.openxmlformats.org/officeDocument/2006/relationships" xmlns:p="http://schemas.openxmlformats.org/presentationml/2006/main">
   <p:cSld>
     <p:bg>
       <p:bgPr>
@@ -4249,7 +5368,14 @@
         <p:cNvGrpSpPr/>
         <p:nvPr/>
       </p:nvGrpSpPr>
-      <p:grpSpPr/>
+      <p:grpSpPr>
+        <a:xfrm>
+          <a:off x="0" y="0"/>
+          <a:ext cx="0" cy="0"/>
+          <a:chOff x="0" y="0"/>
+          <a:chExt cx="0" cy="0"/>
+        </a:xfrm>
+      </p:grpSpPr>
       <p:sp>
         <p:nvSpPr>
           <p:cNvPr id="2" name="Rounded Rectangle 1"/>
@@ -4290,6 +5416,7 @@
           <a:lstStyle/>
           <a:p>
             <a:pPr algn="ctr"/>
+            <a:endParaRPr/>
           </a:p>
         </p:txBody>
       </p:sp>
@@ -4333,6 +5460,7 @@
           <a:lstStyle/>
           <a:p>
             <a:pPr algn="ctr"/>
+            <a:endParaRPr/>
           </a:p>
         </p:txBody>
       </p:sp>
@@ -4376,6 +5504,7 @@
           <a:lstStyle/>
           <a:p>
             <a:pPr algn="ctr"/>
+            <a:endParaRPr/>
           </a:p>
         </p:txBody>
       </p:sp>
@@ -4457,8 +5586,8 @@
         </p:nvSpPr>
         <p:spPr>
           <a:xfrm>
-            <a:off x="777240" y="3749039"/>
-            <a:ext cx="3474720" cy="1234440"/>
+            <a:off x="777240" y="3227831"/>
+            <a:ext cx="3474720" cy="1581910"/>
           </a:xfrm>
           <a:prstGeom prst="roundRect">
             <a:avLst/>
@@ -4491,6 +5620,7 @@
           <a:lstStyle/>
           <a:p>
             <a:pPr algn="ctr"/>
+            <a:endParaRPr/>
           </a:p>
         </p:txBody>
       </p:sp>
@@ -4502,7 +5632,7 @@
         </p:nvSpPr>
         <p:spPr>
           <a:xfrm>
-            <a:off x="777240" y="3749039"/>
+            <a:off x="777240" y="3227831"/>
             <a:ext cx="73152" cy="1234440"/>
           </a:xfrm>
           <a:prstGeom prst="rect">
@@ -4534,6 +5664,7 @@
           <a:lstStyle/>
           <a:p>
             <a:pPr algn="ctr"/>
+            <a:endParaRPr/>
           </a:p>
         </p:txBody>
       </p:sp>
@@ -4545,7 +5676,7 @@
         </p:nvSpPr>
         <p:spPr>
           <a:xfrm>
-            <a:off x="978408" y="3913631"/>
+            <a:off x="978408" y="3392423"/>
             <a:ext cx="3154679" cy="228600"/>
           </a:xfrm>
           <a:prstGeom prst="rect">
@@ -4580,7 +5711,7 @@
         </p:nvSpPr>
         <p:spPr>
           <a:xfrm>
-            <a:off x="978408" y="4251959"/>
+            <a:off x="978408" y="3730751"/>
             <a:ext cx="3154679" cy="594360"/>
           </a:xfrm>
           <a:prstGeom prst="rect">
@@ -4615,8 +5746,8 @@
         </p:nvSpPr>
         <p:spPr>
           <a:xfrm>
-            <a:off x="4526280" y="3749039"/>
-            <a:ext cx="3474720" cy="1234440"/>
+            <a:off x="4526280" y="3227830"/>
+            <a:ext cx="3474720" cy="1581911"/>
           </a:xfrm>
           <a:prstGeom prst="roundRect">
             <a:avLst/>
@@ -4649,6 +5780,7 @@
           <a:lstStyle/>
           <a:p>
             <a:pPr algn="ctr"/>
+            <a:endParaRPr/>
           </a:p>
         </p:txBody>
       </p:sp>
@@ -4660,7 +5792,7 @@
         </p:nvSpPr>
         <p:spPr>
           <a:xfrm>
-            <a:off x="4526280" y="3749039"/>
+            <a:off x="4526280" y="3227831"/>
             <a:ext cx="73152" cy="1234440"/>
           </a:xfrm>
           <a:prstGeom prst="rect">
@@ -4692,6 +5824,7 @@
           <a:lstStyle/>
           <a:p>
             <a:pPr algn="ctr"/>
+            <a:endParaRPr/>
           </a:p>
         </p:txBody>
       </p:sp>
@@ -4703,7 +5836,7 @@
         </p:nvSpPr>
         <p:spPr>
           <a:xfrm>
-            <a:off x="4727448" y="3913631"/>
+            <a:off x="4727448" y="3392423"/>
             <a:ext cx="3154679" cy="228600"/>
           </a:xfrm>
           <a:prstGeom prst="rect">
@@ -4738,7 +5871,7 @@
         </p:nvSpPr>
         <p:spPr>
           <a:xfrm>
-            <a:off x="4727448" y="4251959"/>
+            <a:off x="4727448" y="3730751"/>
             <a:ext cx="3154679" cy="594360"/>
           </a:xfrm>
           <a:prstGeom prst="rect">
@@ -4773,8 +5906,8 @@
         </p:nvSpPr>
         <p:spPr>
           <a:xfrm>
-            <a:off x="8275320" y="3749039"/>
-            <a:ext cx="3108960" cy="1234440"/>
+            <a:off x="8275320" y="3227831"/>
+            <a:ext cx="3108960" cy="1609346"/>
           </a:xfrm>
           <a:prstGeom prst="roundRect">
             <a:avLst/>
@@ -4807,6 +5940,7 @@
           <a:lstStyle/>
           <a:p>
             <a:pPr algn="ctr"/>
+            <a:endParaRPr/>
           </a:p>
         </p:txBody>
       </p:sp>
@@ -4818,7 +5952,7 @@
         </p:nvSpPr>
         <p:spPr>
           <a:xfrm>
-            <a:off x="8275320" y="3749039"/>
+            <a:off x="8275320" y="3227831"/>
             <a:ext cx="73152" cy="1234440"/>
           </a:xfrm>
           <a:prstGeom prst="rect">
@@ -4850,6 +5984,7 @@
           <a:lstStyle/>
           <a:p>
             <a:pPr algn="ctr"/>
+            <a:endParaRPr/>
           </a:p>
         </p:txBody>
       </p:sp>
@@ -4861,7 +5996,7 @@
         </p:nvSpPr>
         <p:spPr>
           <a:xfrm>
-            <a:off x="8476488" y="3913631"/>
+            <a:off x="8476488" y="3392423"/>
             <a:ext cx="2788920" cy="228600"/>
           </a:xfrm>
           <a:prstGeom prst="rect">
@@ -4896,7 +6031,7 @@
         </p:nvSpPr>
         <p:spPr>
           <a:xfrm>
-            <a:off x="8476488" y="4251959"/>
+            <a:off x="8476488" y="3730751"/>
             <a:ext cx="2788920" cy="594360"/>
           </a:xfrm>
           <a:prstGeom prst="rect">
@@ -4912,13 +6047,13 @@
           <a:p>
             <a:pPr algn="l"/>
             <a:r>
-              <a:rPr sz="1400" b="0">
+              <a:rPr sz="1400" b="0" dirty="0">
                 <a:solidFill>
                   <a:srgbClr val="F6F8FF"/>
                 </a:solidFill>
                 <a:latin typeface="Aptos"/>
               </a:rPr>
-              <a:t>Persistent memory, streaming agent responses, user accounts, multi-video comparison, and hosted deployment.</a:t>
+              <a:t>Persistent user accounts, multi-video comparison, HTTPS custom domain, and a stronger production transcript proxy.</a:t>
             </a:r>
           </a:p>
         </p:txBody>
@@ -4931,8 +6066,8 @@
         </p:nvSpPr>
         <p:spPr>
           <a:xfrm>
-            <a:off x="777240" y="6144768"/>
-            <a:ext cx="2743200" cy="274320"/>
+            <a:off x="3154680" y="5486400"/>
+            <a:ext cx="2743200" cy="307777"/>
           </a:xfrm>
           <a:prstGeom prst="rect">
             <a:avLst/>
@@ -4947,7 +6082,7 @@
           <a:p>
             <a:pPr algn="l"/>
             <a:r>
-              <a:rPr sz="1400" b="1">
+              <a:rPr sz="1400" b="1" dirty="0">
                 <a:solidFill>
                   <a:srgbClr val="94A3B8"/>
                 </a:solidFill>
@@ -4955,6 +6090,21 @@
               </a:rPr>
               <a:t>Thank you</a:t>
             </a:r>
+            <a:r>
+              <a:rPr lang="de-DE" sz="1400" b="1" dirty="0">
+                <a:solidFill>
+                  <a:srgbClr val="94A3B8"/>
+                </a:solidFill>
+                <a:latin typeface="Aptos"/>
+              </a:rPr>
+              <a:t>!</a:t>
+            </a:r>
+            <a:endParaRPr sz="1400" b="1" dirty="0">
+              <a:solidFill>
+                <a:srgbClr val="94A3B8"/>
+              </a:solidFill>
+              <a:latin typeface="Aptos"/>
+            </a:endParaRPr>
           </a:p>
         </p:txBody>
       </p:sp>
@@ -4967,7 +6117,7 @@
 </file>
 
 <file path=ppt/slides/slide2.xml><?xml version="1.0" encoding="utf-8"?>
-<p:sld xmlns:a="http://schemas.openxmlformats.org/drawingml/2006/main" xmlns:p="http://schemas.openxmlformats.org/presentationml/2006/main" xmlns:r="http://schemas.openxmlformats.org/officeDocument/2006/relationships">
+<p:sld xmlns:a="http://schemas.openxmlformats.org/drawingml/2006/main" xmlns:r="http://schemas.openxmlformats.org/officeDocument/2006/relationships" xmlns:p="http://schemas.openxmlformats.org/presentationml/2006/main">
   <p:cSld>
     <p:bg>
       <p:bgPr>
@@ -4983,7 +6133,14 @@
         <p:cNvGrpSpPr/>
         <p:nvPr/>
       </p:nvGrpSpPr>
-      <p:grpSpPr/>
+      <p:grpSpPr>
+        <a:xfrm>
+          <a:off x="0" y="0"/>
+          <a:ext cx="0" cy="0"/>
+          <a:chOff x="0" y="0"/>
+          <a:chExt cx="0" cy="0"/>
+        </a:xfrm>
+      </p:grpSpPr>
       <p:sp>
         <p:nvSpPr>
           <p:cNvPr id="2" name="Rounded Rectangle 1"/>
@@ -5024,6 +6181,7 @@
           <a:lstStyle/>
           <a:p>
             <a:pPr algn="ctr"/>
+            <a:endParaRPr/>
           </a:p>
         </p:txBody>
       </p:sp>
@@ -5067,6 +6225,7 @@
           <a:lstStyle/>
           <a:p>
             <a:pPr algn="ctr"/>
+            <a:endParaRPr/>
           </a:p>
         </p:txBody>
       </p:sp>
@@ -5110,6 +6269,7 @@
           <a:lstStyle/>
           <a:p>
             <a:pPr algn="ctr"/>
+            <a:endParaRPr/>
           </a:p>
         </p:txBody>
       </p:sp>
@@ -5192,7 +6352,7 @@
         <p:spPr>
           <a:xfrm>
             <a:off x="594360" y="1051560"/>
-            <a:ext cx="7863840" cy="685800"/>
+            <a:ext cx="7086600" cy="1138773"/>
           </a:xfrm>
           <a:prstGeom prst="rect">
             <a:avLst/>
@@ -5207,7 +6367,7 @@
           <a:p>
             <a:pPr algn="l"/>
             <a:r>
-              <a:rPr sz="3400" b="1">
+              <a:rPr sz="3400" b="1" dirty="0">
                 <a:solidFill>
                   <a:srgbClr val="F6F8FF"/>
                 </a:solidFill>
@@ -5226,7 +6386,7 @@
         </p:nvSpPr>
         <p:spPr>
           <a:xfrm>
-            <a:off x="621792" y="1828800"/>
+            <a:off x="621792" y="2121408"/>
             <a:ext cx="7315200" cy="411480"/>
           </a:xfrm>
           <a:prstGeom prst="rect">
@@ -5242,13 +6402,22 @@
           <a:p>
             <a:pPr algn="l"/>
             <a:r>
-              <a:rPr sz="1800" b="0">
+              <a:rPr sz="1800" b="0" dirty="0" err="1">
                 <a:solidFill>
                   <a:srgbClr val="22D3EE"/>
                 </a:solidFill>
                 <a:latin typeface="Aptos"/>
               </a:rPr>
-              <a:t>AskTube AI turns a video into a searchable, conversational knowledge base.</a:t>
+              <a:t>AskTube</a:t>
+            </a:r>
+            <a:r>
+              <a:rPr sz="1800" b="0" dirty="0">
+                <a:solidFill>
+                  <a:srgbClr val="22D3EE"/>
+                </a:solidFill>
+                <a:latin typeface="Aptos"/>
+              </a:rPr>
+              <a:t> AI turns a video into a searchable, conversational knowledge base.</a:t>
             </a:r>
           </a:p>
         </p:txBody>
@@ -5261,7 +6430,7 @@
         </p:nvSpPr>
         <p:spPr>
           <a:xfrm>
-            <a:off x="658368" y="2743200"/>
+            <a:off x="658368" y="3035808"/>
             <a:ext cx="3246120" cy="1737360"/>
           </a:xfrm>
           <a:prstGeom prst="roundRect">
@@ -5295,6 +6464,7 @@
           <a:lstStyle/>
           <a:p>
             <a:pPr algn="ctr"/>
+            <a:endParaRPr/>
           </a:p>
         </p:txBody>
       </p:sp>
@@ -5306,7 +6476,7 @@
         </p:nvSpPr>
         <p:spPr>
           <a:xfrm>
-            <a:off x="658368" y="2743200"/>
+            <a:off x="658368" y="3035808"/>
             <a:ext cx="73152" cy="1737360"/>
           </a:xfrm>
           <a:prstGeom prst="rect">
@@ -5338,6 +6508,7 @@
           <a:lstStyle/>
           <a:p>
             <a:pPr algn="ctr"/>
+            <a:endParaRPr/>
           </a:p>
         </p:txBody>
       </p:sp>
@@ -5349,7 +6520,7 @@
         </p:nvSpPr>
         <p:spPr>
           <a:xfrm>
-            <a:off x="859536" y="2907792"/>
+            <a:off x="859536" y="3200400"/>
             <a:ext cx="2926079" cy="228600"/>
           </a:xfrm>
           <a:prstGeom prst="rect">
@@ -5384,7 +6555,7 @@
         </p:nvSpPr>
         <p:spPr>
           <a:xfrm>
-            <a:off x="859536" y="3246120"/>
+            <a:off x="859536" y="3538728"/>
             <a:ext cx="2926079" cy="1097280"/>
           </a:xfrm>
           <a:prstGeom prst="rect">
@@ -5419,7 +6590,7 @@
         </p:nvSpPr>
         <p:spPr>
           <a:xfrm>
-            <a:off x="4160520" y="2743200"/>
+            <a:off x="4160520" y="3035808"/>
             <a:ext cx="3246120" cy="1737360"/>
           </a:xfrm>
           <a:prstGeom prst="roundRect">
@@ -5453,6 +6624,7 @@
           <a:lstStyle/>
           <a:p>
             <a:pPr algn="ctr"/>
+            <a:endParaRPr/>
           </a:p>
         </p:txBody>
       </p:sp>
@@ -5464,7 +6636,7 @@
         </p:nvSpPr>
         <p:spPr>
           <a:xfrm>
-            <a:off x="4160520" y="2743200"/>
+            <a:off x="4160520" y="3035808"/>
             <a:ext cx="73152" cy="1737360"/>
           </a:xfrm>
           <a:prstGeom prst="rect">
@@ -5496,6 +6668,7 @@
           <a:lstStyle/>
           <a:p>
             <a:pPr algn="ctr"/>
+            <a:endParaRPr/>
           </a:p>
         </p:txBody>
       </p:sp>
@@ -5507,7 +6680,7 @@
         </p:nvSpPr>
         <p:spPr>
           <a:xfrm>
-            <a:off x="4361688" y="2907792"/>
+            <a:off x="4361688" y="3200400"/>
             <a:ext cx="2926079" cy="228600"/>
           </a:xfrm>
           <a:prstGeom prst="rect">
@@ -5542,7 +6715,7 @@
         </p:nvSpPr>
         <p:spPr>
           <a:xfrm>
-            <a:off x="4361688" y="3246120"/>
+            <a:off x="4361688" y="3538728"/>
             <a:ext cx="2926079" cy="1097280"/>
           </a:xfrm>
           <a:prstGeom prst="rect">
@@ -5577,7 +6750,7 @@
         </p:nvSpPr>
         <p:spPr>
           <a:xfrm>
-            <a:off x="7662672" y="2743200"/>
+            <a:off x="7662672" y="3035808"/>
             <a:ext cx="3246120" cy="1737360"/>
           </a:xfrm>
           <a:prstGeom prst="roundRect">
@@ -5611,6 +6784,7 @@
           <a:lstStyle/>
           <a:p>
             <a:pPr algn="ctr"/>
+            <a:endParaRPr/>
           </a:p>
         </p:txBody>
       </p:sp>
@@ -5622,7 +6796,7 @@
         </p:nvSpPr>
         <p:spPr>
           <a:xfrm>
-            <a:off x="7662672" y="2743200"/>
+            <a:off x="7662672" y="3035808"/>
             <a:ext cx="73152" cy="1737360"/>
           </a:xfrm>
           <a:prstGeom prst="rect">
@@ -5654,6 +6828,7 @@
           <a:lstStyle/>
           <a:p>
             <a:pPr algn="ctr"/>
+            <a:endParaRPr/>
           </a:p>
         </p:txBody>
       </p:sp>
@@ -5665,7 +6840,7 @@
         </p:nvSpPr>
         <p:spPr>
           <a:xfrm>
-            <a:off x="7863840" y="2907792"/>
+            <a:off x="7863840" y="3200400"/>
             <a:ext cx="2926079" cy="228600"/>
           </a:xfrm>
           <a:prstGeom prst="rect">
@@ -5700,7 +6875,7 @@
         </p:nvSpPr>
         <p:spPr>
           <a:xfrm>
-            <a:off x="7863840" y="3246120"/>
+            <a:off x="7863840" y="3538728"/>
             <a:ext cx="2926079" cy="1097280"/>
           </a:xfrm>
           <a:prstGeom prst="rect">
@@ -5736,7 +6911,7 @@
 </file>
 
 <file path=ppt/slides/slide3.xml><?xml version="1.0" encoding="utf-8"?>
-<p:sld xmlns:a="http://schemas.openxmlformats.org/drawingml/2006/main" xmlns:p="http://schemas.openxmlformats.org/presentationml/2006/main" xmlns:r="http://schemas.openxmlformats.org/officeDocument/2006/relationships">
+<p:sld xmlns:a="http://schemas.openxmlformats.org/drawingml/2006/main" xmlns:r="http://schemas.openxmlformats.org/officeDocument/2006/relationships" xmlns:p="http://schemas.openxmlformats.org/presentationml/2006/main">
   <p:cSld>
     <p:bg>
       <p:bgPr>
@@ -5752,7 +6927,14 @@
         <p:cNvGrpSpPr/>
         <p:nvPr/>
       </p:nvGrpSpPr>
-      <p:grpSpPr/>
+      <p:grpSpPr>
+        <a:xfrm>
+          <a:off x="0" y="0"/>
+          <a:ext cx="0" cy="0"/>
+          <a:chOff x="0" y="0"/>
+          <a:chExt cx="0" cy="0"/>
+        </a:xfrm>
+      </p:grpSpPr>
       <p:sp>
         <p:nvSpPr>
           <p:cNvPr id="2" name="Rounded Rectangle 1"/>
@@ -5793,6 +6975,7 @@
           <a:lstStyle/>
           <a:p>
             <a:pPr algn="ctr"/>
+            <a:endParaRPr/>
           </a:p>
         </p:txBody>
       </p:sp>
@@ -5836,6 +7019,7 @@
           <a:lstStyle/>
           <a:p>
             <a:pPr algn="ctr"/>
+            <a:endParaRPr/>
           </a:p>
         </p:txBody>
       </p:sp>
@@ -5879,6 +7063,7 @@
           <a:lstStyle/>
           <a:p>
             <a:pPr algn="ctr"/>
+            <a:endParaRPr/>
           </a:p>
         </p:txBody>
       </p:sp>
@@ -5961,7 +7146,7 @@
         <p:spPr>
           <a:xfrm>
             <a:off x="594360" y="914400"/>
-            <a:ext cx="5486400" cy="548640"/>
+            <a:ext cx="6364224" cy="615553"/>
           </a:xfrm>
           <a:prstGeom prst="rect">
             <a:avLst/>
@@ -5976,7 +7161,7 @@
           <a:p>
             <a:pPr algn="l"/>
             <a:r>
-              <a:rPr sz="3400" b="1">
+              <a:rPr sz="3400" b="1" dirty="0">
                 <a:solidFill>
                   <a:srgbClr val="F6F8FF"/>
                 </a:solidFill>
@@ -6029,6 +7214,7 @@
           <a:lstStyle/>
           <a:p>
             <a:pPr algn="ctr"/>
+            <a:endParaRPr/>
           </a:p>
         </p:txBody>
       </p:sp>
@@ -6072,6 +7258,7 @@
           <a:lstStyle/>
           <a:p>
             <a:pPr algn="ctr"/>
+            <a:endParaRPr/>
           </a:p>
         </p:txBody>
       </p:sp>
@@ -6222,6 +7409,7 @@
           <a:lstStyle/>
           <a:p>
             <a:pPr algn="ctr"/>
+            <a:endParaRPr/>
           </a:p>
         </p:txBody>
       </p:sp>
@@ -6265,6 +7453,7 @@
           <a:lstStyle/>
           <a:p>
             <a:pPr algn="ctr"/>
+            <a:endParaRPr/>
           </a:p>
         </p:txBody>
       </p:sp>
@@ -6415,6 +7604,7 @@
           <a:lstStyle/>
           <a:p>
             <a:pPr algn="ctr"/>
+            <a:endParaRPr/>
           </a:p>
         </p:txBody>
       </p:sp>
@@ -6458,6 +7648,7 @@
           <a:lstStyle/>
           <a:p>
             <a:pPr algn="ctr"/>
+            <a:endParaRPr/>
           </a:p>
         </p:txBody>
       </p:sp>
@@ -6608,6 +7799,7 @@
           <a:lstStyle/>
           <a:p>
             <a:pPr algn="ctr"/>
+            <a:endParaRPr/>
           </a:p>
         </p:txBody>
       </p:sp>
@@ -6651,6 +7843,7 @@
           <a:lstStyle/>
           <a:p>
             <a:pPr algn="ctr"/>
+            <a:endParaRPr/>
           </a:p>
         </p:txBody>
       </p:sp>
@@ -6713,7 +7906,7 @@
           <a:p>
             <a:pPr algn="l"/>
             <a:r>
-              <a:rPr sz="1200" b="1">
+              <a:rPr sz="1200" b="1" dirty="0">
                 <a:solidFill>
                   <a:srgbClr val="F6F8FF"/>
                 </a:solidFill>
@@ -6888,13 +8081,13 @@
           <a:p>
             <a:pPr algn="l"/>
             <a:r>
-              <a:rPr sz="1800" b="0">
+              <a:rPr sz="1700" b="0" dirty="0">
                 <a:solidFill>
                   <a:srgbClr val="94A3B8"/>
                 </a:solidFill>
                 <a:latin typeface="Aptos"/>
               </a:rPr>
-              <a:t>The UI is intentionally cinematic: dark mode, glass surfaces, smooth transitions, a 3D assistant, and graceful loading/error states.</a:t>
+              <a:t>The UI is intentionally cinematic: dark mode, glass surfaces, duration filters, smooth transitions, a 3D assistant, and graceful loading/error states.</a:t>
             </a:r>
           </a:p>
         </p:txBody>
@@ -6908,7 +8101,7 @@
 </file>
 
 <file path=ppt/slides/slide4.xml><?xml version="1.0" encoding="utf-8"?>
-<p:sld xmlns:a="http://schemas.openxmlformats.org/drawingml/2006/main" xmlns:p="http://schemas.openxmlformats.org/presentationml/2006/main" xmlns:r="http://schemas.openxmlformats.org/officeDocument/2006/relationships">
+<p:sld xmlns:a="http://schemas.openxmlformats.org/drawingml/2006/main" xmlns:r="http://schemas.openxmlformats.org/officeDocument/2006/relationships" xmlns:p="http://schemas.openxmlformats.org/presentationml/2006/main">
   <p:cSld>
     <p:bg>
       <p:bgPr>
@@ -6924,7 +8117,14 @@
         <p:cNvGrpSpPr/>
         <p:nvPr/>
       </p:nvGrpSpPr>
-      <p:grpSpPr/>
+      <p:grpSpPr>
+        <a:xfrm>
+          <a:off x="0" y="0"/>
+          <a:ext cx="0" cy="0"/>
+          <a:chOff x="0" y="0"/>
+          <a:chExt cx="0" cy="0"/>
+        </a:xfrm>
+      </p:grpSpPr>
       <p:sp>
         <p:nvSpPr>
           <p:cNvPr id="2" name="Rounded Rectangle 1"/>
@@ -6965,6 +8165,7 @@
           <a:lstStyle/>
           <a:p>
             <a:pPr algn="ctr"/>
+            <a:endParaRPr/>
           </a:p>
         </p:txBody>
       </p:sp>
@@ -7008,6 +8209,7 @@
           <a:lstStyle/>
           <a:p>
             <a:pPr algn="ctr"/>
+            <a:endParaRPr/>
           </a:p>
         </p:txBody>
       </p:sp>
@@ -7051,6 +8253,7 @@
           <a:lstStyle/>
           <a:p>
             <a:pPr algn="ctr"/>
+            <a:endParaRPr/>
           </a:p>
         </p:txBody>
       </p:sp>
@@ -7201,6 +8404,7 @@
           <a:lstStyle/>
           <a:p>
             <a:pPr algn="ctr"/>
+            <a:endParaRPr/>
           </a:p>
         </p:txBody>
       </p:sp>
@@ -7244,6 +8448,7 @@
           <a:lstStyle/>
           <a:p>
             <a:pPr algn="ctr"/>
+            <a:endParaRPr/>
           </a:p>
         </p:txBody>
       </p:sp>
@@ -7359,6 +8564,7 @@
           <a:lstStyle/>
           <a:p>
             <a:pPr algn="ctr"/>
+            <a:endParaRPr/>
           </a:p>
         </p:txBody>
       </p:sp>
@@ -7402,6 +8608,7 @@
           <a:lstStyle/>
           <a:p>
             <a:pPr algn="ctr"/>
+            <a:endParaRPr/>
           </a:p>
         </p:txBody>
       </p:sp>
@@ -7517,6 +8724,7 @@
           <a:lstStyle/>
           <a:p>
             <a:pPr algn="ctr"/>
+            <a:endParaRPr/>
           </a:p>
         </p:txBody>
       </p:sp>
@@ -7560,6 +8768,7 @@
           <a:lstStyle/>
           <a:p>
             <a:pPr algn="ctr"/>
+            <a:endParaRPr/>
           </a:p>
         </p:txBody>
       </p:sp>
@@ -7747,7 +8956,7 @@
 </file>
 
 <file path=ppt/slides/slide5.xml><?xml version="1.0" encoding="utf-8"?>
-<p:sld xmlns:a="http://schemas.openxmlformats.org/drawingml/2006/main" xmlns:p="http://schemas.openxmlformats.org/presentationml/2006/main" xmlns:r="http://schemas.openxmlformats.org/officeDocument/2006/relationships">
+<p:sld xmlns:a="http://schemas.openxmlformats.org/drawingml/2006/main" xmlns:r="http://schemas.openxmlformats.org/officeDocument/2006/relationships" xmlns:p="http://schemas.openxmlformats.org/presentationml/2006/main">
   <p:cSld>
     <p:bg>
       <p:bgPr>
@@ -7763,7 +8972,14 @@
         <p:cNvGrpSpPr/>
         <p:nvPr/>
       </p:nvGrpSpPr>
-      <p:grpSpPr/>
+      <p:grpSpPr>
+        <a:xfrm>
+          <a:off x="0" y="0"/>
+          <a:ext cx="0" cy="0"/>
+          <a:chOff x="0" y="0"/>
+          <a:chExt cx="0" cy="0"/>
+        </a:xfrm>
+      </p:grpSpPr>
       <p:sp>
         <p:nvSpPr>
           <p:cNvPr id="2" name="Rounded Rectangle 1"/>
@@ -7804,6 +9020,7 @@
           <a:lstStyle/>
           <a:p>
             <a:pPr algn="ctr"/>
+            <a:endParaRPr/>
           </a:p>
         </p:txBody>
       </p:sp>
@@ -7847,6 +9064,7 @@
           <a:lstStyle/>
           <a:p>
             <a:pPr algn="ctr"/>
+            <a:endParaRPr/>
           </a:p>
         </p:txBody>
       </p:sp>
@@ -7890,6 +9108,7 @@
           <a:lstStyle/>
           <a:p>
             <a:pPr algn="ctr"/>
+            <a:endParaRPr/>
           </a:p>
         </p:txBody>
       </p:sp>
@@ -8044,7 +9263,7 @@
                 </a:solidFill>
                 <a:latin typeface="Aptos"/>
               </a:rPr>
-              <a:t>YouTube Data API retrieves metadata, thumbnails, duration, and channel information.</a:t>
+              <a:t>YouTube Data API retrieves metadata, thumbnails, duration, and channel information, then applies the selected length filter.</a:t>
             </a:r>
           </a:p>
           <a:p>
@@ -8100,7 +9319,7 @@
                 </a:solidFill>
                 <a:latin typeface="Aptos"/>
               </a:rPr>
-              <a:t>Whisper is used only as a fallback when captions are unavailable.</a:t>
+              <a:t>Whisper is used only as a fallback when captions are unavailable and the deployment can safely fetch audio.</a:t>
             </a:r>
           </a:p>
           <a:p>
@@ -8203,6 +9422,7 @@
           <a:lstStyle/>
           <a:p>
             <a:pPr algn="ctr"/>
+            <a:endParaRPr/>
           </a:p>
         </p:txBody>
       </p:sp>
@@ -8325,7 +9545,7 @@
 </file>
 
 <file path=ppt/slides/slide6.xml><?xml version="1.0" encoding="utf-8"?>
-<p:sld xmlns:a="http://schemas.openxmlformats.org/drawingml/2006/main" xmlns:p="http://schemas.openxmlformats.org/presentationml/2006/main" xmlns:r="http://schemas.openxmlformats.org/officeDocument/2006/relationships">
+<p:sld xmlns:a="http://schemas.openxmlformats.org/drawingml/2006/main" xmlns:r="http://schemas.openxmlformats.org/officeDocument/2006/relationships" xmlns:p="http://schemas.openxmlformats.org/presentationml/2006/main">
   <p:cSld>
     <p:bg>
       <p:bgPr>
@@ -8341,7 +9561,14 @@
         <p:cNvGrpSpPr/>
         <p:nvPr/>
       </p:nvGrpSpPr>
-      <p:grpSpPr/>
+      <p:grpSpPr>
+        <a:xfrm>
+          <a:off x="0" y="0"/>
+          <a:ext cx="0" cy="0"/>
+          <a:chOff x="0" y="0"/>
+          <a:chExt cx="0" cy="0"/>
+        </a:xfrm>
+      </p:grpSpPr>
       <p:sp>
         <p:nvSpPr>
           <p:cNvPr id="2" name="Rounded Rectangle 1"/>
@@ -8382,6 +9609,7 @@
           <a:lstStyle/>
           <a:p>
             <a:pPr algn="ctr"/>
+            <a:endParaRPr/>
           </a:p>
         </p:txBody>
       </p:sp>
@@ -8425,6 +9653,7 @@
           <a:lstStyle/>
           <a:p>
             <a:pPr algn="ctr"/>
+            <a:endParaRPr/>
           </a:p>
         </p:txBody>
       </p:sp>
@@ -8468,6 +9697,7 @@
           <a:lstStyle/>
           <a:p>
             <a:pPr algn="ctr"/>
+            <a:endParaRPr/>
           </a:p>
         </p:txBody>
       </p:sp>
@@ -8584,8 +9814,8 @@
         </p:nvSpPr>
         <p:spPr>
           <a:xfrm>
-            <a:off x="658368" y="1600200"/>
-            <a:ext cx="9875520" cy="329184"/>
+            <a:off x="658368" y="1901952"/>
+            <a:ext cx="6665976" cy="584775"/>
           </a:xfrm>
           <a:prstGeom prst="rect">
             <a:avLst/>
@@ -8600,13 +9830,58 @@
           <a:p>
             <a:pPr algn="l"/>
             <a:r>
-              <a:rPr sz="1600" b="0">
+              <a:rPr sz="1600" b="0" dirty="0" err="1">
                 <a:solidFill>
                   <a:srgbClr val="94A3B8"/>
                 </a:solidFill>
                 <a:latin typeface="Aptos"/>
               </a:rPr>
-              <a:t>AgentService binds StructuredTool objects to the LLM and returns answer, citations, tool steps, and session_id.</a:t>
+              <a:t>AgentService</a:t>
+            </a:r>
+            <a:r>
+              <a:rPr sz="1600" b="0" dirty="0">
+                <a:solidFill>
+                  <a:srgbClr val="94A3B8"/>
+                </a:solidFill>
+                <a:latin typeface="Aptos"/>
+              </a:rPr>
+              <a:t> binds </a:t>
+            </a:r>
+            <a:r>
+              <a:rPr sz="1600" b="0" dirty="0" err="1">
+                <a:solidFill>
+                  <a:srgbClr val="94A3B8"/>
+                </a:solidFill>
+                <a:latin typeface="Aptos"/>
+              </a:rPr>
+              <a:t>StructuredTool</a:t>
+            </a:r>
+            <a:r>
+              <a:rPr sz="1600" b="0" dirty="0">
+                <a:solidFill>
+                  <a:srgbClr val="94A3B8"/>
+                </a:solidFill>
+                <a:latin typeface="Aptos"/>
+              </a:rPr>
+              <a:t> objects to the LLM and returns answer, citations, tool steps, and </a:t>
+            </a:r>
+            <a:r>
+              <a:rPr sz="1600" b="0" dirty="0" err="1">
+                <a:solidFill>
+                  <a:srgbClr val="94A3B8"/>
+                </a:solidFill>
+                <a:latin typeface="Aptos"/>
+              </a:rPr>
+              <a:t>session_id</a:t>
+            </a:r>
+            <a:r>
+              <a:rPr sz="1600" b="0" dirty="0">
+                <a:solidFill>
+                  <a:srgbClr val="94A3B8"/>
+                </a:solidFill>
+                <a:latin typeface="Aptos"/>
+              </a:rPr>
+              <a:t>.</a:t>
             </a:r>
           </a:p>
         </p:txBody>
@@ -8619,7 +9894,7 @@
         </p:nvSpPr>
         <p:spPr>
           <a:xfrm>
-            <a:off x="777240" y="2148840"/>
+            <a:off x="777240" y="2450592"/>
             <a:ext cx="2880360" cy="438912"/>
           </a:xfrm>
           <a:prstGeom prst="roundRect">
@@ -8653,6 +9928,7 @@
           <a:lstStyle/>
           <a:p>
             <a:pPr algn="ctr"/>
+            <a:endParaRPr/>
           </a:p>
         </p:txBody>
       </p:sp>
@@ -8664,7 +9940,7 @@
         </p:nvSpPr>
         <p:spPr>
           <a:xfrm>
-            <a:off x="960120" y="2258568"/>
+            <a:off x="960120" y="2560320"/>
             <a:ext cx="2514600" cy="201168"/>
           </a:xfrm>
           <a:prstGeom prst="rect">
@@ -8699,7 +9975,7 @@
         </p:nvSpPr>
         <p:spPr>
           <a:xfrm>
-            <a:off x="4023359" y="2148840"/>
+            <a:off x="4023359" y="2450592"/>
             <a:ext cx="2880360" cy="438912"/>
           </a:xfrm>
           <a:prstGeom prst="roundRect">
@@ -8733,6 +10009,7 @@
           <a:lstStyle/>
           <a:p>
             <a:pPr algn="ctr"/>
+            <a:endParaRPr/>
           </a:p>
         </p:txBody>
       </p:sp>
@@ -8744,7 +10021,7 @@
         </p:nvSpPr>
         <p:spPr>
           <a:xfrm>
-            <a:off x="4206240" y="2258568"/>
+            <a:off x="4206240" y="2560320"/>
             <a:ext cx="2514600" cy="201168"/>
           </a:xfrm>
           <a:prstGeom prst="rect">
@@ -8779,7 +10056,7 @@
         </p:nvSpPr>
         <p:spPr>
           <a:xfrm>
-            <a:off x="777240" y="2807208"/>
+            <a:off x="777240" y="3108960"/>
             <a:ext cx="2880360" cy="438912"/>
           </a:xfrm>
           <a:prstGeom prst="roundRect">
@@ -8813,6 +10090,7 @@
           <a:lstStyle/>
           <a:p>
             <a:pPr algn="ctr"/>
+            <a:endParaRPr/>
           </a:p>
         </p:txBody>
       </p:sp>
@@ -8824,7 +10102,7 @@
         </p:nvSpPr>
         <p:spPr>
           <a:xfrm>
-            <a:off x="960120" y="2916936"/>
+            <a:off x="960120" y="3218688"/>
             <a:ext cx="2514600" cy="201168"/>
           </a:xfrm>
           <a:prstGeom prst="rect">
@@ -8859,7 +10137,7 @@
         </p:nvSpPr>
         <p:spPr>
           <a:xfrm>
-            <a:off x="4023359" y="2807208"/>
+            <a:off x="4023359" y="3108960"/>
             <a:ext cx="2880360" cy="438912"/>
           </a:xfrm>
           <a:prstGeom prst="roundRect">
@@ -8893,6 +10171,7 @@
           <a:lstStyle/>
           <a:p>
             <a:pPr algn="ctr"/>
+            <a:endParaRPr/>
           </a:p>
         </p:txBody>
       </p:sp>
@@ -8904,7 +10183,7 @@
         </p:nvSpPr>
         <p:spPr>
           <a:xfrm>
-            <a:off x="4206240" y="2916936"/>
+            <a:off x="4206240" y="3218688"/>
             <a:ext cx="2514600" cy="201168"/>
           </a:xfrm>
           <a:prstGeom prst="rect">
@@ -8939,7 +10218,7 @@
         </p:nvSpPr>
         <p:spPr>
           <a:xfrm>
-            <a:off x="777240" y="3465576"/>
+            <a:off x="777240" y="3767328"/>
             <a:ext cx="2880360" cy="438912"/>
           </a:xfrm>
           <a:prstGeom prst="roundRect">
@@ -8973,6 +10252,7 @@
           <a:lstStyle/>
           <a:p>
             <a:pPr algn="ctr"/>
+            <a:endParaRPr/>
           </a:p>
         </p:txBody>
       </p:sp>
@@ -8984,7 +10264,7 @@
         </p:nvSpPr>
         <p:spPr>
           <a:xfrm>
-            <a:off x="960120" y="3575304"/>
+            <a:off x="960120" y="3877056"/>
             <a:ext cx="2514600" cy="201168"/>
           </a:xfrm>
           <a:prstGeom prst="rect">
@@ -9019,7 +10299,7 @@
         </p:nvSpPr>
         <p:spPr>
           <a:xfrm>
-            <a:off x="4023359" y="3465576"/>
+            <a:off x="4023359" y="3767328"/>
             <a:ext cx="2880360" cy="438912"/>
           </a:xfrm>
           <a:prstGeom prst="roundRect">
@@ -9053,6 +10333,7 @@
           <a:lstStyle/>
           <a:p>
             <a:pPr algn="ctr"/>
+            <a:endParaRPr/>
           </a:p>
         </p:txBody>
       </p:sp>
@@ -9064,7 +10345,7 @@
         </p:nvSpPr>
         <p:spPr>
           <a:xfrm>
-            <a:off x="4206240" y="3575304"/>
+            <a:off x="4206240" y="3877056"/>
             <a:ext cx="2514600" cy="201168"/>
           </a:xfrm>
           <a:prstGeom prst="rect">
@@ -9099,7 +10380,7 @@
         </p:nvSpPr>
         <p:spPr>
           <a:xfrm>
-            <a:off x="777240" y="4123944"/>
+            <a:off x="777240" y="4425696"/>
             <a:ext cx="2880360" cy="438912"/>
           </a:xfrm>
           <a:prstGeom prst="roundRect">
@@ -9133,6 +10414,7 @@
           <a:lstStyle/>
           <a:p>
             <a:pPr algn="ctr"/>
+            <a:endParaRPr/>
           </a:p>
         </p:txBody>
       </p:sp>
@@ -9144,7 +10426,7 @@
         </p:nvSpPr>
         <p:spPr>
           <a:xfrm>
-            <a:off x="960120" y="4233672"/>
+            <a:off x="960120" y="4535424"/>
             <a:ext cx="2514600" cy="201168"/>
           </a:xfrm>
           <a:prstGeom prst="rect">
@@ -9213,6 +10495,7 @@
           <a:lstStyle/>
           <a:p>
             <a:pPr algn="ctr"/>
+            <a:endParaRPr/>
           </a:p>
         </p:txBody>
       </p:sp>
@@ -9256,6 +10539,7 @@
           <a:lstStyle/>
           <a:p>
             <a:pPr algn="ctr"/>
+            <a:endParaRPr/>
           </a:p>
         </p:txBody>
       </p:sp>
@@ -9371,6 +10655,7 @@
           <a:lstStyle/>
           <a:p>
             <a:pPr algn="ctr"/>
+            <a:endParaRPr/>
           </a:p>
         </p:txBody>
       </p:sp>
@@ -9414,6 +10699,7 @@
           <a:lstStyle/>
           <a:p>
             <a:pPr algn="ctr"/>
+            <a:endParaRPr/>
           </a:p>
         </p:txBody>
       </p:sp>
@@ -9496,7 +10782,7 @@
 </file>
 
 <file path=ppt/slides/slide7.xml><?xml version="1.0" encoding="utf-8"?>
-<p:sld xmlns:a="http://schemas.openxmlformats.org/drawingml/2006/main" xmlns:p="http://schemas.openxmlformats.org/presentationml/2006/main" xmlns:r="http://schemas.openxmlformats.org/officeDocument/2006/relationships">
+<p:sld xmlns:a="http://schemas.openxmlformats.org/drawingml/2006/main" xmlns:r="http://schemas.openxmlformats.org/officeDocument/2006/relationships" xmlns:p="http://schemas.openxmlformats.org/presentationml/2006/main">
   <p:cSld>
     <p:bg>
       <p:bgPr>
@@ -9512,7 +10798,14 @@
         <p:cNvGrpSpPr/>
         <p:nvPr/>
       </p:nvGrpSpPr>
-      <p:grpSpPr/>
+      <p:grpSpPr>
+        <a:xfrm>
+          <a:off x="0" y="0"/>
+          <a:ext cx="0" cy="0"/>
+          <a:chOff x="0" y="0"/>
+          <a:chExt cx="0" cy="0"/>
+        </a:xfrm>
+      </p:grpSpPr>
       <p:sp>
         <p:nvSpPr>
           <p:cNvPr id="2" name="Rounded Rectangle 1"/>
@@ -9553,6 +10846,7 @@
           <a:lstStyle/>
           <a:p>
             <a:pPr algn="ctr"/>
+            <a:endParaRPr/>
           </a:p>
         </p:txBody>
       </p:sp>
@@ -9596,6 +10890,7 @@
           <a:lstStyle/>
           <a:p>
             <a:pPr algn="ctr"/>
+            <a:endParaRPr/>
           </a:p>
         </p:txBody>
       </p:sp>
@@ -9639,6 +10934,7 @@
           <a:lstStyle/>
           <a:p>
             <a:pPr algn="ctr"/>
+            <a:endParaRPr/>
           </a:p>
         </p:txBody>
       </p:sp>
@@ -9755,7 +11051,7 @@
         </p:nvSpPr>
         <p:spPr>
           <a:xfrm>
-            <a:off x="777240" y="2011680"/>
+            <a:off x="777240" y="2432304"/>
             <a:ext cx="2057400" cy="1325880"/>
           </a:xfrm>
           <a:prstGeom prst="roundRect">
@@ -9789,6 +11085,7 @@
           <a:lstStyle/>
           <a:p>
             <a:pPr algn="ctr"/>
+            <a:endParaRPr/>
           </a:p>
         </p:txBody>
       </p:sp>
@@ -9800,7 +11097,7 @@
         </p:nvSpPr>
         <p:spPr>
           <a:xfrm>
-            <a:off x="941832" y="2176272"/>
+            <a:off x="941832" y="2596896"/>
             <a:ext cx="384048" cy="384048"/>
           </a:xfrm>
           <a:prstGeom prst="roundRect">
@@ -9832,6 +11129,7 @@
           <a:lstStyle/>
           <a:p>
             <a:pPr algn="ctr"/>
+            <a:endParaRPr/>
           </a:p>
         </p:txBody>
       </p:sp>
@@ -9843,7 +11141,7 @@
         </p:nvSpPr>
         <p:spPr>
           <a:xfrm>
-            <a:off x="1042415" y="2258568"/>
+            <a:off x="1042415" y="2679192"/>
             <a:ext cx="182880" cy="182880"/>
           </a:xfrm>
           <a:prstGeom prst="rect">
@@ -9878,7 +11176,7 @@
         </p:nvSpPr>
         <p:spPr>
           <a:xfrm>
-            <a:off x="1435607" y="2194560"/>
+            <a:off x="1435607" y="2615184"/>
             <a:ext cx="1234440" cy="228600"/>
           </a:xfrm>
           <a:prstGeom prst="rect">
@@ -9913,7 +11211,7 @@
         </p:nvSpPr>
         <p:spPr>
           <a:xfrm>
-            <a:off x="960120" y="2670048"/>
+            <a:off x="960120" y="3090672"/>
             <a:ext cx="1691640" cy="411480"/>
           </a:xfrm>
           <a:prstGeom prst="rect">
@@ -9948,7 +11246,7 @@
         </p:nvSpPr>
         <p:spPr>
           <a:xfrm>
-            <a:off x="3246120" y="2011680"/>
+            <a:off x="3246120" y="2432304"/>
             <a:ext cx="2057400" cy="1325880"/>
           </a:xfrm>
           <a:prstGeom prst="roundRect">
@@ -9982,6 +11280,7 @@
           <a:lstStyle/>
           <a:p>
             <a:pPr algn="ctr"/>
+            <a:endParaRPr/>
           </a:p>
         </p:txBody>
       </p:sp>
@@ -9993,7 +11292,7 @@
         </p:nvSpPr>
         <p:spPr>
           <a:xfrm>
-            <a:off x="3410712" y="2176272"/>
+            <a:off x="3410712" y="2596896"/>
             <a:ext cx="384048" cy="384048"/>
           </a:xfrm>
           <a:prstGeom prst="roundRect">
@@ -10025,6 +11324,7 @@
           <a:lstStyle/>
           <a:p>
             <a:pPr algn="ctr"/>
+            <a:endParaRPr/>
           </a:p>
         </p:txBody>
       </p:sp>
@@ -10036,7 +11336,7 @@
         </p:nvSpPr>
         <p:spPr>
           <a:xfrm>
-            <a:off x="3511296" y="2258568"/>
+            <a:off x="3511296" y="2679192"/>
             <a:ext cx="182880" cy="182880"/>
           </a:xfrm>
           <a:prstGeom prst="rect">
@@ -10071,7 +11371,7 @@
         </p:nvSpPr>
         <p:spPr>
           <a:xfrm>
-            <a:off x="3904487" y="2194560"/>
+            <a:off x="3904487" y="2615184"/>
             <a:ext cx="1234440" cy="228600"/>
           </a:xfrm>
           <a:prstGeom prst="rect">
@@ -10106,7 +11406,7 @@
         </p:nvSpPr>
         <p:spPr>
           <a:xfrm>
-            <a:off x="3429000" y="2670048"/>
+            <a:off x="3429000" y="3090672"/>
             <a:ext cx="1691640" cy="411480"/>
           </a:xfrm>
           <a:prstGeom prst="rect">
@@ -10141,7 +11441,7 @@
         </p:nvSpPr>
         <p:spPr>
           <a:xfrm>
-            <a:off x="5715000" y="2011680"/>
+            <a:off x="5715000" y="2432304"/>
             <a:ext cx="2057400" cy="1325880"/>
           </a:xfrm>
           <a:prstGeom prst="roundRect">
@@ -10175,6 +11475,7 @@
           <a:lstStyle/>
           <a:p>
             <a:pPr algn="ctr"/>
+            <a:endParaRPr/>
           </a:p>
         </p:txBody>
       </p:sp>
@@ -10186,7 +11487,7 @@
         </p:nvSpPr>
         <p:spPr>
           <a:xfrm>
-            <a:off x="5879592" y="2176272"/>
+            <a:off x="5879592" y="2596896"/>
             <a:ext cx="384048" cy="384048"/>
           </a:xfrm>
           <a:prstGeom prst="roundRect">
@@ -10218,6 +11519,7 @@
           <a:lstStyle/>
           <a:p>
             <a:pPr algn="ctr"/>
+            <a:endParaRPr/>
           </a:p>
         </p:txBody>
       </p:sp>
@@ -10229,7 +11531,7 @@
         </p:nvSpPr>
         <p:spPr>
           <a:xfrm>
-            <a:off x="5980176" y="2258568"/>
+            <a:off x="5980176" y="2679192"/>
             <a:ext cx="182880" cy="182880"/>
           </a:xfrm>
           <a:prstGeom prst="rect">
@@ -10264,7 +11566,7 @@
         </p:nvSpPr>
         <p:spPr>
           <a:xfrm>
-            <a:off x="6373368" y="2194560"/>
+            <a:off x="6373368" y="2615184"/>
             <a:ext cx="1234440" cy="228600"/>
           </a:xfrm>
           <a:prstGeom prst="rect">
@@ -10299,7 +11601,7 @@
         </p:nvSpPr>
         <p:spPr>
           <a:xfrm>
-            <a:off x="5897880" y="2670048"/>
+            <a:off x="5897880" y="3090672"/>
             <a:ext cx="1691640" cy="411480"/>
           </a:xfrm>
           <a:prstGeom prst="rect">
@@ -10321,7 +11623,7 @@
                 </a:solidFill>
                 <a:latin typeface="Aptos"/>
               </a:rPr>
-              <a:t>GPT-4o-mini writes the answer.</a:t>
+              <a:t>GPT-4o-mini writes from retrieved context.</a:t>
             </a:r>
           </a:p>
         </p:txBody>
@@ -10334,7 +11636,7 @@
         </p:nvSpPr>
         <p:spPr>
           <a:xfrm>
-            <a:off x="8183879" y="2011680"/>
+            <a:off x="8183879" y="2432304"/>
             <a:ext cx="2057400" cy="1325880"/>
           </a:xfrm>
           <a:prstGeom prst="roundRect">
@@ -10368,6 +11670,7 @@
           <a:lstStyle/>
           <a:p>
             <a:pPr algn="ctr"/>
+            <a:endParaRPr/>
           </a:p>
         </p:txBody>
       </p:sp>
@@ -10379,7 +11682,7 @@
         </p:nvSpPr>
         <p:spPr>
           <a:xfrm>
-            <a:off x="8348471" y="2176272"/>
+            <a:off x="8348471" y="2596896"/>
             <a:ext cx="384048" cy="384048"/>
           </a:xfrm>
           <a:prstGeom prst="roundRect">
@@ -10411,6 +11714,7 @@
           <a:lstStyle/>
           <a:p>
             <a:pPr algn="ctr"/>
+            <a:endParaRPr/>
           </a:p>
         </p:txBody>
       </p:sp>
@@ -10422,7 +11726,7 @@
         </p:nvSpPr>
         <p:spPr>
           <a:xfrm>
-            <a:off x="8449055" y="2258568"/>
+            <a:off x="8449055" y="2679192"/>
             <a:ext cx="182880" cy="182880"/>
           </a:xfrm>
           <a:prstGeom prst="rect">
@@ -10457,7 +11761,7 @@
         </p:nvSpPr>
         <p:spPr>
           <a:xfrm>
-            <a:off x="8842248" y="2194560"/>
+            <a:off x="8842248" y="2615184"/>
             <a:ext cx="1234440" cy="228600"/>
           </a:xfrm>
           <a:prstGeom prst="rect">
@@ -10492,7 +11796,7 @@
         </p:nvSpPr>
         <p:spPr>
           <a:xfrm>
-            <a:off x="8366759" y="2670048"/>
+            <a:off x="8366759" y="3090672"/>
             <a:ext cx="1691640" cy="411480"/>
           </a:xfrm>
           <a:prstGeom prst="rect">
@@ -10527,7 +11831,7 @@
         </p:nvCxnSpPr>
         <p:spPr>
           <a:xfrm>
-            <a:off x="2971800" y="2670048"/>
+            <a:off x="2971800" y="3090672"/>
             <a:ext cx="201168" cy="0"/>
           </a:xfrm>
           <a:prstGeom prst="line">
@@ -10562,7 +11866,7 @@
         </p:nvCxnSpPr>
         <p:spPr>
           <a:xfrm>
-            <a:off x="5440680" y="2670048"/>
+            <a:off x="5440680" y="3090672"/>
             <a:ext cx="201168" cy="0"/>
           </a:xfrm>
           <a:prstGeom prst="line">
@@ -10597,7 +11901,7 @@
         </p:nvCxnSpPr>
         <p:spPr>
           <a:xfrm>
-            <a:off x="7909560" y="2670048"/>
+            <a:off x="7909560" y="3090672"/>
             <a:ext cx="201168" cy="0"/>
           </a:xfrm>
           <a:prstGeom prst="line">
@@ -10648,7 +11952,7 @@
           <a:p>
             <a:pPr algn="l"/>
             <a:r>
-              <a:rPr sz="1800" b="0">
+              <a:rPr sz="1800" b="0" dirty="0">
                 <a:solidFill>
                   <a:srgbClr val="94A3B8"/>
                 </a:solidFill>
@@ -10668,7 +11972,7 @@
 </file>
 
 <file path=ppt/slides/slide8.xml><?xml version="1.0" encoding="utf-8"?>
-<p:sld xmlns:a="http://schemas.openxmlformats.org/drawingml/2006/main" xmlns:p="http://schemas.openxmlformats.org/presentationml/2006/main" xmlns:r="http://schemas.openxmlformats.org/officeDocument/2006/relationships">
+<p:sld xmlns:a="http://schemas.openxmlformats.org/drawingml/2006/main" xmlns:r="http://schemas.openxmlformats.org/officeDocument/2006/relationships" xmlns:p="http://schemas.openxmlformats.org/presentationml/2006/main">
   <p:cSld>
     <p:bg>
       <p:bgPr>
@@ -10684,7 +11988,14 @@
         <p:cNvGrpSpPr/>
         <p:nvPr/>
       </p:nvGrpSpPr>
-      <p:grpSpPr/>
+      <p:grpSpPr>
+        <a:xfrm>
+          <a:off x="0" y="0"/>
+          <a:ext cx="0" cy="0"/>
+          <a:chOff x="0" y="0"/>
+          <a:chExt cx="0" cy="0"/>
+        </a:xfrm>
+      </p:grpSpPr>
       <p:sp>
         <p:nvSpPr>
           <p:cNvPr id="2" name="Rounded Rectangle 1"/>
@@ -10725,6 +12036,7 @@
           <a:lstStyle/>
           <a:p>
             <a:pPr algn="ctr"/>
+            <a:endParaRPr/>
           </a:p>
         </p:txBody>
       </p:sp>
@@ -10768,6 +12080,7 @@
           <a:lstStyle/>
           <a:p>
             <a:pPr algn="ctr"/>
+            <a:endParaRPr/>
           </a:p>
         </p:txBody>
       </p:sp>
@@ -10811,6 +12124,7 @@
           <a:lstStyle/>
           <a:p>
             <a:pPr algn="ctr"/>
+            <a:endParaRPr/>
           </a:p>
         </p:txBody>
       </p:sp>
@@ -10927,7 +12241,7 @@
         </p:nvSpPr>
         <p:spPr>
           <a:xfrm>
-            <a:off x="685800" y="1920240"/>
+            <a:off x="685800" y="2468880"/>
             <a:ext cx="3337560" cy="1828800"/>
           </a:xfrm>
           <a:prstGeom prst="roundRect">
@@ -10961,6 +12275,7 @@
           <a:lstStyle/>
           <a:p>
             <a:pPr algn="ctr"/>
+            <a:endParaRPr/>
           </a:p>
         </p:txBody>
       </p:sp>
@@ -10972,7 +12287,7 @@
         </p:nvSpPr>
         <p:spPr>
           <a:xfrm>
-            <a:off x="685800" y="1920240"/>
+            <a:off x="685800" y="2468880"/>
             <a:ext cx="73152" cy="1828800"/>
           </a:xfrm>
           <a:prstGeom prst="rect">
@@ -11004,6 +12319,7 @@
           <a:lstStyle/>
           <a:p>
             <a:pPr algn="ctr"/>
+            <a:endParaRPr/>
           </a:p>
         </p:txBody>
       </p:sp>
@@ -11015,7 +12331,7 @@
         </p:nvSpPr>
         <p:spPr>
           <a:xfrm>
-            <a:off x="886968" y="2084832"/>
+            <a:off x="886968" y="2633472"/>
             <a:ext cx="3017520" cy="228600"/>
           </a:xfrm>
           <a:prstGeom prst="rect">
@@ -11050,7 +12366,7 @@
         </p:nvSpPr>
         <p:spPr>
           <a:xfrm>
-            <a:off x="886968" y="2423160"/>
+            <a:off x="886968" y="2971800"/>
             <a:ext cx="3017520" cy="1188720"/>
           </a:xfrm>
           <a:prstGeom prst="rect">
@@ -11085,7 +12401,7 @@
         </p:nvSpPr>
         <p:spPr>
           <a:xfrm>
-            <a:off x="4434840" y="1920240"/>
+            <a:off x="4434840" y="2468880"/>
             <a:ext cx="3337560" cy="1828800"/>
           </a:xfrm>
           <a:prstGeom prst="roundRect">
@@ -11119,6 +12435,7 @@
           <a:lstStyle/>
           <a:p>
             <a:pPr algn="ctr"/>
+            <a:endParaRPr/>
           </a:p>
         </p:txBody>
       </p:sp>
@@ -11130,7 +12447,7 @@
         </p:nvSpPr>
         <p:spPr>
           <a:xfrm>
-            <a:off x="4434840" y="1920240"/>
+            <a:off x="4434840" y="2468880"/>
             <a:ext cx="73152" cy="1828800"/>
           </a:xfrm>
           <a:prstGeom prst="rect">
@@ -11162,6 +12479,7 @@
           <a:lstStyle/>
           <a:p>
             <a:pPr algn="ctr"/>
+            <a:endParaRPr/>
           </a:p>
         </p:txBody>
       </p:sp>
@@ -11173,7 +12491,7 @@
         </p:nvSpPr>
         <p:spPr>
           <a:xfrm>
-            <a:off x="4636007" y="2084832"/>
+            <a:off x="4636007" y="2633472"/>
             <a:ext cx="3017520" cy="228600"/>
           </a:xfrm>
           <a:prstGeom prst="rect">
@@ -11208,7 +12526,7 @@
         </p:nvSpPr>
         <p:spPr>
           <a:xfrm>
-            <a:off x="4636007" y="2423160"/>
+            <a:off x="4636007" y="2971800"/>
             <a:ext cx="3017520" cy="1188720"/>
           </a:xfrm>
           <a:prstGeom prst="rect">
@@ -11243,7 +12561,7 @@
         </p:nvSpPr>
         <p:spPr>
           <a:xfrm>
-            <a:off x="8183879" y="1920240"/>
+            <a:off x="8183879" y="2468880"/>
             <a:ext cx="3337560" cy="1828800"/>
           </a:xfrm>
           <a:prstGeom prst="roundRect">
@@ -11277,6 +12595,7 @@
           <a:lstStyle/>
           <a:p>
             <a:pPr algn="ctr"/>
+            <a:endParaRPr/>
           </a:p>
         </p:txBody>
       </p:sp>
@@ -11288,7 +12607,7 @@
         </p:nvSpPr>
         <p:spPr>
           <a:xfrm>
-            <a:off x="8183879" y="1920240"/>
+            <a:off x="8183879" y="2468880"/>
             <a:ext cx="73152" cy="1828800"/>
           </a:xfrm>
           <a:prstGeom prst="rect">
@@ -11320,6 +12639,7 @@
           <a:lstStyle/>
           <a:p>
             <a:pPr algn="ctr"/>
+            <a:endParaRPr/>
           </a:p>
         </p:txBody>
       </p:sp>
@@ -11331,7 +12651,7 @@
         </p:nvSpPr>
         <p:spPr>
           <a:xfrm>
-            <a:off x="8385048" y="2084832"/>
+            <a:off x="8385048" y="2633472"/>
             <a:ext cx="3017520" cy="228600"/>
           </a:xfrm>
           <a:prstGeom prst="rect">
@@ -11366,7 +12686,7 @@
         </p:nvSpPr>
         <p:spPr>
           <a:xfrm>
-            <a:off x="8385048" y="2423160"/>
+            <a:off x="8385048" y="2971800"/>
             <a:ext cx="3017520" cy="1188720"/>
           </a:xfrm>
           <a:prstGeom prst="rect">
@@ -11437,7 +12757,7 @@
 </file>
 
 <file path=ppt/slides/slide9.xml><?xml version="1.0" encoding="utf-8"?>
-<p:sld xmlns:a="http://schemas.openxmlformats.org/drawingml/2006/main" xmlns:p="http://schemas.openxmlformats.org/presentationml/2006/main" xmlns:r="http://schemas.openxmlformats.org/officeDocument/2006/relationships">
+<p:sld xmlns:a="http://schemas.openxmlformats.org/drawingml/2006/main" xmlns:r="http://schemas.openxmlformats.org/officeDocument/2006/relationships" xmlns:p="http://schemas.openxmlformats.org/presentationml/2006/main">
   <p:cSld>
     <p:bg>
       <p:bgPr>
@@ -11453,7 +12773,14 @@
         <p:cNvGrpSpPr/>
         <p:nvPr/>
       </p:nvGrpSpPr>
-      <p:grpSpPr/>
+      <p:grpSpPr>
+        <a:xfrm>
+          <a:off x="0" y="0"/>
+          <a:ext cx="0" cy="0"/>
+          <a:chOff x="0" y="0"/>
+          <a:chExt cx="0" cy="0"/>
+        </a:xfrm>
+      </p:grpSpPr>
       <p:sp>
         <p:nvSpPr>
           <p:cNvPr id="2" name="Rounded Rectangle 1"/>
@@ -11494,6 +12821,7 @@
           <a:lstStyle/>
           <a:p>
             <a:pPr algn="ctr"/>
+            <a:endParaRPr/>
           </a:p>
         </p:txBody>
       </p:sp>
@@ -11537,6 +12865,7 @@
           <a:lstStyle/>
           <a:p>
             <a:pPr algn="ctr"/>
+            <a:endParaRPr/>
           </a:p>
         </p:txBody>
       </p:sp>
@@ -11580,6 +12909,7 @@
           <a:lstStyle/>
           <a:p>
             <a:pPr algn="ctr"/>
+            <a:endParaRPr/>
           </a:p>
         </p:txBody>
       </p:sp>
@@ -11696,7 +13026,7 @@
         </p:nvSpPr>
         <p:spPr>
           <a:xfrm>
-            <a:off x="822960" y="1965960"/>
+            <a:off x="822960" y="2395728"/>
             <a:ext cx="1828800" cy="594360"/>
           </a:xfrm>
           <a:prstGeom prst="rect">
@@ -11718,7 +13048,7 @@
                 </a:solidFill>
                 <a:latin typeface="Aptos"/>
               </a:rPr>
-              <a:t>82</a:t>
+              <a:t>98</a:t>
             </a:r>
           </a:p>
         </p:txBody>
@@ -11731,7 +13061,7 @@
         </p:nvSpPr>
         <p:spPr>
           <a:xfrm>
-            <a:off x="822960" y="2532888"/>
+            <a:off x="822960" y="2962656"/>
             <a:ext cx="1828800" cy="320040"/>
           </a:xfrm>
           <a:prstGeom prst="rect">
@@ -11766,7 +13096,7 @@
         </p:nvSpPr>
         <p:spPr>
           <a:xfrm>
-            <a:off x="3063240" y="1965960"/>
+            <a:off x="3063240" y="2395728"/>
             <a:ext cx="2011680" cy="594360"/>
           </a:xfrm>
           <a:prstGeom prst="rect">
@@ -11801,7 +13131,7 @@
         </p:nvSpPr>
         <p:spPr>
           <a:xfrm>
-            <a:off x="3063240" y="2532888"/>
+            <a:off x="3063240" y="2962656"/>
             <a:ext cx="2011680" cy="320040"/>
           </a:xfrm>
           <a:prstGeom prst="rect">
@@ -11836,7 +13166,7 @@
         </p:nvSpPr>
         <p:spPr>
           <a:xfrm>
-            <a:off x="5486400" y="1965960"/>
+            <a:off x="5486400" y="2395728"/>
             <a:ext cx="2011680" cy="594360"/>
           </a:xfrm>
           <a:prstGeom prst="rect">
@@ -11871,7 +13201,7 @@
         </p:nvSpPr>
         <p:spPr>
           <a:xfrm>
-            <a:off x="5486400" y="2532888"/>
+            <a:off x="5486400" y="2962656"/>
             <a:ext cx="2011680" cy="320040"/>
           </a:xfrm>
           <a:prstGeom prst="rect">
@@ -11906,7 +13236,7 @@
         </p:nvSpPr>
         <p:spPr>
           <a:xfrm>
-            <a:off x="7726679" y="1965960"/>
+            <a:off x="7726679" y="2395728"/>
             <a:ext cx="2011680" cy="594360"/>
           </a:xfrm>
           <a:prstGeom prst="rect">
@@ -11941,7 +13271,7 @@
         </p:nvSpPr>
         <p:spPr>
           <a:xfrm>
-            <a:off x="7726679" y="2532888"/>
+            <a:off x="7726679" y="2962656"/>
             <a:ext cx="2011680" cy="320040"/>
           </a:xfrm>
           <a:prstGeom prst="rect">

</xml_diff>

<commit_message>
docs: add live EC2 URL to presentation slides
</commit_message>
<xml_diff>
--- a/docs/AskTube_AI_Presentation.pptx
+++ b/docs/AskTube_AI_Presentation.pptx
@@ -4,23 +4,20 @@
   <p:sldMasterIdLst>
     <p:sldMasterId id="2147483648" r:id="rId1"/>
   </p:sldMasterIdLst>
-  <p:notesMasterIdLst>
-    <p:notesMasterId r:id="rId17"/>
-  </p:notesMasterIdLst>
   <p:sldIdLst>
-    <p:sldId id="256" r:id="rId2"/>
-    <p:sldId id="257" r:id="rId3"/>
-    <p:sldId id="258" r:id="rId4"/>
-    <p:sldId id="259" r:id="rId5"/>
-    <p:sldId id="260" r:id="rId6"/>
-    <p:sldId id="261" r:id="rId7"/>
-    <p:sldId id="262" r:id="rId8"/>
-    <p:sldId id="263" r:id="rId9"/>
-    <p:sldId id="264" r:id="rId10"/>
-    <p:sldId id="265" r:id="rId11"/>
-    <p:sldId id="266" r:id="rId12"/>
+    <p:sldId id="256" r:id="rId7"/>
+    <p:sldId id="257" r:id="rId8"/>
+    <p:sldId id="258" r:id="rId9"/>
+    <p:sldId id="259" r:id="rId10"/>
+    <p:sldId id="260" r:id="rId11"/>
+    <p:sldId id="261" r:id="rId12"/>
+    <p:sldId id="262" r:id="rId13"/>
+    <p:sldId id="263" r:id="rId14"/>
+    <p:sldId id="264" r:id="rId15"/>
+    <p:sldId id="265" r:id="rId16"/>
+    <p:sldId id="266" r:id="rId17"/>
   </p:sldIdLst>
-  <p:sldSz cx="12192000" cy="6858000"/>
+  <p:sldSz cx="12191695" cy="6858000" type="screen4x3"/>
   <p:notesSz cx="6858000" cy="9144000"/>
   <p:defaultTextStyle>
     <a:defPPr>
@@ -117,1066 +114,7 @@
       </a:defRPr>
     </a:lvl9pPr>
   </p:defaultTextStyle>
-  <p:extLst>
-    <p:ext uri="{EFAFB233-063F-42B5-8137-9DF3F51BA10A}">
-      <p15:sldGuideLst xmlns:p15="http://schemas.microsoft.com/office/powerpoint/2012/main">
-        <p15:guide id="1" orient="horz" pos="2160">
-          <p15:clr>
-            <a:srgbClr val="A4A3A4"/>
-          </p15:clr>
-        </p15:guide>
-        <p15:guide id="2" pos="2880">
-          <p15:clr>
-            <a:srgbClr val="A4A3A4"/>
-          </p15:clr>
-        </p15:guide>
-      </p15:sldGuideLst>
-    </p:ext>
-  </p:extLst>
 </p:presentation>
-</file>
-
-<file path=ppt/notesMasters/notesMaster1.xml><?xml version="1.0" encoding="utf-8"?>
-<p:notesMaster xmlns:p="http://schemas.openxmlformats.org/presentationml/2006/main" xmlns:a="http://schemas.openxmlformats.org/drawingml/2006/main" xmlns:r="http://schemas.openxmlformats.org/officeDocument/2006/relationships">
-  <p:cSld>
-    <p:spTree>
-      <p:nvGrpSpPr>
-        <p:cNvPr id="1" name=""/>
-        <p:cNvGrpSpPr/>
-        <p:nvPr/>
-      </p:nvGrpSpPr>
-      <p:grpSpPr>
-        <a:xfrm>
-          <a:off x="0" y="0"/>
-          <a:ext cx="0" cy="0"/>
-          <a:chOff x="0" y="0"/>
-          <a:chExt cx="0" cy="0"/>
-        </a:xfrm>
-      </p:grpSpPr>
-    </p:spTree>
-  </p:cSld>
-  <p:clrMap bg1="lt1" tx1="dk1" bg2="lt2" tx2="dk2" accent1="accent1" accent2="accent2" accent3="accent3" accent4="accent4" accent5="accent5" accent6="accent6" hlink="hlink" folHlink="folHlink"/>
-  <p:hf/>
-  <p:notesStyle>
-    <a:lvl1pPr marL="0" algn="l" defTabSz="457200">
-      <a:defRPr sz="1500">
-        <a:latin typeface="Arial"/>
-      </a:defRPr>
-    </a:lvl1pPr>
-  </p:notesStyle>
-  <p:clrMapOvr>
-    <a:masterClrMapping/>
-  </p:clrMapOvr>
-</p:notesMaster>
-</file>
-
-<file path=ppt/notesSlides/notesSlide1.xml><?xml version="1.0" encoding="utf-8"?>
-<p:notes xmlns:p="http://schemas.openxmlformats.org/presentationml/2006/main" xmlns:a="http://schemas.openxmlformats.org/drawingml/2006/main" xmlns:r="http://schemas.openxmlformats.org/officeDocument/2006/relationships">
-  <p:cSld>
-    <p:spTree>
-      <p:nvGrpSpPr>
-        <p:cNvPr id="1" name=""/>
-        <p:cNvGrpSpPr/>
-        <p:nvPr/>
-      </p:nvGrpSpPr>
-      <p:grpSpPr>
-        <a:xfrm>
-          <a:off x="0" y="0"/>
-          <a:ext cx="0" cy="0"/>
-          <a:chOff x="0" y="0"/>
-          <a:chExt cx="0" cy="0"/>
-        </a:xfrm>
-      </p:grpSpPr>
-      <p:sp>
-        <p:nvSpPr>
-          <p:cNvPr id="2" name="Slide Image Placeholder 1"/>
-          <p:cNvSpPr>
-            <a:spLocks noGrp="1"/>
-          </p:cNvSpPr>
-          <p:nvPr>
-            <p:ph type="sldImg" idx="2"/>
-          </p:nvPr>
-        </p:nvSpPr>
-        <p:spPr>
-          <a:xfrm>
-            <a:off x="685800" y="685800"/>
-            <a:ext cx="5486400" cy="3086100"/>
-          </a:xfrm>
-          <a:prstGeom prst="rect"/>
-        </p:spPr>
-      </p:sp>
-      <p:sp>
-        <p:nvSpPr>
-          <p:cNvPr id="3" name="Notes Placeholder 2"/>
-          <p:cNvSpPr>
-            <a:spLocks noGrp="1"/>
-          </p:cNvSpPr>
-          <p:nvPr>
-            <p:ph type="body" sz="quarter" idx="1"/>
-          </p:nvPr>
-        </p:nvSpPr>
-        <p:spPr>
-          <a:xfrm>
-            <a:off x="685800" y="4114800"/>
-            <a:ext cx="5486400" cy="4114800"/>
-          </a:xfrm>
-          <a:prstGeom prst="rect"/>
-        </p:spPr>
-        <p:txBody>
-          <a:bodyPr/>
-          <a:lstStyle/>
-          <a:p>
-            <a:r>
-              <a:rPr lang="en-US" sz="1500"/>
-              <a:t>AskTube AI is my final project: a learning assistant for YouTube videos.</a:t>
-            </a:r>
-          </a:p>
-          <a:p>
-            <a:r>
-              <a:rPr lang="en-US" sz="1500"/>
-              <a:t>The user searches, selects a video, the app processes the transcript, and then the user chats with the video content.</a:t>
-            </a:r>
-          </a:p>
-          <a:p>
-            <a:r>
-              <a:rPr lang="en-US" sz="1500"/>
-              <a:t>The important part is trust: answers are grounded in the transcript and include timestamp citations.</a:t>
-            </a:r>
-          </a:p>
-          <a:p>
-            <a:r>
-              <a:rPr lang="en-US" sz="1500"/>
-              <a:t>Key message: this is not a generic chatbot; it is a transcript-grounded learning workflow.</a:t>
-            </a:r>
-          </a:p>
-        </p:txBody>
-      </p:sp>
-    </p:spTree>
-  </p:cSld>
-  <p:clrMapOvr>
-    <a:masterClrMapping/>
-  </p:clrMapOvr>
-</p:notes>
-</file>
-
-<file path=ppt/notesSlides/notesSlide10.xml><?xml version="1.0" encoding="utf-8"?>
-<p:notes xmlns:p="http://schemas.openxmlformats.org/presentationml/2006/main" xmlns:a="http://schemas.openxmlformats.org/drawingml/2006/main" xmlns:r="http://schemas.openxmlformats.org/officeDocument/2006/relationships">
-  <p:cSld>
-    <p:spTree>
-      <p:nvGrpSpPr>
-        <p:cNvPr id="1" name=""/>
-        <p:cNvGrpSpPr/>
-        <p:nvPr/>
-      </p:nvGrpSpPr>
-      <p:grpSpPr>
-        <a:xfrm>
-          <a:off x="0" y="0"/>
-          <a:ext cx="0" cy="0"/>
-          <a:chOff x="0" y="0"/>
-          <a:chExt cx="0" cy="0"/>
-        </a:xfrm>
-      </p:grpSpPr>
-      <p:sp>
-        <p:nvSpPr>
-          <p:cNvPr id="2" name="Slide Image Placeholder 1"/>
-          <p:cNvSpPr>
-            <a:spLocks noGrp="1"/>
-          </p:cNvSpPr>
-          <p:nvPr>
-            <p:ph type="sldImg" idx="2"/>
-          </p:nvPr>
-        </p:nvSpPr>
-        <p:spPr>
-          <a:xfrm>
-            <a:off x="685800" y="685800"/>
-            <a:ext cx="5486400" cy="3086100"/>
-          </a:xfrm>
-          <a:prstGeom prst="rect"/>
-        </p:spPr>
-      </p:sp>
-      <p:sp>
-        <p:nvSpPr>
-          <p:cNvPr id="3" name="Notes Placeholder 2"/>
-          <p:cNvSpPr>
-            <a:spLocks noGrp="1"/>
-          </p:cNvSpPr>
-          <p:nvPr>
-            <p:ph type="body" sz="quarter" idx="1"/>
-          </p:nvPr>
-        </p:nvSpPr>
-        <p:spPr>
-          <a:xfrm>
-            <a:off x="685800" y="4114800"/>
-            <a:ext cx="5486400" cy="4114800"/>
-          </a:xfrm>
-          <a:prstGeom prst="rect"/>
-        </p:spPr>
-        <p:txBody>
-          <a:bodyPr/>
-          <a:lstStyle/>
-          <a:p>
-            <a:r>
-              <a:rPr lang="en-US" sz="1500"/>
-              <a:t>The live demo path is: search, prepare, ask, and verify.</a:t>
-            </a:r>
-          </a:p>
-          <a:p>
-            <a:r>
-              <a:rPr lang="en-US" sz="1500"/>
-              <a:t>I can show EC2 to prove Docker deployment: frontend on port 3001 and backend health on port 8000.</a:t>
-            </a:r>
-          </a:p>
-          <a:p>
-            <a:r>
-              <a:rPr lang="en-US" sz="1500"/>
-              <a:t>For the most reliable full transcript/RAG demo, local Docker is better because YouTube often blocks transcript access from cloud IPs.</a:t>
-            </a:r>
-          </a:p>
-          <a:p>
-            <a:r>
-              <a:rPr lang="en-US" sz="1500"/>
-              <a:t>This is an infrastructure limitation of YouTube transcript access, not a broken RAG pipeline.</a:t>
-            </a:r>
-          </a:p>
-          <a:p>
-            <a:r>
-              <a:rPr lang="en-US" sz="1500"/>
-              <a:t>Keep the demo focused on trust: every useful answer links back to transcript timestamps.</a:t>
-            </a:r>
-          </a:p>
-        </p:txBody>
-      </p:sp>
-    </p:spTree>
-  </p:cSld>
-  <p:clrMapOvr>
-    <a:masterClrMapping/>
-  </p:clrMapOvr>
-</p:notes>
-</file>
-
-<file path=ppt/notesSlides/notesSlide11.xml><?xml version="1.0" encoding="utf-8"?>
-<p:notes xmlns:p="http://schemas.openxmlformats.org/presentationml/2006/main" xmlns:a="http://schemas.openxmlformats.org/drawingml/2006/main" xmlns:r="http://schemas.openxmlformats.org/officeDocument/2006/relationships">
-  <p:cSld>
-    <p:spTree>
-      <p:nvGrpSpPr>
-        <p:cNvPr id="1" name=""/>
-        <p:cNvGrpSpPr/>
-        <p:nvPr/>
-      </p:nvGrpSpPr>
-      <p:grpSpPr>
-        <a:xfrm>
-          <a:off x="0" y="0"/>
-          <a:ext cx="0" cy="0"/>
-          <a:chOff x="0" y="0"/>
-          <a:chExt cx="0" cy="0"/>
-        </a:xfrm>
-      </p:grpSpPr>
-      <p:sp>
-        <p:nvSpPr>
-          <p:cNvPr id="2" name="Slide Image Placeholder 1"/>
-          <p:cNvSpPr>
-            <a:spLocks noGrp="1"/>
-          </p:cNvSpPr>
-          <p:nvPr>
-            <p:ph type="sldImg" idx="2"/>
-          </p:nvPr>
-        </p:nvSpPr>
-        <p:spPr>
-          <a:xfrm>
-            <a:off x="685800" y="685800"/>
-            <a:ext cx="5486400" cy="3086100"/>
-          </a:xfrm>
-          <a:prstGeom prst="rect"/>
-        </p:spPr>
-      </p:sp>
-      <p:sp>
-        <p:nvSpPr>
-          <p:cNvPr id="3" name="Notes Placeholder 2"/>
-          <p:cNvSpPr>
-            <a:spLocks noGrp="1"/>
-          </p:cNvSpPr>
-          <p:nvPr>
-            <p:ph type="body" sz="quarter" idx="1"/>
-          </p:nvPr>
-        </p:nvSpPr>
-        <p:spPr>
-          <a:xfrm>
-            <a:off x="685800" y="4114800"/>
-            <a:ext cx="5486400" cy="4114800"/>
-          </a:xfrm>
-          <a:prstGeom prst="rect"/>
-        </p:spPr>
-        <p:txBody>
-          <a:bodyPr/>
-          <a:lstStyle/>
-          <a:p>
-            <a:r>
-              <a:rPr lang="en-US" sz="1500"/>
-              <a:t>To close: AskTube AI covers the mandatory requirements: LLM chatbot, tools, memory, vector database, text processing, UI, tests, evaluation, and deployment.</a:t>
-            </a:r>
-          </a:p>
-          <a:p>
-            <a:r>
-              <a:rPr lang="en-US" sz="1500"/>
-              <a:t>It also includes optional features: voice input, Whisper fallback, streaming, TTS, 3D assistant, and LangSmith tracing.</a:t>
-            </a:r>
-          </a:p>
-          <a:p>
-            <a:r>
-              <a:rPr lang="en-US" sz="1500"/>
-              <a:t>Future improvements are persistent user accounts, multi-video comparison, HTTPS custom domain, and a stronger production transcript proxy.</a:t>
-            </a:r>
-          </a:p>
-          <a:p>
-            <a:r>
-              <a:rPr lang="en-US" sz="1500"/>
-              <a:t>Final sentence: AskTube AI makes YouTube videos learnable by conversation while keeping answers grounded in the original transcript.</a:t>
-            </a:r>
-          </a:p>
-        </p:txBody>
-      </p:sp>
-    </p:spTree>
-  </p:cSld>
-  <p:clrMapOvr>
-    <a:masterClrMapping/>
-  </p:clrMapOvr>
-</p:notes>
-</file>
-
-<file path=ppt/notesSlides/notesSlide2.xml><?xml version="1.0" encoding="utf-8"?>
-<p:notes xmlns:p="http://schemas.openxmlformats.org/presentationml/2006/main" xmlns:a="http://schemas.openxmlformats.org/drawingml/2006/main" xmlns:r="http://schemas.openxmlformats.org/officeDocument/2006/relationships">
-  <p:cSld>
-    <p:spTree>
-      <p:nvGrpSpPr>
-        <p:cNvPr id="1" name=""/>
-        <p:cNvGrpSpPr/>
-        <p:nvPr/>
-      </p:nvGrpSpPr>
-      <p:grpSpPr>
-        <a:xfrm>
-          <a:off x="0" y="0"/>
-          <a:ext cx="0" cy="0"/>
-          <a:chOff x="0" y="0"/>
-          <a:chExt cx="0" cy="0"/>
-        </a:xfrm>
-      </p:grpSpPr>
-      <p:sp>
-        <p:nvSpPr>
-          <p:cNvPr id="2" name="Slide Image Placeholder 1"/>
-          <p:cNvSpPr>
-            <a:spLocks noGrp="1"/>
-          </p:cNvSpPr>
-          <p:nvPr>
-            <p:ph type="sldImg" idx="2"/>
-          </p:nvPr>
-        </p:nvSpPr>
-        <p:spPr>
-          <a:xfrm>
-            <a:off x="685800" y="685800"/>
-            <a:ext cx="5486400" cy="3086100"/>
-          </a:xfrm>
-          <a:prstGeom prst="rect"/>
-        </p:spPr>
-      </p:sp>
-      <p:sp>
-        <p:nvSpPr>
-          <p:cNvPr id="3" name="Notes Placeholder 2"/>
-          <p:cNvSpPr>
-            <a:spLocks noGrp="1"/>
-          </p:cNvSpPr>
-          <p:nvPr>
-            <p:ph type="body" sz="quarter" idx="1"/>
-          </p:nvPr>
-        </p:nvSpPr>
-        <p:spPr>
-          <a:xfrm>
-            <a:off x="685800" y="4114800"/>
-            <a:ext cx="5486400" cy="4114800"/>
-          </a:xfrm>
-          <a:prstGeom prst="rect"/>
-        </p:spPr>
-        <p:txBody>
-          <a:bodyPr/>
-          <a:lstStyle/>
-          <a:p>
-            <a:r>
-              <a:rPr lang="en-US" sz="1500"/>
-              <a:t>The problem is that YouTube has a lot of good learning content, but long videos are hard to search inside.</a:t>
-            </a:r>
-          </a:p>
-          <a:p>
-            <a:r>
-              <a:rPr lang="en-US" sz="1500"/>
-              <a:t>AskTube AI turns the transcript into a searchable knowledge base.</a:t>
-            </a:r>
-          </a:p>
-          <a:p>
-            <a:r>
-              <a:rPr lang="en-US" sz="1500"/>
-              <a:t>The trust rule is central: if the transcript cannot answer, the assistant should refuse instead of inventing.</a:t>
-            </a:r>
-          </a:p>
-          <a:p>
-            <a:r>
-              <a:rPr lang="en-US" sz="1500"/>
-              <a:t>Key message: the project combines speed with verifiable answers.</a:t>
-            </a:r>
-          </a:p>
-        </p:txBody>
-      </p:sp>
-    </p:spTree>
-  </p:cSld>
-  <p:clrMapOvr>
-    <a:masterClrMapping/>
-  </p:clrMapOvr>
-</p:notes>
-</file>
-
-<file path=ppt/notesSlides/notesSlide3.xml><?xml version="1.0" encoding="utf-8"?>
-<p:notes xmlns:p="http://schemas.openxmlformats.org/presentationml/2006/main" xmlns:a="http://schemas.openxmlformats.org/drawingml/2006/main" xmlns:r="http://schemas.openxmlformats.org/officeDocument/2006/relationships">
-  <p:cSld>
-    <p:spTree>
-      <p:nvGrpSpPr>
-        <p:cNvPr id="1" name=""/>
-        <p:cNvGrpSpPr/>
-        <p:nvPr/>
-      </p:nvGrpSpPr>
-      <p:grpSpPr>
-        <a:xfrm>
-          <a:off x="0" y="0"/>
-          <a:ext cx="0" cy="0"/>
-          <a:chOff x="0" y="0"/>
-          <a:chExt cx="0" cy="0"/>
-        </a:xfrm>
-      </p:grpSpPr>
-      <p:sp>
-        <p:nvSpPr>
-          <p:cNvPr id="2" name="Slide Image Placeholder 1"/>
-          <p:cNvSpPr>
-            <a:spLocks noGrp="1"/>
-          </p:cNvSpPr>
-          <p:nvPr>
-            <p:ph type="sldImg" idx="2"/>
-          </p:nvPr>
-        </p:nvSpPr>
-        <p:spPr>
-          <a:xfrm>
-            <a:off x="685800" y="685800"/>
-            <a:ext cx="5486400" cy="3086100"/>
-          </a:xfrm>
-          <a:prstGeom prst="rect"/>
-        </p:spPr>
-      </p:sp>
-      <p:sp>
-        <p:nvSpPr>
-          <p:cNvPr id="3" name="Notes Placeholder 2"/>
-          <p:cNvSpPr>
-            <a:spLocks noGrp="1"/>
-          </p:cNvSpPr>
-          <p:nvPr>
-            <p:ph type="body" sz="quarter" idx="1"/>
-          </p:nvPr>
-        </p:nvSpPr>
-        <p:spPr>
-          <a:xfrm>
-            <a:off x="685800" y="4114800"/>
-            <a:ext cx="5486400" cy="4114800"/>
-          </a:xfrm>
-          <a:prstGeom prst="rect"/>
-        </p:spPr>
-        <p:txBody>
-          <a:bodyPr/>
-          <a:lstStyle/>
-          <a:p>
-            <a:r>
-              <a:rPr lang="en-US" sz="1500"/>
-              <a:t>The user journey has four steps: search, choose, process, and chat.</a:t>
-            </a:r>
-          </a:p>
-          <a:p>
-            <a:r>
-              <a:rPr lang="en-US" sz="1500"/>
-              <a:t>Search can be text or voice, with optional duration filters.</a:t>
-            </a:r>
-          </a:p>
-          <a:p>
-            <a:r>
-              <a:rPr lang="en-US" sz="1500"/>
-              <a:t>After a video is selected, the backend extracts the transcript, chunks it, embeds it, and stores it in ChromaDB.</a:t>
-            </a:r>
-          </a:p>
-          <a:p>
-            <a:r>
-              <a:rPr lang="en-US" sz="1500"/>
-              <a:t>The technical pipeline is hidden behind a simple product flow.</a:t>
-            </a:r>
-          </a:p>
-        </p:txBody>
-      </p:sp>
-    </p:spTree>
-  </p:cSld>
-  <p:clrMapOvr>
-    <a:masterClrMapping/>
-  </p:clrMapOvr>
-</p:notes>
-</file>
-
-<file path=ppt/notesSlides/notesSlide4.xml><?xml version="1.0" encoding="utf-8"?>
-<p:notes xmlns:p="http://schemas.openxmlformats.org/presentationml/2006/main" xmlns:a="http://schemas.openxmlformats.org/drawingml/2006/main" xmlns:r="http://schemas.openxmlformats.org/officeDocument/2006/relationships">
-  <p:cSld>
-    <p:spTree>
-      <p:nvGrpSpPr>
-        <p:cNvPr id="1" name=""/>
-        <p:cNvGrpSpPr/>
-        <p:nvPr/>
-      </p:nvGrpSpPr>
-      <p:grpSpPr>
-        <a:xfrm>
-          <a:off x="0" y="0"/>
-          <a:ext cx="0" cy="0"/>
-          <a:chOff x="0" y="0"/>
-          <a:chExt cx="0" cy="0"/>
-        </a:xfrm>
-      </p:grpSpPr>
-      <p:sp>
-        <p:nvSpPr>
-          <p:cNvPr id="2" name="Slide Image Placeholder 1"/>
-          <p:cNvSpPr>
-            <a:spLocks noGrp="1"/>
-          </p:cNvSpPr>
-          <p:nvPr>
-            <p:ph type="sldImg" idx="2"/>
-          </p:nvPr>
-        </p:nvSpPr>
-        <p:spPr>
-          <a:xfrm>
-            <a:off x="685800" y="685800"/>
-            <a:ext cx="5486400" cy="3086100"/>
-          </a:xfrm>
-          <a:prstGeom prst="rect"/>
-        </p:spPr>
-      </p:sp>
-      <p:sp>
-        <p:nvSpPr>
-          <p:cNvPr id="3" name="Notes Placeholder 2"/>
-          <p:cNvSpPr>
-            <a:spLocks noGrp="1"/>
-          </p:cNvSpPr>
-          <p:nvPr>
-            <p:ph type="body" sz="quarter" idx="1"/>
-          </p:nvPr>
-        </p:nvSpPr>
-        <p:spPr>
-          <a:xfrm>
-            <a:off x="685800" y="4114800"/>
-            <a:ext cx="5486400" cy="4114800"/>
-          </a:xfrm>
-          <a:prstGeom prst="rect"/>
-        </p:spPr>
-        <p:txBody>
-          <a:bodyPr/>
-          <a:lstStyle/>
-          <a:p>
-            <a:r>
-              <a:rPr lang="en-US" sz="1500"/>
-              <a:t>The architecture has three layers: frontend, backend API, and AI/data.</a:t>
-            </a:r>
-          </a:p>
-          <a:p>
-            <a:r>
-              <a:rPr lang="en-US" sz="1500"/>
-              <a:t>The frontend is Next.js with TypeScript, Tailwind, Framer Motion, Embla, and Three.js.</a:t>
-            </a:r>
-          </a:p>
-          <a:p>
-            <a:r>
-              <a:rPr lang="en-US" sz="1500"/>
-              <a:t>The backend is FastAPI with async routes for search, transcripts, chunking, vector storage, chat, agent chat, speech, and evaluations.</a:t>
-            </a:r>
-          </a:p>
-          <a:p>
-            <a:r>
-              <a:rPr lang="en-US" sz="1500"/>
-              <a:t>The AI layer uses LangChain, OpenAI models, ChromaDB, Whisper fallback, and optional LangSmith tracing.</a:t>
-            </a:r>
-          </a:p>
-          <a:p>
-            <a:r>
-              <a:rPr lang="en-US" sz="1500"/>
-              <a:t>Everything runs through Docker Compose.</a:t>
-            </a:r>
-          </a:p>
-        </p:txBody>
-      </p:sp>
-    </p:spTree>
-  </p:cSld>
-  <p:clrMapOvr>
-    <a:masterClrMapping/>
-  </p:clrMapOvr>
-</p:notes>
-</file>
-
-<file path=ppt/notesSlides/notesSlide5.xml><?xml version="1.0" encoding="utf-8"?>
-<p:notes xmlns:p="http://schemas.openxmlformats.org/presentationml/2006/main" xmlns:a="http://schemas.openxmlformats.org/drawingml/2006/main" xmlns:r="http://schemas.openxmlformats.org/officeDocument/2006/relationships">
-  <p:cSld>
-    <p:spTree>
-      <p:nvGrpSpPr>
-        <p:cNvPr id="1" name=""/>
-        <p:cNvGrpSpPr/>
-        <p:nvPr/>
-      </p:nvGrpSpPr>
-      <p:grpSpPr>
-        <a:xfrm>
-          <a:off x="0" y="0"/>
-          <a:ext cx="0" cy="0"/>
-          <a:chOff x="0" y="0"/>
-          <a:chExt cx="0" cy="0"/>
-        </a:xfrm>
-      </p:grpSpPr>
-      <p:sp>
-        <p:nvSpPr>
-          <p:cNvPr id="2" name="Slide Image Placeholder 1"/>
-          <p:cNvSpPr>
-            <a:spLocks noGrp="1"/>
-          </p:cNvSpPr>
-          <p:nvPr>
-            <p:ph type="sldImg" idx="2"/>
-          </p:nvPr>
-        </p:nvSpPr>
-        <p:spPr>
-          <a:xfrm>
-            <a:off x="685800" y="685800"/>
-            <a:ext cx="5486400" cy="3086100"/>
-          </a:xfrm>
-          <a:prstGeom prst="rect"/>
-        </p:spPr>
-      </p:sp>
-      <p:sp>
-        <p:nvSpPr>
-          <p:cNvPr id="3" name="Notes Placeholder 2"/>
-          <p:cNvSpPr>
-            <a:spLocks noGrp="1"/>
-          </p:cNvSpPr>
-          <p:nvPr>
-            <p:ph type="body" sz="quarter" idx="1"/>
-          </p:nvPr>
-        </p:nvSpPr>
-        <p:spPr>
-          <a:xfrm>
-            <a:off x="685800" y="4114800"/>
-            <a:ext cx="5486400" cy="4114800"/>
-          </a:xfrm>
-          <a:prstGeom prst="rect"/>
-        </p:spPr>
-        <p:txBody>
-          <a:bodyPr/>
-          <a:lstStyle/>
-          <a:p>
-            <a:r>
-              <a:rPr lang="en-US" sz="1500"/>
-              <a:t>This is the key backend pipeline.</a:t>
-            </a:r>
-          </a:p>
-          <a:p>
-            <a:r>
-              <a:rPr lang="en-US" sz="1500"/>
-              <a:t>First, YouTube Data API gets metadata like title, thumbnail, duration, and channel.</a:t>
-            </a:r>
-          </a:p>
-          <a:p>
-            <a:r>
-              <a:rPr lang="en-US" sz="1500"/>
-              <a:t>Then youtube-transcript-api fetches public captions. This follows Carlos's recommendation to avoid downloading full videos.</a:t>
-            </a:r>
-          </a:p>
-          <a:p>
-            <a:r>
-              <a:rPr lang="en-US" sz="1500"/>
-              <a:t>The transcript is split into chunks, and each chunk keeps timestamp metadata.</a:t>
-            </a:r>
-          </a:p>
-          <a:p>
-            <a:r>
-              <a:rPr lang="en-US" sz="1500"/>
-              <a:t>OpenAI embeddings are stored in ChromaDB. Whisper and yt-dlp are fallback only when captions are unavailable.</a:t>
-            </a:r>
-          </a:p>
-        </p:txBody>
-      </p:sp>
-    </p:spTree>
-  </p:cSld>
-  <p:clrMapOvr>
-    <a:masterClrMapping/>
-  </p:clrMapOvr>
-</p:notes>
-</file>
-
-<file path=ppt/notesSlides/notesSlide6.xml><?xml version="1.0" encoding="utf-8"?>
-<p:notes xmlns:p="http://schemas.openxmlformats.org/presentationml/2006/main" xmlns:a="http://schemas.openxmlformats.org/drawingml/2006/main" xmlns:r="http://schemas.openxmlformats.org/officeDocument/2006/relationships">
-  <p:cSld>
-    <p:spTree>
-      <p:nvGrpSpPr>
-        <p:cNvPr id="1" name=""/>
-        <p:cNvGrpSpPr/>
-        <p:nvPr/>
-      </p:nvGrpSpPr>
-      <p:grpSpPr>
-        <a:xfrm>
-          <a:off x="0" y="0"/>
-          <a:ext cx="0" cy="0"/>
-          <a:chOff x="0" y="0"/>
-          <a:chExt cx="0" cy="0"/>
-        </a:xfrm>
-      </p:grpSpPr>
-      <p:sp>
-        <p:nvSpPr>
-          <p:cNvPr id="2" name="Slide Image Placeholder 1"/>
-          <p:cNvSpPr>
-            <a:spLocks noGrp="1"/>
-          </p:cNvSpPr>
-          <p:nvPr>
-            <p:ph type="sldImg" idx="2"/>
-          </p:nvPr>
-        </p:nvSpPr>
-        <p:spPr>
-          <a:xfrm>
-            <a:off x="685800" y="685800"/>
-            <a:ext cx="5486400" cy="3086100"/>
-          </a:xfrm>
-          <a:prstGeom prst="rect"/>
-        </p:spPr>
-      </p:sp>
-      <p:sp>
-        <p:nvSpPr>
-          <p:cNvPr id="3" name="Notes Placeholder 2"/>
-          <p:cNvSpPr>
-            <a:spLocks noGrp="1"/>
-          </p:cNvSpPr>
-          <p:nvPr>
-            <p:ph type="body" sz="quarter" idx="1"/>
-          </p:nvPr>
-        </p:nvSpPr>
-        <p:spPr>
-          <a:xfrm>
-            <a:off x="685800" y="4114800"/>
-            <a:ext cx="5486400" cy="4114800"/>
-          </a:xfrm>
-          <a:prstGeom prst="rect"/>
-        </p:spPr>
-        <p:txBody>
-          <a:bodyPr/>
-          <a:lstStyle/>
-          <a:p>
-            <a:r>
-              <a:rPr lang="en-US" sz="1500"/>
-              <a:t>This slide shows how I covered the tools requirement.</a:t>
-            </a:r>
-          </a:p>
-          <a:p>
-            <a:r>
-              <a:rPr lang="en-US" sz="1500"/>
-              <a:t>Each LangChain tool wraps an existing backend service instead of duplicating logic.</a:t>
-            </a:r>
-          </a:p>
-          <a:p>
-            <a:r>
-              <a:rPr lang="en-US" sz="1500"/>
-              <a:t>The AgentService binds these tools to the model and returns the answer, citations, tool steps, and session_id.</a:t>
-            </a:r>
-          </a:p>
-          <a:p>
-            <a:r>
-              <a:rPr lang="en-US" sz="1500"/>
-              <a:t>Memory keeps follow-up questions coherent inside the same session.</a:t>
-            </a:r>
-          </a:p>
-          <a:p>
-            <a:r>
-              <a:rPr lang="en-US" sz="1500"/>
-              <a:t>Key message: this is an LLM with tools and memory, not one big prompt.</a:t>
-            </a:r>
-          </a:p>
-        </p:txBody>
-      </p:sp>
-    </p:spTree>
-  </p:cSld>
-  <p:clrMapOvr>
-    <a:masterClrMapping/>
-  </p:clrMapOvr>
-</p:notes>
-</file>
-
-<file path=ppt/notesSlides/notesSlide7.xml><?xml version="1.0" encoding="utf-8"?>
-<p:notes xmlns:p="http://schemas.openxmlformats.org/presentationml/2006/main" xmlns:a="http://schemas.openxmlformats.org/drawingml/2006/main" xmlns:r="http://schemas.openxmlformats.org/officeDocument/2006/relationships">
-  <p:cSld>
-    <p:spTree>
-      <p:nvGrpSpPr>
-        <p:cNvPr id="1" name=""/>
-        <p:cNvGrpSpPr/>
-        <p:nvPr/>
-      </p:nvGrpSpPr>
-      <p:grpSpPr>
-        <a:xfrm>
-          <a:off x="0" y="0"/>
-          <a:ext cx="0" cy="0"/>
-          <a:chOff x="0" y="0"/>
-          <a:chExt cx="0" cy="0"/>
-        </a:xfrm>
-      </p:grpSpPr>
-      <p:sp>
-        <p:nvSpPr>
-          <p:cNvPr id="2" name="Slide Image Placeholder 1"/>
-          <p:cNvSpPr>
-            <a:spLocks noGrp="1"/>
-          </p:cNvSpPr>
-          <p:nvPr>
-            <p:ph type="sldImg" idx="2"/>
-          </p:nvPr>
-        </p:nvSpPr>
-        <p:spPr>
-          <a:xfrm>
-            <a:off x="685800" y="685800"/>
-            <a:ext cx="5486400" cy="3086100"/>
-          </a:xfrm>
-          <a:prstGeom prst="rect"/>
-        </p:spPr>
-      </p:sp>
-      <p:sp>
-        <p:nvSpPr>
-          <p:cNvPr id="3" name="Notes Placeholder 2"/>
-          <p:cNvSpPr>
-            <a:spLocks noGrp="1"/>
-          </p:cNvSpPr>
-          <p:nvPr>
-            <p:ph type="body" sz="quarter" idx="1"/>
-          </p:nvPr>
-        </p:nvSpPr>
-        <p:spPr>
-          <a:xfrm>
-            <a:off x="685800" y="4114800"/>
-            <a:ext cx="5486400" cy="4114800"/>
-          </a:xfrm>
-          <a:prstGeom prst="rect"/>
-        </p:spPr>
-        <p:txBody>
-          <a:bodyPr/>
-          <a:lstStyle/>
-          <a:p>
-            <a:r>
-              <a:rPr lang="en-US" sz="1500"/>
-              <a:t>The RAG flow has four steps: retrieve, inject, generate, and cite.</a:t>
-            </a:r>
-          </a:p>
-          <a:p>
-            <a:r>
-              <a:rPr lang="en-US" sz="1500"/>
-              <a:t>The question is matched against ChromaDB transcript chunks.</a:t>
-            </a:r>
-          </a:p>
-          <a:p>
-            <a:r>
-              <a:rPr lang="en-US" sz="1500"/>
-              <a:t>Only the retrieved transcript context, memory, and rules are passed to the model.</a:t>
-            </a:r>
-          </a:p>
-          <a:p>
-            <a:r>
-              <a:rPr lang="en-US" sz="1500"/>
-              <a:t>GPT-4o-mini writes from retrieved context, and the UI shows timestamp citations.</a:t>
-            </a:r>
-          </a:p>
-          <a:p>
-            <a:r>
-              <a:rPr lang="en-US" sz="1500"/>
-              <a:t>If the transcript does not contain the answer, the system should refuse. That is the anti-hallucination behavior.</a:t>
-            </a:r>
-          </a:p>
-        </p:txBody>
-      </p:sp>
-    </p:spTree>
-  </p:cSld>
-  <p:clrMapOvr>
-    <a:masterClrMapping/>
-  </p:clrMapOvr>
-</p:notes>
-</file>
-
-<file path=ppt/notesSlides/notesSlide8.xml><?xml version="1.0" encoding="utf-8"?>
-<p:notes xmlns:p="http://schemas.openxmlformats.org/presentationml/2006/main" xmlns:a="http://schemas.openxmlformats.org/drawingml/2006/main" xmlns:r="http://schemas.openxmlformats.org/officeDocument/2006/relationships">
-  <p:cSld>
-    <p:spTree>
-      <p:nvGrpSpPr>
-        <p:cNvPr id="1" name=""/>
-        <p:cNvGrpSpPr/>
-        <p:nvPr/>
-      </p:nvGrpSpPr>
-      <p:grpSpPr>
-        <a:xfrm>
-          <a:off x="0" y="0"/>
-          <a:ext cx="0" cy="0"/>
-          <a:chOff x="0" y="0"/>
-          <a:chExt cx="0" cy="0"/>
-        </a:xfrm>
-      </p:grpSpPr>
-      <p:sp>
-        <p:nvSpPr>
-          <p:cNvPr id="2" name="Slide Image Placeholder 1"/>
-          <p:cNvSpPr>
-            <a:spLocks noGrp="1"/>
-          </p:cNvSpPr>
-          <p:nvPr>
-            <p:ph type="sldImg" idx="2"/>
-          </p:nvPr>
-        </p:nvSpPr>
-        <p:spPr>
-          <a:xfrm>
-            <a:off x="685800" y="685800"/>
-            <a:ext cx="5486400" cy="3086100"/>
-          </a:xfrm>
-          <a:prstGeom prst="rect"/>
-        </p:spPr>
-      </p:sp>
-      <p:sp>
-        <p:nvSpPr>
-          <p:cNvPr id="3" name="Notes Placeholder 2"/>
-          <p:cNvSpPr>
-            <a:spLocks noGrp="1"/>
-          </p:cNvSpPr>
-          <p:nvPr>
-            <p:ph type="body" sz="quarter" idx="1"/>
-          </p:nvPr>
-        </p:nvSpPr>
-        <p:spPr>
-          <a:xfrm>
-            <a:off x="685800" y="4114800"/>
-            <a:ext cx="5486400" cy="4114800"/>
-          </a:xfrm>
-          <a:prstGeom prst="rect"/>
-        </p:spPr>
-        <p:txBody>
-          <a:bodyPr/>
-          <a:lstStyle/>
-          <a:p>
-            <a:r>
-              <a:rPr lang="en-US" sz="1500"/>
-              <a:t>These are optional UX features that make the project feel like a real learning product.</a:t>
-            </a:r>
-          </a:p>
-          <a:p>
-            <a:r>
-              <a:rPr lang="en-US" sz="1500"/>
-              <a:t>Voice search uses the browser Web Speech API first, then Whisper fallback if needed.</a:t>
-            </a:r>
-          </a:p>
-          <a:p>
-            <a:r>
-              <a:rPr lang="en-US" sz="1500"/>
-              <a:t>There is a 3D assistant, loading skeletons, retry states, text-to-speech for answers, responsive layouts, and accessibility work.</a:t>
-            </a:r>
-          </a:p>
-          <a:p>
-            <a:r>
-              <a:rPr lang="en-US" sz="1500"/>
-              <a:t>Key message: the UX supports the learning flow, but the core project remains RAG.</a:t>
-            </a:r>
-          </a:p>
-        </p:txBody>
-      </p:sp>
-    </p:spTree>
-  </p:cSld>
-  <p:clrMapOvr>
-    <a:masterClrMapping/>
-  </p:clrMapOvr>
-</p:notes>
-</file>
-
-<file path=ppt/notesSlides/notesSlide9.xml><?xml version="1.0" encoding="utf-8"?>
-<p:notes xmlns:p="http://schemas.openxmlformats.org/presentationml/2006/main" xmlns:a="http://schemas.openxmlformats.org/drawingml/2006/main" xmlns:r="http://schemas.openxmlformats.org/officeDocument/2006/relationships">
-  <p:cSld>
-    <p:spTree>
-      <p:nvGrpSpPr>
-        <p:cNvPr id="1" name=""/>
-        <p:cNvGrpSpPr/>
-        <p:nvPr/>
-      </p:nvGrpSpPr>
-      <p:grpSpPr>
-        <a:xfrm>
-          <a:off x="0" y="0"/>
-          <a:ext cx="0" cy="0"/>
-          <a:chOff x="0" y="0"/>
-          <a:chExt cx="0" cy="0"/>
-        </a:xfrm>
-      </p:grpSpPr>
-      <p:sp>
-        <p:nvSpPr>
-          <p:cNvPr id="2" name="Slide Image Placeholder 1"/>
-          <p:cNvSpPr>
-            <a:spLocks noGrp="1"/>
-          </p:cNvSpPr>
-          <p:nvPr>
-            <p:ph type="sldImg" idx="2"/>
-          </p:nvPr>
-        </p:nvSpPr>
-        <p:spPr>
-          <a:xfrm>
-            <a:off x="685800" y="685800"/>
-            <a:ext cx="5486400" cy="3086100"/>
-          </a:xfrm>
-          <a:prstGeom prst="rect"/>
-        </p:spPr>
-      </p:sp>
-      <p:sp>
-        <p:nvSpPr>
-          <p:cNvPr id="3" name="Notes Placeholder 2"/>
-          <p:cNvSpPr>
-            <a:spLocks noGrp="1"/>
-          </p:cNvSpPr>
-          <p:nvPr>
-            <p:ph type="body" sz="quarter" idx="1"/>
-          </p:nvPr>
-        </p:nvSpPr>
-        <p:spPr>
-          <a:xfrm>
-            <a:off x="685800" y="4114800"/>
-            <a:ext cx="5486400" cy="4114800"/>
-          </a:xfrm>
-          <a:prstGeom prst="rect"/>
-        </p:spPr>
-        <p:txBody>
-          <a:bodyPr/>
-          <a:lstStyle/>
-          <a:p>
-            <a:r>
-              <a:rPr lang="en-US" sz="1500"/>
-              <a:t>The backend has 98 pytest tests covering routes, services, tools, WebSocket ingestion, speech, memory, vector storage, and RAG behavior.</a:t>
-            </a:r>
-          </a:p>
-          <a:p>
-            <a:r>
-              <a:rPr lang="en-US" sz="1500"/>
-              <a:t>There is also a 17-case RAG evaluation dataset.</a:t>
-            </a:r>
-          </a:p>
-          <a:p>
-            <a:r>
-              <a:rPr lang="en-US" sz="1500"/>
-              <a:t>The evaluation cases check answerable questions, refusals, citation accuracy, summaries, memory, and hallucination prevention.</a:t>
-            </a:r>
-          </a:p>
-          <a:p>
-            <a:r>
-              <a:rPr lang="en-US" sz="1500"/>
-              <a:t>LangSmith tracing can inspect latency, context, tool calls, and answer quality.</a:t>
-            </a:r>
-          </a:p>
-        </p:txBody>
-      </p:sp>
-    </p:spTree>
-  </p:cSld>
-  <p:clrMapOvr>
-    <a:masterClrMapping/>
-  </p:clrMapOvr>
-</p:notes>
 </file>
 
 <file path=ppt/slideLayouts/slideLayout1.xml><?xml version="1.0" encoding="utf-8"?>
@@ -1217,9 +155,10 @@
           <a:lstStyle/>
           <a:p>
             <a:r>
-              <a:rPr lang="en-US"/>
+              <a:rPr lang="en-US" smtClean="0"/>
               <a:t>Click to edit Master title style</a:t>
             </a:r>
+            <a:endParaRPr lang="en-US"/>
           </a:p>
         </p:txBody>
       </p:sp>
@@ -1335,9 +274,10 @@
           </a:lstStyle>
           <a:p>
             <a:r>
-              <a:rPr lang="en-US"/>
+              <a:rPr lang="en-US" smtClean="0"/>
               <a:t>Click to edit Master subtitle style</a:t>
             </a:r>
+            <a:endParaRPr lang="en-US"/>
           </a:p>
         </p:txBody>
       </p:sp>
@@ -1358,7 +298,7 @@
           <a:p>
             <a:fld id="{5BCAD085-E8A6-8845-BD4E-CB4CCA059FC4}" type="datetimeFigureOut">
               <a:rPr lang="en-US" smtClean="0"/>
-              <a:t>5/26/2026</a:t>
+              <a:t>1/27/13</a:t>
             </a:fld>
             <a:endParaRPr lang="en-US"/>
           </a:p>
@@ -1452,9 +392,10 @@
           <a:lstStyle/>
           <a:p>
             <a:r>
-              <a:rPr lang="en-US"/>
+              <a:rPr lang="en-US" smtClean="0"/>
               <a:t>Click to edit Master title style</a:t>
             </a:r>
+            <a:endParaRPr lang="en-US"/>
           </a:p>
         </p:txBody>
       </p:sp>
@@ -1475,37 +416,38 @@
           <a:p>
             <a:pPr lvl="0"/>
             <a:r>
-              <a:rPr lang="en-US"/>
+              <a:rPr lang="en-US" smtClean="0"/>
               <a:t>Click to edit Master text styles</a:t>
             </a:r>
           </a:p>
           <a:p>
             <a:pPr lvl="1"/>
             <a:r>
-              <a:rPr lang="en-US"/>
+              <a:rPr lang="en-US" smtClean="0"/>
               <a:t>Second level</a:t>
             </a:r>
           </a:p>
           <a:p>
             <a:pPr lvl="2"/>
             <a:r>
-              <a:rPr lang="en-US"/>
+              <a:rPr lang="en-US" smtClean="0"/>
               <a:t>Third level</a:t>
             </a:r>
           </a:p>
           <a:p>
             <a:pPr lvl="3"/>
             <a:r>
-              <a:rPr lang="en-US"/>
+              <a:rPr lang="en-US" smtClean="0"/>
               <a:t>Fourth level</a:t>
             </a:r>
           </a:p>
           <a:p>
             <a:pPr lvl="4"/>
             <a:r>
-              <a:rPr lang="en-US"/>
+              <a:rPr lang="en-US" smtClean="0"/>
               <a:t>Fifth level</a:t>
             </a:r>
+            <a:endParaRPr lang="en-US"/>
           </a:p>
         </p:txBody>
       </p:sp>
@@ -1526,7 +468,7 @@
           <a:p>
             <a:fld id="{5BCAD085-E8A6-8845-BD4E-CB4CCA059FC4}" type="datetimeFigureOut">
               <a:rPr lang="en-US" smtClean="0"/>
-              <a:t>5/26/2026</a:t>
+              <a:t>1/27/13</a:t>
             </a:fld>
             <a:endParaRPr lang="en-US"/>
           </a:p>
@@ -1625,9 +567,10 @@
           <a:lstStyle/>
           <a:p>
             <a:r>
-              <a:rPr lang="en-US"/>
+              <a:rPr lang="en-US" smtClean="0"/>
               <a:t>Click to edit Master title style</a:t>
             </a:r>
+            <a:endParaRPr lang="en-US"/>
           </a:p>
         </p:txBody>
       </p:sp>
@@ -1653,37 +596,38 @@
           <a:p>
             <a:pPr lvl="0"/>
             <a:r>
-              <a:rPr lang="en-US"/>
+              <a:rPr lang="en-US" smtClean="0"/>
               <a:t>Click to edit Master text styles</a:t>
             </a:r>
           </a:p>
           <a:p>
             <a:pPr lvl="1"/>
             <a:r>
-              <a:rPr lang="en-US"/>
+              <a:rPr lang="en-US" smtClean="0"/>
               <a:t>Second level</a:t>
             </a:r>
           </a:p>
           <a:p>
             <a:pPr lvl="2"/>
             <a:r>
-              <a:rPr lang="en-US"/>
+              <a:rPr lang="en-US" smtClean="0"/>
               <a:t>Third level</a:t>
             </a:r>
           </a:p>
           <a:p>
             <a:pPr lvl="3"/>
             <a:r>
-              <a:rPr lang="en-US"/>
+              <a:rPr lang="en-US" smtClean="0"/>
               <a:t>Fourth level</a:t>
             </a:r>
           </a:p>
           <a:p>
             <a:pPr lvl="4"/>
             <a:r>
-              <a:rPr lang="en-US"/>
+              <a:rPr lang="en-US" smtClean="0"/>
               <a:t>Fifth level</a:t>
             </a:r>
+            <a:endParaRPr lang="en-US"/>
           </a:p>
         </p:txBody>
       </p:sp>
@@ -1704,7 +648,7 @@
           <a:p>
             <a:fld id="{5BCAD085-E8A6-8845-BD4E-CB4CCA059FC4}" type="datetimeFigureOut">
               <a:rPr lang="en-US" smtClean="0"/>
-              <a:t>5/26/2026</a:t>
+              <a:t>1/27/13</a:t>
             </a:fld>
             <a:endParaRPr lang="en-US"/>
           </a:p>
@@ -1798,9 +742,10 @@
           <a:lstStyle/>
           <a:p>
             <a:r>
-              <a:rPr lang="en-US"/>
+              <a:rPr lang="en-US" smtClean="0"/>
               <a:t>Click to edit Master title style</a:t>
             </a:r>
+            <a:endParaRPr lang="en-US"/>
           </a:p>
         </p:txBody>
       </p:sp>
@@ -1821,37 +766,38 @@
           <a:p>
             <a:pPr lvl="0"/>
             <a:r>
-              <a:rPr lang="en-US"/>
+              <a:rPr lang="en-US" smtClean="0"/>
               <a:t>Click to edit Master text styles</a:t>
             </a:r>
           </a:p>
           <a:p>
             <a:pPr lvl="1"/>
             <a:r>
-              <a:rPr lang="en-US"/>
+              <a:rPr lang="en-US" smtClean="0"/>
               <a:t>Second level</a:t>
             </a:r>
           </a:p>
           <a:p>
             <a:pPr lvl="2"/>
             <a:r>
-              <a:rPr lang="en-US"/>
+              <a:rPr lang="en-US" smtClean="0"/>
               <a:t>Third level</a:t>
             </a:r>
           </a:p>
           <a:p>
             <a:pPr lvl="3"/>
             <a:r>
-              <a:rPr lang="en-US"/>
+              <a:rPr lang="en-US" smtClean="0"/>
               <a:t>Fourth level</a:t>
             </a:r>
           </a:p>
           <a:p>
             <a:pPr lvl="4"/>
             <a:r>
-              <a:rPr lang="en-US"/>
+              <a:rPr lang="en-US" smtClean="0"/>
               <a:t>Fifth level</a:t>
             </a:r>
+            <a:endParaRPr lang="en-US"/>
           </a:p>
         </p:txBody>
       </p:sp>
@@ -1872,7 +818,7 @@
           <a:p>
             <a:fld id="{5BCAD085-E8A6-8845-BD4E-CB4CCA059FC4}" type="datetimeFigureOut">
               <a:rPr lang="en-US" smtClean="0"/>
-              <a:t>5/26/2026</a:t>
+              <a:t>1/27/13</a:t>
             </a:fld>
             <a:endParaRPr lang="en-US"/>
           </a:p>
@@ -1975,9 +921,10 @@
           </a:lstStyle>
           <a:p>
             <a:r>
-              <a:rPr lang="en-US"/>
+              <a:rPr lang="en-US" smtClean="0"/>
               <a:t>Click to edit Master title style</a:t>
             </a:r>
+            <a:endParaRPr lang="en-US"/>
           </a:p>
         </p:txBody>
       </p:sp>
@@ -2094,7 +1041,7 @@
           <a:p>
             <a:pPr lvl="0"/>
             <a:r>
-              <a:rPr lang="en-US"/>
+              <a:rPr lang="en-US" smtClean="0"/>
               <a:t>Click to edit Master text styles</a:t>
             </a:r>
           </a:p>
@@ -2117,7 +1064,7 @@
           <a:p>
             <a:fld id="{5BCAD085-E8A6-8845-BD4E-CB4CCA059FC4}" type="datetimeFigureOut">
               <a:rPr lang="en-US" smtClean="0"/>
-              <a:t>5/26/2026</a:t>
+              <a:t>1/27/13</a:t>
             </a:fld>
             <a:endParaRPr lang="en-US"/>
           </a:p>
@@ -2211,9 +1158,10 @@
           <a:lstStyle/>
           <a:p>
             <a:r>
-              <a:rPr lang="en-US"/>
+              <a:rPr lang="en-US" smtClean="0"/>
               <a:t>Click to edit Master title style</a:t>
             </a:r>
+            <a:endParaRPr lang="en-US"/>
           </a:p>
         </p:txBody>
       </p:sp>
@@ -2267,37 +1215,38 @@
           <a:p>
             <a:pPr lvl="0"/>
             <a:r>
-              <a:rPr lang="en-US"/>
+              <a:rPr lang="en-US" smtClean="0"/>
               <a:t>Click to edit Master text styles</a:t>
             </a:r>
           </a:p>
           <a:p>
             <a:pPr lvl="1"/>
             <a:r>
-              <a:rPr lang="en-US"/>
+              <a:rPr lang="en-US" smtClean="0"/>
               <a:t>Second level</a:t>
             </a:r>
           </a:p>
           <a:p>
             <a:pPr lvl="2"/>
             <a:r>
-              <a:rPr lang="en-US"/>
+              <a:rPr lang="en-US" smtClean="0"/>
               <a:t>Third level</a:t>
             </a:r>
           </a:p>
           <a:p>
             <a:pPr lvl="3"/>
             <a:r>
-              <a:rPr lang="en-US"/>
+              <a:rPr lang="en-US" smtClean="0"/>
               <a:t>Fourth level</a:t>
             </a:r>
           </a:p>
           <a:p>
             <a:pPr lvl="4"/>
             <a:r>
-              <a:rPr lang="en-US"/>
+              <a:rPr lang="en-US" smtClean="0"/>
               <a:t>Fifth level</a:t>
             </a:r>
+            <a:endParaRPr lang="en-US"/>
           </a:p>
         </p:txBody>
       </p:sp>
@@ -2351,37 +1300,38 @@
           <a:p>
             <a:pPr lvl="0"/>
             <a:r>
-              <a:rPr lang="en-US"/>
+              <a:rPr lang="en-US" smtClean="0"/>
               <a:t>Click to edit Master text styles</a:t>
             </a:r>
           </a:p>
           <a:p>
             <a:pPr lvl="1"/>
             <a:r>
-              <a:rPr lang="en-US"/>
+              <a:rPr lang="en-US" smtClean="0"/>
               <a:t>Second level</a:t>
             </a:r>
           </a:p>
           <a:p>
             <a:pPr lvl="2"/>
             <a:r>
-              <a:rPr lang="en-US"/>
+              <a:rPr lang="en-US" smtClean="0"/>
               <a:t>Third level</a:t>
             </a:r>
           </a:p>
           <a:p>
             <a:pPr lvl="3"/>
             <a:r>
-              <a:rPr lang="en-US"/>
+              <a:rPr lang="en-US" smtClean="0"/>
               <a:t>Fourth level</a:t>
             </a:r>
           </a:p>
           <a:p>
             <a:pPr lvl="4"/>
             <a:r>
-              <a:rPr lang="en-US"/>
+              <a:rPr lang="en-US" smtClean="0"/>
               <a:t>Fifth level</a:t>
             </a:r>
+            <a:endParaRPr lang="en-US"/>
           </a:p>
         </p:txBody>
       </p:sp>
@@ -2402,7 +1352,7 @@
           <a:p>
             <a:fld id="{5BCAD085-E8A6-8845-BD4E-CB4CCA059FC4}" type="datetimeFigureOut">
               <a:rPr lang="en-US" smtClean="0"/>
-              <a:t>5/26/2026</a:t>
+              <a:t>1/27/13</a:t>
             </a:fld>
             <a:endParaRPr lang="en-US"/>
           </a:p>
@@ -2500,9 +1450,10 @@
           </a:lstStyle>
           <a:p>
             <a:r>
-              <a:rPr lang="en-US"/>
+              <a:rPr lang="en-US" smtClean="0"/>
               <a:t>Click to edit Master title style</a:t>
             </a:r>
+            <a:endParaRPr lang="en-US"/>
           </a:p>
         </p:txBody>
       </p:sp>
@@ -2565,7 +1516,7 @@
           <a:p>
             <a:pPr lvl="0"/>
             <a:r>
-              <a:rPr lang="en-US"/>
+              <a:rPr lang="en-US" smtClean="0"/>
               <a:t>Click to edit Master text styles</a:t>
             </a:r>
           </a:p>
@@ -2621,37 +1572,38 @@
           <a:p>
             <a:pPr lvl="0"/>
             <a:r>
-              <a:rPr lang="en-US"/>
+              <a:rPr lang="en-US" smtClean="0"/>
               <a:t>Click to edit Master text styles</a:t>
             </a:r>
           </a:p>
           <a:p>
             <a:pPr lvl="1"/>
             <a:r>
-              <a:rPr lang="en-US"/>
+              <a:rPr lang="en-US" smtClean="0"/>
               <a:t>Second level</a:t>
             </a:r>
           </a:p>
           <a:p>
             <a:pPr lvl="2"/>
             <a:r>
-              <a:rPr lang="en-US"/>
+              <a:rPr lang="en-US" smtClean="0"/>
               <a:t>Third level</a:t>
             </a:r>
           </a:p>
           <a:p>
             <a:pPr lvl="3"/>
             <a:r>
-              <a:rPr lang="en-US"/>
+              <a:rPr lang="en-US" smtClean="0"/>
               <a:t>Fourth level</a:t>
             </a:r>
           </a:p>
           <a:p>
             <a:pPr lvl="4"/>
             <a:r>
-              <a:rPr lang="en-US"/>
+              <a:rPr lang="en-US" smtClean="0"/>
               <a:t>Fifth level</a:t>
             </a:r>
+            <a:endParaRPr lang="en-US"/>
           </a:p>
         </p:txBody>
       </p:sp>
@@ -2714,7 +1666,7 @@
           <a:p>
             <a:pPr lvl="0"/>
             <a:r>
-              <a:rPr lang="en-US"/>
+              <a:rPr lang="en-US" smtClean="0"/>
               <a:t>Click to edit Master text styles</a:t>
             </a:r>
           </a:p>
@@ -2770,37 +1722,38 @@
           <a:p>
             <a:pPr lvl="0"/>
             <a:r>
-              <a:rPr lang="en-US"/>
+              <a:rPr lang="en-US" smtClean="0"/>
               <a:t>Click to edit Master text styles</a:t>
             </a:r>
           </a:p>
           <a:p>
             <a:pPr lvl="1"/>
             <a:r>
-              <a:rPr lang="en-US"/>
+              <a:rPr lang="en-US" smtClean="0"/>
               <a:t>Second level</a:t>
             </a:r>
           </a:p>
           <a:p>
             <a:pPr lvl="2"/>
             <a:r>
-              <a:rPr lang="en-US"/>
+              <a:rPr lang="en-US" smtClean="0"/>
               <a:t>Third level</a:t>
             </a:r>
           </a:p>
           <a:p>
             <a:pPr lvl="3"/>
             <a:r>
-              <a:rPr lang="en-US"/>
+              <a:rPr lang="en-US" smtClean="0"/>
               <a:t>Fourth level</a:t>
             </a:r>
           </a:p>
           <a:p>
             <a:pPr lvl="4"/>
             <a:r>
-              <a:rPr lang="en-US"/>
+              <a:rPr lang="en-US" smtClean="0"/>
               <a:t>Fifth level</a:t>
             </a:r>
+            <a:endParaRPr lang="en-US"/>
           </a:p>
         </p:txBody>
       </p:sp>
@@ -2821,7 +1774,7 @@
           <a:p>
             <a:fld id="{5BCAD085-E8A6-8845-BD4E-CB4CCA059FC4}" type="datetimeFigureOut">
               <a:rPr lang="en-US" smtClean="0"/>
-              <a:t>5/26/2026</a:t>
+              <a:t>1/27/13</a:t>
             </a:fld>
             <a:endParaRPr lang="en-US"/>
           </a:p>
@@ -2915,9 +1868,10 @@
           <a:lstStyle/>
           <a:p>
             <a:r>
-              <a:rPr lang="en-US"/>
+              <a:rPr lang="en-US" smtClean="0"/>
               <a:t>Click to edit Master title style</a:t>
             </a:r>
+            <a:endParaRPr lang="en-US"/>
           </a:p>
         </p:txBody>
       </p:sp>
@@ -2938,7 +1892,7 @@
           <a:p>
             <a:fld id="{5BCAD085-E8A6-8845-BD4E-CB4CCA059FC4}" type="datetimeFigureOut">
               <a:rPr lang="en-US" smtClean="0"/>
-              <a:t>5/26/2026</a:t>
+              <a:t>1/27/13</a:t>
             </a:fld>
             <a:endParaRPr lang="en-US"/>
           </a:p>
@@ -3033,7 +1987,7 @@
           <a:p>
             <a:fld id="{5BCAD085-E8A6-8845-BD4E-CB4CCA059FC4}" type="datetimeFigureOut">
               <a:rPr lang="en-US" smtClean="0"/>
-              <a:t>5/26/2026</a:t>
+              <a:t>1/27/13</a:t>
             </a:fld>
             <a:endParaRPr lang="en-US"/>
           </a:p>
@@ -3136,9 +2090,10 @@
           </a:lstStyle>
           <a:p>
             <a:r>
-              <a:rPr lang="en-US"/>
+              <a:rPr lang="en-US" smtClean="0"/>
               <a:t>Click to edit Master title style</a:t>
             </a:r>
+            <a:endParaRPr lang="en-US"/>
           </a:p>
         </p:txBody>
       </p:sp>
@@ -3192,37 +2147,38 @@
           <a:p>
             <a:pPr lvl="0"/>
             <a:r>
-              <a:rPr lang="en-US"/>
+              <a:rPr lang="en-US" smtClean="0"/>
               <a:t>Click to edit Master text styles</a:t>
             </a:r>
           </a:p>
           <a:p>
             <a:pPr lvl="1"/>
             <a:r>
-              <a:rPr lang="en-US"/>
+              <a:rPr lang="en-US" smtClean="0"/>
               <a:t>Second level</a:t>
             </a:r>
           </a:p>
           <a:p>
             <a:pPr lvl="2"/>
             <a:r>
-              <a:rPr lang="en-US"/>
+              <a:rPr lang="en-US" smtClean="0"/>
               <a:t>Third level</a:t>
             </a:r>
           </a:p>
           <a:p>
             <a:pPr lvl="3"/>
             <a:r>
-              <a:rPr lang="en-US"/>
+              <a:rPr lang="en-US" smtClean="0"/>
               <a:t>Fourth level</a:t>
             </a:r>
           </a:p>
           <a:p>
             <a:pPr lvl="4"/>
             <a:r>
-              <a:rPr lang="en-US"/>
+              <a:rPr lang="en-US" smtClean="0"/>
               <a:t>Fifth level</a:t>
             </a:r>
+            <a:endParaRPr lang="en-US"/>
           </a:p>
         </p:txBody>
       </p:sp>
@@ -3285,7 +2241,7 @@
           <a:p>
             <a:pPr lvl="0"/>
             <a:r>
-              <a:rPr lang="en-US"/>
+              <a:rPr lang="en-US" smtClean="0"/>
               <a:t>Click to edit Master text styles</a:t>
             </a:r>
           </a:p>
@@ -3308,7 +2264,7 @@
           <a:p>
             <a:fld id="{5BCAD085-E8A6-8845-BD4E-CB4CCA059FC4}" type="datetimeFigureOut">
               <a:rPr lang="en-US" smtClean="0"/>
-              <a:t>5/26/2026</a:t>
+              <a:t>1/27/13</a:t>
             </a:fld>
             <a:endParaRPr lang="en-US"/>
           </a:p>
@@ -3411,9 +2367,10 @@
           </a:lstStyle>
           <a:p>
             <a:r>
-              <a:rPr lang="en-US"/>
+              <a:rPr lang="en-US" smtClean="0"/>
               <a:t>Click to edit Master title style</a:t>
             </a:r>
+            <a:endParaRPr lang="en-US"/>
           </a:p>
         </p:txBody>
       </p:sp>
@@ -3537,7 +2494,7 @@
           <a:p>
             <a:pPr lvl="0"/>
             <a:r>
-              <a:rPr lang="en-US"/>
+              <a:rPr lang="en-US" smtClean="0"/>
               <a:t>Click to edit Master text styles</a:t>
             </a:r>
           </a:p>
@@ -3560,7 +2517,7 @@
           <a:p>
             <a:fld id="{5BCAD085-E8A6-8845-BD4E-CB4CCA059FC4}" type="datetimeFigureOut">
               <a:rPr lang="en-US" smtClean="0"/>
-              <a:t>5/26/2026</a:t>
+              <a:t>1/27/13</a:t>
             </a:fld>
             <a:endParaRPr lang="en-US"/>
           </a:p>
@@ -3669,9 +2626,10 @@
           <a:lstStyle/>
           <a:p>
             <a:r>
-              <a:rPr lang="en-US"/>
+              <a:rPr lang="en-US" smtClean="0"/>
               <a:t>Click to edit Master title style</a:t>
             </a:r>
+            <a:endParaRPr lang="en-US"/>
           </a:p>
         </p:txBody>
       </p:sp>
@@ -3702,37 +2660,38 @@
           <a:p>
             <a:pPr lvl="0"/>
             <a:r>
-              <a:rPr lang="en-US"/>
+              <a:rPr lang="en-US" smtClean="0"/>
               <a:t>Click to edit Master text styles</a:t>
             </a:r>
           </a:p>
           <a:p>
             <a:pPr lvl="1"/>
             <a:r>
-              <a:rPr lang="en-US"/>
+              <a:rPr lang="en-US" smtClean="0"/>
               <a:t>Second level</a:t>
             </a:r>
           </a:p>
           <a:p>
             <a:pPr lvl="2"/>
             <a:r>
-              <a:rPr lang="en-US"/>
+              <a:rPr lang="en-US" smtClean="0"/>
               <a:t>Third level</a:t>
             </a:r>
           </a:p>
           <a:p>
             <a:pPr lvl="3"/>
             <a:r>
-              <a:rPr lang="en-US"/>
+              <a:rPr lang="en-US" smtClean="0"/>
               <a:t>Fourth level</a:t>
             </a:r>
           </a:p>
           <a:p>
             <a:pPr lvl="4"/>
             <a:r>
-              <a:rPr lang="en-US"/>
+              <a:rPr lang="en-US" smtClean="0"/>
               <a:t>Fifth level</a:t>
             </a:r>
+            <a:endParaRPr lang="en-US"/>
           </a:p>
         </p:txBody>
       </p:sp>
@@ -3771,7 +2730,7 @@
           <a:p>
             <a:fld id="{5BCAD085-E8A6-8845-BD4E-CB4CCA059FC4}" type="datetimeFigureOut">
               <a:rPr lang="en-US" smtClean="0"/>
-              <a:t>5/26/2026</a:t>
+              <a:t>1/27/13</a:t>
             </a:fld>
             <a:endParaRPr lang="en-US"/>
           </a:p>
@@ -4130,7 +3089,7 @@
 </file>
 
 <file path=ppt/slides/slide1.xml><?xml version="1.0" encoding="utf-8"?>
-<p:sld xmlns:a="http://schemas.openxmlformats.org/drawingml/2006/main" xmlns:r="http://schemas.openxmlformats.org/officeDocument/2006/relationships" xmlns:p="http://schemas.openxmlformats.org/presentationml/2006/main">
+<p:sld xmlns:a="http://schemas.openxmlformats.org/drawingml/2006/main" xmlns:p="http://schemas.openxmlformats.org/presentationml/2006/main" xmlns:r="http://schemas.openxmlformats.org/officeDocument/2006/relationships">
   <p:cSld>
     <p:bg>
       <p:bgPr>
@@ -4146,14 +3105,7 @@
         <p:cNvGrpSpPr/>
         <p:nvPr/>
       </p:nvGrpSpPr>
-      <p:grpSpPr>
-        <a:xfrm>
-          <a:off x="0" y="0"/>
-          <a:ext cx="0" cy="0"/>
-          <a:chOff x="0" y="0"/>
-          <a:chExt cx="0" cy="0"/>
-        </a:xfrm>
-      </p:grpSpPr>
+      <p:grpSpPr/>
       <p:sp>
         <p:nvSpPr>
           <p:cNvPr id="2" name="Rounded Rectangle 1"/>
@@ -4194,7 +3146,6 @@
           <a:lstStyle/>
           <a:p>
             <a:pPr algn="ctr"/>
-            <a:endParaRPr/>
           </a:p>
         </p:txBody>
       </p:sp>
@@ -4238,7 +3189,6 @@
           <a:lstStyle/>
           <a:p>
             <a:pPr algn="ctr"/>
-            <a:endParaRPr/>
           </a:p>
         </p:txBody>
       </p:sp>
@@ -4282,7 +3232,6 @@
           <a:lstStyle/>
           <a:p>
             <a:pPr algn="ctr"/>
-            <a:endParaRPr/>
           </a:p>
         </p:txBody>
       </p:sp>
@@ -4364,7 +3313,7 @@
         </p:nvSpPr>
         <p:spPr>
           <a:xfrm>
-            <a:off x="713232" y="6199632"/>
+            <a:off x="713232" y="5989320"/>
             <a:ext cx="6035040" cy="256032"/>
           </a:xfrm>
           <a:prstGeom prst="rect">
@@ -4393,7 +3342,42 @@
       </p:sp>
       <p:sp>
         <p:nvSpPr>
-          <p:cNvPr id="8" name="Rounded Rectangle 7"/>
+          <p:cNvPr id="8" name="TextBox 7"/>
+          <p:cNvSpPr txBox="1"/>
+          <p:nvPr/>
+        </p:nvSpPr>
+        <p:spPr>
+          <a:xfrm>
+            <a:off x="713232" y="6236208"/>
+            <a:ext cx="6858000" cy="256032"/>
+          </a:xfrm>
+          <a:prstGeom prst="rect">
+            <a:avLst/>
+          </a:prstGeom>
+          <a:noFill/>
+        </p:spPr>
+        <p:txBody>
+          <a:bodyPr wrap="square">
+            <a:spAutoFit/>
+          </a:bodyPr>
+          <a:lstStyle/>
+          <a:p>
+            <a:pPr algn="l"/>
+            <a:r>
+              <a:rPr sz="1200" b="1">
+                <a:solidFill>
+                  <a:srgbClr val="22D3EE"/>
+                </a:solidFill>
+                <a:latin typeface="Aptos"/>
+              </a:rPr>
+              <a:t>Live demo: http://18.157.233.122:3001/</a:t>
+            </a:r>
+          </a:p>
+        </p:txBody>
+      </p:sp>
+      <p:sp>
+        <p:nvSpPr>
+          <p:cNvPr id="9" name="Rounded Rectangle 8"/>
           <p:cNvSpPr/>
           <p:nvPr/>
         </p:nvSpPr>
@@ -4433,13 +3417,12 @@
           <a:lstStyle/>
           <a:p>
             <a:pPr algn="ctr"/>
-            <a:endParaRPr/>
-          </a:p>
-        </p:txBody>
-      </p:sp>
-      <p:sp>
-        <p:nvSpPr>
-          <p:cNvPr id="9" name="TextBox 8"/>
+          </a:p>
+        </p:txBody>
+      </p:sp>
+      <p:sp>
+        <p:nvSpPr>
+          <p:cNvPr id="10" name="TextBox 9"/>
           <p:cNvSpPr txBox="1"/>
           <p:nvPr/>
         </p:nvSpPr>
@@ -4474,7 +3457,7 @@
       </p:sp>
       <p:sp>
         <p:nvSpPr>
-          <p:cNvPr id="10" name="TextBox 9"/>
+          <p:cNvPr id="11" name="TextBox 10"/>
           <p:cNvSpPr txBox="1"/>
           <p:nvPr/>
         </p:nvSpPr>
@@ -4509,7 +3492,7 @@
       </p:sp>
       <p:sp>
         <p:nvSpPr>
-          <p:cNvPr id="11" name="TextBox 10"/>
+          <p:cNvPr id="12" name="TextBox 11"/>
           <p:cNvSpPr txBox="1"/>
           <p:nvPr/>
         </p:nvSpPr>
@@ -4544,7 +3527,7 @@
       </p:sp>
       <p:sp>
         <p:nvSpPr>
-          <p:cNvPr id="12" name="TextBox 11"/>
+          <p:cNvPr id="13" name="TextBox 12"/>
           <p:cNvSpPr txBox="1"/>
           <p:nvPr/>
         </p:nvSpPr>
@@ -4579,7 +3562,7 @@
       </p:sp>
       <p:cxnSp>
         <p:nvCxnSpPr>
-          <p:cNvPr id="13" name="Connector 12"/>
+          <p:cNvPr id="14" name="Connector 13"/>
           <p:cNvCxnSpPr/>
           <p:nvPr/>
         </p:nvCxnSpPr>
@@ -4614,7 +3597,7 @@
       </p:cxnSp>
       <p:sp>
         <p:nvSpPr>
-          <p:cNvPr id="14" name="TextBox 13"/>
+          <p:cNvPr id="15" name="TextBox 14"/>
           <p:cNvSpPr txBox="1"/>
           <p:nvPr/>
         </p:nvSpPr>
@@ -4656,7 +3639,7 @@
 </file>
 
 <file path=ppt/slides/slide10.xml><?xml version="1.0" encoding="utf-8"?>
-<p:sld xmlns:a="http://schemas.openxmlformats.org/drawingml/2006/main" xmlns:r="http://schemas.openxmlformats.org/officeDocument/2006/relationships" xmlns:p="http://schemas.openxmlformats.org/presentationml/2006/main">
+<p:sld xmlns:a="http://schemas.openxmlformats.org/drawingml/2006/main" xmlns:p="http://schemas.openxmlformats.org/presentationml/2006/main" xmlns:r="http://schemas.openxmlformats.org/officeDocument/2006/relationships">
   <p:cSld>
     <p:bg>
       <p:bgPr>
@@ -4672,14 +3655,7 @@
         <p:cNvGrpSpPr/>
         <p:nvPr/>
       </p:nvGrpSpPr>
-      <p:grpSpPr>
-        <a:xfrm>
-          <a:off x="0" y="0"/>
-          <a:ext cx="0" cy="0"/>
-          <a:chOff x="0" y="0"/>
-          <a:chExt cx="0" cy="0"/>
-        </a:xfrm>
-      </p:grpSpPr>
+      <p:grpSpPr/>
       <p:sp>
         <p:nvSpPr>
           <p:cNvPr id="2" name="Rounded Rectangle 1"/>
@@ -4720,7 +3696,6 @@
           <a:lstStyle/>
           <a:p>
             <a:pPr algn="ctr"/>
-            <a:endParaRPr/>
           </a:p>
         </p:txBody>
       </p:sp>
@@ -4764,7 +3739,6 @@
           <a:lstStyle/>
           <a:p>
             <a:pPr algn="ctr"/>
-            <a:endParaRPr/>
           </a:p>
         </p:txBody>
       </p:sp>
@@ -4808,7 +3782,6 @@
           <a:lstStyle/>
           <a:p>
             <a:pPr algn="ctr"/>
-            <a:endParaRPr/>
           </a:p>
         </p:txBody>
       </p:sp>
@@ -4926,7 +3899,7 @@
         <p:spPr>
           <a:xfrm>
             <a:off x="868680" y="1828800"/>
-            <a:ext cx="6409944" cy="4201086"/>
+            <a:ext cx="5577840" cy="3931920"/>
           </a:xfrm>
           <a:prstGeom prst="rect">
             <a:avLst/>
@@ -4948,7 +3921,7 @@
               </a:spcAft>
             </a:pPr>
             <a:r>
-              <a:rPr sz="1700" b="1" dirty="0">
+              <a:rPr sz="1700" b="1">
                 <a:solidFill>
                   <a:srgbClr val="22D3EE"/>
                 </a:solidFill>
@@ -4957,13 +3930,13 @@
               <a:t>- </a:t>
             </a:r>
             <a:r>
-              <a:rPr sz="1700" dirty="0">
+              <a:rPr sz="1700">
                 <a:solidFill>
                   <a:srgbClr val="F6F8FF"/>
                 </a:solidFill>
                 <a:latin typeface="Aptos"/>
               </a:rPr>
-              <a:t>Open localhost:3000 for the full RAG demo, or EC2 :3001 to show deployment.</a:t>
+              <a:t>Live app: http://18.157.233.122:3001/ (EC2 deployment with Webshare proxy)</a:t>
             </a:r>
           </a:p>
           <a:p>
@@ -4976,7 +3949,7 @@
               </a:spcAft>
             </a:pPr>
             <a:r>
-              <a:rPr sz="1700" b="1" dirty="0">
+              <a:rPr sz="1700" b="1">
                 <a:solidFill>
                   <a:srgbClr val="22D3EE"/>
                 </a:solidFill>
@@ -4985,7 +3958,7 @@
               <a:t>- </a:t>
             </a:r>
             <a:r>
-              <a:rPr sz="1700" dirty="0">
+              <a:rPr sz="1700">
                 <a:solidFill>
                   <a:srgbClr val="F6F8FF"/>
                 </a:solidFill>
@@ -5004,7 +3977,7 @@
               </a:spcAft>
             </a:pPr>
             <a:r>
-              <a:rPr sz="1700" b="1" dirty="0">
+              <a:rPr sz="1700" b="1">
                 <a:solidFill>
                   <a:srgbClr val="22D3EE"/>
                 </a:solidFill>
@@ -5013,7 +3986,7 @@
               <a:t>- </a:t>
             </a:r>
             <a:r>
-              <a:rPr sz="1700" dirty="0">
+              <a:rPr sz="1700">
                 <a:solidFill>
                   <a:srgbClr val="F6F8FF"/>
                 </a:solidFill>
@@ -5032,7 +4005,7 @@
               </a:spcAft>
             </a:pPr>
             <a:r>
-              <a:rPr sz="1700" b="1" dirty="0">
+              <a:rPr sz="1700" b="1">
                 <a:solidFill>
                   <a:srgbClr val="22D3EE"/>
                 </a:solidFill>
@@ -5041,7 +4014,7 @@
               <a:t>- </a:t>
             </a:r>
             <a:r>
-              <a:rPr sz="1700" dirty="0">
+              <a:rPr sz="1700">
                 <a:solidFill>
                   <a:srgbClr val="F6F8FF"/>
                 </a:solidFill>
@@ -5060,7 +4033,7 @@
               </a:spcAft>
             </a:pPr>
             <a:r>
-              <a:rPr sz="1700" b="1" dirty="0">
+              <a:rPr sz="1700" b="1">
                 <a:solidFill>
                   <a:srgbClr val="22D3EE"/>
                 </a:solidFill>
@@ -5069,7 +4042,7 @@
               <a:t>- </a:t>
             </a:r>
             <a:r>
-              <a:rPr sz="1700" dirty="0">
+              <a:rPr sz="1700">
                 <a:solidFill>
                   <a:srgbClr val="F6F8FF"/>
                 </a:solidFill>
@@ -5088,7 +4061,7 @@
               </a:spcAft>
             </a:pPr>
             <a:r>
-              <a:rPr sz="1700" b="1" dirty="0">
+              <a:rPr sz="1700" b="1">
                 <a:solidFill>
                   <a:srgbClr val="22D3EE"/>
                 </a:solidFill>
@@ -5097,7 +4070,7 @@
               <a:t>- </a:t>
             </a:r>
             <a:r>
-              <a:rPr sz="1700" dirty="0">
+              <a:rPr sz="1700">
                 <a:solidFill>
                   <a:srgbClr val="F6F8FF"/>
                 </a:solidFill>
@@ -5116,7 +4089,7 @@
               </a:spcAft>
             </a:pPr>
             <a:r>
-              <a:rPr sz="1700" b="1" dirty="0">
+              <a:rPr sz="1700" b="1">
                 <a:solidFill>
                   <a:srgbClr val="22D3EE"/>
                 </a:solidFill>
@@ -5125,7 +4098,7 @@
               <a:t>- </a:t>
             </a:r>
             <a:r>
-              <a:rPr sz="1700" dirty="0">
+              <a:rPr sz="1700">
                 <a:solidFill>
                   <a:srgbClr val="F6F8FF"/>
                 </a:solidFill>
@@ -5144,7 +4117,7 @@
               </a:spcAft>
             </a:pPr>
             <a:r>
-              <a:rPr sz="1700" b="1" dirty="0">
+              <a:rPr sz="1700" b="1">
                 <a:solidFill>
                   <a:srgbClr val="22D3EE"/>
                 </a:solidFill>
@@ -5153,7 +4126,7 @@
               <a:t>- </a:t>
             </a:r>
             <a:r>
-              <a:rPr sz="1700" dirty="0">
+              <a:rPr sz="1700">
                 <a:solidFill>
                   <a:srgbClr val="F6F8FF"/>
                 </a:solidFill>
@@ -5172,7 +4145,7 @@
               </a:spcAft>
             </a:pPr>
             <a:r>
-              <a:rPr sz="1700" b="1" dirty="0">
+              <a:rPr sz="1700" b="1">
                 <a:solidFill>
                   <a:srgbClr val="22D3EE"/>
                 </a:solidFill>
@@ -5181,7 +4154,7 @@
               <a:t>- </a:t>
             </a:r>
             <a:r>
-              <a:rPr sz="1700" dirty="0">
+              <a:rPr sz="1700">
                 <a:solidFill>
                   <a:srgbClr val="F6F8FF"/>
                 </a:solidFill>
@@ -5234,7 +4207,6 @@
           <a:lstStyle/>
           <a:p>
             <a:pPr algn="ctr"/>
-            <a:endParaRPr/>
           </a:p>
         </p:txBody>
       </p:sp>
@@ -5352,7 +4324,7 @@
 </file>
 
 <file path=ppt/slides/slide11.xml><?xml version="1.0" encoding="utf-8"?>
-<p:sld xmlns:a="http://schemas.openxmlformats.org/drawingml/2006/main" xmlns:r="http://schemas.openxmlformats.org/officeDocument/2006/relationships" xmlns:p="http://schemas.openxmlformats.org/presentationml/2006/main">
+<p:sld xmlns:a="http://schemas.openxmlformats.org/drawingml/2006/main" xmlns:p="http://schemas.openxmlformats.org/presentationml/2006/main" xmlns:r="http://schemas.openxmlformats.org/officeDocument/2006/relationships">
   <p:cSld>
     <p:bg>
       <p:bgPr>
@@ -5368,14 +4340,7 @@
         <p:cNvGrpSpPr/>
         <p:nvPr/>
       </p:nvGrpSpPr>
-      <p:grpSpPr>
-        <a:xfrm>
-          <a:off x="0" y="0"/>
-          <a:ext cx="0" cy="0"/>
-          <a:chOff x="0" y="0"/>
-          <a:chExt cx="0" cy="0"/>
-        </a:xfrm>
-      </p:grpSpPr>
+      <p:grpSpPr/>
       <p:sp>
         <p:nvSpPr>
           <p:cNvPr id="2" name="Rounded Rectangle 1"/>
@@ -5416,7 +4381,6 @@
           <a:lstStyle/>
           <a:p>
             <a:pPr algn="ctr"/>
-            <a:endParaRPr/>
           </a:p>
         </p:txBody>
       </p:sp>
@@ -5460,7 +4424,6 @@
           <a:lstStyle/>
           <a:p>
             <a:pPr algn="ctr"/>
-            <a:endParaRPr/>
           </a:p>
         </p:txBody>
       </p:sp>
@@ -5504,7 +4467,6 @@
           <a:lstStyle/>
           <a:p>
             <a:pPr algn="ctr"/>
-            <a:endParaRPr/>
           </a:p>
         </p:txBody>
       </p:sp>
@@ -5586,8 +4548,8 @@
         </p:nvSpPr>
         <p:spPr>
           <a:xfrm>
-            <a:off x="777240" y="3227831"/>
-            <a:ext cx="3474720" cy="1581910"/>
+            <a:off x="777240" y="3749039"/>
+            <a:ext cx="3474720" cy="1234440"/>
           </a:xfrm>
           <a:prstGeom prst="roundRect">
             <a:avLst/>
@@ -5620,7 +4582,6 @@
           <a:lstStyle/>
           <a:p>
             <a:pPr algn="ctr"/>
-            <a:endParaRPr/>
           </a:p>
         </p:txBody>
       </p:sp>
@@ -5632,7 +4593,7 @@
         </p:nvSpPr>
         <p:spPr>
           <a:xfrm>
-            <a:off x="777240" y="3227831"/>
+            <a:off x="777240" y="3749039"/>
             <a:ext cx="73152" cy="1234440"/>
           </a:xfrm>
           <a:prstGeom prst="rect">
@@ -5664,7 +4625,6 @@
           <a:lstStyle/>
           <a:p>
             <a:pPr algn="ctr"/>
-            <a:endParaRPr/>
           </a:p>
         </p:txBody>
       </p:sp>
@@ -5676,7 +4636,7 @@
         </p:nvSpPr>
         <p:spPr>
           <a:xfrm>
-            <a:off x="978408" y="3392423"/>
+            <a:off x="978408" y="3913631"/>
             <a:ext cx="3154679" cy="228600"/>
           </a:xfrm>
           <a:prstGeom prst="rect">
@@ -5711,7 +4671,7 @@
         </p:nvSpPr>
         <p:spPr>
           <a:xfrm>
-            <a:off x="978408" y="3730751"/>
+            <a:off x="978408" y="4251959"/>
             <a:ext cx="3154679" cy="594360"/>
           </a:xfrm>
           <a:prstGeom prst="rect">
@@ -5746,8 +4706,8 @@
         </p:nvSpPr>
         <p:spPr>
           <a:xfrm>
-            <a:off x="4526280" y="3227830"/>
-            <a:ext cx="3474720" cy="1581911"/>
+            <a:off x="4526280" y="3749039"/>
+            <a:ext cx="3474720" cy="1234440"/>
           </a:xfrm>
           <a:prstGeom prst="roundRect">
             <a:avLst/>
@@ -5780,7 +4740,6 @@
           <a:lstStyle/>
           <a:p>
             <a:pPr algn="ctr"/>
-            <a:endParaRPr/>
           </a:p>
         </p:txBody>
       </p:sp>
@@ -5792,7 +4751,7 @@
         </p:nvSpPr>
         <p:spPr>
           <a:xfrm>
-            <a:off x="4526280" y="3227831"/>
+            <a:off x="4526280" y="3749039"/>
             <a:ext cx="73152" cy="1234440"/>
           </a:xfrm>
           <a:prstGeom prst="rect">
@@ -5824,7 +4783,6 @@
           <a:lstStyle/>
           <a:p>
             <a:pPr algn="ctr"/>
-            <a:endParaRPr/>
           </a:p>
         </p:txBody>
       </p:sp>
@@ -5836,7 +4794,7 @@
         </p:nvSpPr>
         <p:spPr>
           <a:xfrm>
-            <a:off x="4727448" y="3392423"/>
+            <a:off x="4727448" y="3913631"/>
             <a:ext cx="3154679" cy="228600"/>
           </a:xfrm>
           <a:prstGeom prst="rect">
@@ -5871,7 +4829,7 @@
         </p:nvSpPr>
         <p:spPr>
           <a:xfrm>
-            <a:off x="4727448" y="3730751"/>
+            <a:off x="4727448" y="4251959"/>
             <a:ext cx="3154679" cy="594360"/>
           </a:xfrm>
           <a:prstGeom prst="rect">
@@ -5906,8 +4864,8 @@
         </p:nvSpPr>
         <p:spPr>
           <a:xfrm>
-            <a:off x="8275320" y="3227831"/>
-            <a:ext cx="3108960" cy="1609346"/>
+            <a:off x="8275320" y="3749039"/>
+            <a:ext cx="3108960" cy="1234440"/>
           </a:xfrm>
           <a:prstGeom prst="roundRect">
             <a:avLst/>
@@ -5940,7 +4898,6 @@
           <a:lstStyle/>
           <a:p>
             <a:pPr algn="ctr"/>
-            <a:endParaRPr/>
           </a:p>
         </p:txBody>
       </p:sp>
@@ -5952,7 +4909,7 @@
         </p:nvSpPr>
         <p:spPr>
           <a:xfrm>
-            <a:off x="8275320" y="3227831"/>
+            <a:off x="8275320" y="3749039"/>
             <a:ext cx="73152" cy="1234440"/>
           </a:xfrm>
           <a:prstGeom prst="rect">
@@ -5984,7 +4941,6 @@
           <a:lstStyle/>
           <a:p>
             <a:pPr algn="ctr"/>
-            <a:endParaRPr/>
           </a:p>
         </p:txBody>
       </p:sp>
@@ -5996,7 +4952,7 @@
         </p:nvSpPr>
         <p:spPr>
           <a:xfrm>
-            <a:off x="8476488" y="3392423"/>
+            <a:off x="8476488" y="3913631"/>
             <a:ext cx="2788920" cy="228600"/>
           </a:xfrm>
           <a:prstGeom prst="rect">
@@ -6031,7 +4987,7 @@
         </p:nvSpPr>
         <p:spPr>
           <a:xfrm>
-            <a:off x="8476488" y="3730751"/>
+            <a:off x="8476488" y="4251959"/>
             <a:ext cx="2788920" cy="594360"/>
           </a:xfrm>
           <a:prstGeom prst="rect">
@@ -6047,7 +5003,7 @@
           <a:p>
             <a:pPr algn="l"/>
             <a:r>
-              <a:rPr sz="1400" b="0" dirty="0">
+              <a:rPr sz="1400" b="0">
                 <a:solidFill>
                   <a:srgbClr val="F6F8FF"/>
                 </a:solidFill>
@@ -6066,8 +5022,8 @@
         </p:nvSpPr>
         <p:spPr>
           <a:xfrm>
-            <a:off x="3154680" y="5486400"/>
-            <a:ext cx="2743200" cy="307777"/>
+            <a:off x="777240" y="6144768"/>
+            <a:ext cx="2743200" cy="274320"/>
           </a:xfrm>
           <a:prstGeom prst="rect">
             <a:avLst/>
@@ -6082,7 +5038,7 @@
           <a:p>
             <a:pPr algn="l"/>
             <a:r>
-              <a:rPr sz="1400" b="1" dirty="0">
+              <a:rPr sz="1400" b="1">
                 <a:solidFill>
                   <a:srgbClr val="94A3B8"/>
                 </a:solidFill>
@@ -6090,21 +5046,6 @@
               </a:rPr>
               <a:t>Thank you</a:t>
             </a:r>
-            <a:r>
-              <a:rPr lang="de-DE" sz="1400" b="1" dirty="0">
-                <a:solidFill>
-                  <a:srgbClr val="94A3B8"/>
-                </a:solidFill>
-                <a:latin typeface="Aptos"/>
-              </a:rPr>
-              <a:t>!</a:t>
-            </a:r>
-            <a:endParaRPr sz="1400" b="1" dirty="0">
-              <a:solidFill>
-                <a:srgbClr val="94A3B8"/>
-              </a:solidFill>
-              <a:latin typeface="Aptos"/>
-            </a:endParaRPr>
           </a:p>
         </p:txBody>
       </p:sp>
@@ -6117,7 +5058,7 @@
 </file>
 
 <file path=ppt/slides/slide2.xml><?xml version="1.0" encoding="utf-8"?>
-<p:sld xmlns:a="http://schemas.openxmlformats.org/drawingml/2006/main" xmlns:r="http://schemas.openxmlformats.org/officeDocument/2006/relationships" xmlns:p="http://schemas.openxmlformats.org/presentationml/2006/main">
+<p:sld xmlns:a="http://schemas.openxmlformats.org/drawingml/2006/main" xmlns:p="http://schemas.openxmlformats.org/presentationml/2006/main" xmlns:r="http://schemas.openxmlformats.org/officeDocument/2006/relationships">
   <p:cSld>
     <p:bg>
       <p:bgPr>
@@ -6133,14 +5074,7 @@
         <p:cNvGrpSpPr/>
         <p:nvPr/>
       </p:nvGrpSpPr>
-      <p:grpSpPr>
-        <a:xfrm>
-          <a:off x="0" y="0"/>
-          <a:ext cx="0" cy="0"/>
-          <a:chOff x="0" y="0"/>
-          <a:chExt cx="0" cy="0"/>
-        </a:xfrm>
-      </p:grpSpPr>
+      <p:grpSpPr/>
       <p:sp>
         <p:nvSpPr>
           <p:cNvPr id="2" name="Rounded Rectangle 1"/>
@@ -6181,7 +5115,6 @@
           <a:lstStyle/>
           <a:p>
             <a:pPr algn="ctr"/>
-            <a:endParaRPr/>
           </a:p>
         </p:txBody>
       </p:sp>
@@ -6225,7 +5158,6 @@
           <a:lstStyle/>
           <a:p>
             <a:pPr algn="ctr"/>
-            <a:endParaRPr/>
           </a:p>
         </p:txBody>
       </p:sp>
@@ -6269,7 +5201,6 @@
           <a:lstStyle/>
           <a:p>
             <a:pPr algn="ctr"/>
-            <a:endParaRPr/>
           </a:p>
         </p:txBody>
       </p:sp>
@@ -6352,7 +5283,7 @@
         <p:spPr>
           <a:xfrm>
             <a:off x="594360" y="1051560"/>
-            <a:ext cx="7086600" cy="1138773"/>
+            <a:ext cx="7863840" cy="685800"/>
           </a:xfrm>
           <a:prstGeom prst="rect">
             <a:avLst/>
@@ -6367,7 +5298,7 @@
           <a:p>
             <a:pPr algn="l"/>
             <a:r>
-              <a:rPr sz="3400" b="1" dirty="0">
+              <a:rPr sz="3400" b="1">
                 <a:solidFill>
                   <a:srgbClr val="F6F8FF"/>
                 </a:solidFill>
@@ -6386,7 +5317,7 @@
         </p:nvSpPr>
         <p:spPr>
           <a:xfrm>
-            <a:off x="621792" y="2121408"/>
+            <a:off x="621792" y="1828800"/>
             <a:ext cx="7315200" cy="411480"/>
           </a:xfrm>
           <a:prstGeom prst="rect">
@@ -6402,22 +5333,13 @@
           <a:p>
             <a:pPr algn="l"/>
             <a:r>
-              <a:rPr sz="1800" b="0" dirty="0" err="1">
+              <a:rPr sz="1800" b="0">
                 <a:solidFill>
                   <a:srgbClr val="22D3EE"/>
                 </a:solidFill>
                 <a:latin typeface="Aptos"/>
               </a:rPr>
-              <a:t>AskTube</a:t>
-            </a:r>
-            <a:r>
-              <a:rPr sz="1800" b="0" dirty="0">
-                <a:solidFill>
-                  <a:srgbClr val="22D3EE"/>
-                </a:solidFill>
-                <a:latin typeface="Aptos"/>
-              </a:rPr>
-              <a:t> AI turns a video into a searchable, conversational knowledge base.</a:t>
+              <a:t>AskTube AI turns a video into a searchable, conversational knowledge base.</a:t>
             </a:r>
           </a:p>
         </p:txBody>
@@ -6430,7 +5352,7 @@
         </p:nvSpPr>
         <p:spPr>
           <a:xfrm>
-            <a:off x="658368" y="3035808"/>
+            <a:off x="658368" y="2743200"/>
             <a:ext cx="3246120" cy="1737360"/>
           </a:xfrm>
           <a:prstGeom prst="roundRect">
@@ -6464,7 +5386,6 @@
           <a:lstStyle/>
           <a:p>
             <a:pPr algn="ctr"/>
-            <a:endParaRPr/>
           </a:p>
         </p:txBody>
       </p:sp>
@@ -6476,7 +5397,7 @@
         </p:nvSpPr>
         <p:spPr>
           <a:xfrm>
-            <a:off x="658368" y="3035808"/>
+            <a:off x="658368" y="2743200"/>
             <a:ext cx="73152" cy="1737360"/>
           </a:xfrm>
           <a:prstGeom prst="rect">
@@ -6508,7 +5429,6 @@
           <a:lstStyle/>
           <a:p>
             <a:pPr algn="ctr"/>
-            <a:endParaRPr/>
           </a:p>
         </p:txBody>
       </p:sp>
@@ -6520,7 +5440,7 @@
         </p:nvSpPr>
         <p:spPr>
           <a:xfrm>
-            <a:off x="859536" y="3200400"/>
+            <a:off x="859536" y="2907792"/>
             <a:ext cx="2926079" cy="228600"/>
           </a:xfrm>
           <a:prstGeom prst="rect">
@@ -6555,7 +5475,7 @@
         </p:nvSpPr>
         <p:spPr>
           <a:xfrm>
-            <a:off x="859536" y="3538728"/>
+            <a:off x="859536" y="3246120"/>
             <a:ext cx="2926079" cy="1097280"/>
           </a:xfrm>
           <a:prstGeom prst="rect">
@@ -6590,7 +5510,7 @@
         </p:nvSpPr>
         <p:spPr>
           <a:xfrm>
-            <a:off x="4160520" y="3035808"/>
+            <a:off x="4160520" y="2743200"/>
             <a:ext cx="3246120" cy="1737360"/>
           </a:xfrm>
           <a:prstGeom prst="roundRect">
@@ -6624,7 +5544,6 @@
           <a:lstStyle/>
           <a:p>
             <a:pPr algn="ctr"/>
-            <a:endParaRPr/>
           </a:p>
         </p:txBody>
       </p:sp>
@@ -6636,7 +5555,7 @@
         </p:nvSpPr>
         <p:spPr>
           <a:xfrm>
-            <a:off x="4160520" y="3035808"/>
+            <a:off x="4160520" y="2743200"/>
             <a:ext cx="73152" cy="1737360"/>
           </a:xfrm>
           <a:prstGeom prst="rect">
@@ -6668,7 +5587,6 @@
           <a:lstStyle/>
           <a:p>
             <a:pPr algn="ctr"/>
-            <a:endParaRPr/>
           </a:p>
         </p:txBody>
       </p:sp>
@@ -6680,7 +5598,7 @@
         </p:nvSpPr>
         <p:spPr>
           <a:xfrm>
-            <a:off x="4361688" y="3200400"/>
+            <a:off x="4361688" y="2907792"/>
             <a:ext cx="2926079" cy="228600"/>
           </a:xfrm>
           <a:prstGeom prst="rect">
@@ -6715,7 +5633,7 @@
         </p:nvSpPr>
         <p:spPr>
           <a:xfrm>
-            <a:off x="4361688" y="3538728"/>
+            <a:off x="4361688" y="3246120"/>
             <a:ext cx="2926079" cy="1097280"/>
           </a:xfrm>
           <a:prstGeom prst="rect">
@@ -6750,7 +5668,7 @@
         </p:nvSpPr>
         <p:spPr>
           <a:xfrm>
-            <a:off x="7662672" y="3035808"/>
+            <a:off x="7662672" y="2743200"/>
             <a:ext cx="3246120" cy="1737360"/>
           </a:xfrm>
           <a:prstGeom prst="roundRect">
@@ -6784,7 +5702,6 @@
           <a:lstStyle/>
           <a:p>
             <a:pPr algn="ctr"/>
-            <a:endParaRPr/>
           </a:p>
         </p:txBody>
       </p:sp>
@@ -6796,7 +5713,7 @@
         </p:nvSpPr>
         <p:spPr>
           <a:xfrm>
-            <a:off x="7662672" y="3035808"/>
+            <a:off x="7662672" y="2743200"/>
             <a:ext cx="73152" cy="1737360"/>
           </a:xfrm>
           <a:prstGeom prst="rect">
@@ -6828,7 +5745,6 @@
           <a:lstStyle/>
           <a:p>
             <a:pPr algn="ctr"/>
-            <a:endParaRPr/>
           </a:p>
         </p:txBody>
       </p:sp>
@@ -6840,7 +5756,7 @@
         </p:nvSpPr>
         <p:spPr>
           <a:xfrm>
-            <a:off x="7863840" y="3200400"/>
+            <a:off x="7863840" y="2907792"/>
             <a:ext cx="2926079" cy="228600"/>
           </a:xfrm>
           <a:prstGeom prst="rect">
@@ -6875,7 +5791,7 @@
         </p:nvSpPr>
         <p:spPr>
           <a:xfrm>
-            <a:off x="7863840" y="3538728"/>
+            <a:off x="7863840" y="3246120"/>
             <a:ext cx="2926079" cy="1097280"/>
           </a:xfrm>
           <a:prstGeom prst="rect">
@@ -6911,7 +5827,7 @@
 </file>
 
 <file path=ppt/slides/slide3.xml><?xml version="1.0" encoding="utf-8"?>
-<p:sld xmlns:a="http://schemas.openxmlformats.org/drawingml/2006/main" xmlns:r="http://schemas.openxmlformats.org/officeDocument/2006/relationships" xmlns:p="http://schemas.openxmlformats.org/presentationml/2006/main">
+<p:sld xmlns:a="http://schemas.openxmlformats.org/drawingml/2006/main" xmlns:p="http://schemas.openxmlformats.org/presentationml/2006/main" xmlns:r="http://schemas.openxmlformats.org/officeDocument/2006/relationships">
   <p:cSld>
     <p:bg>
       <p:bgPr>
@@ -6927,14 +5843,7 @@
         <p:cNvGrpSpPr/>
         <p:nvPr/>
       </p:nvGrpSpPr>
-      <p:grpSpPr>
-        <a:xfrm>
-          <a:off x="0" y="0"/>
-          <a:ext cx="0" cy="0"/>
-          <a:chOff x="0" y="0"/>
-          <a:chExt cx="0" cy="0"/>
-        </a:xfrm>
-      </p:grpSpPr>
+      <p:grpSpPr/>
       <p:sp>
         <p:nvSpPr>
           <p:cNvPr id="2" name="Rounded Rectangle 1"/>
@@ -6975,7 +5884,6 @@
           <a:lstStyle/>
           <a:p>
             <a:pPr algn="ctr"/>
-            <a:endParaRPr/>
           </a:p>
         </p:txBody>
       </p:sp>
@@ -7019,7 +5927,6 @@
           <a:lstStyle/>
           <a:p>
             <a:pPr algn="ctr"/>
-            <a:endParaRPr/>
           </a:p>
         </p:txBody>
       </p:sp>
@@ -7063,7 +5970,6 @@
           <a:lstStyle/>
           <a:p>
             <a:pPr algn="ctr"/>
-            <a:endParaRPr/>
           </a:p>
         </p:txBody>
       </p:sp>
@@ -7146,7 +6052,7 @@
         <p:spPr>
           <a:xfrm>
             <a:off x="594360" y="914400"/>
-            <a:ext cx="6364224" cy="615553"/>
+            <a:ext cx="5486400" cy="548640"/>
           </a:xfrm>
           <a:prstGeom prst="rect">
             <a:avLst/>
@@ -7161,7 +6067,7 @@
           <a:p>
             <a:pPr algn="l"/>
             <a:r>
-              <a:rPr sz="3400" b="1" dirty="0">
+              <a:rPr sz="3400" b="1">
                 <a:solidFill>
                   <a:srgbClr val="F6F8FF"/>
                 </a:solidFill>
@@ -7214,7 +6120,6 @@
           <a:lstStyle/>
           <a:p>
             <a:pPr algn="ctr"/>
-            <a:endParaRPr/>
           </a:p>
         </p:txBody>
       </p:sp>
@@ -7258,7 +6163,6 @@
           <a:lstStyle/>
           <a:p>
             <a:pPr algn="ctr"/>
-            <a:endParaRPr/>
           </a:p>
         </p:txBody>
       </p:sp>
@@ -7409,7 +6313,6 @@
           <a:lstStyle/>
           <a:p>
             <a:pPr algn="ctr"/>
-            <a:endParaRPr/>
           </a:p>
         </p:txBody>
       </p:sp>
@@ -7453,7 +6356,6 @@
           <a:lstStyle/>
           <a:p>
             <a:pPr algn="ctr"/>
-            <a:endParaRPr/>
           </a:p>
         </p:txBody>
       </p:sp>
@@ -7604,7 +6506,6 @@
           <a:lstStyle/>
           <a:p>
             <a:pPr algn="ctr"/>
-            <a:endParaRPr/>
           </a:p>
         </p:txBody>
       </p:sp>
@@ -7648,7 +6549,6 @@
           <a:lstStyle/>
           <a:p>
             <a:pPr algn="ctr"/>
-            <a:endParaRPr/>
           </a:p>
         </p:txBody>
       </p:sp>
@@ -7799,7 +6699,6 @@
           <a:lstStyle/>
           <a:p>
             <a:pPr algn="ctr"/>
-            <a:endParaRPr/>
           </a:p>
         </p:txBody>
       </p:sp>
@@ -7843,7 +6742,6 @@
           <a:lstStyle/>
           <a:p>
             <a:pPr algn="ctr"/>
-            <a:endParaRPr/>
           </a:p>
         </p:txBody>
       </p:sp>
@@ -7906,7 +6804,7 @@
           <a:p>
             <a:pPr algn="l"/>
             <a:r>
-              <a:rPr sz="1200" b="1" dirty="0">
+              <a:rPr sz="1200" b="1">
                 <a:solidFill>
                   <a:srgbClr val="F6F8FF"/>
                 </a:solidFill>
@@ -8081,7 +6979,7 @@
           <a:p>
             <a:pPr algn="l"/>
             <a:r>
-              <a:rPr sz="1700" b="0" dirty="0">
+              <a:rPr sz="1700" b="0">
                 <a:solidFill>
                   <a:srgbClr val="94A3B8"/>
                 </a:solidFill>
@@ -8101,7 +6999,7 @@
 </file>
 
 <file path=ppt/slides/slide4.xml><?xml version="1.0" encoding="utf-8"?>
-<p:sld xmlns:a="http://schemas.openxmlformats.org/drawingml/2006/main" xmlns:r="http://schemas.openxmlformats.org/officeDocument/2006/relationships" xmlns:p="http://schemas.openxmlformats.org/presentationml/2006/main">
+<p:sld xmlns:a="http://schemas.openxmlformats.org/drawingml/2006/main" xmlns:p="http://schemas.openxmlformats.org/presentationml/2006/main" xmlns:r="http://schemas.openxmlformats.org/officeDocument/2006/relationships">
   <p:cSld>
     <p:bg>
       <p:bgPr>
@@ -8117,14 +7015,7 @@
         <p:cNvGrpSpPr/>
         <p:nvPr/>
       </p:nvGrpSpPr>
-      <p:grpSpPr>
-        <a:xfrm>
-          <a:off x="0" y="0"/>
-          <a:ext cx="0" cy="0"/>
-          <a:chOff x="0" y="0"/>
-          <a:chExt cx="0" cy="0"/>
-        </a:xfrm>
-      </p:grpSpPr>
+      <p:grpSpPr/>
       <p:sp>
         <p:nvSpPr>
           <p:cNvPr id="2" name="Rounded Rectangle 1"/>
@@ -8165,7 +7056,6 @@
           <a:lstStyle/>
           <a:p>
             <a:pPr algn="ctr"/>
-            <a:endParaRPr/>
           </a:p>
         </p:txBody>
       </p:sp>
@@ -8209,7 +7099,6 @@
           <a:lstStyle/>
           <a:p>
             <a:pPr algn="ctr"/>
-            <a:endParaRPr/>
           </a:p>
         </p:txBody>
       </p:sp>
@@ -8253,7 +7142,6 @@
           <a:lstStyle/>
           <a:p>
             <a:pPr algn="ctr"/>
-            <a:endParaRPr/>
           </a:p>
         </p:txBody>
       </p:sp>
@@ -8404,7 +7292,6 @@
           <a:lstStyle/>
           <a:p>
             <a:pPr algn="ctr"/>
-            <a:endParaRPr/>
           </a:p>
         </p:txBody>
       </p:sp>
@@ -8448,7 +7335,6 @@
           <a:lstStyle/>
           <a:p>
             <a:pPr algn="ctr"/>
-            <a:endParaRPr/>
           </a:p>
         </p:txBody>
       </p:sp>
@@ -8564,7 +7450,6 @@
           <a:lstStyle/>
           <a:p>
             <a:pPr algn="ctr"/>
-            <a:endParaRPr/>
           </a:p>
         </p:txBody>
       </p:sp>
@@ -8608,7 +7493,6 @@
           <a:lstStyle/>
           <a:p>
             <a:pPr algn="ctr"/>
-            <a:endParaRPr/>
           </a:p>
         </p:txBody>
       </p:sp>
@@ -8724,7 +7608,6 @@
           <a:lstStyle/>
           <a:p>
             <a:pPr algn="ctr"/>
-            <a:endParaRPr/>
           </a:p>
         </p:txBody>
       </p:sp>
@@ -8768,7 +7651,6 @@
           <a:lstStyle/>
           <a:p>
             <a:pPr algn="ctr"/>
-            <a:endParaRPr/>
           </a:p>
         </p:txBody>
       </p:sp>
@@ -8956,7 +7838,7 @@
 </file>
 
 <file path=ppt/slides/slide5.xml><?xml version="1.0" encoding="utf-8"?>
-<p:sld xmlns:a="http://schemas.openxmlformats.org/drawingml/2006/main" xmlns:r="http://schemas.openxmlformats.org/officeDocument/2006/relationships" xmlns:p="http://schemas.openxmlformats.org/presentationml/2006/main">
+<p:sld xmlns:a="http://schemas.openxmlformats.org/drawingml/2006/main" xmlns:p="http://schemas.openxmlformats.org/presentationml/2006/main" xmlns:r="http://schemas.openxmlformats.org/officeDocument/2006/relationships">
   <p:cSld>
     <p:bg>
       <p:bgPr>
@@ -8972,14 +7854,7 @@
         <p:cNvGrpSpPr/>
         <p:nvPr/>
       </p:nvGrpSpPr>
-      <p:grpSpPr>
-        <a:xfrm>
-          <a:off x="0" y="0"/>
-          <a:ext cx="0" cy="0"/>
-          <a:chOff x="0" y="0"/>
-          <a:chExt cx="0" cy="0"/>
-        </a:xfrm>
-      </p:grpSpPr>
+      <p:grpSpPr/>
       <p:sp>
         <p:nvSpPr>
           <p:cNvPr id="2" name="Rounded Rectangle 1"/>
@@ -9020,7 +7895,6 @@
           <a:lstStyle/>
           <a:p>
             <a:pPr algn="ctr"/>
-            <a:endParaRPr/>
           </a:p>
         </p:txBody>
       </p:sp>
@@ -9064,7 +7938,6 @@
           <a:lstStyle/>
           <a:p>
             <a:pPr algn="ctr"/>
-            <a:endParaRPr/>
           </a:p>
         </p:txBody>
       </p:sp>
@@ -9108,7 +7981,6 @@
           <a:lstStyle/>
           <a:p>
             <a:pPr algn="ctr"/>
-            <a:endParaRPr/>
           </a:p>
         </p:txBody>
       </p:sp>
@@ -9422,7 +8294,6 @@
           <a:lstStyle/>
           <a:p>
             <a:pPr algn="ctr"/>
-            <a:endParaRPr/>
           </a:p>
         </p:txBody>
       </p:sp>
@@ -9545,7 +8416,7 @@
 </file>
 
 <file path=ppt/slides/slide6.xml><?xml version="1.0" encoding="utf-8"?>
-<p:sld xmlns:a="http://schemas.openxmlformats.org/drawingml/2006/main" xmlns:r="http://schemas.openxmlformats.org/officeDocument/2006/relationships" xmlns:p="http://schemas.openxmlformats.org/presentationml/2006/main">
+<p:sld xmlns:a="http://schemas.openxmlformats.org/drawingml/2006/main" xmlns:p="http://schemas.openxmlformats.org/presentationml/2006/main" xmlns:r="http://schemas.openxmlformats.org/officeDocument/2006/relationships">
   <p:cSld>
     <p:bg>
       <p:bgPr>
@@ -9561,14 +8432,7 @@
         <p:cNvGrpSpPr/>
         <p:nvPr/>
       </p:nvGrpSpPr>
-      <p:grpSpPr>
-        <a:xfrm>
-          <a:off x="0" y="0"/>
-          <a:ext cx="0" cy="0"/>
-          <a:chOff x="0" y="0"/>
-          <a:chExt cx="0" cy="0"/>
-        </a:xfrm>
-      </p:grpSpPr>
+      <p:grpSpPr/>
       <p:sp>
         <p:nvSpPr>
           <p:cNvPr id="2" name="Rounded Rectangle 1"/>
@@ -9609,7 +8473,6 @@
           <a:lstStyle/>
           <a:p>
             <a:pPr algn="ctr"/>
-            <a:endParaRPr/>
           </a:p>
         </p:txBody>
       </p:sp>
@@ -9653,7 +8516,6 @@
           <a:lstStyle/>
           <a:p>
             <a:pPr algn="ctr"/>
-            <a:endParaRPr/>
           </a:p>
         </p:txBody>
       </p:sp>
@@ -9697,7 +8559,6 @@
           <a:lstStyle/>
           <a:p>
             <a:pPr algn="ctr"/>
-            <a:endParaRPr/>
           </a:p>
         </p:txBody>
       </p:sp>
@@ -9814,8 +8675,8 @@
         </p:nvSpPr>
         <p:spPr>
           <a:xfrm>
-            <a:off x="658368" y="1901952"/>
-            <a:ext cx="6665976" cy="584775"/>
+            <a:off x="658368" y="1600200"/>
+            <a:ext cx="9875520" cy="329184"/>
           </a:xfrm>
           <a:prstGeom prst="rect">
             <a:avLst/>
@@ -9830,58 +8691,13 @@
           <a:p>
             <a:pPr algn="l"/>
             <a:r>
-              <a:rPr sz="1600" b="0" dirty="0" err="1">
+              <a:rPr sz="1600" b="0">
                 <a:solidFill>
                   <a:srgbClr val="94A3B8"/>
                 </a:solidFill>
                 <a:latin typeface="Aptos"/>
               </a:rPr>
-              <a:t>AgentService</a:t>
-            </a:r>
-            <a:r>
-              <a:rPr sz="1600" b="0" dirty="0">
-                <a:solidFill>
-                  <a:srgbClr val="94A3B8"/>
-                </a:solidFill>
-                <a:latin typeface="Aptos"/>
-              </a:rPr>
-              <a:t> binds </a:t>
-            </a:r>
-            <a:r>
-              <a:rPr sz="1600" b="0" dirty="0" err="1">
-                <a:solidFill>
-                  <a:srgbClr val="94A3B8"/>
-                </a:solidFill>
-                <a:latin typeface="Aptos"/>
-              </a:rPr>
-              <a:t>StructuredTool</a:t>
-            </a:r>
-            <a:r>
-              <a:rPr sz="1600" b="0" dirty="0">
-                <a:solidFill>
-                  <a:srgbClr val="94A3B8"/>
-                </a:solidFill>
-                <a:latin typeface="Aptos"/>
-              </a:rPr>
-              <a:t> objects to the LLM and returns answer, citations, tool steps, and </a:t>
-            </a:r>
-            <a:r>
-              <a:rPr sz="1600" b="0" dirty="0" err="1">
-                <a:solidFill>
-                  <a:srgbClr val="94A3B8"/>
-                </a:solidFill>
-                <a:latin typeface="Aptos"/>
-              </a:rPr>
-              <a:t>session_id</a:t>
-            </a:r>
-            <a:r>
-              <a:rPr sz="1600" b="0" dirty="0">
-                <a:solidFill>
-                  <a:srgbClr val="94A3B8"/>
-                </a:solidFill>
-                <a:latin typeface="Aptos"/>
-              </a:rPr>
-              <a:t>.</a:t>
+              <a:t>AgentService binds StructuredTool objects to the LLM and returns answer, citations, tool steps, and session_id.</a:t>
             </a:r>
           </a:p>
         </p:txBody>
@@ -9894,7 +8710,7 @@
         </p:nvSpPr>
         <p:spPr>
           <a:xfrm>
-            <a:off x="777240" y="2450592"/>
+            <a:off x="777240" y="2148840"/>
             <a:ext cx="2880360" cy="438912"/>
           </a:xfrm>
           <a:prstGeom prst="roundRect">
@@ -9928,7 +8744,6 @@
           <a:lstStyle/>
           <a:p>
             <a:pPr algn="ctr"/>
-            <a:endParaRPr/>
           </a:p>
         </p:txBody>
       </p:sp>
@@ -9940,7 +8755,7 @@
         </p:nvSpPr>
         <p:spPr>
           <a:xfrm>
-            <a:off x="960120" y="2560320"/>
+            <a:off x="960120" y="2258568"/>
             <a:ext cx="2514600" cy="201168"/>
           </a:xfrm>
           <a:prstGeom prst="rect">
@@ -9975,7 +8790,7 @@
         </p:nvSpPr>
         <p:spPr>
           <a:xfrm>
-            <a:off x="4023359" y="2450592"/>
+            <a:off x="4023359" y="2148840"/>
             <a:ext cx="2880360" cy="438912"/>
           </a:xfrm>
           <a:prstGeom prst="roundRect">
@@ -10009,7 +8824,6 @@
           <a:lstStyle/>
           <a:p>
             <a:pPr algn="ctr"/>
-            <a:endParaRPr/>
           </a:p>
         </p:txBody>
       </p:sp>
@@ -10021,7 +8835,7 @@
         </p:nvSpPr>
         <p:spPr>
           <a:xfrm>
-            <a:off x="4206240" y="2560320"/>
+            <a:off x="4206240" y="2258568"/>
             <a:ext cx="2514600" cy="201168"/>
           </a:xfrm>
           <a:prstGeom prst="rect">
@@ -10056,7 +8870,7 @@
         </p:nvSpPr>
         <p:spPr>
           <a:xfrm>
-            <a:off x="777240" y="3108960"/>
+            <a:off x="777240" y="2807208"/>
             <a:ext cx="2880360" cy="438912"/>
           </a:xfrm>
           <a:prstGeom prst="roundRect">
@@ -10090,7 +8904,6 @@
           <a:lstStyle/>
           <a:p>
             <a:pPr algn="ctr"/>
-            <a:endParaRPr/>
           </a:p>
         </p:txBody>
       </p:sp>
@@ -10102,7 +8915,7 @@
         </p:nvSpPr>
         <p:spPr>
           <a:xfrm>
-            <a:off x="960120" y="3218688"/>
+            <a:off x="960120" y="2916936"/>
             <a:ext cx="2514600" cy="201168"/>
           </a:xfrm>
           <a:prstGeom prst="rect">
@@ -10137,7 +8950,7 @@
         </p:nvSpPr>
         <p:spPr>
           <a:xfrm>
-            <a:off x="4023359" y="3108960"/>
+            <a:off x="4023359" y="2807208"/>
             <a:ext cx="2880360" cy="438912"/>
           </a:xfrm>
           <a:prstGeom prst="roundRect">
@@ -10171,7 +8984,6 @@
           <a:lstStyle/>
           <a:p>
             <a:pPr algn="ctr"/>
-            <a:endParaRPr/>
           </a:p>
         </p:txBody>
       </p:sp>
@@ -10183,7 +8995,7 @@
         </p:nvSpPr>
         <p:spPr>
           <a:xfrm>
-            <a:off x="4206240" y="3218688"/>
+            <a:off x="4206240" y="2916936"/>
             <a:ext cx="2514600" cy="201168"/>
           </a:xfrm>
           <a:prstGeom prst="rect">
@@ -10218,7 +9030,7 @@
         </p:nvSpPr>
         <p:spPr>
           <a:xfrm>
-            <a:off x="777240" y="3767328"/>
+            <a:off x="777240" y="3465576"/>
             <a:ext cx="2880360" cy="438912"/>
           </a:xfrm>
           <a:prstGeom prst="roundRect">
@@ -10252,7 +9064,6 @@
           <a:lstStyle/>
           <a:p>
             <a:pPr algn="ctr"/>
-            <a:endParaRPr/>
           </a:p>
         </p:txBody>
       </p:sp>
@@ -10264,7 +9075,7 @@
         </p:nvSpPr>
         <p:spPr>
           <a:xfrm>
-            <a:off x="960120" y="3877056"/>
+            <a:off x="960120" y="3575304"/>
             <a:ext cx="2514600" cy="201168"/>
           </a:xfrm>
           <a:prstGeom prst="rect">
@@ -10299,7 +9110,7 @@
         </p:nvSpPr>
         <p:spPr>
           <a:xfrm>
-            <a:off x="4023359" y="3767328"/>
+            <a:off x="4023359" y="3465576"/>
             <a:ext cx="2880360" cy="438912"/>
           </a:xfrm>
           <a:prstGeom prst="roundRect">
@@ -10333,7 +9144,6 @@
           <a:lstStyle/>
           <a:p>
             <a:pPr algn="ctr"/>
-            <a:endParaRPr/>
           </a:p>
         </p:txBody>
       </p:sp>
@@ -10345,7 +9155,7 @@
         </p:nvSpPr>
         <p:spPr>
           <a:xfrm>
-            <a:off x="4206240" y="3877056"/>
+            <a:off x="4206240" y="3575304"/>
             <a:ext cx="2514600" cy="201168"/>
           </a:xfrm>
           <a:prstGeom prst="rect">
@@ -10380,7 +9190,7 @@
         </p:nvSpPr>
         <p:spPr>
           <a:xfrm>
-            <a:off x="777240" y="4425696"/>
+            <a:off x="777240" y="4123944"/>
             <a:ext cx="2880360" cy="438912"/>
           </a:xfrm>
           <a:prstGeom prst="roundRect">
@@ -10414,7 +9224,6 @@
           <a:lstStyle/>
           <a:p>
             <a:pPr algn="ctr"/>
-            <a:endParaRPr/>
           </a:p>
         </p:txBody>
       </p:sp>
@@ -10426,7 +9235,7 @@
         </p:nvSpPr>
         <p:spPr>
           <a:xfrm>
-            <a:off x="960120" y="4535424"/>
+            <a:off x="960120" y="4233672"/>
             <a:ext cx="2514600" cy="201168"/>
           </a:xfrm>
           <a:prstGeom prst="rect">
@@ -10495,7 +9304,6 @@
           <a:lstStyle/>
           <a:p>
             <a:pPr algn="ctr"/>
-            <a:endParaRPr/>
           </a:p>
         </p:txBody>
       </p:sp>
@@ -10539,7 +9347,6 @@
           <a:lstStyle/>
           <a:p>
             <a:pPr algn="ctr"/>
-            <a:endParaRPr/>
           </a:p>
         </p:txBody>
       </p:sp>
@@ -10655,7 +9462,6 @@
           <a:lstStyle/>
           <a:p>
             <a:pPr algn="ctr"/>
-            <a:endParaRPr/>
           </a:p>
         </p:txBody>
       </p:sp>
@@ -10699,7 +9505,6 @@
           <a:lstStyle/>
           <a:p>
             <a:pPr algn="ctr"/>
-            <a:endParaRPr/>
           </a:p>
         </p:txBody>
       </p:sp>
@@ -10782,7 +9587,7 @@
 </file>
 
 <file path=ppt/slides/slide7.xml><?xml version="1.0" encoding="utf-8"?>
-<p:sld xmlns:a="http://schemas.openxmlformats.org/drawingml/2006/main" xmlns:r="http://schemas.openxmlformats.org/officeDocument/2006/relationships" xmlns:p="http://schemas.openxmlformats.org/presentationml/2006/main">
+<p:sld xmlns:a="http://schemas.openxmlformats.org/drawingml/2006/main" xmlns:p="http://schemas.openxmlformats.org/presentationml/2006/main" xmlns:r="http://schemas.openxmlformats.org/officeDocument/2006/relationships">
   <p:cSld>
     <p:bg>
       <p:bgPr>
@@ -10798,14 +9603,7 @@
         <p:cNvGrpSpPr/>
         <p:nvPr/>
       </p:nvGrpSpPr>
-      <p:grpSpPr>
-        <a:xfrm>
-          <a:off x="0" y="0"/>
-          <a:ext cx="0" cy="0"/>
-          <a:chOff x="0" y="0"/>
-          <a:chExt cx="0" cy="0"/>
-        </a:xfrm>
-      </p:grpSpPr>
+      <p:grpSpPr/>
       <p:sp>
         <p:nvSpPr>
           <p:cNvPr id="2" name="Rounded Rectangle 1"/>
@@ -10846,7 +9644,6 @@
           <a:lstStyle/>
           <a:p>
             <a:pPr algn="ctr"/>
-            <a:endParaRPr/>
           </a:p>
         </p:txBody>
       </p:sp>
@@ -10890,7 +9687,6 @@
           <a:lstStyle/>
           <a:p>
             <a:pPr algn="ctr"/>
-            <a:endParaRPr/>
           </a:p>
         </p:txBody>
       </p:sp>
@@ -10934,7 +9730,6 @@
           <a:lstStyle/>
           <a:p>
             <a:pPr algn="ctr"/>
-            <a:endParaRPr/>
           </a:p>
         </p:txBody>
       </p:sp>
@@ -11051,7 +9846,7 @@
         </p:nvSpPr>
         <p:spPr>
           <a:xfrm>
-            <a:off x="777240" y="2432304"/>
+            <a:off x="777240" y="2011680"/>
             <a:ext cx="2057400" cy="1325880"/>
           </a:xfrm>
           <a:prstGeom prst="roundRect">
@@ -11085,7 +9880,6 @@
           <a:lstStyle/>
           <a:p>
             <a:pPr algn="ctr"/>
-            <a:endParaRPr/>
           </a:p>
         </p:txBody>
       </p:sp>
@@ -11097,7 +9891,7 @@
         </p:nvSpPr>
         <p:spPr>
           <a:xfrm>
-            <a:off x="941832" y="2596896"/>
+            <a:off x="941832" y="2176272"/>
             <a:ext cx="384048" cy="384048"/>
           </a:xfrm>
           <a:prstGeom prst="roundRect">
@@ -11129,7 +9923,6 @@
           <a:lstStyle/>
           <a:p>
             <a:pPr algn="ctr"/>
-            <a:endParaRPr/>
           </a:p>
         </p:txBody>
       </p:sp>
@@ -11141,7 +9934,7 @@
         </p:nvSpPr>
         <p:spPr>
           <a:xfrm>
-            <a:off x="1042415" y="2679192"/>
+            <a:off x="1042415" y="2258568"/>
             <a:ext cx="182880" cy="182880"/>
           </a:xfrm>
           <a:prstGeom prst="rect">
@@ -11176,7 +9969,7 @@
         </p:nvSpPr>
         <p:spPr>
           <a:xfrm>
-            <a:off x="1435607" y="2615184"/>
+            <a:off x="1435607" y="2194560"/>
             <a:ext cx="1234440" cy="228600"/>
           </a:xfrm>
           <a:prstGeom prst="rect">
@@ -11211,7 +10004,7 @@
         </p:nvSpPr>
         <p:spPr>
           <a:xfrm>
-            <a:off x="960120" y="3090672"/>
+            <a:off x="960120" y="2670048"/>
             <a:ext cx="1691640" cy="411480"/>
           </a:xfrm>
           <a:prstGeom prst="rect">
@@ -11246,7 +10039,7 @@
         </p:nvSpPr>
         <p:spPr>
           <a:xfrm>
-            <a:off x="3246120" y="2432304"/>
+            <a:off x="3246120" y="2011680"/>
             <a:ext cx="2057400" cy="1325880"/>
           </a:xfrm>
           <a:prstGeom prst="roundRect">
@@ -11280,7 +10073,6 @@
           <a:lstStyle/>
           <a:p>
             <a:pPr algn="ctr"/>
-            <a:endParaRPr/>
           </a:p>
         </p:txBody>
       </p:sp>
@@ -11292,7 +10084,7 @@
         </p:nvSpPr>
         <p:spPr>
           <a:xfrm>
-            <a:off x="3410712" y="2596896"/>
+            <a:off x="3410712" y="2176272"/>
             <a:ext cx="384048" cy="384048"/>
           </a:xfrm>
           <a:prstGeom prst="roundRect">
@@ -11324,7 +10116,6 @@
           <a:lstStyle/>
           <a:p>
             <a:pPr algn="ctr"/>
-            <a:endParaRPr/>
           </a:p>
         </p:txBody>
       </p:sp>
@@ -11336,7 +10127,7 @@
         </p:nvSpPr>
         <p:spPr>
           <a:xfrm>
-            <a:off x="3511296" y="2679192"/>
+            <a:off x="3511296" y="2258568"/>
             <a:ext cx="182880" cy="182880"/>
           </a:xfrm>
           <a:prstGeom prst="rect">
@@ -11371,7 +10162,7 @@
         </p:nvSpPr>
         <p:spPr>
           <a:xfrm>
-            <a:off x="3904487" y="2615184"/>
+            <a:off x="3904487" y="2194560"/>
             <a:ext cx="1234440" cy="228600"/>
           </a:xfrm>
           <a:prstGeom prst="rect">
@@ -11406,7 +10197,7 @@
         </p:nvSpPr>
         <p:spPr>
           <a:xfrm>
-            <a:off x="3429000" y="3090672"/>
+            <a:off x="3429000" y="2670048"/>
             <a:ext cx="1691640" cy="411480"/>
           </a:xfrm>
           <a:prstGeom prst="rect">
@@ -11441,7 +10232,7 @@
         </p:nvSpPr>
         <p:spPr>
           <a:xfrm>
-            <a:off x="5715000" y="2432304"/>
+            <a:off x="5715000" y="2011680"/>
             <a:ext cx="2057400" cy="1325880"/>
           </a:xfrm>
           <a:prstGeom prst="roundRect">
@@ -11475,7 +10266,6 @@
           <a:lstStyle/>
           <a:p>
             <a:pPr algn="ctr"/>
-            <a:endParaRPr/>
           </a:p>
         </p:txBody>
       </p:sp>
@@ -11487,7 +10277,7 @@
         </p:nvSpPr>
         <p:spPr>
           <a:xfrm>
-            <a:off x="5879592" y="2596896"/>
+            <a:off x="5879592" y="2176272"/>
             <a:ext cx="384048" cy="384048"/>
           </a:xfrm>
           <a:prstGeom prst="roundRect">
@@ -11519,7 +10309,6 @@
           <a:lstStyle/>
           <a:p>
             <a:pPr algn="ctr"/>
-            <a:endParaRPr/>
           </a:p>
         </p:txBody>
       </p:sp>
@@ -11531,7 +10320,7 @@
         </p:nvSpPr>
         <p:spPr>
           <a:xfrm>
-            <a:off x="5980176" y="2679192"/>
+            <a:off x="5980176" y="2258568"/>
             <a:ext cx="182880" cy="182880"/>
           </a:xfrm>
           <a:prstGeom prst="rect">
@@ -11566,7 +10355,7 @@
         </p:nvSpPr>
         <p:spPr>
           <a:xfrm>
-            <a:off x="6373368" y="2615184"/>
+            <a:off x="6373368" y="2194560"/>
             <a:ext cx="1234440" cy="228600"/>
           </a:xfrm>
           <a:prstGeom prst="rect">
@@ -11601,7 +10390,7 @@
         </p:nvSpPr>
         <p:spPr>
           <a:xfrm>
-            <a:off x="5897880" y="3090672"/>
+            <a:off x="5897880" y="2670048"/>
             <a:ext cx="1691640" cy="411480"/>
           </a:xfrm>
           <a:prstGeom prst="rect">
@@ -11636,7 +10425,7 @@
         </p:nvSpPr>
         <p:spPr>
           <a:xfrm>
-            <a:off x="8183879" y="2432304"/>
+            <a:off x="8183879" y="2011680"/>
             <a:ext cx="2057400" cy="1325880"/>
           </a:xfrm>
           <a:prstGeom prst="roundRect">
@@ -11670,7 +10459,6 @@
           <a:lstStyle/>
           <a:p>
             <a:pPr algn="ctr"/>
-            <a:endParaRPr/>
           </a:p>
         </p:txBody>
       </p:sp>
@@ -11682,7 +10470,7 @@
         </p:nvSpPr>
         <p:spPr>
           <a:xfrm>
-            <a:off x="8348471" y="2596896"/>
+            <a:off x="8348471" y="2176272"/>
             <a:ext cx="384048" cy="384048"/>
           </a:xfrm>
           <a:prstGeom prst="roundRect">
@@ -11714,7 +10502,6 @@
           <a:lstStyle/>
           <a:p>
             <a:pPr algn="ctr"/>
-            <a:endParaRPr/>
           </a:p>
         </p:txBody>
       </p:sp>
@@ -11726,7 +10513,7 @@
         </p:nvSpPr>
         <p:spPr>
           <a:xfrm>
-            <a:off x="8449055" y="2679192"/>
+            <a:off x="8449055" y="2258568"/>
             <a:ext cx="182880" cy="182880"/>
           </a:xfrm>
           <a:prstGeom prst="rect">
@@ -11761,7 +10548,7 @@
         </p:nvSpPr>
         <p:spPr>
           <a:xfrm>
-            <a:off x="8842248" y="2615184"/>
+            <a:off x="8842248" y="2194560"/>
             <a:ext cx="1234440" cy="228600"/>
           </a:xfrm>
           <a:prstGeom prst="rect">
@@ -11796,7 +10583,7 @@
         </p:nvSpPr>
         <p:spPr>
           <a:xfrm>
-            <a:off x="8366759" y="3090672"/>
+            <a:off x="8366759" y="2670048"/>
             <a:ext cx="1691640" cy="411480"/>
           </a:xfrm>
           <a:prstGeom prst="rect">
@@ -11831,7 +10618,7 @@
         </p:nvCxnSpPr>
         <p:spPr>
           <a:xfrm>
-            <a:off x="2971800" y="3090672"/>
+            <a:off x="2971800" y="2670048"/>
             <a:ext cx="201168" cy="0"/>
           </a:xfrm>
           <a:prstGeom prst="line">
@@ -11866,7 +10653,7 @@
         </p:nvCxnSpPr>
         <p:spPr>
           <a:xfrm>
-            <a:off x="5440680" y="3090672"/>
+            <a:off x="5440680" y="2670048"/>
             <a:ext cx="201168" cy="0"/>
           </a:xfrm>
           <a:prstGeom prst="line">
@@ -11901,7 +10688,7 @@
         </p:nvCxnSpPr>
         <p:spPr>
           <a:xfrm>
-            <a:off x="7909560" y="3090672"/>
+            <a:off x="7909560" y="2670048"/>
             <a:ext cx="201168" cy="0"/>
           </a:xfrm>
           <a:prstGeom prst="line">
@@ -11952,7 +10739,7 @@
           <a:p>
             <a:pPr algn="l"/>
             <a:r>
-              <a:rPr sz="1800" b="0" dirty="0">
+              <a:rPr sz="1800" b="0">
                 <a:solidFill>
                   <a:srgbClr val="94A3B8"/>
                 </a:solidFill>
@@ -11972,7 +10759,7 @@
 </file>
 
 <file path=ppt/slides/slide8.xml><?xml version="1.0" encoding="utf-8"?>
-<p:sld xmlns:a="http://schemas.openxmlformats.org/drawingml/2006/main" xmlns:r="http://schemas.openxmlformats.org/officeDocument/2006/relationships" xmlns:p="http://schemas.openxmlformats.org/presentationml/2006/main">
+<p:sld xmlns:a="http://schemas.openxmlformats.org/drawingml/2006/main" xmlns:p="http://schemas.openxmlformats.org/presentationml/2006/main" xmlns:r="http://schemas.openxmlformats.org/officeDocument/2006/relationships">
   <p:cSld>
     <p:bg>
       <p:bgPr>
@@ -11988,14 +10775,7 @@
         <p:cNvGrpSpPr/>
         <p:nvPr/>
       </p:nvGrpSpPr>
-      <p:grpSpPr>
-        <a:xfrm>
-          <a:off x="0" y="0"/>
-          <a:ext cx="0" cy="0"/>
-          <a:chOff x="0" y="0"/>
-          <a:chExt cx="0" cy="0"/>
-        </a:xfrm>
-      </p:grpSpPr>
+      <p:grpSpPr/>
       <p:sp>
         <p:nvSpPr>
           <p:cNvPr id="2" name="Rounded Rectangle 1"/>
@@ -12036,7 +10816,6 @@
           <a:lstStyle/>
           <a:p>
             <a:pPr algn="ctr"/>
-            <a:endParaRPr/>
           </a:p>
         </p:txBody>
       </p:sp>
@@ -12080,7 +10859,6 @@
           <a:lstStyle/>
           <a:p>
             <a:pPr algn="ctr"/>
-            <a:endParaRPr/>
           </a:p>
         </p:txBody>
       </p:sp>
@@ -12124,7 +10902,6 @@
           <a:lstStyle/>
           <a:p>
             <a:pPr algn="ctr"/>
-            <a:endParaRPr/>
           </a:p>
         </p:txBody>
       </p:sp>
@@ -12241,7 +11018,7 @@
         </p:nvSpPr>
         <p:spPr>
           <a:xfrm>
-            <a:off x="685800" y="2468880"/>
+            <a:off x="685800" y="1920240"/>
             <a:ext cx="3337560" cy="1828800"/>
           </a:xfrm>
           <a:prstGeom prst="roundRect">
@@ -12275,7 +11052,6 @@
           <a:lstStyle/>
           <a:p>
             <a:pPr algn="ctr"/>
-            <a:endParaRPr/>
           </a:p>
         </p:txBody>
       </p:sp>
@@ -12287,7 +11063,7 @@
         </p:nvSpPr>
         <p:spPr>
           <a:xfrm>
-            <a:off x="685800" y="2468880"/>
+            <a:off x="685800" y="1920240"/>
             <a:ext cx="73152" cy="1828800"/>
           </a:xfrm>
           <a:prstGeom prst="rect">
@@ -12319,7 +11095,6 @@
           <a:lstStyle/>
           <a:p>
             <a:pPr algn="ctr"/>
-            <a:endParaRPr/>
           </a:p>
         </p:txBody>
       </p:sp>
@@ -12331,7 +11106,7 @@
         </p:nvSpPr>
         <p:spPr>
           <a:xfrm>
-            <a:off x="886968" y="2633472"/>
+            <a:off x="886968" y="2084832"/>
             <a:ext cx="3017520" cy="228600"/>
           </a:xfrm>
           <a:prstGeom prst="rect">
@@ -12366,7 +11141,7 @@
         </p:nvSpPr>
         <p:spPr>
           <a:xfrm>
-            <a:off x="886968" y="2971800"/>
+            <a:off x="886968" y="2423160"/>
             <a:ext cx="3017520" cy="1188720"/>
           </a:xfrm>
           <a:prstGeom prst="rect">
@@ -12401,7 +11176,7 @@
         </p:nvSpPr>
         <p:spPr>
           <a:xfrm>
-            <a:off x="4434840" y="2468880"/>
+            <a:off x="4434840" y="1920240"/>
             <a:ext cx="3337560" cy="1828800"/>
           </a:xfrm>
           <a:prstGeom prst="roundRect">
@@ -12435,7 +11210,6 @@
           <a:lstStyle/>
           <a:p>
             <a:pPr algn="ctr"/>
-            <a:endParaRPr/>
           </a:p>
         </p:txBody>
       </p:sp>
@@ -12447,7 +11221,7 @@
         </p:nvSpPr>
         <p:spPr>
           <a:xfrm>
-            <a:off x="4434840" y="2468880"/>
+            <a:off x="4434840" y="1920240"/>
             <a:ext cx="73152" cy="1828800"/>
           </a:xfrm>
           <a:prstGeom prst="rect">
@@ -12479,7 +11253,6 @@
           <a:lstStyle/>
           <a:p>
             <a:pPr algn="ctr"/>
-            <a:endParaRPr/>
           </a:p>
         </p:txBody>
       </p:sp>
@@ -12491,7 +11264,7 @@
         </p:nvSpPr>
         <p:spPr>
           <a:xfrm>
-            <a:off x="4636007" y="2633472"/>
+            <a:off x="4636007" y="2084832"/>
             <a:ext cx="3017520" cy="228600"/>
           </a:xfrm>
           <a:prstGeom prst="rect">
@@ -12526,7 +11299,7 @@
         </p:nvSpPr>
         <p:spPr>
           <a:xfrm>
-            <a:off x="4636007" y="2971800"/>
+            <a:off x="4636007" y="2423160"/>
             <a:ext cx="3017520" cy="1188720"/>
           </a:xfrm>
           <a:prstGeom prst="rect">
@@ -12561,7 +11334,7 @@
         </p:nvSpPr>
         <p:spPr>
           <a:xfrm>
-            <a:off x="8183879" y="2468880"/>
+            <a:off x="8183879" y="1920240"/>
             <a:ext cx="3337560" cy="1828800"/>
           </a:xfrm>
           <a:prstGeom prst="roundRect">
@@ -12595,7 +11368,6 @@
           <a:lstStyle/>
           <a:p>
             <a:pPr algn="ctr"/>
-            <a:endParaRPr/>
           </a:p>
         </p:txBody>
       </p:sp>
@@ -12607,7 +11379,7 @@
         </p:nvSpPr>
         <p:spPr>
           <a:xfrm>
-            <a:off x="8183879" y="2468880"/>
+            <a:off x="8183879" y="1920240"/>
             <a:ext cx="73152" cy="1828800"/>
           </a:xfrm>
           <a:prstGeom prst="rect">
@@ -12639,7 +11411,6 @@
           <a:lstStyle/>
           <a:p>
             <a:pPr algn="ctr"/>
-            <a:endParaRPr/>
           </a:p>
         </p:txBody>
       </p:sp>
@@ -12651,7 +11422,7 @@
         </p:nvSpPr>
         <p:spPr>
           <a:xfrm>
-            <a:off x="8385048" y="2633472"/>
+            <a:off x="8385048" y="2084832"/>
             <a:ext cx="3017520" cy="228600"/>
           </a:xfrm>
           <a:prstGeom prst="rect">
@@ -12686,7 +11457,7 @@
         </p:nvSpPr>
         <p:spPr>
           <a:xfrm>
-            <a:off x="8385048" y="2971800"/>
+            <a:off x="8385048" y="2423160"/>
             <a:ext cx="3017520" cy="1188720"/>
           </a:xfrm>
           <a:prstGeom prst="rect">
@@ -12757,7 +11528,7 @@
 </file>
 
 <file path=ppt/slides/slide9.xml><?xml version="1.0" encoding="utf-8"?>
-<p:sld xmlns:a="http://schemas.openxmlformats.org/drawingml/2006/main" xmlns:r="http://schemas.openxmlformats.org/officeDocument/2006/relationships" xmlns:p="http://schemas.openxmlformats.org/presentationml/2006/main">
+<p:sld xmlns:a="http://schemas.openxmlformats.org/drawingml/2006/main" xmlns:p="http://schemas.openxmlformats.org/presentationml/2006/main" xmlns:r="http://schemas.openxmlformats.org/officeDocument/2006/relationships">
   <p:cSld>
     <p:bg>
       <p:bgPr>
@@ -12773,14 +11544,7 @@
         <p:cNvGrpSpPr/>
         <p:nvPr/>
       </p:nvGrpSpPr>
-      <p:grpSpPr>
-        <a:xfrm>
-          <a:off x="0" y="0"/>
-          <a:ext cx="0" cy="0"/>
-          <a:chOff x="0" y="0"/>
-          <a:chExt cx="0" cy="0"/>
-        </a:xfrm>
-      </p:grpSpPr>
+      <p:grpSpPr/>
       <p:sp>
         <p:nvSpPr>
           <p:cNvPr id="2" name="Rounded Rectangle 1"/>
@@ -12821,7 +11585,6 @@
           <a:lstStyle/>
           <a:p>
             <a:pPr algn="ctr"/>
-            <a:endParaRPr/>
           </a:p>
         </p:txBody>
       </p:sp>
@@ -12865,7 +11628,6 @@
           <a:lstStyle/>
           <a:p>
             <a:pPr algn="ctr"/>
-            <a:endParaRPr/>
           </a:p>
         </p:txBody>
       </p:sp>
@@ -12909,7 +11671,6 @@
           <a:lstStyle/>
           <a:p>
             <a:pPr algn="ctr"/>
-            <a:endParaRPr/>
           </a:p>
         </p:txBody>
       </p:sp>
@@ -13026,7 +11787,7 @@
         </p:nvSpPr>
         <p:spPr>
           <a:xfrm>
-            <a:off x="822960" y="2395728"/>
+            <a:off x="822960" y="1965960"/>
             <a:ext cx="1828800" cy="594360"/>
           </a:xfrm>
           <a:prstGeom prst="rect">
@@ -13061,7 +11822,7 @@
         </p:nvSpPr>
         <p:spPr>
           <a:xfrm>
-            <a:off x="822960" y="2962656"/>
+            <a:off x="822960" y="2532888"/>
             <a:ext cx="1828800" cy="320040"/>
           </a:xfrm>
           <a:prstGeom prst="rect">
@@ -13096,7 +11857,7 @@
         </p:nvSpPr>
         <p:spPr>
           <a:xfrm>
-            <a:off x="3063240" y="2395728"/>
+            <a:off x="3063240" y="1965960"/>
             <a:ext cx="2011680" cy="594360"/>
           </a:xfrm>
           <a:prstGeom prst="rect">
@@ -13131,7 +11892,7 @@
         </p:nvSpPr>
         <p:spPr>
           <a:xfrm>
-            <a:off x="3063240" y="2962656"/>
+            <a:off x="3063240" y="2532888"/>
             <a:ext cx="2011680" cy="320040"/>
           </a:xfrm>
           <a:prstGeom prst="rect">
@@ -13166,7 +11927,7 @@
         </p:nvSpPr>
         <p:spPr>
           <a:xfrm>
-            <a:off x="5486400" y="2395728"/>
+            <a:off x="5486400" y="1965960"/>
             <a:ext cx="2011680" cy="594360"/>
           </a:xfrm>
           <a:prstGeom prst="rect">
@@ -13201,7 +11962,7 @@
         </p:nvSpPr>
         <p:spPr>
           <a:xfrm>
-            <a:off x="5486400" y="2962656"/>
+            <a:off x="5486400" y="2532888"/>
             <a:ext cx="2011680" cy="320040"/>
           </a:xfrm>
           <a:prstGeom prst="rect">
@@ -13236,7 +11997,7 @@
         </p:nvSpPr>
         <p:spPr>
           <a:xfrm>
-            <a:off x="7726679" y="2395728"/>
+            <a:off x="7726679" y="1965960"/>
             <a:ext cx="2011680" cy="594360"/>
           </a:xfrm>
           <a:prstGeom prst="rect">
@@ -13271,7 +12032,7 @@
         </p:nvSpPr>
         <p:spPr>
           <a:xfrm>
-            <a:off x="7726679" y="2962656"/>
+            <a:off x="7726679" y="2532888"/>
             <a:ext cx="2011680" cy="320040"/>
           </a:xfrm>
           <a:prstGeom prst="rect">

</xml_diff>

<commit_message>
docs: add 7-minute speaker notes to all presentation slides
</commit_message>
<xml_diff>
--- a/docs/AskTube_AI_Presentation.pptx
+++ b/docs/AskTube_AI_Presentation.pptx
@@ -6,16 +6,16 @@
   </p:sldMasterIdLst>
   <p:sldIdLst>
     <p:sldId id="256" r:id="rId7"/>
-    <p:sldId id="257" r:id="rId8"/>
-    <p:sldId id="258" r:id="rId9"/>
-    <p:sldId id="259" r:id="rId10"/>
-    <p:sldId id="260" r:id="rId11"/>
-    <p:sldId id="261" r:id="rId12"/>
-    <p:sldId id="262" r:id="rId13"/>
-    <p:sldId id="263" r:id="rId14"/>
-    <p:sldId id="264" r:id="rId15"/>
-    <p:sldId id="265" r:id="rId16"/>
-    <p:sldId id="266" r:id="rId17"/>
+    <p:sldId id="257" r:id="rId9"/>
+    <p:sldId id="258" r:id="rId10"/>
+    <p:sldId id="259" r:id="rId11"/>
+    <p:sldId id="260" r:id="rId12"/>
+    <p:sldId id="261" r:id="rId13"/>
+    <p:sldId id="262" r:id="rId14"/>
+    <p:sldId id="263" r:id="rId15"/>
+    <p:sldId id="264" r:id="rId16"/>
+    <p:sldId id="265" r:id="rId17"/>
+    <p:sldId id="266" r:id="rId18"/>
   </p:sldIdLst>
   <p:sldSz cx="12191695" cy="6858000" type="screen4x3"/>
   <p:notesSz cx="6858000" cy="9144000"/>
@@ -115,6 +115,1258 @@
     </a:lvl9pPr>
   </p:defaultTextStyle>
 </p:presentation>
+</file>
+
+<file path=ppt/notesMasters/notesMaster1.xml><?xml version="1.0" encoding="utf-8"?>
+<p:notesMaster xmlns:a="http://schemas.openxmlformats.org/drawingml/2006/main" xmlns:p="http://schemas.openxmlformats.org/presentationml/2006/main" xmlns:r="http://schemas.openxmlformats.org/officeDocument/2006/relationships">
+  <p:cSld>
+    <p:bg>
+      <p:bgRef idx="1001">
+        <a:schemeClr val="bg1"/>
+      </p:bgRef>
+    </p:bg>
+    <p:spTree>
+      <p:nvGrpSpPr>
+        <p:cNvPr id="1" name=""/>
+        <p:cNvGrpSpPr/>
+        <p:nvPr/>
+      </p:nvGrpSpPr>
+      <p:grpSpPr>
+        <a:xfrm>
+          <a:off x="0" y="0"/>
+          <a:ext cx="0" cy="0"/>
+          <a:chOff x="0" y="0"/>
+          <a:chExt cx="0" cy="0"/>
+        </a:xfrm>
+      </p:grpSpPr>
+      <p:sp>
+        <p:nvSpPr>
+          <p:cNvPr id="2" name="Header Placeholder 1"/>
+          <p:cNvSpPr>
+            <a:spLocks noGrp="1"/>
+          </p:cNvSpPr>
+          <p:nvPr>
+            <p:ph type="hdr" sz="quarter"/>
+          </p:nvPr>
+        </p:nvSpPr>
+        <p:spPr>
+          <a:xfrm>
+            <a:off x="0" y="0"/>
+            <a:ext cx="2971800" cy="457200"/>
+          </a:xfrm>
+          <a:prstGeom prst="rect">
+            <a:avLst/>
+          </a:prstGeom>
+        </p:spPr>
+        <p:txBody>
+          <a:bodyPr vert="horz" lIns="91440" tIns="45720" rIns="91440" bIns="45720" rtlCol="0"/>
+          <a:lstStyle>
+            <a:lvl1pPr algn="l">
+              <a:defRPr sz="1200"/>
+            </a:lvl1pPr>
+          </a:lstStyle>
+          <a:p>
+            <a:endParaRPr lang="en-US"/>
+          </a:p>
+        </p:txBody>
+      </p:sp>
+      <p:sp>
+        <p:nvSpPr>
+          <p:cNvPr id="3" name="Date Placeholder 2"/>
+          <p:cNvSpPr>
+            <a:spLocks noGrp="1"/>
+          </p:cNvSpPr>
+          <p:nvPr>
+            <p:ph type="dt" idx="1"/>
+          </p:nvPr>
+        </p:nvSpPr>
+        <p:spPr>
+          <a:xfrm>
+            <a:off x="3884613" y="0"/>
+            <a:ext cx="2971800" cy="457200"/>
+          </a:xfrm>
+          <a:prstGeom prst="rect">
+            <a:avLst/>
+          </a:prstGeom>
+        </p:spPr>
+        <p:txBody>
+          <a:bodyPr vert="horz" lIns="91440" tIns="45720" rIns="91440" bIns="45720" rtlCol="0"/>
+          <a:lstStyle>
+            <a:lvl1pPr algn="r">
+              <a:defRPr sz="1200"/>
+            </a:lvl1pPr>
+          </a:lstStyle>
+          <a:p>
+            <a:fld id="{0F89C1C7-3DCD-1040-A9CF-14679D8B5DDD}" type="datetimeFigureOut">
+              <a:rPr lang="en-US" smtClean="0"/>
+              <a:t>10/17/16</a:t>
+            </a:fld>
+            <a:endParaRPr lang="en-US"/>
+          </a:p>
+        </p:txBody>
+      </p:sp>
+      <p:sp>
+        <p:nvSpPr>
+          <p:cNvPr id="4" name="Slide Image Placeholder 3"/>
+          <p:cNvSpPr>
+            <a:spLocks noGrp="1" noRot="1" noChangeAspect="1"/>
+          </p:cNvSpPr>
+          <p:nvPr>
+            <p:ph type="sldImg" idx="2"/>
+          </p:nvPr>
+        </p:nvSpPr>
+        <p:spPr>
+          <a:xfrm>
+            <a:off x="1143000" y="685800"/>
+            <a:ext cx="4572000" cy="3429000"/>
+          </a:xfrm>
+          <a:prstGeom prst="rect">
+            <a:avLst/>
+          </a:prstGeom>
+          <a:noFill/>
+          <a:ln w="12700">
+            <a:solidFill>
+              <a:prstClr val="black"/>
+            </a:solidFill>
+          </a:ln>
+        </p:spPr>
+        <p:txBody>
+          <a:bodyPr vert="horz" lIns="91440" tIns="45720" rIns="91440" bIns="45720" rtlCol="0" anchor="ctr"/>
+          <a:lstStyle/>
+          <a:p>
+            <a:endParaRPr lang="en-US"/>
+          </a:p>
+        </p:txBody>
+      </p:sp>
+      <p:sp>
+        <p:nvSpPr>
+          <p:cNvPr id="5" name="Notes Placeholder 4"/>
+          <p:cNvSpPr>
+            <a:spLocks noGrp="1"/>
+          </p:cNvSpPr>
+          <p:nvPr>
+            <p:ph type="body" sz="quarter" idx="3"/>
+          </p:nvPr>
+        </p:nvSpPr>
+        <p:spPr>
+          <a:xfrm>
+            <a:off x="685800" y="4343400"/>
+            <a:ext cx="5486400" cy="4114800"/>
+          </a:xfrm>
+          <a:prstGeom prst="rect">
+            <a:avLst/>
+          </a:prstGeom>
+        </p:spPr>
+        <p:txBody>
+          <a:bodyPr vert="horz" lIns="91440" tIns="45720" rIns="91440" bIns="45720" rtlCol="0"/>
+          <a:lstStyle/>
+          <a:p>
+            <a:pPr lvl="0"/>
+            <a:r>
+              <a:rPr lang="en-US" smtClean="0"/>
+              <a:t>Click to edit Master text styles</a:t>
+            </a:r>
+          </a:p>
+          <a:p>
+            <a:pPr lvl="1"/>
+            <a:r>
+              <a:rPr lang="en-US" smtClean="0"/>
+              <a:t>Second level</a:t>
+            </a:r>
+          </a:p>
+          <a:p>
+            <a:pPr lvl="2"/>
+            <a:r>
+              <a:rPr lang="en-US" smtClean="0"/>
+              <a:t>Third level</a:t>
+            </a:r>
+          </a:p>
+          <a:p>
+            <a:pPr lvl="3"/>
+            <a:r>
+              <a:rPr lang="en-US" smtClean="0"/>
+              <a:t>Fourth level</a:t>
+            </a:r>
+          </a:p>
+          <a:p>
+            <a:pPr lvl="4"/>
+            <a:r>
+              <a:rPr lang="en-US" smtClean="0"/>
+              <a:t>Fifth level</a:t>
+            </a:r>
+            <a:endParaRPr lang="en-US"/>
+          </a:p>
+        </p:txBody>
+      </p:sp>
+      <p:sp>
+        <p:nvSpPr>
+          <p:cNvPr id="6" name="Footer Placeholder 5"/>
+          <p:cNvSpPr>
+            <a:spLocks noGrp="1"/>
+          </p:cNvSpPr>
+          <p:nvPr>
+            <p:ph type="ftr" sz="quarter" idx="4"/>
+          </p:nvPr>
+        </p:nvSpPr>
+        <p:spPr>
+          <a:xfrm>
+            <a:off x="0" y="8685213"/>
+            <a:ext cx="2971800" cy="457200"/>
+          </a:xfrm>
+          <a:prstGeom prst="rect">
+            <a:avLst/>
+          </a:prstGeom>
+        </p:spPr>
+        <p:txBody>
+          <a:bodyPr vert="horz" lIns="91440" tIns="45720" rIns="91440" bIns="45720" rtlCol="0" anchor="b"/>
+          <a:lstStyle>
+            <a:lvl1pPr algn="l">
+              <a:defRPr sz="1200"/>
+            </a:lvl1pPr>
+          </a:lstStyle>
+          <a:p>
+            <a:endParaRPr lang="en-US"/>
+          </a:p>
+        </p:txBody>
+      </p:sp>
+      <p:sp>
+        <p:nvSpPr>
+          <p:cNvPr id="7" name="Slide Number Placeholder 6"/>
+          <p:cNvSpPr>
+            <a:spLocks noGrp="1"/>
+          </p:cNvSpPr>
+          <p:nvPr>
+            <p:ph type="sldNum" sz="quarter" idx="5"/>
+          </p:nvPr>
+        </p:nvSpPr>
+        <p:spPr>
+          <a:xfrm>
+            <a:off x="3884613" y="8685213"/>
+            <a:ext cx="2971800" cy="457200"/>
+          </a:xfrm>
+          <a:prstGeom prst="rect">
+            <a:avLst/>
+          </a:prstGeom>
+        </p:spPr>
+        <p:txBody>
+          <a:bodyPr vert="horz" lIns="91440" tIns="45720" rIns="91440" bIns="45720" rtlCol="0" anchor="b"/>
+          <a:lstStyle>
+            <a:lvl1pPr algn="r">
+              <a:defRPr sz="1200"/>
+            </a:lvl1pPr>
+          </a:lstStyle>
+          <a:p>
+            <a:fld id="{BB5E49A5-4136-284D-997B-48E1D791AD67}" type="slidenum">
+              <a:rPr lang="en-US" smtClean="0"/>
+              <a:t>‹#›</a:t>
+            </a:fld>
+            <a:endParaRPr lang="en-US"/>
+          </a:p>
+        </p:txBody>
+      </p:sp>
+    </p:spTree>
+    <p:extLst>
+      <p:ext uri="{BB962C8B-B14F-4D97-AF65-F5344CB8AC3E}">
+        <p14:creationId xmlns:p14="http://schemas.microsoft.com/office/powerpoint/2010/main" val="2623252185"/>
+      </p:ext>
+    </p:extLst>
+  </p:cSld>
+  <p:clrMap bg1="lt1" tx1="dk1" bg2="lt2" tx2="dk2" accent1="accent1" accent2="accent2" accent3="accent3" accent4="accent4" accent5="accent5" accent6="accent6" hlink="hlink" folHlink="folHlink"/>
+  <p:notesStyle>
+    <a:lvl1pPr marL="0" algn="l" defTabSz="457200" rtl="0" eaLnBrk="1" latinLnBrk="0" hangingPunct="1">
+      <a:defRPr sz="1200" kern="1200">
+        <a:solidFill>
+          <a:schemeClr val="tx1"/>
+        </a:solidFill>
+        <a:latin typeface="+mn-lt"/>
+        <a:ea typeface="+mn-ea"/>
+        <a:cs typeface="+mn-cs"/>
+      </a:defRPr>
+    </a:lvl1pPr>
+    <a:lvl2pPr marL="457200" algn="l" defTabSz="457200" rtl="0" eaLnBrk="1" latinLnBrk="0" hangingPunct="1">
+      <a:defRPr sz="1200" kern="1200">
+        <a:solidFill>
+          <a:schemeClr val="tx1"/>
+        </a:solidFill>
+        <a:latin typeface="+mn-lt"/>
+        <a:ea typeface="+mn-ea"/>
+        <a:cs typeface="+mn-cs"/>
+      </a:defRPr>
+    </a:lvl2pPr>
+    <a:lvl3pPr marL="914400" algn="l" defTabSz="457200" rtl="0" eaLnBrk="1" latinLnBrk="0" hangingPunct="1">
+      <a:defRPr sz="1200" kern="1200">
+        <a:solidFill>
+          <a:schemeClr val="tx1"/>
+        </a:solidFill>
+        <a:latin typeface="+mn-lt"/>
+        <a:ea typeface="+mn-ea"/>
+        <a:cs typeface="+mn-cs"/>
+      </a:defRPr>
+    </a:lvl3pPr>
+    <a:lvl4pPr marL="1371600" algn="l" defTabSz="457200" rtl="0" eaLnBrk="1" latinLnBrk="0" hangingPunct="1">
+      <a:defRPr sz="1200" kern="1200">
+        <a:solidFill>
+          <a:schemeClr val="tx1"/>
+        </a:solidFill>
+        <a:latin typeface="+mn-lt"/>
+        <a:ea typeface="+mn-ea"/>
+        <a:cs typeface="+mn-cs"/>
+      </a:defRPr>
+    </a:lvl4pPr>
+    <a:lvl5pPr marL="1828800" algn="l" defTabSz="457200" rtl="0" eaLnBrk="1" latinLnBrk="0" hangingPunct="1">
+      <a:defRPr sz="1200" kern="1200">
+        <a:solidFill>
+          <a:schemeClr val="tx1"/>
+        </a:solidFill>
+        <a:latin typeface="+mn-lt"/>
+        <a:ea typeface="+mn-ea"/>
+        <a:cs typeface="+mn-cs"/>
+      </a:defRPr>
+    </a:lvl5pPr>
+    <a:lvl6pPr marL="2286000" algn="l" defTabSz="457200" rtl="0" eaLnBrk="1" latinLnBrk="0" hangingPunct="1">
+      <a:defRPr sz="1200" kern="1200">
+        <a:solidFill>
+          <a:schemeClr val="tx1"/>
+        </a:solidFill>
+        <a:latin typeface="+mn-lt"/>
+        <a:ea typeface="+mn-ea"/>
+        <a:cs typeface="+mn-cs"/>
+      </a:defRPr>
+    </a:lvl6pPr>
+    <a:lvl7pPr marL="2743200" algn="l" defTabSz="457200" rtl="0" eaLnBrk="1" latinLnBrk="0" hangingPunct="1">
+      <a:defRPr sz="1200" kern="1200">
+        <a:solidFill>
+          <a:schemeClr val="tx1"/>
+        </a:solidFill>
+        <a:latin typeface="+mn-lt"/>
+        <a:ea typeface="+mn-ea"/>
+        <a:cs typeface="+mn-cs"/>
+      </a:defRPr>
+    </a:lvl7pPr>
+    <a:lvl8pPr marL="3200400" algn="l" defTabSz="457200" rtl="0" eaLnBrk="1" latinLnBrk="0" hangingPunct="1">
+      <a:defRPr sz="1200" kern="1200">
+        <a:solidFill>
+          <a:schemeClr val="tx1"/>
+        </a:solidFill>
+        <a:latin typeface="+mn-lt"/>
+        <a:ea typeface="+mn-ea"/>
+        <a:cs typeface="+mn-cs"/>
+      </a:defRPr>
+    </a:lvl8pPr>
+    <a:lvl9pPr marL="3657600" algn="l" defTabSz="457200" rtl="0" eaLnBrk="1" latinLnBrk="0" hangingPunct="1">
+      <a:defRPr sz="1200" kern="1200">
+        <a:solidFill>
+          <a:schemeClr val="tx1"/>
+        </a:solidFill>
+        <a:latin typeface="+mn-lt"/>
+        <a:ea typeface="+mn-ea"/>
+        <a:cs typeface="+mn-cs"/>
+      </a:defRPr>
+    </a:lvl9pPr>
+  </p:notesStyle>
+</p:notesMaster>
+</file>
+
+<file path=ppt/notesSlides/notesSlide1.xml><?xml version="1.0" encoding="utf-8"?>
+<p:notes xmlns:a="http://schemas.openxmlformats.org/drawingml/2006/main" xmlns:p="http://schemas.openxmlformats.org/presentationml/2006/main" xmlns:r="http://schemas.openxmlformats.org/officeDocument/2006/relationships">
+  <p:cSld>
+    <p:spTree>
+      <p:nvGrpSpPr>
+        <p:cNvPr id="1" name=""/>
+        <p:cNvGrpSpPr/>
+        <p:nvPr/>
+      </p:nvGrpSpPr>
+      <p:grpSpPr>
+        <a:xfrm>
+          <a:off x="0" y="0"/>
+          <a:ext cx="0" cy="0"/>
+          <a:chOff x="0" y="0"/>
+          <a:chExt cx="0" cy="0"/>
+        </a:xfrm>
+      </p:grpSpPr>
+      <p:sp>
+        <p:nvSpPr>
+          <p:cNvPr id="2" name="Slide Image Placeholder 1"/>
+          <p:cNvSpPr>
+            <a:spLocks noGrp="1"/>
+          </p:cNvSpPr>
+          <p:nvPr>
+            <p:ph type="sldImg" idx="2"/>
+          </p:nvPr>
+        </p:nvSpPr>
+        <p:spPr/>
+      </p:sp>
+      <p:sp>
+        <p:nvSpPr>
+          <p:cNvPr id="3" name="Notes Placeholder 2"/>
+          <p:cNvSpPr>
+            <a:spLocks noGrp="1"/>
+          </p:cNvSpPr>
+          <p:nvPr>
+            <p:ph type="body" idx="3" sz="quarter"/>
+          </p:nvPr>
+        </p:nvSpPr>
+        <p:spPr/>
+        <p:txBody>
+          <a:bodyPr/>
+          <a:lstStyle/>
+          <a:p>
+            <a:r>
+              <a:t>~20 seconds</a:t>
+            </a:r>
+          </a:p>
+          <a:p/>
+          <a:p>
+            <a:r>
+              <a:t>Hi, I'm Sabeur. AskTube AI is an AI platform that lets you chat with any YouTube video using its transcript. It is not a generic chatbot — every answer is grounded in the video, with timestamp citations so you can verify exactly where the information comes from.</a:t>
+            </a:r>
+          </a:p>
+        </p:txBody>
+      </p:sp>
+      <p:sp>
+        <p:nvSpPr>
+          <p:cNvPr id="4" name="Slide Number Placeholder 3"/>
+          <p:cNvSpPr>
+            <a:spLocks noGrp="1"/>
+          </p:cNvSpPr>
+          <p:nvPr>
+            <p:ph type="sldNum" idx="5" sz="quarter"/>
+          </p:nvPr>
+        </p:nvSpPr>
+        <p:spPr/>
+      </p:sp>
+    </p:spTree>
+  </p:cSld>
+  <p:clrMapOvr>
+    <a:masterClrMapping/>
+  </p:clrMapOvr>
+</p:notes>
+</file>
+
+<file path=ppt/notesSlides/notesSlide10.xml><?xml version="1.0" encoding="utf-8"?>
+<p:notes xmlns:a="http://schemas.openxmlformats.org/drawingml/2006/main" xmlns:p="http://schemas.openxmlformats.org/presentationml/2006/main" xmlns:r="http://schemas.openxmlformats.org/officeDocument/2006/relationships">
+  <p:cSld>
+    <p:spTree>
+      <p:nvGrpSpPr>
+        <p:cNvPr id="1" name=""/>
+        <p:cNvGrpSpPr/>
+        <p:nvPr/>
+      </p:nvGrpSpPr>
+      <p:grpSpPr>
+        <a:xfrm>
+          <a:off x="0" y="0"/>
+          <a:ext cx="0" cy="0"/>
+          <a:chOff x="0" y="0"/>
+          <a:chExt cx="0" cy="0"/>
+        </a:xfrm>
+      </p:grpSpPr>
+      <p:sp>
+        <p:nvSpPr>
+          <p:cNvPr id="2" name="Slide Image Placeholder 1"/>
+          <p:cNvSpPr>
+            <a:spLocks noGrp="1"/>
+          </p:cNvSpPr>
+          <p:nvPr>
+            <p:ph type="sldImg" idx="2"/>
+          </p:nvPr>
+        </p:nvSpPr>
+        <p:spPr/>
+      </p:sp>
+      <p:sp>
+        <p:nvSpPr>
+          <p:cNvPr id="3" name="Notes Placeholder 2"/>
+          <p:cNvSpPr>
+            <a:spLocks noGrp="1"/>
+          </p:cNvSpPr>
+          <p:nvPr>
+            <p:ph type="body" idx="3" sz="quarter"/>
+          </p:nvPr>
+        </p:nvSpPr>
+        <p:spPr/>
+        <p:txBody>
+          <a:bodyPr/>
+          <a:lstStyle/>
+          <a:p>
+            <a:r>
+              <a:t>~90 seconds</a:t>
+            </a:r>
+          </a:p>
+          <a:p/>
+          <a:p>
+            <a:r>
+              <a:t>Let me show you the live app. Open http://18.157.233.122:3001/ — this is running on AWS EC2 with a Webshare residential proxy to bypass YouTube's cloud IP restrictions.</a:t>
+            </a:r>
+          </a:p>
+          <a:p/>
+          <a:p>
+            <a:r>
+              <a:t>[Search] I'll type 'python tutorial for beginners' and apply a duration filter. [Results appear] Pick a video and click Prepare. [Watch the progress steps: metadata, transcript, chunking, embeddings, storage.]</a:t>
+            </a:r>
+          </a:p>
+          <a:p/>
+          <a:p>
+            <a:r>
+              <a:t>[Chat] Now I ask: 'What is Python used for?' — [Answer appears with timestamp chips] See the citations — each one links to the exact moment in the video. [Click a timestamp]</a:t>
+            </a:r>
+          </a:p>
+          <a:p/>
+          <a:p>
+            <a:r>
+              <a:t>[Follow-up] Now a follow-up: 'Can you give me an example?' — the memory keeps the context so it understands what I mean.</a:t>
+            </a:r>
+          </a:p>
+          <a:p/>
+          <a:p>
+            <a:r>
+              <a:t>[Refusal] Now I ask something off-topic like 'What is the weather today?' — it refuses. It only answers from the video transcript. That is the trust guarantee.</a:t>
+            </a:r>
+          </a:p>
+        </p:txBody>
+      </p:sp>
+      <p:sp>
+        <p:nvSpPr>
+          <p:cNvPr id="4" name="Slide Number Placeholder 3"/>
+          <p:cNvSpPr>
+            <a:spLocks noGrp="1"/>
+          </p:cNvSpPr>
+          <p:nvPr>
+            <p:ph type="sldNum" idx="5" sz="quarter"/>
+          </p:nvPr>
+        </p:nvSpPr>
+        <p:spPr/>
+      </p:sp>
+    </p:spTree>
+  </p:cSld>
+  <p:clrMapOvr>
+    <a:masterClrMapping/>
+  </p:clrMapOvr>
+</p:notes>
+</file>
+
+<file path=ppt/notesSlides/notesSlide11.xml><?xml version="1.0" encoding="utf-8"?>
+<p:notes xmlns:a="http://schemas.openxmlformats.org/drawingml/2006/main" xmlns:p="http://schemas.openxmlformats.org/presentationml/2006/main" xmlns:r="http://schemas.openxmlformats.org/officeDocument/2006/relationships">
+  <p:cSld>
+    <p:spTree>
+      <p:nvGrpSpPr>
+        <p:cNvPr id="1" name=""/>
+        <p:cNvGrpSpPr/>
+        <p:nvPr/>
+      </p:nvGrpSpPr>
+      <p:grpSpPr>
+        <a:xfrm>
+          <a:off x="0" y="0"/>
+          <a:ext cx="0" cy="0"/>
+          <a:chOff x="0" y="0"/>
+          <a:chExt cx="0" cy="0"/>
+        </a:xfrm>
+      </p:grpSpPr>
+      <p:sp>
+        <p:nvSpPr>
+          <p:cNvPr id="2" name="Slide Image Placeholder 1"/>
+          <p:cNvSpPr>
+            <a:spLocks noGrp="1"/>
+          </p:cNvSpPr>
+          <p:nvPr>
+            <p:ph type="sldImg" idx="2"/>
+          </p:nvPr>
+        </p:nvSpPr>
+        <p:spPr/>
+      </p:sp>
+      <p:sp>
+        <p:nvSpPr>
+          <p:cNvPr id="3" name="Notes Placeholder 2"/>
+          <p:cNvSpPr>
+            <a:spLocks noGrp="1"/>
+          </p:cNvSpPr>
+          <p:nvPr>
+            <p:ph type="body" idx="3" sz="quarter"/>
+          </p:nvPr>
+        </p:nvSpPr>
+        <p:spPr/>
+        <p:txBody>
+          <a:bodyPr/>
+          <a:lstStyle/>
+          <a:p>
+            <a:r>
+              <a:t>~15 seconds</a:t>
+            </a:r>
+          </a:p>
+          <a:p/>
+          <a:p>
+            <a:r>
+              <a:t>AskTube AI covers all the mandatory IronHack requirements: LLM chatbot, LangChain tools, conversational memory, ChromaDB vector database, text processing, a polished UI, 98 tests, RAG evaluation, and Docker deployment on EC2. Thank you.</a:t>
+            </a:r>
+          </a:p>
+        </p:txBody>
+      </p:sp>
+      <p:sp>
+        <p:nvSpPr>
+          <p:cNvPr id="4" name="Slide Number Placeholder 3"/>
+          <p:cNvSpPr>
+            <a:spLocks noGrp="1"/>
+          </p:cNvSpPr>
+          <p:nvPr>
+            <p:ph type="sldNum" idx="5" sz="quarter"/>
+          </p:nvPr>
+        </p:nvSpPr>
+        <p:spPr/>
+      </p:sp>
+    </p:spTree>
+  </p:cSld>
+  <p:clrMapOvr>
+    <a:masterClrMapping/>
+  </p:clrMapOvr>
+</p:notes>
+</file>
+
+<file path=ppt/notesSlides/notesSlide2.xml><?xml version="1.0" encoding="utf-8"?>
+<p:notes xmlns:a="http://schemas.openxmlformats.org/drawingml/2006/main" xmlns:p="http://schemas.openxmlformats.org/presentationml/2006/main" xmlns:r="http://schemas.openxmlformats.org/officeDocument/2006/relationships">
+  <p:cSld>
+    <p:spTree>
+      <p:nvGrpSpPr>
+        <p:cNvPr id="1" name=""/>
+        <p:cNvGrpSpPr/>
+        <p:nvPr/>
+      </p:nvGrpSpPr>
+      <p:grpSpPr>
+        <a:xfrm>
+          <a:off x="0" y="0"/>
+          <a:ext cx="0" cy="0"/>
+          <a:chOff x="0" y="0"/>
+          <a:chExt cx="0" cy="0"/>
+        </a:xfrm>
+      </p:grpSpPr>
+      <p:sp>
+        <p:nvSpPr>
+          <p:cNvPr id="2" name="Slide Image Placeholder 1"/>
+          <p:cNvSpPr>
+            <a:spLocks noGrp="1"/>
+          </p:cNvSpPr>
+          <p:nvPr>
+            <p:ph type="sldImg" idx="2"/>
+          </p:nvPr>
+        </p:nvSpPr>
+        <p:spPr/>
+      </p:sp>
+      <p:sp>
+        <p:nvSpPr>
+          <p:cNvPr id="3" name="Notes Placeholder 2"/>
+          <p:cNvSpPr>
+            <a:spLocks noGrp="1"/>
+          </p:cNvSpPr>
+          <p:nvPr>
+            <p:ph type="body" idx="3" sz="quarter"/>
+          </p:nvPr>
+        </p:nvSpPr>
+        <p:spPr/>
+        <p:txBody>
+          <a:bodyPr/>
+          <a:lstStyle/>
+          <a:p>
+            <a:r>
+              <a:t>~40 seconds</a:t>
+            </a:r>
+          </a:p>
+          <a:p/>
+          <a:p>
+            <a:r>
+              <a:t>YouTube has over 800 million videos. Learning from long videos is frustrating — you scrub back and forth looking for one specific answer.</a:t>
+            </a:r>
+          </a:p>
+          <a:p/>
+          <a:p>
+            <a:r>
+              <a:t>AskTube solves this by turning any video into a conversational knowledge base. You ask a question and the AI answers using the transcript, with the exact timestamp. The key rule: if the transcript doesn't contain the answer, the system refuses — no hallucinations, no invented content.</a:t>
+            </a:r>
+          </a:p>
+        </p:txBody>
+      </p:sp>
+      <p:sp>
+        <p:nvSpPr>
+          <p:cNvPr id="4" name="Slide Number Placeholder 3"/>
+          <p:cNvSpPr>
+            <a:spLocks noGrp="1"/>
+          </p:cNvSpPr>
+          <p:nvPr>
+            <p:ph type="sldNum" idx="5" sz="quarter"/>
+          </p:nvPr>
+        </p:nvSpPr>
+        <p:spPr/>
+      </p:sp>
+    </p:spTree>
+  </p:cSld>
+  <p:clrMapOvr>
+    <a:masterClrMapping/>
+  </p:clrMapOvr>
+</p:notes>
+</file>
+
+<file path=ppt/notesSlides/notesSlide3.xml><?xml version="1.0" encoding="utf-8"?>
+<p:notes xmlns:a="http://schemas.openxmlformats.org/drawingml/2006/main" xmlns:p="http://schemas.openxmlformats.org/presentationml/2006/main" xmlns:r="http://schemas.openxmlformats.org/officeDocument/2006/relationships">
+  <p:cSld>
+    <p:spTree>
+      <p:nvGrpSpPr>
+        <p:cNvPr id="1" name=""/>
+        <p:cNvGrpSpPr/>
+        <p:nvPr/>
+      </p:nvGrpSpPr>
+      <p:grpSpPr>
+        <a:xfrm>
+          <a:off x="0" y="0"/>
+          <a:ext cx="0" cy="0"/>
+          <a:chOff x="0" y="0"/>
+          <a:chExt cx="0" cy="0"/>
+        </a:xfrm>
+      </p:grpSpPr>
+      <p:sp>
+        <p:nvSpPr>
+          <p:cNvPr id="2" name="Slide Image Placeholder 1"/>
+          <p:cNvSpPr>
+            <a:spLocks noGrp="1"/>
+          </p:cNvSpPr>
+          <p:nvPr>
+            <p:ph type="sldImg" idx="2"/>
+          </p:nvPr>
+        </p:nvSpPr>
+        <p:spPr/>
+      </p:sp>
+      <p:sp>
+        <p:nvSpPr>
+          <p:cNvPr id="3" name="Notes Placeholder 2"/>
+          <p:cNvSpPr>
+            <a:spLocks noGrp="1"/>
+          </p:cNvSpPr>
+          <p:nvPr>
+            <p:ph type="body" idx="3" sz="quarter"/>
+          </p:nvPr>
+        </p:nvSpPr>
+        <p:spPr/>
+        <p:txBody>
+          <a:bodyPr/>
+          <a:lstStyle/>
+          <a:p>
+            <a:r>
+              <a:t>~35 seconds</a:t>
+            </a:r>
+          </a:p>
+          <a:p/>
+          <a:p>
+            <a:r>
+              <a:t>The flow is four steps. Search for a topic by text or voice. Pick a video from a carousel. The app processes the transcript in real time — you see each step happening. Then you chat with the video content and get answers with clickable timestamp citations.</a:t>
+            </a:r>
+          </a:p>
+          <a:p/>
+          <a:p>
+            <a:r>
+              <a:t>The whole journey is guided by a 3D robot companion that moves around the screen and speaks at each stage.</a:t>
+            </a:r>
+          </a:p>
+        </p:txBody>
+      </p:sp>
+      <p:sp>
+        <p:nvSpPr>
+          <p:cNvPr id="4" name="Slide Number Placeholder 3"/>
+          <p:cNvSpPr>
+            <a:spLocks noGrp="1"/>
+          </p:cNvSpPr>
+          <p:nvPr>
+            <p:ph type="sldNum" idx="5" sz="quarter"/>
+          </p:nvPr>
+        </p:nvSpPr>
+        <p:spPr/>
+      </p:sp>
+    </p:spTree>
+  </p:cSld>
+  <p:clrMapOvr>
+    <a:masterClrMapping/>
+  </p:clrMapOvr>
+</p:notes>
+</file>
+
+<file path=ppt/notesSlides/notesSlide4.xml><?xml version="1.0" encoding="utf-8"?>
+<p:notes xmlns:a="http://schemas.openxmlformats.org/drawingml/2006/main" xmlns:p="http://schemas.openxmlformats.org/presentationml/2006/main" xmlns:r="http://schemas.openxmlformats.org/officeDocument/2006/relationships">
+  <p:cSld>
+    <p:spTree>
+      <p:nvGrpSpPr>
+        <p:cNvPr id="1" name=""/>
+        <p:cNvGrpSpPr/>
+        <p:nvPr/>
+      </p:nvGrpSpPr>
+      <p:grpSpPr>
+        <a:xfrm>
+          <a:off x="0" y="0"/>
+          <a:ext cx="0" cy="0"/>
+          <a:chOff x="0" y="0"/>
+          <a:chExt cx="0" cy="0"/>
+        </a:xfrm>
+      </p:grpSpPr>
+      <p:sp>
+        <p:nvSpPr>
+          <p:cNvPr id="2" name="Slide Image Placeholder 1"/>
+          <p:cNvSpPr>
+            <a:spLocks noGrp="1"/>
+          </p:cNvSpPr>
+          <p:nvPr>
+            <p:ph type="sldImg" idx="2"/>
+          </p:nvPr>
+        </p:nvSpPr>
+        <p:spPr/>
+      </p:sp>
+      <p:sp>
+        <p:nvSpPr>
+          <p:cNvPr id="3" name="Notes Placeholder 2"/>
+          <p:cNvSpPr>
+            <a:spLocks noGrp="1"/>
+          </p:cNvSpPr>
+          <p:nvPr>
+            <p:ph type="body" idx="3" sz="quarter"/>
+          </p:nvPr>
+        </p:nvSpPr>
+        <p:spPr/>
+        <p:txBody>
+          <a:bodyPr/>
+          <a:lstStyle/>
+          <a:p>
+            <a:r>
+              <a:t>~40 seconds</a:t>
+            </a:r>
+          </a:p>
+          <a:p/>
+          <a:p>
+            <a:r>
+              <a:t>Three layers. Frontend: Next.js 14, TypeScript, TailwindCSS, Framer Motion, and Three.js for the 3D robot. Backend: FastAPI with async routes for search, transcripts, chunking, vector storage, chat, agent, and speech. AI layer: LangChain tools, OpenAI GPT-4o-mini for chat and text-embedding-3-small for vectors, ChromaDB as the vector store, and Whisper as a fallback for videos without captions.</a:t>
+            </a:r>
+          </a:p>
+          <a:p/>
+          <a:p>
+            <a:r>
+              <a:t>Everything ships as three Docker containers orchestrated by Docker Compose and deployed on AWS EC2.</a:t>
+            </a:r>
+          </a:p>
+        </p:txBody>
+      </p:sp>
+      <p:sp>
+        <p:nvSpPr>
+          <p:cNvPr id="4" name="Slide Number Placeholder 3"/>
+          <p:cNvSpPr>
+            <a:spLocks noGrp="1"/>
+          </p:cNvSpPr>
+          <p:nvPr>
+            <p:ph type="sldNum" idx="5" sz="quarter"/>
+          </p:nvPr>
+        </p:nvSpPr>
+        <p:spPr/>
+      </p:sp>
+    </p:spTree>
+  </p:cSld>
+  <p:clrMapOvr>
+    <a:masterClrMapping/>
+  </p:clrMapOvr>
+</p:notes>
+</file>
+
+<file path=ppt/notesSlides/notesSlide5.xml><?xml version="1.0" encoding="utf-8"?>
+<p:notes xmlns:a="http://schemas.openxmlformats.org/drawingml/2006/main" xmlns:p="http://schemas.openxmlformats.org/presentationml/2006/main" xmlns:r="http://schemas.openxmlformats.org/officeDocument/2006/relationships">
+  <p:cSld>
+    <p:spTree>
+      <p:nvGrpSpPr>
+        <p:cNvPr id="1" name=""/>
+        <p:cNvGrpSpPr/>
+        <p:nvPr/>
+      </p:nvGrpSpPr>
+      <p:grpSpPr>
+        <a:xfrm>
+          <a:off x="0" y="0"/>
+          <a:ext cx="0" cy="0"/>
+          <a:chOff x="0" y="0"/>
+          <a:chExt cx="0" cy="0"/>
+        </a:xfrm>
+      </p:grpSpPr>
+      <p:sp>
+        <p:nvSpPr>
+          <p:cNvPr id="2" name="Slide Image Placeholder 1"/>
+          <p:cNvSpPr>
+            <a:spLocks noGrp="1"/>
+          </p:cNvSpPr>
+          <p:nvPr>
+            <p:ph type="sldImg" idx="2"/>
+          </p:nvPr>
+        </p:nvSpPr>
+        <p:spPr/>
+      </p:sp>
+      <p:sp>
+        <p:nvSpPr>
+          <p:cNvPr id="3" name="Notes Placeholder 2"/>
+          <p:cNvSpPr>
+            <a:spLocks noGrp="1"/>
+          </p:cNvSpPr>
+          <p:nvPr>
+            <p:ph type="body" idx="3" sz="quarter"/>
+          </p:nvPr>
+        </p:nvSpPr>
+        <p:spPr/>
+        <p:txBody>
+          <a:bodyPr/>
+          <a:lstStyle/>
+          <a:p>
+            <a:r>
+              <a:t>~40 seconds</a:t>
+            </a:r>
+          </a:p>
+          <a:p/>
+          <a:p>
+            <a:r>
+              <a:t>When you click Prepare, the ingestion pipeline runs live. The YouTube Data API fetches the video metadata. youtube-transcript-api pulls the captions — no audio download needed in the normal flow. LangChain splits the transcript into overlapping chunks and keeps the timestamp attached to each one. OpenAI embeds each chunk and ChromaDB stores them for similarity search.</a:t>
+            </a:r>
+          </a:p>
+          <a:p/>
+          <a:p>
+            <a:r>
+              <a:t>The status stream on the right — metadata, transcript, chunking, embeddings, storage — is live WebSocket progress from the backend, not just decoration.</a:t>
+            </a:r>
+          </a:p>
+        </p:txBody>
+      </p:sp>
+      <p:sp>
+        <p:nvSpPr>
+          <p:cNvPr id="4" name="Slide Number Placeholder 3"/>
+          <p:cNvSpPr>
+            <a:spLocks noGrp="1"/>
+          </p:cNvSpPr>
+          <p:nvPr>
+            <p:ph type="sldNum" idx="5" sz="quarter"/>
+          </p:nvPr>
+        </p:nvSpPr>
+        <p:spPr/>
+      </p:sp>
+    </p:spTree>
+  </p:cSld>
+  <p:clrMapOvr>
+    <a:masterClrMapping/>
+  </p:clrMapOvr>
+</p:notes>
+</file>
+
+<file path=ppt/notesSlides/notesSlide6.xml><?xml version="1.0" encoding="utf-8"?>
+<p:notes xmlns:a="http://schemas.openxmlformats.org/drawingml/2006/main" xmlns:p="http://schemas.openxmlformats.org/presentationml/2006/main" xmlns:r="http://schemas.openxmlformats.org/officeDocument/2006/relationships">
+  <p:cSld>
+    <p:spTree>
+      <p:nvGrpSpPr>
+        <p:cNvPr id="1" name=""/>
+        <p:cNvGrpSpPr/>
+        <p:nvPr/>
+      </p:nvGrpSpPr>
+      <p:grpSpPr>
+        <a:xfrm>
+          <a:off x="0" y="0"/>
+          <a:ext cx="0" cy="0"/>
+          <a:chOff x="0" y="0"/>
+          <a:chExt cx="0" cy="0"/>
+        </a:xfrm>
+      </p:grpSpPr>
+      <p:sp>
+        <p:nvSpPr>
+          <p:cNvPr id="2" name="Slide Image Placeholder 1"/>
+          <p:cNvSpPr>
+            <a:spLocks noGrp="1"/>
+          </p:cNvSpPr>
+          <p:nvPr>
+            <p:ph type="sldImg" idx="2"/>
+          </p:nvPr>
+        </p:nvSpPr>
+        <p:spPr/>
+      </p:sp>
+      <p:sp>
+        <p:nvSpPr>
+          <p:cNvPr id="3" name="Notes Placeholder 2"/>
+          <p:cNvSpPr>
+            <a:spLocks noGrp="1"/>
+          </p:cNvSpPr>
+          <p:nvPr>
+            <p:ph type="body" idx="3" sz="quarter"/>
+          </p:nvPr>
+        </p:nvSpPr>
+        <p:spPr/>
+        <p:txBody>
+          <a:bodyPr/>
+          <a:lstStyle/>
+          <a:p>
+            <a:r>
+              <a:t>~50 seconds</a:t>
+            </a:r>
+          </a:p>
+          <a:p/>
+          <a:p>
+            <a:r>
+              <a:t>The chat is not just a single prompt — it uses a real tool-calling agent. I built seven LangChain StructuredTools: search YouTube, extract transcript, chunk, store vectors, full ingest, retrieve context, and answer question.</a:t>
+            </a:r>
+          </a:p>
+          <a:p/>
+          <a:p>
+            <a:r>
+              <a:t>The agent decides which tools to call based on the question. For a chat question it calls retrieve_context then answer_question. For a new video request it chains through the full ingestion flow automatically.</a:t>
+            </a:r>
+          </a:p>
+          <a:p/>
+          <a:p>
+            <a:r>
+              <a:t>Two guardrails are enforced: answers must come from the transcript only, and off-topic questions must be refused. ConversationMemoryService keeps session history so follow-up questions stay coherent.</a:t>
+            </a:r>
+          </a:p>
+        </p:txBody>
+      </p:sp>
+      <p:sp>
+        <p:nvSpPr>
+          <p:cNvPr id="4" name="Slide Number Placeholder 3"/>
+          <p:cNvSpPr>
+            <a:spLocks noGrp="1"/>
+          </p:cNvSpPr>
+          <p:nvPr>
+            <p:ph type="sldNum" idx="5" sz="quarter"/>
+          </p:nvPr>
+        </p:nvSpPr>
+        <p:spPr/>
+      </p:sp>
+    </p:spTree>
+  </p:cSld>
+  <p:clrMapOvr>
+    <a:masterClrMapping/>
+  </p:clrMapOvr>
+</p:notes>
+</file>
+
+<file path=ppt/notesSlides/notesSlide7.xml><?xml version="1.0" encoding="utf-8"?>
+<p:notes xmlns:a="http://schemas.openxmlformats.org/drawingml/2006/main" xmlns:p="http://schemas.openxmlformats.org/presentationml/2006/main" xmlns:r="http://schemas.openxmlformats.org/officeDocument/2006/relationships">
+  <p:cSld>
+    <p:spTree>
+      <p:nvGrpSpPr>
+        <p:cNvPr id="1" name=""/>
+        <p:cNvGrpSpPr/>
+        <p:nvPr/>
+      </p:nvGrpSpPr>
+      <p:grpSpPr>
+        <a:xfrm>
+          <a:off x="0" y="0"/>
+          <a:ext cx="0" cy="0"/>
+          <a:chOff x="0" y="0"/>
+          <a:chExt cx="0" cy="0"/>
+        </a:xfrm>
+      </p:grpSpPr>
+      <p:sp>
+        <p:nvSpPr>
+          <p:cNvPr id="2" name="Slide Image Placeholder 1"/>
+          <p:cNvSpPr>
+            <a:spLocks noGrp="1"/>
+          </p:cNvSpPr>
+          <p:nvPr>
+            <p:ph type="sldImg" idx="2"/>
+          </p:nvPr>
+        </p:nvSpPr>
+        <p:spPr/>
+      </p:sp>
+      <p:sp>
+        <p:nvSpPr>
+          <p:cNvPr id="3" name="Notes Placeholder 2"/>
+          <p:cNvSpPr>
+            <a:spLocks noGrp="1"/>
+          </p:cNvSpPr>
+          <p:nvPr>
+            <p:ph type="body" idx="3" sz="quarter"/>
+          </p:nvPr>
+        </p:nvSpPr>
+        <p:spPr/>
+        <p:txBody>
+          <a:bodyPr/>
+          <a:lstStyle/>
+          <a:p>
+            <a:r>
+              <a:t>~45 seconds</a:t>
+            </a:r>
+          </a:p>
+          <a:p/>
+          <a:p>
+            <a:r>
+              <a:t>The RAG pipeline is four steps. Retrieve: ChromaDB finds the most relevant transcript chunks by semantic similarity. Inject: the prompt receives those chunks, the conversation memory, and strict grounding rules. Generate: GPT-4o-mini writes an answer using only what is in the context. Cite: the response includes timestamp chips that link to the exact moment in the video.</a:t>
+            </a:r>
+          </a:p>
+          <a:p/>
+          <a:p>
+            <a:r>
+              <a:t>If the answer is not in the transcript, the system says it cannot answer from this video. That refusal is the core anti-hallucination mechanism.</a:t>
+            </a:r>
+          </a:p>
+        </p:txBody>
+      </p:sp>
+      <p:sp>
+        <p:nvSpPr>
+          <p:cNvPr id="4" name="Slide Number Placeholder 3"/>
+          <p:cNvSpPr>
+            <a:spLocks noGrp="1"/>
+          </p:cNvSpPr>
+          <p:nvPr>
+            <p:ph type="sldNum" idx="5" sz="quarter"/>
+          </p:nvPr>
+        </p:nvSpPr>
+        <p:spPr/>
+      </p:sp>
+    </p:spTree>
+  </p:cSld>
+  <p:clrMapOvr>
+    <a:masterClrMapping/>
+  </p:clrMapOvr>
+</p:notes>
+</file>
+
+<file path=ppt/notesSlides/notesSlide8.xml><?xml version="1.0" encoding="utf-8"?>
+<p:notes xmlns:a="http://schemas.openxmlformats.org/drawingml/2006/main" xmlns:p="http://schemas.openxmlformats.org/presentationml/2006/main" xmlns:r="http://schemas.openxmlformats.org/officeDocument/2006/relationships">
+  <p:cSld>
+    <p:spTree>
+      <p:nvGrpSpPr>
+        <p:cNvPr id="1" name=""/>
+        <p:cNvGrpSpPr/>
+        <p:nvPr/>
+      </p:nvGrpSpPr>
+      <p:grpSpPr>
+        <a:xfrm>
+          <a:off x="0" y="0"/>
+          <a:ext cx="0" cy="0"/>
+          <a:chOff x="0" y="0"/>
+          <a:chExt cx="0" cy="0"/>
+        </a:xfrm>
+      </p:grpSpPr>
+      <p:sp>
+        <p:nvSpPr>
+          <p:cNvPr id="2" name="Slide Image Placeholder 1"/>
+          <p:cNvSpPr>
+            <a:spLocks noGrp="1"/>
+          </p:cNvSpPr>
+          <p:nvPr>
+            <p:ph type="sldImg" idx="2"/>
+          </p:nvPr>
+        </p:nvSpPr>
+        <p:spPr/>
+      </p:sp>
+      <p:sp>
+        <p:nvSpPr>
+          <p:cNvPr id="3" name="Notes Placeholder 2"/>
+          <p:cNvSpPr>
+            <a:spLocks noGrp="1"/>
+          </p:cNvSpPr>
+          <p:nvPr>
+            <p:ph type="body" idx="3" sz="quarter"/>
+          </p:nvPr>
+        </p:nvSpPr>
+        <p:spPr/>
+        <p:txBody>
+          <a:bodyPr/>
+          <a:lstStyle/>
+          <a:p>
+            <a:r>
+              <a:t>~30 seconds</a:t>
+            </a:r>
+          </a:p>
+          <a:p/>
+          <a:p>
+            <a:r>
+              <a:t>The UI is designed to feel like a real product. Voice search tries the browser Web Speech API first, and automatically falls back to MediaRecorder plus Whisper if it fails. The 3D robot moves through the journey stages and speaks short guidance at each step. Accessibility is built in: semantic labels, visible focus states, reduced-motion support, and screen-reader status messages.</a:t>
+            </a:r>
+          </a:p>
+        </p:txBody>
+      </p:sp>
+      <p:sp>
+        <p:nvSpPr>
+          <p:cNvPr id="4" name="Slide Number Placeholder 3"/>
+          <p:cNvSpPr>
+            <a:spLocks noGrp="1"/>
+          </p:cNvSpPr>
+          <p:nvPr>
+            <p:ph type="sldNum" idx="5" sz="quarter"/>
+          </p:nvPr>
+        </p:nvSpPr>
+        <p:spPr/>
+      </p:sp>
+    </p:spTree>
+  </p:cSld>
+  <p:clrMapOvr>
+    <a:masterClrMapping/>
+  </p:clrMapOvr>
+</p:notes>
+</file>
+
+<file path=ppt/notesSlides/notesSlide9.xml><?xml version="1.0" encoding="utf-8"?>
+<p:notes xmlns:a="http://schemas.openxmlformats.org/drawingml/2006/main" xmlns:p="http://schemas.openxmlformats.org/presentationml/2006/main" xmlns:r="http://schemas.openxmlformats.org/officeDocument/2006/relationships">
+  <p:cSld>
+    <p:spTree>
+      <p:nvGrpSpPr>
+        <p:cNvPr id="1" name=""/>
+        <p:cNvGrpSpPr/>
+        <p:nvPr/>
+      </p:nvGrpSpPr>
+      <p:grpSpPr>
+        <a:xfrm>
+          <a:off x="0" y="0"/>
+          <a:ext cx="0" cy="0"/>
+          <a:chOff x="0" y="0"/>
+          <a:chExt cx="0" cy="0"/>
+        </a:xfrm>
+      </p:grpSpPr>
+      <p:sp>
+        <p:nvSpPr>
+          <p:cNvPr id="2" name="Slide Image Placeholder 1"/>
+          <p:cNvSpPr>
+            <a:spLocks noGrp="1"/>
+          </p:cNvSpPr>
+          <p:nvPr>
+            <p:ph type="sldImg" idx="2"/>
+          </p:nvPr>
+        </p:nvSpPr>
+        <p:spPr/>
+      </p:sp>
+      <p:sp>
+        <p:nvSpPr>
+          <p:cNvPr id="3" name="Notes Placeholder 2"/>
+          <p:cNvSpPr>
+            <a:spLocks noGrp="1"/>
+          </p:cNvSpPr>
+          <p:nvPr>
+            <p:ph type="body" idx="3" sz="quarter"/>
+          </p:nvPr>
+        </p:nvSpPr>
+        <p:spPr/>
+        <p:txBody>
+          <a:bodyPr/>
+          <a:lstStyle/>
+          <a:p>
+            <a:r>
+              <a:t>~35 seconds</a:t>
+            </a:r>
+          </a:p>
+          <a:p/>
+          <a:p>
+            <a:r>
+              <a:t>The project has 98 pytest tests covering routes, services, tools, WebSocket ingest, speech, and the RAG pipeline. I also built 17 hand-crafted RAG evaluation cases that test answerable questions, refusals, citation accuracy, summaries, memory, and hallucination prevention — all pass with zero behavioral failures. LangSmith tracing is available for live chain inspection, and the inline heuristic evaluator scores every RAG response at inference time.</a:t>
+            </a:r>
+          </a:p>
+        </p:txBody>
+      </p:sp>
+      <p:sp>
+        <p:nvSpPr>
+          <p:cNvPr id="4" name="Slide Number Placeholder 3"/>
+          <p:cNvSpPr>
+            <a:spLocks noGrp="1"/>
+          </p:cNvSpPr>
+          <p:nvPr>
+            <p:ph type="sldNum" idx="5" sz="quarter"/>
+          </p:nvPr>
+        </p:nvSpPr>
+        <p:spPr/>
+      </p:sp>
+    </p:spTree>
+  </p:cSld>
+  <p:clrMapOvr>
+    <a:masterClrMapping/>
+  </p:clrMapOvr>
+</p:notes>
 </file>
 
 <file path=ppt/slideLayouts/slideLayout1.xml><?xml version="1.0" encoding="utf-8"?>
@@ -12492,4 +13744,324 @@
   </a:objectDefaults>
   <a:extraClrSchemeLst/>
 </a:theme>
+</file>
+
+<file path=ppt/theme/theme2.xml><?xml version="1.0" encoding="utf-8"?>
+<a:theme xmlns:a="http://schemas.openxmlformats.org/drawingml/2006/main" name="Office Theme">
+  <a:themeElements>
+    <a:clrScheme name="Office">
+      <a:dk1>
+        <a:sysClr val="windowText" lastClr="000000"/>
+      </a:dk1>
+      <a:lt1>
+        <a:sysClr val="window" lastClr="FFFFFF"/>
+      </a:lt1>
+      <a:dk2>
+        <a:srgbClr val="1F497D"/>
+      </a:dk2>
+      <a:lt2>
+        <a:srgbClr val="EEECE1"/>
+      </a:lt2>
+      <a:accent1>
+        <a:srgbClr val="4F81BD"/>
+      </a:accent1>
+      <a:accent2>
+        <a:srgbClr val="C0504D"/>
+      </a:accent2>
+      <a:accent3>
+        <a:srgbClr val="9BBB59"/>
+      </a:accent3>
+      <a:accent4>
+        <a:srgbClr val="8064A2"/>
+      </a:accent4>
+      <a:accent5>
+        <a:srgbClr val="4BACC6"/>
+      </a:accent5>
+      <a:accent6>
+        <a:srgbClr val="F79646"/>
+      </a:accent6>
+      <a:hlink>
+        <a:srgbClr val="0000FF"/>
+      </a:hlink>
+      <a:folHlink>
+        <a:srgbClr val="800080"/>
+      </a:folHlink>
+    </a:clrScheme>
+    <a:fontScheme name="Office">
+      <a:majorFont>
+        <a:latin typeface="Calibri"/>
+        <a:ea typeface=""/>
+        <a:cs typeface=""/>
+        <a:font script="Jpan" typeface="ＭＳ Ｐゴシック"/>
+        <a:font script="Hang" typeface="맑은 고딕"/>
+        <a:font script="Hans" typeface="宋体"/>
+        <a:font script="Hant" typeface="新細明體"/>
+        <a:font script="Arab" typeface="Times New Roman"/>
+        <a:font script="Hebr" typeface="Times New Roman"/>
+        <a:font script="Thai" typeface="Angsana New"/>
+        <a:font script="Ethi" typeface="Nyala"/>
+        <a:font script="Beng" typeface="Vrinda"/>
+        <a:font script="Gujr" typeface="Shruti"/>
+        <a:font script="Khmr" typeface="MoolBoran"/>
+        <a:font script="Knda" typeface="Tunga"/>
+        <a:font script="Guru" typeface="Raavi"/>
+        <a:font script="Cans" typeface="Euphemia"/>
+        <a:font script="Cher" typeface="Plantagenet Cherokee"/>
+        <a:font script="Yiii" typeface="Microsoft Yi Baiti"/>
+        <a:font script="Tibt" typeface="Microsoft Himalaya"/>
+        <a:font script="Thaa" typeface="MV Boli"/>
+        <a:font script="Deva" typeface="Mangal"/>
+        <a:font script="Telu" typeface="Gautami"/>
+        <a:font script="Taml" typeface="Latha"/>
+        <a:font script="Syrc" typeface="Estrangelo Edessa"/>
+        <a:font script="Orya" typeface="Kalinga"/>
+        <a:font script="Mlym" typeface="Kartika"/>
+        <a:font script="Laoo" typeface="DokChampa"/>
+        <a:font script="Sinh" typeface="Iskoola Pota"/>
+        <a:font script="Mong" typeface="Mongolian Baiti"/>
+        <a:font script="Viet" typeface="Times New Roman"/>
+        <a:font script="Uigh" typeface="Microsoft Uighur"/>
+        <a:font script="Geor" typeface="Sylfaen"/>
+      </a:majorFont>
+      <a:minorFont>
+        <a:latin typeface="Calibri"/>
+        <a:ea typeface=""/>
+        <a:cs typeface=""/>
+        <a:font script="Jpan" typeface="ＭＳ Ｐゴシック"/>
+        <a:font script="Hang" typeface="맑은 고딕"/>
+        <a:font script="Hans" typeface="宋体"/>
+        <a:font script="Hant" typeface="新細明體"/>
+        <a:font script="Arab" typeface="Arial"/>
+        <a:font script="Hebr" typeface="Arial"/>
+        <a:font script="Thai" typeface="Cordia New"/>
+        <a:font script="Ethi" typeface="Nyala"/>
+        <a:font script="Beng" typeface="Vrinda"/>
+        <a:font script="Gujr" typeface="Shruti"/>
+        <a:font script="Khmr" typeface="DaunPenh"/>
+        <a:font script="Knda" typeface="Tunga"/>
+        <a:font script="Guru" typeface="Raavi"/>
+        <a:font script="Cans" typeface="Euphemia"/>
+        <a:font script="Cher" typeface="Plantagenet Cherokee"/>
+        <a:font script="Yiii" typeface="Microsoft Yi Baiti"/>
+        <a:font script="Tibt" typeface="Microsoft Himalaya"/>
+        <a:font script="Thaa" typeface="MV Boli"/>
+        <a:font script="Deva" typeface="Mangal"/>
+        <a:font script="Telu" typeface="Gautami"/>
+        <a:font script="Taml" typeface="Latha"/>
+        <a:font script="Syrc" typeface="Estrangelo Edessa"/>
+        <a:font script="Orya" typeface="Kalinga"/>
+        <a:font script="Mlym" typeface="Kartika"/>
+        <a:font script="Laoo" typeface="DokChampa"/>
+        <a:font script="Sinh" typeface="Iskoola Pota"/>
+        <a:font script="Mong" typeface="Mongolian Baiti"/>
+        <a:font script="Viet" typeface="Arial"/>
+        <a:font script="Uigh" typeface="Microsoft Uighur"/>
+        <a:font script="Geor" typeface="Sylfaen"/>
+      </a:minorFont>
+    </a:fontScheme>
+    <a:fmtScheme name="Office">
+      <a:fillStyleLst>
+        <a:solidFill>
+          <a:schemeClr val="phClr"/>
+        </a:solidFill>
+        <a:gradFill rotWithShape="1">
+          <a:gsLst>
+            <a:gs pos="0">
+              <a:schemeClr val="phClr">
+                <a:tint val="50000"/>
+                <a:satMod val="300000"/>
+              </a:schemeClr>
+            </a:gs>
+            <a:gs pos="35000">
+              <a:schemeClr val="phClr">
+                <a:tint val="37000"/>
+                <a:satMod val="300000"/>
+              </a:schemeClr>
+            </a:gs>
+            <a:gs pos="100000">
+              <a:schemeClr val="phClr">
+                <a:tint val="15000"/>
+                <a:satMod val="350000"/>
+              </a:schemeClr>
+            </a:gs>
+          </a:gsLst>
+          <a:lin ang="16200000" scaled="1"/>
+        </a:gradFill>
+        <a:gradFill rotWithShape="1">
+          <a:gsLst>
+            <a:gs pos="0">
+              <a:schemeClr val="phClr">
+                <a:tint val="100000"/>
+                <a:shade val="100000"/>
+                <a:satMod val="130000"/>
+              </a:schemeClr>
+            </a:gs>
+            <a:gs pos="100000">
+              <a:schemeClr val="phClr">
+                <a:tint val="50000"/>
+                <a:shade val="100000"/>
+                <a:satMod val="350000"/>
+              </a:schemeClr>
+            </a:gs>
+          </a:gsLst>
+          <a:lin ang="16200000" scaled="0"/>
+        </a:gradFill>
+      </a:fillStyleLst>
+      <a:lnStyleLst>
+        <a:ln w="9525" cap="flat" cmpd="sng" algn="ctr">
+          <a:solidFill>
+            <a:schemeClr val="phClr">
+              <a:shade val="95000"/>
+              <a:satMod val="105000"/>
+            </a:schemeClr>
+          </a:solidFill>
+          <a:prstDash val="solid"/>
+        </a:ln>
+        <a:ln w="25400" cap="flat" cmpd="sng" algn="ctr">
+          <a:solidFill>
+            <a:schemeClr val="phClr"/>
+          </a:solidFill>
+          <a:prstDash val="solid"/>
+        </a:ln>
+        <a:ln w="38100" cap="flat" cmpd="sng" algn="ctr">
+          <a:solidFill>
+            <a:schemeClr val="phClr"/>
+          </a:solidFill>
+          <a:prstDash val="solid"/>
+        </a:ln>
+      </a:lnStyleLst>
+      <a:effectStyleLst>
+        <a:effectStyle>
+          <a:effectLst>
+            <a:outerShdw blurRad="40000" dist="20000" dir="5400000" rotWithShape="0">
+              <a:srgbClr val="000000">
+                <a:alpha val="38000"/>
+              </a:srgbClr>
+            </a:outerShdw>
+          </a:effectLst>
+        </a:effectStyle>
+        <a:effectStyle>
+          <a:effectLst>
+            <a:outerShdw blurRad="40000" dist="23000" dir="5400000" rotWithShape="0">
+              <a:srgbClr val="000000">
+                <a:alpha val="35000"/>
+              </a:srgbClr>
+            </a:outerShdw>
+          </a:effectLst>
+        </a:effectStyle>
+        <a:effectStyle>
+          <a:effectLst>
+            <a:outerShdw blurRad="40000" dist="23000" dir="5400000" rotWithShape="0">
+              <a:srgbClr val="000000">
+                <a:alpha val="35000"/>
+              </a:srgbClr>
+            </a:outerShdw>
+          </a:effectLst>
+          <a:scene3d>
+            <a:camera prst="orthographicFront">
+              <a:rot lat="0" lon="0" rev="0"/>
+            </a:camera>
+            <a:lightRig rig="threePt" dir="t">
+              <a:rot lat="0" lon="0" rev="1200000"/>
+            </a:lightRig>
+          </a:scene3d>
+          <a:sp3d>
+            <a:bevelT w="63500" h="25400"/>
+          </a:sp3d>
+        </a:effectStyle>
+      </a:effectStyleLst>
+      <a:bgFillStyleLst>
+        <a:solidFill>
+          <a:schemeClr val="phClr"/>
+        </a:solidFill>
+        <a:gradFill rotWithShape="1">
+          <a:gsLst>
+            <a:gs pos="0">
+              <a:schemeClr val="phClr">
+                <a:tint val="40000"/>
+                <a:satMod val="350000"/>
+              </a:schemeClr>
+            </a:gs>
+            <a:gs pos="40000">
+              <a:schemeClr val="phClr">
+                <a:tint val="45000"/>
+                <a:shade val="99000"/>
+                <a:satMod val="350000"/>
+              </a:schemeClr>
+            </a:gs>
+            <a:gs pos="100000">
+              <a:schemeClr val="phClr">
+                <a:shade val="20000"/>
+                <a:satMod val="255000"/>
+              </a:schemeClr>
+            </a:gs>
+          </a:gsLst>
+          <a:path path="circle">
+            <a:fillToRect l="50000" t="-80000" r="50000" b="180000"/>
+          </a:path>
+        </a:gradFill>
+        <a:gradFill rotWithShape="1">
+          <a:gsLst>
+            <a:gs pos="0">
+              <a:schemeClr val="phClr">
+                <a:tint val="80000"/>
+                <a:satMod val="300000"/>
+              </a:schemeClr>
+            </a:gs>
+            <a:gs pos="100000">
+              <a:schemeClr val="phClr">
+                <a:shade val="30000"/>
+                <a:satMod val="200000"/>
+              </a:schemeClr>
+            </a:gs>
+          </a:gsLst>
+          <a:path path="circle">
+            <a:fillToRect l="50000" t="50000" r="50000" b="50000"/>
+          </a:path>
+        </a:gradFill>
+      </a:bgFillStyleLst>
+    </a:fmtScheme>
+  </a:themeElements>
+  <a:objectDefaults>
+    <a:spDef>
+      <a:spPr/>
+      <a:bodyPr/>
+      <a:lstStyle/>
+      <a:style>
+        <a:lnRef idx="1">
+          <a:schemeClr val="accent1"/>
+        </a:lnRef>
+        <a:fillRef idx="3">
+          <a:schemeClr val="accent1"/>
+        </a:fillRef>
+        <a:effectRef idx="2">
+          <a:schemeClr val="accent1"/>
+        </a:effectRef>
+        <a:fontRef idx="minor">
+          <a:schemeClr val="lt1"/>
+        </a:fontRef>
+      </a:style>
+    </a:spDef>
+    <a:lnDef>
+      <a:spPr/>
+      <a:bodyPr/>
+      <a:lstStyle/>
+      <a:style>
+        <a:lnRef idx="2">
+          <a:schemeClr val="accent1"/>
+        </a:lnRef>
+        <a:fillRef idx="0">
+          <a:schemeClr val="accent1"/>
+        </a:fillRef>
+        <a:effectRef idx="1">
+          <a:schemeClr val="accent1"/>
+        </a:effectRef>
+        <a:fontRef idx="minor">
+          <a:schemeClr val="tx1"/>
+        </a:fontRef>
+      </a:style>
+    </a:lnDef>
+  </a:objectDefaults>
+  <a:extraClrSchemeLst/>
+</a:theme>
 </file>
</xml_diff>

<commit_message>
docs: updated presentation with speaker notes and PDF export
</commit_message>
<xml_diff>
--- a/docs/AskTube_AI_Presentation.pptx
+++ b/docs/AskTube_AI_Presentation.pptx
@@ -4,20 +4,23 @@
   <p:sldMasterIdLst>
     <p:sldMasterId id="2147483648" r:id="rId1"/>
   </p:sldMasterIdLst>
+  <p:notesMasterIdLst>
+    <p:notesMasterId r:id="rId13"/>
+  </p:notesMasterIdLst>
   <p:sldIdLst>
-    <p:sldId id="256" r:id="rId7"/>
-    <p:sldId id="257" r:id="rId9"/>
-    <p:sldId id="258" r:id="rId10"/>
-    <p:sldId id="259" r:id="rId11"/>
-    <p:sldId id="260" r:id="rId12"/>
-    <p:sldId id="261" r:id="rId13"/>
-    <p:sldId id="262" r:id="rId14"/>
-    <p:sldId id="263" r:id="rId15"/>
-    <p:sldId id="264" r:id="rId16"/>
-    <p:sldId id="265" r:id="rId17"/>
-    <p:sldId id="266" r:id="rId18"/>
+    <p:sldId id="256" r:id="rId2"/>
+    <p:sldId id="257" r:id="rId3"/>
+    <p:sldId id="258" r:id="rId4"/>
+    <p:sldId id="259" r:id="rId5"/>
+    <p:sldId id="260" r:id="rId6"/>
+    <p:sldId id="261" r:id="rId7"/>
+    <p:sldId id="262" r:id="rId8"/>
+    <p:sldId id="263" r:id="rId9"/>
+    <p:sldId id="264" r:id="rId10"/>
+    <p:sldId id="265" r:id="rId11"/>
+    <p:sldId id="266" r:id="rId12"/>
   </p:sldIdLst>
-  <p:sldSz cx="12191695" cy="6858000" type="screen4x3"/>
+  <p:sldSz cx="12192000" cy="6858000"/>
   <p:notesSz cx="6858000" cy="9144000"/>
   <p:defaultTextStyle>
     <a:defPPr>
@@ -114,11 +117,27 @@
       </a:defRPr>
     </a:lvl9pPr>
   </p:defaultTextStyle>
+  <p:extLst>
+    <p:ext uri="{EFAFB233-063F-42B5-8137-9DF3F51BA10A}">
+      <p15:sldGuideLst xmlns:p15="http://schemas.microsoft.com/office/powerpoint/2012/main">
+        <p15:guide id="1" orient="horz" pos="2160">
+          <p15:clr>
+            <a:srgbClr val="A4A3A4"/>
+          </p15:clr>
+        </p15:guide>
+        <p15:guide id="2" pos="2880">
+          <p15:clr>
+            <a:srgbClr val="A4A3A4"/>
+          </p15:clr>
+        </p15:guide>
+      </p15:sldGuideLst>
+    </p:ext>
+  </p:extLst>
 </p:presentation>
 </file>
 
 <file path=ppt/notesMasters/notesMaster1.xml><?xml version="1.0" encoding="utf-8"?>
-<p:notesMaster xmlns:a="http://schemas.openxmlformats.org/drawingml/2006/main" xmlns:p="http://schemas.openxmlformats.org/presentationml/2006/main" xmlns:r="http://schemas.openxmlformats.org/officeDocument/2006/relationships">
+<p:notesMaster xmlns:a="http://schemas.openxmlformats.org/drawingml/2006/main" xmlns:r="http://schemas.openxmlformats.org/officeDocument/2006/relationships" xmlns:p="http://schemas.openxmlformats.org/presentationml/2006/main">
   <p:cSld>
     <p:bg>
       <p:bgRef idx="1001">
@@ -139,241 +158,16 @@
           <a:chExt cx="0" cy="0"/>
         </a:xfrm>
       </p:grpSpPr>
-      <p:sp>
-        <p:nvSpPr>
-          <p:cNvPr id="2" name="Header Placeholder 1"/>
-          <p:cNvSpPr>
-            <a:spLocks noGrp="1"/>
-          </p:cNvSpPr>
-          <p:nvPr>
-            <p:ph type="hdr" sz="quarter"/>
-          </p:nvPr>
-        </p:nvSpPr>
-        <p:spPr>
-          <a:xfrm>
-            <a:off x="0" y="0"/>
-            <a:ext cx="2971800" cy="457200"/>
-          </a:xfrm>
-          <a:prstGeom prst="rect">
-            <a:avLst/>
-          </a:prstGeom>
-        </p:spPr>
-        <p:txBody>
-          <a:bodyPr vert="horz" lIns="91440" tIns="45720" rIns="91440" bIns="45720" rtlCol="0"/>
-          <a:lstStyle>
-            <a:lvl1pPr algn="l">
-              <a:defRPr sz="1200"/>
-            </a:lvl1pPr>
-          </a:lstStyle>
-          <a:p>
-            <a:endParaRPr lang="en-US"/>
-          </a:p>
-        </p:txBody>
-      </p:sp>
-      <p:sp>
-        <p:nvSpPr>
-          <p:cNvPr id="3" name="Date Placeholder 2"/>
-          <p:cNvSpPr>
-            <a:spLocks noGrp="1"/>
-          </p:cNvSpPr>
-          <p:nvPr>
-            <p:ph type="dt" idx="1"/>
-          </p:nvPr>
-        </p:nvSpPr>
-        <p:spPr>
-          <a:xfrm>
-            <a:off x="3884613" y="0"/>
-            <a:ext cx="2971800" cy="457200"/>
-          </a:xfrm>
-          <a:prstGeom prst="rect">
-            <a:avLst/>
-          </a:prstGeom>
-        </p:spPr>
-        <p:txBody>
-          <a:bodyPr vert="horz" lIns="91440" tIns="45720" rIns="91440" bIns="45720" rtlCol="0"/>
-          <a:lstStyle>
-            <a:lvl1pPr algn="r">
-              <a:defRPr sz="1200"/>
-            </a:lvl1pPr>
-          </a:lstStyle>
-          <a:p>
-            <a:fld id="{0F89C1C7-3DCD-1040-A9CF-14679D8B5DDD}" type="datetimeFigureOut">
-              <a:rPr lang="en-US" smtClean="0"/>
-              <a:t>10/17/16</a:t>
-            </a:fld>
-            <a:endParaRPr lang="en-US"/>
-          </a:p>
-        </p:txBody>
-      </p:sp>
-      <p:sp>
-        <p:nvSpPr>
-          <p:cNvPr id="4" name="Slide Image Placeholder 3"/>
-          <p:cNvSpPr>
-            <a:spLocks noGrp="1" noRot="1" noChangeAspect="1"/>
-          </p:cNvSpPr>
-          <p:nvPr>
-            <p:ph type="sldImg" idx="2"/>
-          </p:nvPr>
-        </p:nvSpPr>
-        <p:spPr>
-          <a:xfrm>
-            <a:off x="1143000" y="685800"/>
-            <a:ext cx="4572000" cy="3429000"/>
-          </a:xfrm>
-          <a:prstGeom prst="rect">
-            <a:avLst/>
-          </a:prstGeom>
-          <a:noFill/>
-          <a:ln w="12700">
-            <a:solidFill>
-              <a:prstClr val="black"/>
-            </a:solidFill>
-          </a:ln>
-        </p:spPr>
-        <p:txBody>
-          <a:bodyPr vert="horz" lIns="91440" tIns="45720" rIns="91440" bIns="45720" rtlCol="0" anchor="ctr"/>
-          <a:lstStyle/>
-          <a:p>
-            <a:endParaRPr lang="en-US"/>
-          </a:p>
-        </p:txBody>
-      </p:sp>
-      <p:sp>
-        <p:nvSpPr>
-          <p:cNvPr id="5" name="Notes Placeholder 4"/>
-          <p:cNvSpPr>
-            <a:spLocks noGrp="1"/>
-          </p:cNvSpPr>
-          <p:nvPr>
-            <p:ph type="body" sz="quarter" idx="3"/>
-          </p:nvPr>
-        </p:nvSpPr>
-        <p:spPr>
-          <a:xfrm>
-            <a:off x="685800" y="4343400"/>
-            <a:ext cx="5486400" cy="4114800"/>
-          </a:xfrm>
-          <a:prstGeom prst="rect">
-            <a:avLst/>
-          </a:prstGeom>
-        </p:spPr>
-        <p:txBody>
-          <a:bodyPr vert="horz" lIns="91440" tIns="45720" rIns="91440" bIns="45720" rtlCol="0"/>
-          <a:lstStyle/>
-          <a:p>
-            <a:pPr lvl="0"/>
-            <a:r>
-              <a:rPr lang="en-US" smtClean="0"/>
-              <a:t>Click to edit Master text styles</a:t>
-            </a:r>
-          </a:p>
-          <a:p>
-            <a:pPr lvl="1"/>
-            <a:r>
-              <a:rPr lang="en-US" smtClean="0"/>
-              <a:t>Second level</a:t>
-            </a:r>
-          </a:p>
-          <a:p>
-            <a:pPr lvl="2"/>
-            <a:r>
-              <a:rPr lang="en-US" smtClean="0"/>
-              <a:t>Third level</a:t>
-            </a:r>
-          </a:p>
-          <a:p>
-            <a:pPr lvl="3"/>
-            <a:r>
-              <a:rPr lang="en-US" smtClean="0"/>
-              <a:t>Fourth level</a:t>
-            </a:r>
-          </a:p>
-          <a:p>
-            <a:pPr lvl="4"/>
-            <a:r>
-              <a:rPr lang="en-US" smtClean="0"/>
-              <a:t>Fifth level</a:t>
-            </a:r>
-            <a:endParaRPr lang="en-US"/>
-          </a:p>
-        </p:txBody>
-      </p:sp>
-      <p:sp>
-        <p:nvSpPr>
-          <p:cNvPr id="6" name="Footer Placeholder 5"/>
-          <p:cNvSpPr>
-            <a:spLocks noGrp="1"/>
-          </p:cNvSpPr>
-          <p:nvPr>
-            <p:ph type="ftr" sz="quarter" idx="4"/>
-          </p:nvPr>
-        </p:nvSpPr>
-        <p:spPr>
-          <a:xfrm>
-            <a:off x="0" y="8685213"/>
-            <a:ext cx="2971800" cy="457200"/>
-          </a:xfrm>
-          <a:prstGeom prst="rect">
-            <a:avLst/>
-          </a:prstGeom>
-        </p:spPr>
-        <p:txBody>
-          <a:bodyPr vert="horz" lIns="91440" tIns="45720" rIns="91440" bIns="45720" rtlCol="0" anchor="b"/>
-          <a:lstStyle>
-            <a:lvl1pPr algn="l">
-              <a:defRPr sz="1200"/>
-            </a:lvl1pPr>
-          </a:lstStyle>
-          <a:p>
-            <a:endParaRPr lang="en-US"/>
-          </a:p>
-        </p:txBody>
-      </p:sp>
-      <p:sp>
-        <p:nvSpPr>
-          <p:cNvPr id="7" name="Slide Number Placeholder 6"/>
-          <p:cNvSpPr>
-            <a:spLocks noGrp="1"/>
-          </p:cNvSpPr>
-          <p:nvPr>
-            <p:ph type="sldNum" sz="quarter" idx="5"/>
-          </p:nvPr>
-        </p:nvSpPr>
-        <p:spPr>
-          <a:xfrm>
-            <a:off x="3884613" y="8685213"/>
-            <a:ext cx="2971800" cy="457200"/>
-          </a:xfrm>
-          <a:prstGeom prst="rect">
-            <a:avLst/>
-          </a:prstGeom>
-        </p:spPr>
-        <p:txBody>
-          <a:bodyPr vert="horz" lIns="91440" tIns="45720" rIns="91440" bIns="45720" rtlCol="0" anchor="b"/>
-          <a:lstStyle>
-            <a:lvl1pPr algn="r">
-              <a:defRPr sz="1200"/>
-            </a:lvl1pPr>
-          </a:lstStyle>
-          <a:p>
-            <a:fld id="{BB5E49A5-4136-284D-997B-48E1D791AD67}" type="slidenum">
-              <a:rPr lang="en-US" smtClean="0"/>
-              <a:t>‹#›</a:t>
-            </a:fld>
-            <a:endParaRPr lang="en-US"/>
-          </a:p>
-        </p:txBody>
-      </p:sp>
     </p:spTree>
     <p:extLst>
       <p:ext uri="{BB962C8B-B14F-4D97-AF65-F5344CB8AC3E}">
-        <p14:creationId xmlns:p14="http://schemas.microsoft.com/office/powerpoint/2010/main" val="2623252185"/>
+        <p14:creationId xmlns:p14="http://schemas.microsoft.com/office/powerpoint/2010/main" val="975621374"/>
       </p:ext>
     </p:extLst>
   </p:cSld>
   <p:clrMap bg1="lt1" tx1="dk1" bg2="lt2" tx2="dk2" accent1="accent1" accent2="accent2" accent3="accent3" accent4="accent4" accent5="accent5" accent6="accent6" hlink="hlink" folHlink="folHlink"/>
   <p:notesStyle>
-    <a:lvl1pPr marL="0" algn="l" defTabSz="457200" rtl="0" eaLnBrk="1" latinLnBrk="0" hangingPunct="1">
+    <a:lvl1pPr marL="0" algn="l" defTabSz="914400" rtl="0" eaLnBrk="1" latinLnBrk="0" hangingPunct="1">
       <a:defRPr sz="1200" kern="1200">
         <a:solidFill>
           <a:schemeClr val="tx1"/>
@@ -383,7 +177,7 @@
         <a:cs typeface="+mn-cs"/>
       </a:defRPr>
     </a:lvl1pPr>
-    <a:lvl2pPr marL="457200" algn="l" defTabSz="457200" rtl="0" eaLnBrk="1" latinLnBrk="0" hangingPunct="1">
+    <a:lvl2pPr marL="457200" algn="l" defTabSz="914400" rtl="0" eaLnBrk="1" latinLnBrk="0" hangingPunct="1">
       <a:defRPr sz="1200" kern="1200">
         <a:solidFill>
           <a:schemeClr val="tx1"/>
@@ -393,7 +187,7 @@
         <a:cs typeface="+mn-cs"/>
       </a:defRPr>
     </a:lvl2pPr>
-    <a:lvl3pPr marL="914400" algn="l" defTabSz="457200" rtl="0" eaLnBrk="1" latinLnBrk="0" hangingPunct="1">
+    <a:lvl3pPr marL="914400" algn="l" defTabSz="914400" rtl="0" eaLnBrk="1" latinLnBrk="0" hangingPunct="1">
       <a:defRPr sz="1200" kern="1200">
         <a:solidFill>
           <a:schemeClr val="tx1"/>
@@ -403,7 +197,7 @@
         <a:cs typeface="+mn-cs"/>
       </a:defRPr>
     </a:lvl3pPr>
-    <a:lvl4pPr marL="1371600" algn="l" defTabSz="457200" rtl="0" eaLnBrk="1" latinLnBrk="0" hangingPunct="1">
+    <a:lvl4pPr marL="1371600" algn="l" defTabSz="914400" rtl="0" eaLnBrk="1" latinLnBrk="0" hangingPunct="1">
       <a:defRPr sz="1200" kern="1200">
         <a:solidFill>
           <a:schemeClr val="tx1"/>
@@ -413,7 +207,7 @@
         <a:cs typeface="+mn-cs"/>
       </a:defRPr>
     </a:lvl4pPr>
-    <a:lvl5pPr marL="1828800" algn="l" defTabSz="457200" rtl="0" eaLnBrk="1" latinLnBrk="0" hangingPunct="1">
+    <a:lvl5pPr marL="1828800" algn="l" defTabSz="914400" rtl="0" eaLnBrk="1" latinLnBrk="0" hangingPunct="1">
       <a:defRPr sz="1200" kern="1200">
         <a:solidFill>
           <a:schemeClr val="tx1"/>
@@ -423,7 +217,7 @@
         <a:cs typeface="+mn-cs"/>
       </a:defRPr>
     </a:lvl5pPr>
-    <a:lvl6pPr marL="2286000" algn="l" defTabSz="457200" rtl="0" eaLnBrk="1" latinLnBrk="0" hangingPunct="1">
+    <a:lvl6pPr marL="2286000" algn="l" defTabSz="914400" rtl="0" eaLnBrk="1" latinLnBrk="0" hangingPunct="1">
       <a:defRPr sz="1200" kern="1200">
         <a:solidFill>
           <a:schemeClr val="tx1"/>
@@ -433,7 +227,7 @@
         <a:cs typeface="+mn-cs"/>
       </a:defRPr>
     </a:lvl6pPr>
-    <a:lvl7pPr marL="2743200" algn="l" defTabSz="457200" rtl="0" eaLnBrk="1" latinLnBrk="0" hangingPunct="1">
+    <a:lvl7pPr marL="2743200" algn="l" defTabSz="914400" rtl="0" eaLnBrk="1" latinLnBrk="0" hangingPunct="1">
       <a:defRPr sz="1200" kern="1200">
         <a:solidFill>
           <a:schemeClr val="tx1"/>
@@ -443,7 +237,7 @@
         <a:cs typeface="+mn-cs"/>
       </a:defRPr>
     </a:lvl7pPr>
-    <a:lvl8pPr marL="3200400" algn="l" defTabSz="457200" rtl="0" eaLnBrk="1" latinLnBrk="0" hangingPunct="1">
+    <a:lvl8pPr marL="3200400" algn="l" defTabSz="914400" rtl="0" eaLnBrk="1" latinLnBrk="0" hangingPunct="1">
       <a:defRPr sz="1200" kern="1200">
         <a:solidFill>
           <a:schemeClr val="tx1"/>
@@ -453,7 +247,7 @@
         <a:cs typeface="+mn-cs"/>
       </a:defRPr>
     </a:lvl8pPr>
-    <a:lvl9pPr marL="3657600" algn="l" defTabSz="457200" rtl="0" eaLnBrk="1" latinLnBrk="0" hangingPunct="1">
+    <a:lvl9pPr marL="3657600" algn="l" defTabSz="914400" rtl="0" eaLnBrk="1" latinLnBrk="0" hangingPunct="1">
       <a:defRPr sz="1200" kern="1200">
         <a:solidFill>
           <a:schemeClr val="tx1"/>
@@ -468,7 +262,7 @@
 </file>
 
 <file path=ppt/notesSlides/notesSlide1.xml><?xml version="1.0" encoding="utf-8"?>
-<p:notes xmlns:a="http://schemas.openxmlformats.org/drawingml/2006/main" xmlns:p="http://schemas.openxmlformats.org/presentationml/2006/main" xmlns:r="http://schemas.openxmlformats.org/officeDocument/2006/relationships">
+<p:notes xmlns:a="http://schemas.openxmlformats.org/drawingml/2006/main" xmlns:r="http://schemas.openxmlformats.org/officeDocument/2006/relationships" xmlns:p="http://schemas.openxmlformats.org/presentationml/2006/main">
   <p:cSld>
     <p:spTree>
       <p:nvGrpSpPr>
@@ -488,7 +282,7 @@
         <p:nvSpPr>
           <p:cNvPr id="2" name="Slide Image Placeholder 1"/>
           <p:cNvSpPr>
-            <a:spLocks noGrp="1"/>
+            <a:spLocks noGrp="1" noRot="1" noChangeAspect="1"/>
           </p:cNvSpPr>
           <p:nvPr>
             <p:ph type="sldImg" idx="2"/>
@@ -503,7 +297,7 @@
             <a:spLocks noGrp="1"/>
           </p:cNvSpPr>
           <p:nvPr>
-            <p:ph type="body" idx="3" sz="quarter"/>
+            <p:ph type="body" sz="quarter" idx="3"/>
           </p:nvPr>
         </p:nvSpPr>
         <p:spPr/>
@@ -515,7 +309,9 @@
               <a:t>~20 seconds</a:t>
             </a:r>
           </a:p>
-          <a:p/>
+          <a:p>
+            <a:endParaRPr/>
+          </a:p>
           <a:p>
             <a:r>
               <a:t>Hi, I'm Sabeur. AskTube AI is an AI platform that lets you chat with any YouTube video using its transcript. It is not a generic chatbot — every answer is grounded in the video, with timestamp citations so you can verify exactly where the information comes from.</a:t>
@@ -530,7 +326,7 @@
             <a:spLocks noGrp="1"/>
           </p:cNvSpPr>
           <p:nvPr>
-            <p:ph type="sldNum" idx="5" sz="quarter"/>
+            <p:ph type="sldNum" sz="quarter" idx="5"/>
           </p:nvPr>
         </p:nvSpPr>
         <p:spPr/>
@@ -544,7 +340,7 @@
 </file>
 
 <file path=ppt/notesSlides/notesSlide10.xml><?xml version="1.0" encoding="utf-8"?>
-<p:notes xmlns:a="http://schemas.openxmlformats.org/drawingml/2006/main" xmlns:p="http://schemas.openxmlformats.org/presentationml/2006/main" xmlns:r="http://schemas.openxmlformats.org/officeDocument/2006/relationships">
+<p:notes xmlns:a="http://schemas.openxmlformats.org/drawingml/2006/main" xmlns:r="http://schemas.openxmlformats.org/officeDocument/2006/relationships" xmlns:p="http://schemas.openxmlformats.org/presentationml/2006/main">
   <p:cSld>
     <p:spTree>
       <p:nvGrpSpPr>
@@ -564,7 +360,7 @@
         <p:nvSpPr>
           <p:cNvPr id="2" name="Slide Image Placeholder 1"/>
           <p:cNvSpPr>
-            <a:spLocks noGrp="1"/>
+            <a:spLocks noGrp="1" noRot="1" noChangeAspect="1"/>
           </p:cNvSpPr>
           <p:nvPr>
             <p:ph type="sldImg" idx="2"/>
@@ -579,7 +375,7 @@
             <a:spLocks noGrp="1"/>
           </p:cNvSpPr>
           <p:nvPr>
-            <p:ph type="body" idx="3" sz="quarter"/>
+            <p:ph type="body" sz="quarter" idx="3"/>
           </p:nvPr>
         </p:nvSpPr>
         <p:spPr/>
@@ -588,36 +384,60 @@
           <a:lstStyle/>
           <a:p>
             <a:r>
+              <a:rPr dirty="0"/>
               <a:t>~90 seconds</a:t>
             </a:r>
           </a:p>
-          <a:p/>
-          <a:p>
-            <a:r>
-              <a:t>Let me show you the live app. Open http://18.157.233.122:3001/ — this is running on AWS EC2 with a Webshare residential proxy to bypass YouTube's cloud IP restrictions.</a:t>
-            </a:r>
-          </a:p>
-          <a:p/>
-          <a:p>
-            <a:r>
+          <a:p>
+            <a:endParaRPr dirty="0"/>
+          </a:p>
+          <a:p>
+            <a:r>
+              <a:rPr dirty="0"/>
+              <a:t>Let me show you the live app. Open http://18.157.233.122:3001/ — this is running on AWS EC2 with a </a:t>
+            </a:r>
+            <a:r>
+              <a:rPr dirty="0" err="1"/>
+              <a:t>Webshare</a:t>
+            </a:r>
+            <a:r>
+              <a:rPr dirty="0"/>
+              <a:t> residential proxy to bypass YouTube's cloud IP restrictions.</a:t>
+            </a:r>
+          </a:p>
+          <a:p>
+            <a:endParaRPr dirty="0"/>
+          </a:p>
+          <a:p>
+            <a:r>
+              <a:rPr dirty="0"/>
               <a:t>[Search] I'll type 'python tutorial for beginners' and apply a duration filter. [Results appear] Pick a video and click Prepare. [Watch the progress steps: metadata, transcript, chunking, embeddings, storage.]</a:t>
             </a:r>
           </a:p>
-          <a:p/>
-          <a:p>
-            <a:r>
+          <a:p>
+            <a:endParaRPr dirty="0"/>
+          </a:p>
+          <a:p>
+            <a:r>
+              <a:rPr dirty="0"/>
               <a:t>[Chat] Now I ask: 'What is Python used for?' — [Answer appears with timestamp chips] See the citations — each one links to the exact moment in the video. [Click a timestamp]</a:t>
             </a:r>
           </a:p>
-          <a:p/>
-          <a:p>
-            <a:r>
+          <a:p>
+            <a:endParaRPr dirty="0"/>
+          </a:p>
+          <a:p>
+            <a:r>
+              <a:rPr dirty="0"/>
               <a:t>[Follow-up] Now a follow-up: 'Can you give me an example?' — the memory keeps the context so it understands what I mean.</a:t>
             </a:r>
           </a:p>
-          <a:p/>
-          <a:p>
-            <a:r>
+          <a:p>
+            <a:endParaRPr dirty="0"/>
+          </a:p>
+          <a:p>
+            <a:r>
+              <a:rPr dirty="0"/>
               <a:t>[Refusal] Now I ask something off-topic like 'What is the weather today?' — it refuses. It only answers from the video transcript. That is the trust guarantee.</a:t>
             </a:r>
           </a:p>
@@ -630,7 +450,7 @@
             <a:spLocks noGrp="1"/>
           </p:cNvSpPr>
           <p:nvPr>
-            <p:ph type="sldNum" idx="5" sz="quarter"/>
+            <p:ph type="sldNum" sz="quarter" idx="5"/>
           </p:nvPr>
         </p:nvSpPr>
         <p:spPr/>
@@ -644,7 +464,7 @@
 </file>
 
 <file path=ppt/notesSlides/notesSlide11.xml><?xml version="1.0" encoding="utf-8"?>
-<p:notes xmlns:a="http://schemas.openxmlformats.org/drawingml/2006/main" xmlns:p="http://schemas.openxmlformats.org/presentationml/2006/main" xmlns:r="http://schemas.openxmlformats.org/officeDocument/2006/relationships">
+<p:notes xmlns:a="http://schemas.openxmlformats.org/drawingml/2006/main" xmlns:r="http://schemas.openxmlformats.org/officeDocument/2006/relationships" xmlns:p="http://schemas.openxmlformats.org/presentationml/2006/main">
   <p:cSld>
     <p:spTree>
       <p:nvGrpSpPr>
@@ -664,7 +484,7 @@
         <p:nvSpPr>
           <p:cNvPr id="2" name="Slide Image Placeholder 1"/>
           <p:cNvSpPr>
-            <a:spLocks noGrp="1"/>
+            <a:spLocks noGrp="1" noRot="1" noChangeAspect="1"/>
           </p:cNvSpPr>
           <p:nvPr>
             <p:ph type="sldImg" idx="2"/>
@@ -679,7 +499,7 @@
             <a:spLocks noGrp="1"/>
           </p:cNvSpPr>
           <p:nvPr>
-            <p:ph type="body" idx="3" sz="quarter"/>
+            <p:ph type="body" sz="quarter" idx="3"/>
           </p:nvPr>
         </p:nvSpPr>
         <p:spPr/>
@@ -688,13 +508,45 @@
           <a:lstStyle/>
           <a:p>
             <a:r>
+              <a:rPr dirty="0"/>
               <a:t>~15 seconds</a:t>
             </a:r>
           </a:p>
-          <a:p/>
-          <a:p>
-            <a:r>
-              <a:t>AskTube AI covers all the mandatory IronHack requirements: LLM chatbot, LangChain tools, conversational memory, ChromaDB vector database, text processing, a polished UI, 98 tests, RAG evaluation, and Docker deployment on EC2. Thank you.</a:t>
+          <a:p>
+            <a:endParaRPr dirty="0"/>
+          </a:p>
+          <a:p>
+            <a:r>
+              <a:rPr dirty="0" err="1"/>
+              <a:t>AskTube</a:t>
+            </a:r>
+            <a:r>
+              <a:rPr dirty="0"/>
+              <a:t> AI covers all the mandatory </a:t>
+            </a:r>
+            <a:r>
+              <a:rPr dirty="0" err="1"/>
+              <a:t>IronHack</a:t>
+            </a:r>
+            <a:r>
+              <a:rPr dirty="0"/>
+              <a:t> requirements: LLM chatbot, </a:t>
+            </a:r>
+            <a:r>
+              <a:rPr dirty="0" err="1"/>
+              <a:t>LangChain</a:t>
+            </a:r>
+            <a:r>
+              <a:rPr dirty="0"/>
+              <a:t> tools, conversational memory, </a:t>
+            </a:r>
+            <a:r>
+              <a:rPr dirty="0" err="1"/>
+              <a:t>ChromaDB</a:t>
+            </a:r>
+            <a:r>
+              <a:rPr dirty="0"/>
+              <a:t> vector database, text processing, a polished UI, 98 tests, RAG evaluation, and Docker deployment on EC2. Thank you.</a:t>
             </a:r>
           </a:p>
         </p:txBody>
@@ -706,7 +558,7 @@
             <a:spLocks noGrp="1"/>
           </p:cNvSpPr>
           <p:nvPr>
-            <p:ph type="sldNum" idx="5" sz="quarter"/>
+            <p:ph type="sldNum" sz="quarter" idx="5"/>
           </p:nvPr>
         </p:nvSpPr>
         <p:spPr/>
@@ -720,7 +572,7 @@
 </file>
 
 <file path=ppt/notesSlides/notesSlide2.xml><?xml version="1.0" encoding="utf-8"?>
-<p:notes xmlns:a="http://schemas.openxmlformats.org/drawingml/2006/main" xmlns:p="http://schemas.openxmlformats.org/presentationml/2006/main" xmlns:r="http://schemas.openxmlformats.org/officeDocument/2006/relationships">
+<p:notes xmlns:a="http://schemas.openxmlformats.org/drawingml/2006/main" xmlns:r="http://schemas.openxmlformats.org/officeDocument/2006/relationships" xmlns:p="http://schemas.openxmlformats.org/presentationml/2006/main">
   <p:cSld>
     <p:spTree>
       <p:nvGrpSpPr>
@@ -740,7 +592,7 @@
         <p:nvSpPr>
           <p:cNvPr id="2" name="Slide Image Placeholder 1"/>
           <p:cNvSpPr>
-            <a:spLocks noGrp="1"/>
+            <a:spLocks noGrp="1" noRot="1" noChangeAspect="1"/>
           </p:cNvSpPr>
           <p:nvPr>
             <p:ph type="sldImg" idx="2"/>
@@ -755,7 +607,7 @@
             <a:spLocks noGrp="1"/>
           </p:cNvSpPr>
           <p:nvPr>
-            <p:ph type="body" idx="3" sz="quarter"/>
+            <p:ph type="body" sz="quarter" idx="3"/>
           </p:nvPr>
         </p:nvSpPr>
         <p:spPr/>
@@ -767,13 +619,17 @@
               <a:t>~40 seconds</a:t>
             </a:r>
           </a:p>
-          <a:p/>
+          <a:p>
+            <a:endParaRPr/>
+          </a:p>
           <a:p>
             <a:r>
               <a:t>YouTube has over 800 million videos. Learning from long videos is frustrating — you scrub back and forth looking for one specific answer.</a:t>
             </a:r>
           </a:p>
-          <a:p/>
+          <a:p>
+            <a:endParaRPr/>
+          </a:p>
           <a:p>
             <a:r>
               <a:t>AskTube solves this by turning any video into a conversational knowledge base. You ask a question and the AI answers using the transcript, with the exact timestamp. The key rule: if the transcript doesn't contain the answer, the system refuses — no hallucinations, no invented content.</a:t>
@@ -788,7 +644,7 @@
             <a:spLocks noGrp="1"/>
           </p:cNvSpPr>
           <p:nvPr>
-            <p:ph type="sldNum" idx="5" sz="quarter"/>
+            <p:ph type="sldNum" sz="quarter" idx="5"/>
           </p:nvPr>
         </p:nvSpPr>
         <p:spPr/>
@@ -802,7 +658,7 @@
 </file>
 
 <file path=ppt/notesSlides/notesSlide3.xml><?xml version="1.0" encoding="utf-8"?>
-<p:notes xmlns:a="http://schemas.openxmlformats.org/drawingml/2006/main" xmlns:p="http://schemas.openxmlformats.org/presentationml/2006/main" xmlns:r="http://schemas.openxmlformats.org/officeDocument/2006/relationships">
+<p:notes xmlns:a="http://schemas.openxmlformats.org/drawingml/2006/main" xmlns:r="http://schemas.openxmlformats.org/officeDocument/2006/relationships" xmlns:p="http://schemas.openxmlformats.org/presentationml/2006/main">
   <p:cSld>
     <p:spTree>
       <p:nvGrpSpPr>
@@ -822,7 +678,7 @@
         <p:nvSpPr>
           <p:cNvPr id="2" name="Slide Image Placeholder 1"/>
           <p:cNvSpPr>
-            <a:spLocks noGrp="1"/>
+            <a:spLocks noGrp="1" noRot="1" noChangeAspect="1"/>
           </p:cNvSpPr>
           <p:nvPr>
             <p:ph type="sldImg" idx="2"/>
@@ -837,7 +693,7 @@
             <a:spLocks noGrp="1"/>
           </p:cNvSpPr>
           <p:nvPr>
-            <p:ph type="body" idx="3" sz="quarter"/>
+            <p:ph type="body" sz="quarter" idx="3"/>
           </p:nvPr>
         </p:nvSpPr>
         <p:spPr/>
@@ -849,13 +705,17 @@
               <a:t>~35 seconds</a:t>
             </a:r>
           </a:p>
-          <a:p/>
+          <a:p>
+            <a:endParaRPr/>
+          </a:p>
           <a:p>
             <a:r>
               <a:t>The flow is four steps. Search for a topic by text or voice. Pick a video from a carousel. The app processes the transcript in real time — you see each step happening. Then you chat with the video content and get answers with clickable timestamp citations.</a:t>
             </a:r>
           </a:p>
-          <a:p/>
+          <a:p>
+            <a:endParaRPr/>
+          </a:p>
           <a:p>
             <a:r>
               <a:t>The whole journey is guided by a 3D robot companion that moves around the screen and speaks at each stage.</a:t>
@@ -870,7 +730,7 @@
             <a:spLocks noGrp="1"/>
           </p:cNvSpPr>
           <p:nvPr>
-            <p:ph type="sldNum" idx="5" sz="quarter"/>
+            <p:ph type="sldNum" sz="quarter" idx="5"/>
           </p:nvPr>
         </p:nvSpPr>
         <p:spPr/>
@@ -884,7 +744,7 @@
 </file>
 
 <file path=ppt/notesSlides/notesSlide4.xml><?xml version="1.0" encoding="utf-8"?>
-<p:notes xmlns:a="http://schemas.openxmlformats.org/drawingml/2006/main" xmlns:p="http://schemas.openxmlformats.org/presentationml/2006/main" xmlns:r="http://schemas.openxmlformats.org/officeDocument/2006/relationships">
+<p:notes xmlns:a="http://schemas.openxmlformats.org/drawingml/2006/main" xmlns:r="http://schemas.openxmlformats.org/officeDocument/2006/relationships" xmlns:p="http://schemas.openxmlformats.org/presentationml/2006/main">
   <p:cSld>
     <p:spTree>
       <p:nvGrpSpPr>
@@ -904,7 +764,7 @@
         <p:nvSpPr>
           <p:cNvPr id="2" name="Slide Image Placeholder 1"/>
           <p:cNvSpPr>
-            <a:spLocks noGrp="1"/>
+            <a:spLocks noGrp="1" noRot="1" noChangeAspect="1"/>
           </p:cNvSpPr>
           <p:nvPr>
             <p:ph type="sldImg" idx="2"/>
@@ -919,7 +779,7 @@
             <a:spLocks noGrp="1"/>
           </p:cNvSpPr>
           <p:nvPr>
-            <p:ph type="body" idx="3" sz="quarter"/>
+            <p:ph type="body" sz="quarter" idx="3"/>
           </p:nvPr>
         </p:nvSpPr>
         <p:spPr/>
@@ -931,13 +791,17 @@
               <a:t>~40 seconds</a:t>
             </a:r>
           </a:p>
-          <a:p/>
+          <a:p>
+            <a:endParaRPr/>
+          </a:p>
           <a:p>
             <a:r>
               <a:t>Three layers. Frontend: Next.js 14, TypeScript, TailwindCSS, Framer Motion, and Three.js for the 3D robot. Backend: FastAPI with async routes for search, transcripts, chunking, vector storage, chat, agent, and speech. AI layer: LangChain tools, OpenAI GPT-4o-mini for chat and text-embedding-3-small for vectors, ChromaDB as the vector store, and Whisper as a fallback for videos without captions.</a:t>
             </a:r>
           </a:p>
-          <a:p/>
+          <a:p>
+            <a:endParaRPr/>
+          </a:p>
           <a:p>
             <a:r>
               <a:t>Everything ships as three Docker containers orchestrated by Docker Compose and deployed on AWS EC2.</a:t>
@@ -952,7 +816,7 @@
             <a:spLocks noGrp="1"/>
           </p:cNvSpPr>
           <p:nvPr>
-            <p:ph type="sldNum" idx="5" sz="quarter"/>
+            <p:ph type="sldNum" sz="quarter" idx="5"/>
           </p:nvPr>
         </p:nvSpPr>
         <p:spPr/>
@@ -966,7 +830,7 @@
 </file>
 
 <file path=ppt/notesSlides/notesSlide5.xml><?xml version="1.0" encoding="utf-8"?>
-<p:notes xmlns:a="http://schemas.openxmlformats.org/drawingml/2006/main" xmlns:p="http://schemas.openxmlformats.org/presentationml/2006/main" xmlns:r="http://schemas.openxmlformats.org/officeDocument/2006/relationships">
+<p:notes xmlns:a="http://schemas.openxmlformats.org/drawingml/2006/main" xmlns:r="http://schemas.openxmlformats.org/officeDocument/2006/relationships" xmlns:p="http://schemas.openxmlformats.org/presentationml/2006/main">
   <p:cSld>
     <p:spTree>
       <p:nvGrpSpPr>
@@ -986,7 +850,7 @@
         <p:nvSpPr>
           <p:cNvPr id="2" name="Slide Image Placeholder 1"/>
           <p:cNvSpPr>
-            <a:spLocks noGrp="1"/>
+            <a:spLocks noGrp="1" noRot="1" noChangeAspect="1"/>
           </p:cNvSpPr>
           <p:nvPr>
             <p:ph type="sldImg" idx="2"/>
@@ -1001,7 +865,7 @@
             <a:spLocks noGrp="1"/>
           </p:cNvSpPr>
           <p:nvPr>
-            <p:ph type="body" idx="3" sz="quarter"/>
+            <p:ph type="body" sz="quarter" idx="3"/>
           </p:nvPr>
         </p:nvSpPr>
         <p:spPr/>
@@ -1013,13 +877,17 @@
               <a:t>~40 seconds</a:t>
             </a:r>
           </a:p>
-          <a:p/>
+          <a:p>
+            <a:endParaRPr/>
+          </a:p>
           <a:p>
             <a:r>
               <a:t>When you click Prepare, the ingestion pipeline runs live. The YouTube Data API fetches the video metadata. youtube-transcript-api pulls the captions — no audio download needed in the normal flow. LangChain splits the transcript into overlapping chunks and keeps the timestamp attached to each one. OpenAI embeds each chunk and ChromaDB stores them for similarity search.</a:t>
             </a:r>
           </a:p>
-          <a:p/>
+          <a:p>
+            <a:endParaRPr/>
+          </a:p>
           <a:p>
             <a:r>
               <a:t>The status stream on the right — metadata, transcript, chunking, embeddings, storage — is live WebSocket progress from the backend, not just decoration.</a:t>
@@ -1034,7 +902,7 @@
             <a:spLocks noGrp="1"/>
           </p:cNvSpPr>
           <p:nvPr>
-            <p:ph type="sldNum" idx="5" sz="quarter"/>
+            <p:ph type="sldNum" sz="quarter" idx="5"/>
           </p:nvPr>
         </p:nvSpPr>
         <p:spPr/>
@@ -1048,7 +916,7 @@
 </file>
 
 <file path=ppt/notesSlides/notesSlide6.xml><?xml version="1.0" encoding="utf-8"?>
-<p:notes xmlns:a="http://schemas.openxmlformats.org/drawingml/2006/main" xmlns:p="http://schemas.openxmlformats.org/presentationml/2006/main" xmlns:r="http://schemas.openxmlformats.org/officeDocument/2006/relationships">
+<p:notes xmlns:a="http://schemas.openxmlformats.org/drawingml/2006/main" xmlns:r="http://schemas.openxmlformats.org/officeDocument/2006/relationships" xmlns:p="http://schemas.openxmlformats.org/presentationml/2006/main">
   <p:cSld>
     <p:spTree>
       <p:nvGrpSpPr>
@@ -1068,7 +936,7 @@
         <p:nvSpPr>
           <p:cNvPr id="2" name="Slide Image Placeholder 1"/>
           <p:cNvSpPr>
-            <a:spLocks noGrp="1"/>
+            <a:spLocks noGrp="1" noRot="1" noChangeAspect="1"/>
           </p:cNvSpPr>
           <p:nvPr>
             <p:ph type="sldImg" idx="2"/>
@@ -1083,7 +951,7 @@
             <a:spLocks noGrp="1"/>
           </p:cNvSpPr>
           <p:nvPr>
-            <p:ph type="body" idx="3" sz="quarter"/>
+            <p:ph type="body" sz="quarter" idx="3"/>
           </p:nvPr>
         </p:nvSpPr>
         <p:spPr/>
@@ -1095,19 +963,25 @@
               <a:t>~50 seconds</a:t>
             </a:r>
           </a:p>
-          <a:p/>
+          <a:p>
+            <a:endParaRPr/>
+          </a:p>
           <a:p>
             <a:r>
               <a:t>The chat is not just a single prompt — it uses a real tool-calling agent. I built seven LangChain StructuredTools: search YouTube, extract transcript, chunk, store vectors, full ingest, retrieve context, and answer question.</a:t>
             </a:r>
           </a:p>
-          <a:p/>
+          <a:p>
+            <a:endParaRPr/>
+          </a:p>
           <a:p>
             <a:r>
               <a:t>The agent decides which tools to call based on the question. For a chat question it calls retrieve_context then answer_question. For a new video request it chains through the full ingestion flow automatically.</a:t>
             </a:r>
           </a:p>
-          <a:p/>
+          <a:p>
+            <a:endParaRPr/>
+          </a:p>
           <a:p>
             <a:r>
               <a:t>Two guardrails are enforced: answers must come from the transcript only, and off-topic questions must be refused. ConversationMemoryService keeps session history so follow-up questions stay coherent.</a:t>
@@ -1122,7 +996,7 @@
             <a:spLocks noGrp="1"/>
           </p:cNvSpPr>
           <p:nvPr>
-            <p:ph type="sldNum" idx="5" sz="quarter"/>
+            <p:ph type="sldNum" sz="quarter" idx="5"/>
           </p:nvPr>
         </p:nvSpPr>
         <p:spPr/>
@@ -1136,7 +1010,7 @@
 </file>
 
 <file path=ppt/notesSlides/notesSlide7.xml><?xml version="1.0" encoding="utf-8"?>
-<p:notes xmlns:a="http://schemas.openxmlformats.org/drawingml/2006/main" xmlns:p="http://schemas.openxmlformats.org/presentationml/2006/main" xmlns:r="http://schemas.openxmlformats.org/officeDocument/2006/relationships">
+<p:notes xmlns:a="http://schemas.openxmlformats.org/drawingml/2006/main" xmlns:r="http://schemas.openxmlformats.org/officeDocument/2006/relationships" xmlns:p="http://schemas.openxmlformats.org/presentationml/2006/main">
   <p:cSld>
     <p:spTree>
       <p:nvGrpSpPr>
@@ -1156,7 +1030,7 @@
         <p:nvSpPr>
           <p:cNvPr id="2" name="Slide Image Placeholder 1"/>
           <p:cNvSpPr>
-            <a:spLocks noGrp="1"/>
+            <a:spLocks noGrp="1" noRot="1" noChangeAspect="1"/>
           </p:cNvSpPr>
           <p:nvPr>
             <p:ph type="sldImg" idx="2"/>
@@ -1171,7 +1045,7 @@
             <a:spLocks noGrp="1"/>
           </p:cNvSpPr>
           <p:nvPr>
-            <p:ph type="body" idx="3" sz="quarter"/>
+            <p:ph type="body" sz="quarter" idx="3"/>
           </p:nvPr>
         </p:nvSpPr>
         <p:spPr/>
@@ -1183,13 +1057,17 @@
               <a:t>~45 seconds</a:t>
             </a:r>
           </a:p>
-          <a:p/>
+          <a:p>
+            <a:endParaRPr/>
+          </a:p>
           <a:p>
             <a:r>
               <a:t>The RAG pipeline is four steps. Retrieve: ChromaDB finds the most relevant transcript chunks by semantic similarity. Inject: the prompt receives those chunks, the conversation memory, and strict grounding rules. Generate: GPT-4o-mini writes an answer using only what is in the context. Cite: the response includes timestamp chips that link to the exact moment in the video.</a:t>
             </a:r>
           </a:p>
-          <a:p/>
+          <a:p>
+            <a:endParaRPr/>
+          </a:p>
           <a:p>
             <a:r>
               <a:t>If the answer is not in the transcript, the system says it cannot answer from this video. That refusal is the core anti-hallucination mechanism.</a:t>
@@ -1204,7 +1082,7 @@
             <a:spLocks noGrp="1"/>
           </p:cNvSpPr>
           <p:nvPr>
-            <p:ph type="sldNum" idx="5" sz="quarter"/>
+            <p:ph type="sldNum" sz="quarter" idx="5"/>
           </p:nvPr>
         </p:nvSpPr>
         <p:spPr/>
@@ -1218,7 +1096,7 @@
 </file>
 
 <file path=ppt/notesSlides/notesSlide8.xml><?xml version="1.0" encoding="utf-8"?>
-<p:notes xmlns:a="http://schemas.openxmlformats.org/drawingml/2006/main" xmlns:p="http://schemas.openxmlformats.org/presentationml/2006/main" xmlns:r="http://schemas.openxmlformats.org/officeDocument/2006/relationships">
+<p:notes xmlns:a="http://schemas.openxmlformats.org/drawingml/2006/main" xmlns:r="http://schemas.openxmlformats.org/officeDocument/2006/relationships" xmlns:p="http://schemas.openxmlformats.org/presentationml/2006/main">
   <p:cSld>
     <p:spTree>
       <p:nvGrpSpPr>
@@ -1238,7 +1116,7 @@
         <p:nvSpPr>
           <p:cNvPr id="2" name="Slide Image Placeholder 1"/>
           <p:cNvSpPr>
-            <a:spLocks noGrp="1"/>
+            <a:spLocks noGrp="1" noRot="1" noChangeAspect="1"/>
           </p:cNvSpPr>
           <p:nvPr>
             <p:ph type="sldImg" idx="2"/>
@@ -1253,7 +1131,7 @@
             <a:spLocks noGrp="1"/>
           </p:cNvSpPr>
           <p:nvPr>
-            <p:ph type="body" idx="3" sz="quarter"/>
+            <p:ph type="body" sz="quarter" idx="3"/>
           </p:nvPr>
         </p:nvSpPr>
         <p:spPr/>
@@ -1265,7 +1143,9 @@
               <a:t>~30 seconds</a:t>
             </a:r>
           </a:p>
-          <a:p/>
+          <a:p>
+            <a:endParaRPr/>
+          </a:p>
           <a:p>
             <a:r>
               <a:t>The UI is designed to feel like a real product. Voice search tries the browser Web Speech API first, and automatically falls back to MediaRecorder plus Whisper if it fails. The 3D robot moves through the journey stages and speaks short guidance at each step. Accessibility is built in: semantic labels, visible focus states, reduced-motion support, and screen-reader status messages.</a:t>
@@ -1280,7 +1160,7 @@
             <a:spLocks noGrp="1"/>
           </p:cNvSpPr>
           <p:nvPr>
-            <p:ph type="sldNum" idx="5" sz="quarter"/>
+            <p:ph type="sldNum" sz="quarter" idx="5"/>
           </p:nvPr>
         </p:nvSpPr>
         <p:spPr/>
@@ -1294,7 +1174,7 @@
 </file>
 
 <file path=ppt/notesSlides/notesSlide9.xml><?xml version="1.0" encoding="utf-8"?>
-<p:notes xmlns:a="http://schemas.openxmlformats.org/drawingml/2006/main" xmlns:p="http://schemas.openxmlformats.org/presentationml/2006/main" xmlns:r="http://schemas.openxmlformats.org/officeDocument/2006/relationships">
+<p:notes xmlns:a="http://schemas.openxmlformats.org/drawingml/2006/main" xmlns:r="http://schemas.openxmlformats.org/officeDocument/2006/relationships" xmlns:p="http://schemas.openxmlformats.org/presentationml/2006/main">
   <p:cSld>
     <p:spTree>
       <p:nvGrpSpPr>
@@ -1314,7 +1194,7 @@
         <p:nvSpPr>
           <p:cNvPr id="2" name="Slide Image Placeholder 1"/>
           <p:cNvSpPr>
-            <a:spLocks noGrp="1"/>
+            <a:spLocks noGrp="1" noRot="1" noChangeAspect="1"/>
           </p:cNvSpPr>
           <p:nvPr>
             <p:ph type="sldImg" idx="2"/>
@@ -1329,7 +1209,7 @@
             <a:spLocks noGrp="1"/>
           </p:cNvSpPr>
           <p:nvPr>
-            <p:ph type="body" idx="3" sz="quarter"/>
+            <p:ph type="body" sz="quarter" idx="3"/>
           </p:nvPr>
         </p:nvSpPr>
         <p:spPr/>
@@ -1341,7 +1221,9 @@
               <a:t>~35 seconds</a:t>
             </a:r>
           </a:p>
-          <a:p/>
+          <a:p>
+            <a:endParaRPr/>
+          </a:p>
           <a:p>
             <a:r>
               <a:t>The project has 98 pytest tests covering routes, services, tools, WebSocket ingest, speech, and the RAG pipeline. I also built 17 hand-crafted RAG evaluation cases that test answerable questions, refusals, citation accuracy, summaries, memory, and hallucination prevention — all pass with zero behavioral failures. LangSmith tracing is available for live chain inspection, and the inline heuristic evaluator scores every RAG response at inference time.</a:t>
@@ -1356,7 +1238,7 @@
             <a:spLocks noGrp="1"/>
           </p:cNvSpPr>
           <p:nvPr>
-            <p:ph type="sldNum" idx="5" sz="quarter"/>
+            <p:ph type="sldNum" sz="quarter" idx="5"/>
           </p:nvPr>
         </p:nvSpPr>
         <p:spPr/>
@@ -1407,10 +1289,9 @@
           <a:lstStyle/>
           <a:p>
             <a:r>
-              <a:rPr lang="en-US" smtClean="0"/>
+              <a:rPr lang="en-US"/>
               <a:t>Click to edit Master title style</a:t>
             </a:r>
-            <a:endParaRPr lang="en-US"/>
           </a:p>
         </p:txBody>
       </p:sp>
@@ -1526,10 +1407,9 @@
           </a:lstStyle>
           <a:p>
             <a:r>
-              <a:rPr lang="en-US" smtClean="0"/>
+              <a:rPr lang="en-US"/>
               <a:t>Click to edit Master subtitle style</a:t>
             </a:r>
-            <a:endParaRPr lang="en-US"/>
           </a:p>
         </p:txBody>
       </p:sp>
@@ -1550,7 +1430,7 @@
           <a:p>
             <a:fld id="{5BCAD085-E8A6-8845-BD4E-CB4CCA059FC4}" type="datetimeFigureOut">
               <a:rPr lang="en-US" smtClean="0"/>
-              <a:t>1/27/13</a:t>
+              <a:t>5/26/2026</a:t>
             </a:fld>
             <a:endParaRPr lang="en-US"/>
           </a:p>
@@ -1644,10 +1524,9 @@
           <a:lstStyle/>
           <a:p>
             <a:r>
-              <a:rPr lang="en-US" smtClean="0"/>
+              <a:rPr lang="en-US"/>
               <a:t>Click to edit Master title style</a:t>
             </a:r>
-            <a:endParaRPr lang="en-US"/>
           </a:p>
         </p:txBody>
       </p:sp>
@@ -1668,38 +1547,37 @@
           <a:p>
             <a:pPr lvl="0"/>
             <a:r>
-              <a:rPr lang="en-US" smtClean="0"/>
+              <a:rPr lang="en-US"/>
               <a:t>Click to edit Master text styles</a:t>
             </a:r>
           </a:p>
           <a:p>
             <a:pPr lvl="1"/>
             <a:r>
-              <a:rPr lang="en-US" smtClean="0"/>
+              <a:rPr lang="en-US"/>
               <a:t>Second level</a:t>
             </a:r>
           </a:p>
           <a:p>
             <a:pPr lvl="2"/>
             <a:r>
-              <a:rPr lang="en-US" smtClean="0"/>
+              <a:rPr lang="en-US"/>
               <a:t>Third level</a:t>
             </a:r>
           </a:p>
           <a:p>
             <a:pPr lvl="3"/>
             <a:r>
-              <a:rPr lang="en-US" smtClean="0"/>
+              <a:rPr lang="en-US"/>
               <a:t>Fourth level</a:t>
             </a:r>
           </a:p>
           <a:p>
             <a:pPr lvl="4"/>
             <a:r>
-              <a:rPr lang="en-US" smtClean="0"/>
+              <a:rPr lang="en-US"/>
               <a:t>Fifth level</a:t>
             </a:r>
-            <a:endParaRPr lang="en-US"/>
           </a:p>
         </p:txBody>
       </p:sp>
@@ -1720,7 +1598,7 @@
           <a:p>
             <a:fld id="{5BCAD085-E8A6-8845-BD4E-CB4CCA059FC4}" type="datetimeFigureOut">
               <a:rPr lang="en-US" smtClean="0"/>
-              <a:t>1/27/13</a:t>
+              <a:t>5/26/2026</a:t>
             </a:fld>
             <a:endParaRPr lang="en-US"/>
           </a:p>
@@ -1819,10 +1697,9 @@
           <a:lstStyle/>
           <a:p>
             <a:r>
-              <a:rPr lang="en-US" smtClean="0"/>
+              <a:rPr lang="en-US"/>
               <a:t>Click to edit Master title style</a:t>
             </a:r>
-            <a:endParaRPr lang="en-US"/>
           </a:p>
         </p:txBody>
       </p:sp>
@@ -1848,38 +1725,37 @@
           <a:p>
             <a:pPr lvl="0"/>
             <a:r>
-              <a:rPr lang="en-US" smtClean="0"/>
+              <a:rPr lang="en-US"/>
               <a:t>Click to edit Master text styles</a:t>
             </a:r>
           </a:p>
           <a:p>
             <a:pPr lvl="1"/>
             <a:r>
-              <a:rPr lang="en-US" smtClean="0"/>
+              <a:rPr lang="en-US"/>
               <a:t>Second level</a:t>
             </a:r>
           </a:p>
           <a:p>
             <a:pPr lvl="2"/>
             <a:r>
-              <a:rPr lang="en-US" smtClean="0"/>
+              <a:rPr lang="en-US"/>
               <a:t>Third level</a:t>
             </a:r>
           </a:p>
           <a:p>
             <a:pPr lvl="3"/>
             <a:r>
-              <a:rPr lang="en-US" smtClean="0"/>
+              <a:rPr lang="en-US"/>
               <a:t>Fourth level</a:t>
             </a:r>
           </a:p>
           <a:p>
             <a:pPr lvl="4"/>
             <a:r>
-              <a:rPr lang="en-US" smtClean="0"/>
+              <a:rPr lang="en-US"/>
               <a:t>Fifth level</a:t>
             </a:r>
-            <a:endParaRPr lang="en-US"/>
           </a:p>
         </p:txBody>
       </p:sp>
@@ -1900,7 +1776,7 @@
           <a:p>
             <a:fld id="{5BCAD085-E8A6-8845-BD4E-CB4CCA059FC4}" type="datetimeFigureOut">
               <a:rPr lang="en-US" smtClean="0"/>
-              <a:t>1/27/13</a:t>
+              <a:t>5/26/2026</a:t>
             </a:fld>
             <a:endParaRPr lang="en-US"/>
           </a:p>
@@ -1994,10 +1870,9 @@
           <a:lstStyle/>
           <a:p>
             <a:r>
-              <a:rPr lang="en-US" smtClean="0"/>
+              <a:rPr lang="en-US"/>
               <a:t>Click to edit Master title style</a:t>
             </a:r>
-            <a:endParaRPr lang="en-US"/>
           </a:p>
         </p:txBody>
       </p:sp>
@@ -2018,38 +1893,37 @@
           <a:p>
             <a:pPr lvl="0"/>
             <a:r>
-              <a:rPr lang="en-US" smtClean="0"/>
+              <a:rPr lang="en-US"/>
               <a:t>Click to edit Master text styles</a:t>
             </a:r>
           </a:p>
           <a:p>
             <a:pPr lvl="1"/>
             <a:r>
-              <a:rPr lang="en-US" smtClean="0"/>
+              <a:rPr lang="en-US"/>
               <a:t>Second level</a:t>
             </a:r>
           </a:p>
           <a:p>
             <a:pPr lvl="2"/>
             <a:r>
-              <a:rPr lang="en-US" smtClean="0"/>
+              <a:rPr lang="en-US"/>
               <a:t>Third level</a:t>
             </a:r>
           </a:p>
           <a:p>
             <a:pPr lvl="3"/>
             <a:r>
-              <a:rPr lang="en-US" smtClean="0"/>
+              <a:rPr lang="en-US"/>
               <a:t>Fourth level</a:t>
             </a:r>
           </a:p>
           <a:p>
             <a:pPr lvl="4"/>
             <a:r>
-              <a:rPr lang="en-US" smtClean="0"/>
+              <a:rPr lang="en-US"/>
               <a:t>Fifth level</a:t>
             </a:r>
-            <a:endParaRPr lang="en-US"/>
           </a:p>
         </p:txBody>
       </p:sp>
@@ -2070,7 +1944,7 @@
           <a:p>
             <a:fld id="{5BCAD085-E8A6-8845-BD4E-CB4CCA059FC4}" type="datetimeFigureOut">
               <a:rPr lang="en-US" smtClean="0"/>
-              <a:t>1/27/13</a:t>
+              <a:t>5/26/2026</a:t>
             </a:fld>
             <a:endParaRPr lang="en-US"/>
           </a:p>
@@ -2173,10 +2047,9 @@
           </a:lstStyle>
           <a:p>
             <a:r>
-              <a:rPr lang="en-US" smtClean="0"/>
+              <a:rPr lang="en-US"/>
               <a:t>Click to edit Master title style</a:t>
             </a:r>
-            <a:endParaRPr lang="en-US"/>
           </a:p>
         </p:txBody>
       </p:sp>
@@ -2293,7 +2166,7 @@
           <a:p>
             <a:pPr lvl="0"/>
             <a:r>
-              <a:rPr lang="en-US" smtClean="0"/>
+              <a:rPr lang="en-US"/>
               <a:t>Click to edit Master text styles</a:t>
             </a:r>
           </a:p>
@@ -2316,7 +2189,7 @@
           <a:p>
             <a:fld id="{5BCAD085-E8A6-8845-BD4E-CB4CCA059FC4}" type="datetimeFigureOut">
               <a:rPr lang="en-US" smtClean="0"/>
-              <a:t>1/27/13</a:t>
+              <a:t>5/26/2026</a:t>
             </a:fld>
             <a:endParaRPr lang="en-US"/>
           </a:p>
@@ -2410,10 +2283,9 @@
           <a:lstStyle/>
           <a:p>
             <a:r>
-              <a:rPr lang="en-US" smtClean="0"/>
+              <a:rPr lang="en-US"/>
               <a:t>Click to edit Master title style</a:t>
             </a:r>
-            <a:endParaRPr lang="en-US"/>
           </a:p>
         </p:txBody>
       </p:sp>
@@ -2467,38 +2339,37 @@
           <a:p>
             <a:pPr lvl="0"/>
             <a:r>
-              <a:rPr lang="en-US" smtClean="0"/>
+              <a:rPr lang="en-US"/>
               <a:t>Click to edit Master text styles</a:t>
             </a:r>
           </a:p>
           <a:p>
             <a:pPr lvl="1"/>
             <a:r>
-              <a:rPr lang="en-US" smtClean="0"/>
+              <a:rPr lang="en-US"/>
               <a:t>Second level</a:t>
             </a:r>
           </a:p>
           <a:p>
             <a:pPr lvl="2"/>
             <a:r>
-              <a:rPr lang="en-US" smtClean="0"/>
+              <a:rPr lang="en-US"/>
               <a:t>Third level</a:t>
             </a:r>
           </a:p>
           <a:p>
             <a:pPr lvl="3"/>
             <a:r>
-              <a:rPr lang="en-US" smtClean="0"/>
+              <a:rPr lang="en-US"/>
               <a:t>Fourth level</a:t>
             </a:r>
           </a:p>
           <a:p>
             <a:pPr lvl="4"/>
             <a:r>
-              <a:rPr lang="en-US" smtClean="0"/>
+              <a:rPr lang="en-US"/>
               <a:t>Fifth level</a:t>
             </a:r>
-            <a:endParaRPr lang="en-US"/>
           </a:p>
         </p:txBody>
       </p:sp>
@@ -2552,38 +2423,37 @@
           <a:p>
             <a:pPr lvl="0"/>
             <a:r>
-              <a:rPr lang="en-US" smtClean="0"/>
+              <a:rPr lang="en-US"/>
               <a:t>Click to edit Master text styles</a:t>
             </a:r>
           </a:p>
           <a:p>
             <a:pPr lvl="1"/>
             <a:r>
-              <a:rPr lang="en-US" smtClean="0"/>
+              <a:rPr lang="en-US"/>
               <a:t>Second level</a:t>
             </a:r>
           </a:p>
           <a:p>
             <a:pPr lvl="2"/>
             <a:r>
-              <a:rPr lang="en-US" smtClean="0"/>
+              <a:rPr lang="en-US"/>
               <a:t>Third level</a:t>
             </a:r>
           </a:p>
           <a:p>
             <a:pPr lvl="3"/>
             <a:r>
-              <a:rPr lang="en-US" smtClean="0"/>
+              <a:rPr lang="en-US"/>
               <a:t>Fourth level</a:t>
             </a:r>
           </a:p>
           <a:p>
             <a:pPr lvl="4"/>
             <a:r>
-              <a:rPr lang="en-US" smtClean="0"/>
+              <a:rPr lang="en-US"/>
               <a:t>Fifth level</a:t>
             </a:r>
-            <a:endParaRPr lang="en-US"/>
           </a:p>
         </p:txBody>
       </p:sp>
@@ -2604,7 +2474,7 @@
           <a:p>
             <a:fld id="{5BCAD085-E8A6-8845-BD4E-CB4CCA059FC4}" type="datetimeFigureOut">
               <a:rPr lang="en-US" smtClean="0"/>
-              <a:t>1/27/13</a:t>
+              <a:t>5/26/2026</a:t>
             </a:fld>
             <a:endParaRPr lang="en-US"/>
           </a:p>
@@ -2702,10 +2572,9 @@
           </a:lstStyle>
           <a:p>
             <a:r>
-              <a:rPr lang="en-US" smtClean="0"/>
+              <a:rPr lang="en-US"/>
               <a:t>Click to edit Master title style</a:t>
             </a:r>
-            <a:endParaRPr lang="en-US"/>
           </a:p>
         </p:txBody>
       </p:sp>
@@ -2768,7 +2637,7 @@
           <a:p>
             <a:pPr lvl="0"/>
             <a:r>
-              <a:rPr lang="en-US" smtClean="0"/>
+              <a:rPr lang="en-US"/>
               <a:t>Click to edit Master text styles</a:t>
             </a:r>
           </a:p>
@@ -2824,38 +2693,37 @@
           <a:p>
             <a:pPr lvl="0"/>
             <a:r>
-              <a:rPr lang="en-US" smtClean="0"/>
+              <a:rPr lang="en-US"/>
               <a:t>Click to edit Master text styles</a:t>
             </a:r>
           </a:p>
           <a:p>
             <a:pPr lvl="1"/>
             <a:r>
-              <a:rPr lang="en-US" smtClean="0"/>
+              <a:rPr lang="en-US"/>
               <a:t>Second level</a:t>
             </a:r>
           </a:p>
           <a:p>
             <a:pPr lvl="2"/>
             <a:r>
-              <a:rPr lang="en-US" smtClean="0"/>
+              <a:rPr lang="en-US"/>
               <a:t>Third level</a:t>
             </a:r>
           </a:p>
           <a:p>
             <a:pPr lvl="3"/>
             <a:r>
-              <a:rPr lang="en-US" smtClean="0"/>
+              <a:rPr lang="en-US"/>
               <a:t>Fourth level</a:t>
             </a:r>
           </a:p>
           <a:p>
             <a:pPr lvl="4"/>
             <a:r>
-              <a:rPr lang="en-US" smtClean="0"/>
+              <a:rPr lang="en-US"/>
               <a:t>Fifth level</a:t>
             </a:r>
-            <a:endParaRPr lang="en-US"/>
           </a:p>
         </p:txBody>
       </p:sp>
@@ -2918,7 +2786,7 @@
           <a:p>
             <a:pPr lvl="0"/>
             <a:r>
-              <a:rPr lang="en-US" smtClean="0"/>
+              <a:rPr lang="en-US"/>
               <a:t>Click to edit Master text styles</a:t>
             </a:r>
           </a:p>
@@ -2974,38 +2842,37 @@
           <a:p>
             <a:pPr lvl="0"/>
             <a:r>
-              <a:rPr lang="en-US" smtClean="0"/>
+              <a:rPr lang="en-US"/>
               <a:t>Click to edit Master text styles</a:t>
             </a:r>
           </a:p>
           <a:p>
             <a:pPr lvl="1"/>
             <a:r>
-              <a:rPr lang="en-US" smtClean="0"/>
+              <a:rPr lang="en-US"/>
               <a:t>Second level</a:t>
             </a:r>
           </a:p>
           <a:p>
             <a:pPr lvl="2"/>
             <a:r>
-              <a:rPr lang="en-US" smtClean="0"/>
+              <a:rPr lang="en-US"/>
               <a:t>Third level</a:t>
             </a:r>
           </a:p>
           <a:p>
             <a:pPr lvl="3"/>
             <a:r>
-              <a:rPr lang="en-US" smtClean="0"/>
+              <a:rPr lang="en-US"/>
               <a:t>Fourth level</a:t>
             </a:r>
           </a:p>
           <a:p>
             <a:pPr lvl="4"/>
             <a:r>
-              <a:rPr lang="en-US" smtClean="0"/>
+              <a:rPr lang="en-US"/>
               <a:t>Fifth level</a:t>
             </a:r>
-            <a:endParaRPr lang="en-US"/>
           </a:p>
         </p:txBody>
       </p:sp>
@@ -3026,7 +2893,7 @@
           <a:p>
             <a:fld id="{5BCAD085-E8A6-8845-BD4E-CB4CCA059FC4}" type="datetimeFigureOut">
               <a:rPr lang="en-US" smtClean="0"/>
-              <a:t>1/27/13</a:t>
+              <a:t>5/26/2026</a:t>
             </a:fld>
             <a:endParaRPr lang="en-US"/>
           </a:p>
@@ -3120,10 +2987,9 @@
           <a:lstStyle/>
           <a:p>
             <a:r>
-              <a:rPr lang="en-US" smtClean="0"/>
+              <a:rPr lang="en-US"/>
               <a:t>Click to edit Master title style</a:t>
             </a:r>
-            <a:endParaRPr lang="en-US"/>
           </a:p>
         </p:txBody>
       </p:sp>
@@ -3144,7 +3010,7 @@
           <a:p>
             <a:fld id="{5BCAD085-E8A6-8845-BD4E-CB4CCA059FC4}" type="datetimeFigureOut">
               <a:rPr lang="en-US" smtClean="0"/>
-              <a:t>1/27/13</a:t>
+              <a:t>5/26/2026</a:t>
             </a:fld>
             <a:endParaRPr lang="en-US"/>
           </a:p>
@@ -3239,7 +3105,7 @@
           <a:p>
             <a:fld id="{5BCAD085-E8A6-8845-BD4E-CB4CCA059FC4}" type="datetimeFigureOut">
               <a:rPr lang="en-US" smtClean="0"/>
-              <a:t>1/27/13</a:t>
+              <a:t>5/26/2026</a:t>
             </a:fld>
             <a:endParaRPr lang="en-US"/>
           </a:p>
@@ -3342,10 +3208,9 @@
           </a:lstStyle>
           <a:p>
             <a:r>
-              <a:rPr lang="en-US" smtClean="0"/>
+              <a:rPr lang="en-US"/>
               <a:t>Click to edit Master title style</a:t>
             </a:r>
-            <a:endParaRPr lang="en-US"/>
           </a:p>
         </p:txBody>
       </p:sp>
@@ -3399,38 +3264,37 @@
           <a:p>
             <a:pPr lvl="0"/>
             <a:r>
-              <a:rPr lang="en-US" smtClean="0"/>
+              <a:rPr lang="en-US"/>
               <a:t>Click to edit Master text styles</a:t>
             </a:r>
           </a:p>
           <a:p>
             <a:pPr lvl="1"/>
             <a:r>
-              <a:rPr lang="en-US" smtClean="0"/>
+              <a:rPr lang="en-US"/>
               <a:t>Second level</a:t>
             </a:r>
           </a:p>
           <a:p>
             <a:pPr lvl="2"/>
             <a:r>
-              <a:rPr lang="en-US" smtClean="0"/>
+              <a:rPr lang="en-US"/>
               <a:t>Third level</a:t>
             </a:r>
           </a:p>
           <a:p>
             <a:pPr lvl="3"/>
             <a:r>
-              <a:rPr lang="en-US" smtClean="0"/>
+              <a:rPr lang="en-US"/>
               <a:t>Fourth level</a:t>
             </a:r>
           </a:p>
           <a:p>
             <a:pPr lvl="4"/>
             <a:r>
-              <a:rPr lang="en-US" smtClean="0"/>
+              <a:rPr lang="en-US"/>
               <a:t>Fifth level</a:t>
             </a:r>
-            <a:endParaRPr lang="en-US"/>
           </a:p>
         </p:txBody>
       </p:sp>
@@ -3493,7 +3357,7 @@
           <a:p>
             <a:pPr lvl="0"/>
             <a:r>
-              <a:rPr lang="en-US" smtClean="0"/>
+              <a:rPr lang="en-US"/>
               <a:t>Click to edit Master text styles</a:t>
             </a:r>
           </a:p>
@@ -3516,7 +3380,7 @@
           <a:p>
             <a:fld id="{5BCAD085-E8A6-8845-BD4E-CB4CCA059FC4}" type="datetimeFigureOut">
               <a:rPr lang="en-US" smtClean="0"/>
-              <a:t>1/27/13</a:t>
+              <a:t>5/26/2026</a:t>
             </a:fld>
             <a:endParaRPr lang="en-US"/>
           </a:p>
@@ -3619,10 +3483,9 @@
           </a:lstStyle>
           <a:p>
             <a:r>
-              <a:rPr lang="en-US" smtClean="0"/>
+              <a:rPr lang="en-US"/>
               <a:t>Click to edit Master title style</a:t>
             </a:r>
-            <a:endParaRPr lang="en-US"/>
           </a:p>
         </p:txBody>
       </p:sp>
@@ -3746,7 +3609,7 @@
           <a:p>
             <a:pPr lvl="0"/>
             <a:r>
-              <a:rPr lang="en-US" smtClean="0"/>
+              <a:rPr lang="en-US"/>
               <a:t>Click to edit Master text styles</a:t>
             </a:r>
           </a:p>
@@ -3769,7 +3632,7 @@
           <a:p>
             <a:fld id="{5BCAD085-E8A6-8845-BD4E-CB4CCA059FC4}" type="datetimeFigureOut">
               <a:rPr lang="en-US" smtClean="0"/>
-              <a:t>1/27/13</a:t>
+              <a:t>5/26/2026</a:t>
             </a:fld>
             <a:endParaRPr lang="en-US"/>
           </a:p>
@@ -3878,10 +3741,9 @@
           <a:lstStyle/>
           <a:p>
             <a:r>
-              <a:rPr lang="en-US" smtClean="0"/>
+              <a:rPr lang="en-US"/>
               <a:t>Click to edit Master title style</a:t>
             </a:r>
-            <a:endParaRPr lang="en-US"/>
           </a:p>
         </p:txBody>
       </p:sp>
@@ -3912,38 +3774,37 @@
           <a:p>
             <a:pPr lvl="0"/>
             <a:r>
-              <a:rPr lang="en-US" smtClean="0"/>
+              <a:rPr lang="en-US"/>
               <a:t>Click to edit Master text styles</a:t>
             </a:r>
           </a:p>
           <a:p>
             <a:pPr lvl="1"/>
             <a:r>
-              <a:rPr lang="en-US" smtClean="0"/>
+              <a:rPr lang="en-US"/>
               <a:t>Second level</a:t>
             </a:r>
           </a:p>
           <a:p>
             <a:pPr lvl="2"/>
             <a:r>
-              <a:rPr lang="en-US" smtClean="0"/>
+              <a:rPr lang="en-US"/>
               <a:t>Third level</a:t>
             </a:r>
           </a:p>
           <a:p>
             <a:pPr lvl="3"/>
             <a:r>
-              <a:rPr lang="en-US" smtClean="0"/>
+              <a:rPr lang="en-US"/>
               <a:t>Fourth level</a:t>
             </a:r>
           </a:p>
           <a:p>
             <a:pPr lvl="4"/>
             <a:r>
-              <a:rPr lang="en-US" smtClean="0"/>
+              <a:rPr lang="en-US"/>
               <a:t>Fifth level</a:t>
             </a:r>
-            <a:endParaRPr lang="en-US"/>
           </a:p>
         </p:txBody>
       </p:sp>
@@ -3982,7 +3843,7 @@
           <a:p>
             <a:fld id="{5BCAD085-E8A6-8845-BD4E-CB4CCA059FC4}" type="datetimeFigureOut">
               <a:rPr lang="en-US" smtClean="0"/>
-              <a:t>1/27/13</a:t>
+              <a:t>5/26/2026</a:t>
             </a:fld>
             <a:endParaRPr lang="en-US"/>
           </a:p>
@@ -4341,7 +4202,7 @@
 </file>
 
 <file path=ppt/slides/slide1.xml><?xml version="1.0" encoding="utf-8"?>
-<p:sld xmlns:a="http://schemas.openxmlformats.org/drawingml/2006/main" xmlns:p="http://schemas.openxmlformats.org/presentationml/2006/main" xmlns:r="http://schemas.openxmlformats.org/officeDocument/2006/relationships">
+<p:sld xmlns:a="http://schemas.openxmlformats.org/drawingml/2006/main" xmlns:r="http://schemas.openxmlformats.org/officeDocument/2006/relationships" xmlns:p="http://schemas.openxmlformats.org/presentationml/2006/main">
   <p:cSld>
     <p:bg>
       <p:bgPr>
@@ -4357,7 +4218,14 @@
         <p:cNvGrpSpPr/>
         <p:nvPr/>
       </p:nvGrpSpPr>
-      <p:grpSpPr/>
+      <p:grpSpPr>
+        <a:xfrm>
+          <a:off x="0" y="0"/>
+          <a:ext cx="0" cy="0"/>
+          <a:chOff x="0" y="0"/>
+          <a:chExt cx="0" cy="0"/>
+        </a:xfrm>
+      </p:grpSpPr>
       <p:sp>
         <p:nvSpPr>
           <p:cNvPr id="2" name="Rounded Rectangle 1"/>
@@ -4398,6 +4266,7 @@
           <a:lstStyle/>
           <a:p>
             <a:pPr algn="ctr"/>
+            <a:endParaRPr/>
           </a:p>
         </p:txBody>
       </p:sp>
@@ -4441,6 +4310,7 @@
           <a:lstStyle/>
           <a:p>
             <a:pPr algn="ctr"/>
+            <a:endParaRPr/>
           </a:p>
         </p:txBody>
       </p:sp>
@@ -4484,6 +4354,7 @@
           <a:lstStyle/>
           <a:p>
             <a:pPr algn="ctr"/>
+            <a:endParaRPr/>
           </a:p>
         </p:txBody>
       </p:sp>
@@ -4546,7 +4417,7 @@
           <a:p>
             <a:pPr algn="l"/>
             <a:r>
-              <a:rPr sz="2100" b="0">
+              <a:rPr sz="2100" b="0" dirty="0">
                 <a:solidFill>
                   <a:srgbClr val="22D3EE"/>
                 </a:solidFill>
@@ -4669,6 +4540,7 @@
           <a:lstStyle/>
           <a:p>
             <a:pPr algn="ctr"/>
+            <a:endParaRPr/>
           </a:p>
         </p:txBody>
       </p:sp>
@@ -4891,7 +4763,7 @@
 </file>
 
 <file path=ppt/slides/slide10.xml><?xml version="1.0" encoding="utf-8"?>
-<p:sld xmlns:a="http://schemas.openxmlformats.org/drawingml/2006/main" xmlns:p="http://schemas.openxmlformats.org/presentationml/2006/main" xmlns:r="http://schemas.openxmlformats.org/officeDocument/2006/relationships">
+<p:sld xmlns:a="http://schemas.openxmlformats.org/drawingml/2006/main" xmlns:r="http://schemas.openxmlformats.org/officeDocument/2006/relationships" xmlns:p="http://schemas.openxmlformats.org/presentationml/2006/main">
   <p:cSld>
     <p:bg>
       <p:bgPr>
@@ -4907,7 +4779,14 @@
         <p:cNvGrpSpPr/>
         <p:nvPr/>
       </p:nvGrpSpPr>
-      <p:grpSpPr/>
+      <p:grpSpPr>
+        <a:xfrm>
+          <a:off x="0" y="0"/>
+          <a:ext cx="0" cy="0"/>
+          <a:chOff x="0" y="0"/>
+          <a:chExt cx="0" cy="0"/>
+        </a:xfrm>
+      </p:grpSpPr>
       <p:sp>
         <p:nvSpPr>
           <p:cNvPr id="2" name="Rounded Rectangle 1"/>
@@ -4948,6 +4827,7 @@
           <a:lstStyle/>
           <a:p>
             <a:pPr algn="ctr"/>
+            <a:endParaRPr/>
           </a:p>
         </p:txBody>
       </p:sp>
@@ -4991,6 +4871,7 @@
           <a:lstStyle/>
           <a:p>
             <a:pPr algn="ctr"/>
+            <a:endParaRPr/>
           </a:p>
         </p:txBody>
       </p:sp>
@@ -5034,6 +4915,7 @@
           <a:lstStyle/>
           <a:p>
             <a:pPr algn="ctr"/>
+            <a:endParaRPr/>
           </a:p>
         </p:txBody>
       </p:sp>
@@ -5151,7 +5033,7 @@
         <p:spPr>
           <a:xfrm>
             <a:off x="868680" y="1828800"/>
-            <a:ext cx="5577840" cy="3931920"/>
+            <a:ext cx="6364224" cy="4201086"/>
           </a:xfrm>
           <a:prstGeom prst="rect">
             <a:avLst/>
@@ -5173,7 +5055,7 @@
               </a:spcAft>
             </a:pPr>
             <a:r>
-              <a:rPr sz="1700" b="1">
+              <a:rPr sz="1700" b="1" dirty="0">
                 <a:solidFill>
                   <a:srgbClr val="22D3EE"/>
                 </a:solidFill>
@@ -5182,13 +5064,31 @@
               <a:t>- </a:t>
             </a:r>
             <a:r>
-              <a:rPr sz="1700">
+              <a:rPr sz="1700" dirty="0">
                 <a:solidFill>
                   <a:srgbClr val="F6F8FF"/>
                 </a:solidFill>
                 <a:latin typeface="Aptos"/>
               </a:rPr>
-              <a:t>Live app: http://18.157.233.122:3001/ (EC2 deployment with Webshare proxy)</a:t>
+              <a:t>Live app: http://18.157.233.122:3001/ (EC2 deployment with </a:t>
+            </a:r>
+            <a:r>
+              <a:rPr sz="1700" dirty="0" err="1">
+                <a:solidFill>
+                  <a:srgbClr val="F6F8FF"/>
+                </a:solidFill>
+                <a:latin typeface="Aptos"/>
+              </a:rPr>
+              <a:t>Webshare</a:t>
+            </a:r>
+            <a:r>
+              <a:rPr sz="1700" dirty="0">
+                <a:solidFill>
+                  <a:srgbClr val="F6F8FF"/>
+                </a:solidFill>
+                <a:latin typeface="Aptos"/>
+              </a:rPr>
+              <a:t> proxy)</a:t>
             </a:r>
           </a:p>
           <a:p>
@@ -5201,7 +5101,7 @@
               </a:spcAft>
             </a:pPr>
             <a:r>
-              <a:rPr sz="1700" b="1">
+              <a:rPr sz="1700" b="1" dirty="0">
                 <a:solidFill>
                   <a:srgbClr val="22D3EE"/>
                 </a:solidFill>
@@ -5210,7 +5110,7 @@
               <a:t>- </a:t>
             </a:r>
             <a:r>
-              <a:rPr sz="1700">
+              <a:rPr sz="1700" dirty="0">
                 <a:solidFill>
                   <a:srgbClr val="F6F8FF"/>
                 </a:solidFill>
@@ -5229,7 +5129,7 @@
               </a:spcAft>
             </a:pPr>
             <a:r>
-              <a:rPr sz="1700" b="1">
+              <a:rPr sz="1700" b="1" dirty="0">
                 <a:solidFill>
                   <a:srgbClr val="22D3EE"/>
                 </a:solidFill>
@@ -5238,7 +5138,7 @@
               <a:t>- </a:t>
             </a:r>
             <a:r>
-              <a:rPr sz="1700">
+              <a:rPr sz="1700" dirty="0">
                 <a:solidFill>
                   <a:srgbClr val="F6F8FF"/>
                 </a:solidFill>
@@ -5257,7 +5157,7 @@
               </a:spcAft>
             </a:pPr>
             <a:r>
-              <a:rPr sz="1700" b="1">
+              <a:rPr sz="1700" b="1" dirty="0">
                 <a:solidFill>
                   <a:srgbClr val="22D3EE"/>
                 </a:solidFill>
@@ -5266,7 +5166,7 @@
               <a:t>- </a:t>
             </a:r>
             <a:r>
-              <a:rPr sz="1700">
+              <a:rPr sz="1700" dirty="0">
                 <a:solidFill>
                   <a:srgbClr val="F6F8FF"/>
                 </a:solidFill>
@@ -5285,7 +5185,7 @@
               </a:spcAft>
             </a:pPr>
             <a:r>
-              <a:rPr sz="1700" b="1">
+              <a:rPr sz="1700" b="1" dirty="0">
                 <a:solidFill>
                   <a:srgbClr val="22D3EE"/>
                 </a:solidFill>
@@ -5294,7 +5194,7 @@
               <a:t>- </a:t>
             </a:r>
             <a:r>
-              <a:rPr sz="1700">
+              <a:rPr sz="1700" dirty="0">
                 <a:solidFill>
                   <a:srgbClr val="F6F8FF"/>
                 </a:solidFill>
@@ -5313,7 +5213,7 @@
               </a:spcAft>
             </a:pPr>
             <a:r>
-              <a:rPr sz="1700" b="1">
+              <a:rPr sz="1700" b="1" dirty="0">
                 <a:solidFill>
                   <a:srgbClr val="22D3EE"/>
                 </a:solidFill>
@@ -5322,7 +5222,7 @@
               <a:t>- </a:t>
             </a:r>
             <a:r>
-              <a:rPr sz="1700">
+              <a:rPr sz="1700" dirty="0">
                 <a:solidFill>
                   <a:srgbClr val="F6F8FF"/>
                 </a:solidFill>
@@ -5341,7 +5241,7 @@
               </a:spcAft>
             </a:pPr>
             <a:r>
-              <a:rPr sz="1700" b="1">
+              <a:rPr sz="1700" b="1" dirty="0">
                 <a:solidFill>
                   <a:srgbClr val="22D3EE"/>
                 </a:solidFill>
@@ -5350,7 +5250,7 @@
               <a:t>- </a:t>
             </a:r>
             <a:r>
-              <a:rPr sz="1700">
+              <a:rPr sz="1700" dirty="0">
                 <a:solidFill>
                   <a:srgbClr val="F6F8FF"/>
                 </a:solidFill>
@@ -5369,7 +5269,7 @@
               </a:spcAft>
             </a:pPr>
             <a:r>
-              <a:rPr sz="1700" b="1">
+              <a:rPr sz="1700" b="1" dirty="0">
                 <a:solidFill>
                   <a:srgbClr val="22D3EE"/>
                 </a:solidFill>
@@ -5378,7 +5278,7 @@
               <a:t>- </a:t>
             </a:r>
             <a:r>
-              <a:rPr sz="1700">
+              <a:rPr sz="1700" dirty="0">
                 <a:solidFill>
                   <a:srgbClr val="F6F8FF"/>
                 </a:solidFill>
@@ -5397,7 +5297,7 @@
               </a:spcAft>
             </a:pPr>
             <a:r>
-              <a:rPr sz="1700" b="1">
+              <a:rPr sz="1700" b="1" dirty="0">
                 <a:solidFill>
                   <a:srgbClr val="22D3EE"/>
                 </a:solidFill>
@@ -5406,7 +5306,7 @@
               <a:t>- </a:t>
             </a:r>
             <a:r>
-              <a:rPr sz="1700">
+              <a:rPr sz="1700" dirty="0">
                 <a:solidFill>
                   <a:srgbClr val="F6F8FF"/>
                 </a:solidFill>
@@ -5459,6 +5359,7 @@
           <a:lstStyle/>
           <a:p>
             <a:pPr algn="ctr"/>
+            <a:endParaRPr/>
           </a:p>
         </p:txBody>
       </p:sp>
@@ -5576,7 +5477,7 @@
 </file>
 
 <file path=ppt/slides/slide11.xml><?xml version="1.0" encoding="utf-8"?>
-<p:sld xmlns:a="http://schemas.openxmlformats.org/drawingml/2006/main" xmlns:p="http://schemas.openxmlformats.org/presentationml/2006/main" xmlns:r="http://schemas.openxmlformats.org/officeDocument/2006/relationships">
+<p:sld xmlns:a="http://schemas.openxmlformats.org/drawingml/2006/main" xmlns:r="http://schemas.openxmlformats.org/officeDocument/2006/relationships" xmlns:p="http://schemas.openxmlformats.org/presentationml/2006/main">
   <p:cSld>
     <p:bg>
       <p:bgPr>
@@ -5592,7 +5493,14 @@
         <p:cNvGrpSpPr/>
         <p:nvPr/>
       </p:nvGrpSpPr>
-      <p:grpSpPr/>
+      <p:grpSpPr>
+        <a:xfrm>
+          <a:off x="0" y="0"/>
+          <a:ext cx="0" cy="0"/>
+          <a:chOff x="0" y="0"/>
+          <a:chExt cx="0" cy="0"/>
+        </a:xfrm>
+      </p:grpSpPr>
       <p:sp>
         <p:nvSpPr>
           <p:cNvPr id="2" name="Rounded Rectangle 1"/>
@@ -5633,6 +5541,7 @@
           <a:lstStyle/>
           <a:p>
             <a:pPr algn="ctr"/>
+            <a:endParaRPr/>
           </a:p>
         </p:txBody>
       </p:sp>
@@ -5676,6 +5585,7 @@
           <a:lstStyle/>
           <a:p>
             <a:pPr algn="ctr"/>
+            <a:endParaRPr/>
           </a:p>
         </p:txBody>
       </p:sp>
@@ -5719,6 +5629,7 @@
           <a:lstStyle/>
           <a:p>
             <a:pPr algn="ctr"/>
+            <a:endParaRPr/>
           </a:p>
         </p:txBody>
       </p:sp>
@@ -5800,8 +5711,8 @@
         </p:nvSpPr>
         <p:spPr>
           <a:xfrm>
-            <a:off x="777240" y="3749039"/>
-            <a:ext cx="3474720" cy="1234440"/>
+            <a:off x="777240" y="3749038"/>
+            <a:ext cx="3474720" cy="1672047"/>
           </a:xfrm>
           <a:prstGeom prst="roundRect">
             <a:avLst/>
@@ -5834,6 +5745,7 @@
           <a:lstStyle/>
           <a:p>
             <a:pPr algn="ctr"/>
+            <a:endParaRPr/>
           </a:p>
         </p:txBody>
       </p:sp>
@@ -5877,6 +5789,7 @@
           <a:lstStyle/>
           <a:p>
             <a:pPr algn="ctr"/>
+            <a:endParaRPr/>
           </a:p>
         </p:txBody>
       </p:sp>
@@ -5959,7 +5872,7 @@
         <p:spPr>
           <a:xfrm>
             <a:off x="4526280" y="3749039"/>
-            <a:ext cx="3474720" cy="1234440"/>
+            <a:ext cx="3474720" cy="1672046"/>
           </a:xfrm>
           <a:prstGeom prst="roundRect">
             <a:avLst/>
@@ -5992,6 +5905,7 @@
           <a:lstStyle/>
           <a:p>
             <a:pPr algn="ctr"/>
+            <a:endParaRPr/>
           </a:p>
         </p:txBody>
       </p:sp>
@@ -6035,6 +5949,7 @@
           <a:lstStyle/>
           <a:p>
             <a:pPr algn="ctr"/>
+            <a:endParaRPr/>
           </a:p>
         </p:txBody>
       </p:sp>
@@ -6097,13 +6012,31 @@
           <a:p>
             <a:pPr algn="l"/>
             <a:r>
-              <a:rPr sz="1400" b="0">
+              <a:rPr sz="1400" b="0" dirty="0">
                 <a:solidFill>
                   <a:srgbClr val="F6F8FF"/>
                 </a:solidFill>
                 <a:latin typeface="Aptos"/>
               </a:rPr>
-              <a:t>Voice input, Whisper fallback, WebSocket streaming, TTS, 3D assistant, and LangSmith tracing are included.</a:t>
+              <a:t>Voice input, Whisper fallback, WebSocket streaming, TTS, 3D assistant, and </a:t>
+            </a:r>
+            <a:r>
+              <a:rPr sz="1400" b="0" dirty="0" err="1">
+                <a:solidFill>
+                  <a:srgbClr val="F6F8FF"/>
+                </a:solidFill>
+                <a:latin typeface="Aptos"/>
+              </a:rPr>
+              <a:t>LangSmith</a:t>
+            </a:r>
+            <a:r>
+              <a:rPr sz="1400" b="0" dirty="0">
+                <a:solidFill>
+                  <a:srgbClr val="F6F8FF"/>
+                </a:solidFill>
+                <a:latin typeface="Aptos"/>
+              </a:rPr>
+              <a:t> tracing are included.</a:t>
             </a:r>
           </a:p>
         </p:txBody>
@@ -6117,7 +6050,7 @@
         <p:spPr>
           <a:xfrm>
             <a:off x="8275320" y="3749039"/>
-            <a:ext cx="3108960" cy="1234440"/>
+            <a:ext cx="3108960" cy="1672046"/>
           </a:xfrm>
           <a:prstGeom prst="roundRect">
             <a:avLst/>
@@ -6150,6 +6083,7 @@
           <a:lstStyle/>
           <a:p>
             <a:pPr algn="ctr"/>
+            <a:endParaRPr/>
           </a:p>
         </p:txBody>
       </p:sp>
@@ -6193,6 +6127,7 @@
           <a:lstStyle/>
           <a:p>
             <a:pPr algn="ctr"/>
+            <a:endParaRPr/>
           </a:p>
         </p:txBody>
       </p:sp>
@@ -6310,7 +6245,7 @@
 </file>
 
 <file path=ppt/slides/slide2.xml><?xml version="1.0" encoding="utf-8"?>
-<p:sld xmlns:a="http://schemas.openxmlformats.org/drawingml/2006/main" xmlns:p="http://schemas.openxmlformats.org/presentationml/2006/main" xmlns:r="http://schemas.openxmlformats.org/officeDocument/2006/relationships">
+<p:sld xmlns:a="http://schemas.openxmlformats.org/drawingml/2006/main" xmlns:r="http://schemas.openxmlformats.org/officeDocument/2006/relationships" xmlns:p="http://schemas.openxmlformats.org/presentationml/2006/main">
   <p:cSld>
     <p:bg>
       <p:bgPr>
@@ -6326,7 +6261,14 @@
         <p:cNvGrpSpPr/>
         <p:nvPr/>
       </p:nvGrpSpPr>
-      <p:grpSpPr/>
+      <p:grpSpPr>
+        <a:xfrm>
+          <a:off x="0" y="0"/>
+          <a:ext cx="0" cy="0"/>
+          <a:chOff x="0" y="0"/>
+          <a:chExt cx="0" cy="0"/>
+        </a:xfrm>
+      </p:grpSpPr>
       <p:sp>
         <p:nvSpPr>
           <p:cNvPr id="2" name="Rounded Rectangle 1"/>
@@ -6367,6 +6309,7 @@
           <a:lstStyle/>
           <a:p>
             <a:pPr algn="ctr"/>
+            <a:endParaRPr/>
           </a:p>
         </p:txBody>
       </p:sp>
@@ -6410,6 +6353,7 @@
           <a:lstStyle/>
           <a:p>
             <a:pPr algn="ctr"/>
+            <a:endParaRPr/>
           </a:p>
         </p:txBody>
       </p:sp>
@@ -6453,6 +6397,7 @@
           <a:lstStyle/>
           <a:p>
             <a:pPr algn="ctr"/>
+            <a:endParaRPr/>
           </a:p>
         </p:txBody>
       </p:sp>
@@ -6569,7 +6514,7 @@
         </p:nvSpPr>
         <p:spPr>
           <a:xfrm>
-            <a:off x="621792" y="1828800"/>
+            <a:off x="621792" y="2013862"/>
             <a:ext cx="7315200" cy="411480"/>
           </a:xfrm>
           <a:prstGeom prst="rect">
@@ -6585,13 +6530,22 @@
           <a:p>
             <a:pPr algn="l"/>
             <a:r>
-              <a:rPr sz="1800" b="0">
+              <a:rPr sz="1800" b="0" dirty="0" err="1">
                 <a:solidFill>
                   <a:srgbClr val="22D3EE"/>
                 </a:solidFill>
                 <a:latin typeface="Aptos"/>
               </a:rPr>
-              <a:t>AskTube AI turns a video into a searchable, conversational knowledge base.</a:t>
+              <a:t>AskTube</a:t>
+            </a:r>
+            <a:r>
+              <a:rPr sz="1800" b="0" dirty="0">
+                <a:solidFill>
+                  <a:srgbClr val="22D3EE"/>
+                </a:solidFill>
+                <a:latin typeface="Aptos"/>
+              </a:rPr>
+              <a:t> AI turns a video into a searchable, conversational knowledge base.</a:t>
             </a:r>
           </a:p>
         </p:txBody>
@@ -6638,6 +6592,7 @@
           <a:lstStyle/>
           <a:p>
             <a:pPr algn="ctr"/>
+            <a:endParaRPr/>
           </a:p>
         </p:txBody>
       </p:sp>
@@ -6681,6 +6636,7 @@
           <a:lstStyle/>
           <a:p>
             <a:pPr algn="ctr"/>
+            <a:endParaRPr/>
           </a:p>
         </p:txBody>
       </p:sp>
@@ -6796,6 +6752,7 @@
           <a:lstStyle/>
           <a:p>
             <a:pPr algn="ctr"/>
+            <a:endParaRPr/>
           </a:p>
         </p:txBody>
       </p:sp>
@@ -6839,6 +6796,7 @@
           <a:lstStyle/>
           <a:p>
             <a:pPr algn="ctr"/>
+            <a:endParaRPr/>
           </a:p>
         </p:txBody>
       </p:sp>
@@ -6954,6 +6912,7 @@
           <a:lstStyle/>
           <a:p>
             <a:pPr algn="ctr"/>
+            <a:endParaRPr/>
           </a:p>
         </p:txBody>
       </p:sp>
@@ -6997,6 +6956,7 @@
           <a:lstStyle/>
           <a:p>
             <a:pPr algn="ctr"/>
+            <a:endParaRPr/>
           </a:p>
         </p:txBody>
       </p:sp>
@@ -7079,7 +7039,7 @@
 </file>
 
 <file path=ppt/slides/slide3.xml><?xml version="1.0" encoding="utf-8"?>
-<p:sld xmlns:a="http://schemas.openxmlformats.org/drawingml/2006/main" xmlns:p="http://schemas.openxmlformats.org/presentationml/2006/main" xmlns:r="http://schemas.openxmlformats.org/officeDocument/2006/relationships">
+<p:sld xmlns:a="http://schemas.openxmlformats.org/drawingml/2006/main" xmlns:r="http://schemas.openxmlformats.org/officeDocument/2006/relationships" xmlns:p="http://schemas.openxmlformats.org/presentationml/2006/main">
   <p:cSld>
     <p:bg>
       <p:bgPr>
@@ -7095,7 +7055,14 @@
         <p:cNvGrpSpPr/>
         <p:nvPr/>
       </p:nvGrpSpPr>
-      <p:grpSpPr/>
+      <p:grpSpPr>
+        <a:xfrm>
+          <a:off x="0" y="0"/>
+          <a:ext cx="0" cy="0"/>
+          <a:chOff x="0" y="0"/>
+          <a:chExt cx="0" cy="0"/>
+        </a:xfrm>
+      </p:grpSpPr>
       <p:sp>
         <p:nvSpPr>
           <p:cNvPr id="2" name="Rounded Rectangle 1"/>
@@ -7136,6 +7103,7 @@
           <a:lstStyle/>
           <a:p>
             <a:pPr algn="ctr"/>
+            <a:endParaRPr/>
           </a:p>
         </p:txBody>
       </p:sp>
@@ -7179,6 +7147,7 @@
           <a:lstStyle/>
           <a:p>
             <a:pPr algn="ctr"/>
+            <a:endParaRPr/>
           </a:p>
         </p:txBody>
       </p:sp>
@@ -7222,6 +7191,7 @@
           <a:lstStyle/>
           <a:p>
             <a:pPr algn="ctr"/>
+            <a:endParaRPr/>
           </a:p>
         </p:txBody>
       </p:sp>
@@ -7338,7 +7308,7 @@
         </p:nvSpPr>
         <p:spPr>
           <a:xfrm>
-            <a:off x="640080" y="1920240"/>
+            <a:off x="640080" y="2616926"/>
             <a:ext cx="2057400" cy="1325880"/>
           </a:xfrm>
           <a:prstGeom prst="roundRect">
@@ -7372,6 +7342,7 @@
           <a:lstStyle/>
           <a:p>
             <a:pPr algn="ctr"/>
+            <a:endParaRPr/>
           </a:p>
         </p:txBody>
       </p:sp>
@@ -7383,7 +7354,7 @@
         </p:nvSpPr>
         <p:spPr>
           <a:xfrm>
-            <a:off x="804671" y="2084832"/>
+            <a:off x="804671" y="2781518"/>
             <a:ext cx="384048" cy="384048"/>
           </a:xfrm>
           <a:prstGeom prst="roundRect">
@@ -7415,6 +7386,7 @@
           <a:lstStyle/>
           <a:p>
             <a:pPr algn="ctr"/>
+            <a:endParaRPr/>
           </a:p>
         </p:txBody>
       </p:sp>
@@ -7426,7 +7398,7 @@
         </p:nvSpPr>
         <p:spPr>
           <a:xfrm>
-            <a:off x="905256" y="2167128"/>
+            <a:off x="905256" y="2863814"/>
             <a:ext cx="182880" cy="182880"/>
           </a:xfrm>
           <a:prstGeom prst="rect">
@@ -7461,7 +7433,7 @@
         </p:nvSpPr>
         <p:spPr>
           <a:xfrm>
-            <a:off x="1298448" y="2103120"/>
+            <a:off x="1298448" y="2799806"/>
             <a:ext cx="1234440" cy="228600"/>
           </a:xfrm>
           <a:prstGeom prst="rect">
@@ -7496,7 +7468,7 @@
         </p:nvSpPr>
         <p:spPr>
           <a:xfrm>
-            <a:off x="822959" y="2578608"/>
+            <a:off x="822959" y="3275294"/>
             <a:ext cx="1691640" cy="411480"/>
           </a:xfrm>
           <a:prstGeom prst="rect">
@@ -7531,7 +7503,7 @@
         </p:nvSpPr>
         <p:spPr>
           <a:xfrm>
-            <a:off x="2971800" y="1920240"/>
+            <a:off x="2971800" y="2616926"/>
             <a:ext cx="2057400" cy="1325880"/>
           </a:xfrm>
           <a:prstGeom prst="roundRect">
@@ -7565,6 +7537,7 @@
           <a:lstStyle/>
           <a:p>
             <a:pPr algn="ctr"/>
+            <a:endParaRPr/>
           </a:p>
         </p:txBody>
       </p:sp>
@@ -7576,7 +7549,7 @@
         </p:nvSpPr>
         <p:spPr>
           <a:xfrm>
-            <a:off x="3136392" y="2084832"/>
+            <a:off x="3136392" y="2781518"/>
             <a:ext cx="384048" cy="384048"/>
           </a:xfrm>
           <a:prstGeom prst="roundRect">
@@ -7608,6 +7581,7 @@
           <a:lstStyle/>
           <a:p>
             <a:pPr algn="ctr"/>
+            <a:endParaRPr/>
           </a:p>
         </p:txBody>
       </p:sp>
@@ -7619,7 +7593,7 @@
         </p:nvSpPr>
         <p:spPr>
           <a:xfrm>
-            <a:off x="3236976" y="2167128"/>
+            <a:off x="3236976" y="2863814"/>
             <a:ext cx="182880" cy="182880"/>
           </a:xfrm>
           <a:prstGeom prst="rect">
@@ -7654,7 +7628,7 @@
         </p:nvSpPr>
         <p:spPr>
           <a:xfrm>
-            <a:off x="3630168" y="2103120"/>
+            <a:off x="3630168" y="2799806"/>
             <a:ext cx="1234440" cy="228600"/>
           </a:xfrm>
           <a:prstGeom prst="rect">
@@ -7689,7 +7663,7 @@
         </p:nvSpPr>
         <p:spPr>
           <a:xfrm>
-            <a:off x="3154680" y="2578608"/>
+            <a:off x="3154680" y="3275294"/>
             <a:ext cx="1691640" cy="411480"/>
           </a:xfrm>
           <a:prstGeom prst="rect">
@@ -7724,7 +7698,7 @@
         </p:nvSpPr>
         <p:spPr>
           <a:xfrm>
-            <a:off x="5303520" y="1920240"/>
+            <a:off x="5303520" y="2616926"/>
             <a:ext cx="2057400" cy="1325880"/>
           </a:xfrm>
           <a:prstGeom prst="roundRect">
@@ -7758,6 +7732,7 @@
           <a:lstStyle/>
           <a:p>
             <a:pPr algn="ctr"/>
+            <a:endParaRPr/>
           </a:p>
         </p:txBody>
       </p:sp>
@@ -7769,7 +7744,7 @@
         </p:nvSpPr>
         <p:spPr>
           <a:xfrm>
-            <a:off x="5468112" y="2084832"/>
+            <a:off x="5468112" y="2781518"/>
             <a:ext cx="384048" cy="384048"/>
           </a:xfrm>
           <a:prstGeom prst="roundRect">
@@ -7801,6 +7776,7 @@
           <a:lstStyle/>
           <a:p>
             <a:pPr algn="ctr"/>
+            <a:endParaRPr/>
           </a:p>
         </p:txBody>
       </p:sp>
@@ -7812,7 +7788,7 @@
         </p:nvSpPr>
         <p:spPr>
           <a:xfrm>
-            <a:off x="5568696" y="2167128"/>
+            <a:off x="5568696" y="2863814"/>
             <a:ext cx="182880" cy="182880"/>
           </a:xfrm>
           <a:prstGeom prst="rect">
@@ -7847,7 +7823,7 @@
         </p:nvSpPr>
         <p:spPr>
           <a:xfrm>
-            <a:off x="5961888" y="2103120"/>
+            <a:off x="5961888" y="2799806"/>
             <a:ext cx="1234440" cy="228600"/>
           </a:xfrm>
           <a:prstGeom prst="rect">
@@ -7882,7 +7858,7 @@
         </p:nvSpPr>
         <p:spPr>
           <a:xfrm>
-            <a:off x="5486400" y="2578608"/>
+            <a:off x="5486400" y="3275294"/>
             <a:ext cx="1691640" cy="411480"/>
           </a:xfrm>
           <a:prstGeom prst="rect">
@@ -7917,7 +7893,7 @@
         </p:nvSpPr>
         <p:spPr>
           <a:xfrm>
-            <a:off x="7635240" y="1920240"/>
+            <a:off x="7635240" y="2616926"/>
             <a:ext cx="2057400" cy="1325880"/>
           </a:xfrm>
           <a:prstGeom prst="roundRect">
@@ -7951,6 +7927,7 @@
           <a:lstStyle/>
           <a:p>
             <a:pPr algn="ctr"/>
+            <a:endParaRPr/>
           </a:p>
         </p:txBody>
       </p:sp>
@@ -7962,7 +7939,7 @@
         </p:nvSpPr>
         <p:spPr>
           <a:xfrm>
-            <a:off x="7799831" y="2084832"/>
+            <a:off x="7799831" y="2781518"/>
             <a:ext cx="384048" cy="384048"/>
           </a:xfrm>
           <a:prstGeom prst="roundRect">
@@ -7994,6 +7971,7 @@
           <a:lstStyle/>
           <a:p>
             <a:pPr algn="ctr"/>
+            <a:endParaRPr/>
           </a:p>
         </p:txBody>
       </p:sp>
@@ -8005,7 +7983,7 @@
         </p:nvSpPr>
         <p:spPr>
           <a:xfrm>
-            <a:off x="7900415" y="2167128"/>
+            <a:off x="7900415" y="2863814"/>
             <a:ext cx="182880" cy="182880"/>
           </a:xfrm>
           <a:prstGeom prst="rect">
@@ -8040,7 +8018,7 @@
         </p:nvSpPr>
         <p:spPr>
           <a:xfrm>
-            <a:off x="8293608" y="2103120"/>
+            <a:off x="8293608" y="2799806"/>
             <a:ext cx="1234440" cy="228600"/>
           </a:xfrm>
           <a:prstGeom prst="rect">
@@ -8075,7 +8053,7 @@
         </p:nvSpPr>
         <p:spPr>
           <a:xfrm>
-            <a:off x="7818119" y="2578608"/>
+            <a:off x="7818119" y="3275294"/>
             <a:ext cx="1691640" cy="411480"/>
           </a:xfrm>
           <a:prstGeom prst="rect">
@@ -8110,7 +8088,7 @@
         </p:nvCxnSpPr>
         <p:spPr>
           <a:xfrm>
-            <a:off x="2724912" y="2578608"/>
+            <a:off x="2724912" y="3275294"/>
             <a:ext cx="201168" cy="0"/>
           </a:xfrm>
           <a:prstGeom prst="line">
@@ -8145,7 +8123,7 @@
         </p:nvCxnSpPr>
         <p:spPr>
           <a:xfrm>
-            <a:off x="5056632" y="2578608"/>
+            <a:off x="5056632" y="3275294"/>
             <a:ext cx="201168" cy="0"/>
           </a:xfrm>
           <a:prstGeom prst="line">
@@ -8180,7 +8158,7 @@
         </p:nvCxnSpPr>
         <p:spPr>
           <a:xfrm>
-            <a:off x="7388352" y="2578608"/>
+            <a:off x="7388352" y="3275294"/>
             <a:ext cx="201168" cy="0"/>
           </a:xfrm>
           <a:prstGeom prst="line">
@@ -8251,7 +8229,7 @@
 </file>
 
 <file path=ppt/slides/slide4.xml><?xml version="1.0" encoding="utf-8"?>
-<p:sld xmlns:a="http://schemas.openxmlformats.org/drawingml/2006/main" xmlns:p="http://schemas.openxmlformats.org/presentationml/2006/main" xmlns:r="http://schemas.openxmlformats.org/officeDocument/2006/relationships">
+<p:sld xmlns:a="http://schemas.openxmlformats.org/drawingml/2006/main" xmlns:r="http://schemas.openxmlformats.org/officeDocument/2006/relationships" xmlns:p="http://schemas.openxmlformats.org/presentationml/2006/main">
   <p:cSld>
     <p:bg>
       <p:bgPr>
@@ -8267,7 +8245,14 @@
         <p:cNvGrpSpPr/>
         <p:nvPr/>
       </p:nvGrpSpPr>
-      <p:grpSpPr/>
+      <p:grpSpPr>
+        <a:xfrm>
+          <a:off x="0" y="0"/>
+          <a:ext cx="0" cy="0"/>
+          <a:chOff x="0" y="0"/>
+          <a:chExt cx="0" cy="0"/>
+        </a:xfrm>
+      </p:grpSpPr>
       <p:sp>
         <p:nvSpPr>
           <p:cNvPr id="2" name="Rounded Rectangle 1"/>
@@ -8308,6 +8293,7 @@
           <a:lstStyle/>
           <a:p>
             <a:pPr algn="ctr"/>
+            <a:endParaRPr/>
           </a:p>
         </p:txBody>
       </p:sp>
@@ -8351,6 +8337,7 @@
           <a:lstStyle/>
           <a:p>
             <a:pPr algn="ctr"/>
+            <a:endParaRPr/>
           </a:p>
         </p:txBody>
       </p:sp>
@@ -8394,6 +8381,7 @@
           <a:lstStyle/>
           <a:p>
             <a:pPr algn="ctr"/>
+            <a:endParaRPr/>
           </a:p>
         </p:txBody>
       </p:sp>
@@ -8510,7 +8498,7 @@
         </p:nvSpPr>
         <p:spPr>
           <a:xfrm>
-            <a:off x="685800" y="1874519"/>
+            <a:off x="685800" y="2266405"/>
             <a:ext cx="3154680" cy="2057400"/>
           </a:xfrm>
           <a:prstGeom prst="roundRect">
@@ -8544,6 +8532,7 @@
           <a:lstStyle/>
           <a:p>
             <a:pPr algn="ctr"/>
+            <a:endParaRPr/>
           </a:p>
         </p:txBody>
       </p:sp>
@@ -8555,7 +8544,7 @@
         </p:nvSpPr>
         <p:spPr>
           <a:xfrm>
-            <a:off x="685800" y="1874519"/>
+            <a:off x="685800" y="2266405"/>
             <a:ext cx="73152" cy="2057400"/>
           </a:xfrm>
           <a:prstGeom prst="rect">
@@ -8587,6 +8576,7 @@
           <a:lstStyle/>
           <a:p>
             <a:pPr algn="ctr"/>
+            <a:endParaRPr/>
           </a:p>
         </p:txBody>
       </p:sp>
@@ -8598,7 +8588,7 @@
         </p:nvSpPr>
         <p:spPr>
           <a:xfrm>
-            <a:off x="886968" y="2039112"/>
+            <a:off x="886968" y="2430998"/>
             <a:ext cx="2834640" cy="228600"/>
           </a:xfrm>
           <a:prstGeom prst="rect">
@@ -8633,7 +8623,7 @@
         </p:nvSpPr>
         <p:spPr>
           <a:xfrm>
-            <a:off x="886968" y="2377439"/>
+            <a:off x="886968" y="2769325"/>
             <a:ext cx="2834640" cy="1417320"/>
           </a:xfrm>
           <a:prstGeom prst="rect">
@@ -8668,7 +8658,7 @@
         </p:nvSpPr>
         <p:spPr>
           <a:xfrm>
-            <a:off x="4526280" y="1874519"/>
+            <a:off x="4526280" y="2266405"/>
             <a:ext cx="3154680" cy="2057400"/>
           </a:xfrm>
           <a:prstGeom prst="roundRect">
@@ -8702,6 +8692,7 @@
           <a:lstStyle/>
           <a:p>
             <a:pPr algn="ctr"/>
+            <a:endParaRPr/>
           </a:p>
         </p:txBody>
       </p:sp>
@@ -8713,7 +8704,7 @@
         </p:nvSpPr>
         <p:spPr>
           <a:xfrm>
-            <a:off x="4526280" y="1874519"/>
+            <a:off x="4526280" y="2266405"/>
             <a:ext cx="73152" cy="2057400"/>
           </a:xfrm>
           <a:prstGeom prst="rect">
@@ -8745,6 +8736,7 @@
           <a:lstStyle/>
           <a:p>
             <a:pPr algn="ctr"/>
+            <a:endParaRPr/>
           </a:p>
         </p:txBody>
       </p:sp>
@@ -8756,7 +8748,7 @@
         </p:nvSpPr>
         <p:spPr>
           <a:xfrm>
-            <a:off x="4727448" y="2039112"/>
+            <a:off x="4727448" y="2430998"/>
             <a:ext cx="2834640" cy="228600"/>
           </a:xfrm>
           <a:prstGeom prst="rect">
@@ -8791,7 +8783,7 @@
         </p:nvSpPr>
         <p:spPr>
           <a:xfrm>
-            <a:off x="4727448" y="2377439"/>
+            <a:off x="4727448" y="2769325"/>
             <a:ext cx="2834640" cy="1417320"/>
           </a:xfrm>
           <a:prstGeom prst="rect">
@@ -8826,7 +8818,7 @@
         </p:nvSpPr>
         <p:spPr>
           <a:xfrm>
-            <a:off x="8366760" y="1874519"/>
+            <a:off x="8366760" y="2266405"/>
             <a:ext cx="3154680" cy="2057400"/>
           </a:xfrm>
           <a:prstGeom prst="roundRect">
@@ -8860,6 +8852,7 @@
           <a:lstStyle/>
           <a:p>
             <a:pPr algn="ctr"/>
+            <a:endParaRPr/>
           </a:p>
         </p:txBody>
       </p:sp>
@@ -8871,7 +8864,7 @@
         </p:nvSpPr>
         <p:spPr>
           <a:xfrm>
-            <a:off x="8366760" y="1874519"/>
+            <a:off x="8366760" y="2266405"/>
             <a:ext cx="73152" cy="2057400"/>
           </a:xfrm>
           <a:prstGeom prst="rect">
@@ -8903,6 +8896,7 @@
           <a:lstStyle/>
           <a:p>
             <a:pPr algn="ctr"/>
+            <a:endParaRPr/>
           </a:p>
         </p:txBody>
       </p:sp>
@@ -8914,7 +8908,7 @@
         </p:nvSpPr>
         <p:spPr>
           <a:xfrm>
-            <a:off x="8567928" y="2039112"/>
+            <a:off x="8567928" y="2430998"/>
             <a:ext cx="2834640" cy="228600"/>
           </a:xfrm>
           <a:prstGeom prst="rect">
@@ -8949,7 +8943,7 @@
         </p:nvSpPr>
         <p:spPr>
           <a:xfrm>
-            <a:off x="8567928" y="2377439"/>
+            <a:off x="8567928" y="2769325"/>
             <a:ext cx="2834640" cy="1417320"/>
           </a:xfrm>
           <a:prstGeom prst="rect">
@@ -8984,7 +8978,7 @@
         </p:nvCxnSpPr>
         <p:spPr>
           <a:xfrm>
-            <a:off x="3840480" y="2880360"/>
+            <a:off x="3840480" y="3272246"/>
             <a:ext cx="640080" cy="0"/>
           </a:xfrm>
           <a:prstGeom prst="line">
@@ -9019,7 +9013,7 @@
         </p:nvCxnSpPr>
         <p:spPr>
           <a:xfrm>
-            <a:off x="7680960" y="2880360"/>
+            <a:off x="7680960" y="3272246"/>
             <a:ext cx="640080" cy="0"/>
           </a:xfrm>
           <a:prstGeom prst="line">
@@ -9090,7 +9084,7 @@
 </file>
 
 <file path=ppt/slides/slide5.xml><?xml version="1.0" encoding="utf-8"?>
-<p:sld xmlns:a="http://schemas.openxmlformats.org/drawingml/2006/main" xmlns:p="http://schemas.openxmlformats.org/presentationml/2006/main" xmlns:r="http://schemas.openxmlformats.org/officeDocument/2006/relationships">
+<p:sld xmlns:a="http://schemas.openxmlformats.org/drawingml/2006/main" xmlns:r="http://schemas.openxmlformats.org/officeDocument/2006/relationships" xmlns:p="http://schemas.openxmlformats.org/presentationml/2006/main">
   <p:cSld>
     <p:bg>
       <p:bgPr>
@@ -9106,7 +9100,14 @@
         <p:cNvGrpSpPr/>
         <p:nvPr/>
       </p:nvGrpSpPr>
-      <p:grpSpPr/>
+      <p:grpSpPr>
+        <a:xfrm>
+          <a:off x="0" y="0"/>
+          <a:ext cx="0" cy="0"/>
+          <a:chOff x="0" y="0"/>
+          <a:chExt cx="0" cy="0"/>
+        </a:xfrm>
+      </p:grpSpPr>
       <p:sp>
         <p:nvSpPr>
           <p:cNvPr id="2" name="Rounded Rectangle 1"/>
@@ -9147,6 +9148,7 @@
           <a:lstStyle/>
           <a:p>
             <a:pPr algn="ctr"/>
+            <a:endParaRPr/>
           </a:p>
         </p:txBody>
       </p:sp>
@@ -9190,6 +9192,7 @@
           <a:lstStyle/>
           <a:p>
             <a:pPr algn="ctr"/>
+            <a:endParaRPr/>
           </a:p>
         </p:txBody>
       </p:sp>
@@ -9233,6 +9236,7 @@
           <a:lstStyle/>
           <a:p>
             <a:pPr algn="ctr"/>
+            <a:endParaRPr/>
           </a:p>
         </p:txBody>
       </p:sp>
@@ -9350,7 +9354,7 @@
         <p:spPr>
           <a:xfrm>
             <a:off x="777240" y="1828800"/>
-            <a:ext cx="6035040" cy="3474720"/>
+            <a:ext cx="6565392" cy="2966646"/>
           </a:xfrm>
           <a:prstGeom prst="rect">
             <a:avLst/>
@@ -9372,7 +9376,7 @@
               </a:spcAft>
             </a:pPr>
             <a:r>
-              <a:rPr sz="1700" b="1">
+              <a:rPr sz="1700" b="1" dirty="0">
                 <a:solidFill>
                   <a:srgbClr val="FBBF24"/>
                 </a:solidFill>
@@ -9381,7 +9385,7 @@
               <a:t>- </a:t>
             </a:r>
             <a:r>
-              <a:rPr sz="1700">
+              <a:rPr sz="1700" dirty="0">
                 <a:solidFill>
                   <a:srgbClr val="F6F8FF"/>
                 </a:solidFill>
@@ -9400,7 +9404,7 @@
               </a:spcAft>
             </a:pPr>
             <a:r>
-              <a:rPr sz="1700" b="1">
+              <a:rPr sz="1700" b="1" dirty="0">
                 <a:solidFill>
                   <a:srgbClr val="FBBF24"/>
                 </a:solidFill>
@@ -9409,13 +9413,40 @@
               <a:t>- </a:t>
             </a:r>
             <a:r>
-              <a:rPr sz="1700">
+              <a:rPr sz="1700" dirty="0" err="1">
                 <a:solidFill>
                   <a:srgbClr val="F6F8FF"/>
                 </a:solidFill>
                 <a:latin typeface="Aptos"/>
               </a:rPr>
-              <a:t>youtube-transcript-api is the primary source for public captions and timestamps.</a:t>
+              <a:t>youtube</a:t>
+            </a:r>
+            <a:r>
+              <a:rPr sz="1700" dirty="0">
+                <a:solidFill>
+                  <a:srgbClr val="F6F8FF"/>
+                </a:solidFill>
+                <a:latin typeface="Aptos"/>
+              </a:rPr>
+              <a:t>-transcript-</a:t>
+            </a:r>
+            <a:r>
+              <a:rPr sz="1700" dirty="0" err="1">
+                <a:solidFill>
+                  <a:srgbClr val="F6F8FF"/>
+                </a:solidFill>
+                <a:latin typeface="Aptos"/>
+              </a:rPr>
+              <a:t>api</a:t>
+            </a:r>
+            <a:r>
+              <a:rPr sz="1700" dirty="0">
+                <a:solidFill>
+                  <a:srgbClr val="F6F8FF"/>
+                </a:solidFill>
+                <a:latin typeface="Aptos"/>
+              </a:rPr>
+              <a:t> is the primary source for public captions and timestamps.</a:t>
             </a:r>
           </a:p>
           <a:p>
@@ -9428,7 +9459,7 @@
               </a:spcAft>
             </a:pPr>
             <a:r>
-              <a:rPr sz="1700" b="1">
+              <a:rPr sz="1700" b="1" dirty="0">
                 <a:solidFill>
                   <a:srgbClr val="FBBF24"/>
                 </a:solidFill>
@@ -9437,7 +9468,7 @@
               <a:t>- </a:t>
             </a:r>
             <a:r>
-              <a:rPr sz="1700">
+              <a:rPr sz="1700" dirty="0">
                 <a:solidFill>
                   <a:srgbClr val="F6F8FF"/>
                 </a:solidFill>
@@ -9456,7 +9487,7 @@
               </a:spcAft>
             </a:pPr>
             <a:r>
-              <a:rPr sz="1700" b="1">
+              <a:rPr sz="1700" b="1" dirty="0">
                 <a:solidFill>
                   <a:srgbClr val="FBBF24"/>
                 </a:solidFill>
@@ -9465,13 +9496,22 @@
               <a:t>- </a:t>
             </a:r>
             <a:r>
-              <a:rPr sz="1700">
+              <a:rPr sz="1700" dirty="0" err="1">
                 <a:solidFill>
                   <a:srgbClr val="F6F8FF"/>
                 </a:solidFill>
                 <a:latin typeface="Aptos"/>
               </a:rPr>
-              <a:t>LangChain chunking keeps timestamp metadata attached to every chunk.</a:t>
+              <a:t>LangChain</a:t>
+            </a:r>
+            <a:r>
+              <a:rPr sz="1700" dirty="0">
+                <a:solidFill>
+                  <a:srgbClr val="F6F8FF"/>
+                </a:solidFill>
+                <a:latin typeface="Aptos"/>
+              </a:rPr>
+              <a:t> chunking keeps timestamp metadata attached to every chunk.</a:t>
             </a:r>
           </a:p>
           <a:p>
@@ -9484,7 +9524,7 @@
               </a:spcAft>
             </a:pPr>
             <a:r>
-              <a:rPr sz="1700" b="1">
+              <a:rPr sz="1700" b="1" dirty="0">
                 <a:solidFill>
                   <a:srgbClr val="FBBF24"/>
                 </a:solidFill>
@@ -9493,13 +9533,31 @@
               <a:t>- </a:t>
             </a:r>
             <a:r>
-              <a:rPr sz="1700">
+              <a:rPr sz="1700" dirty="0">
                 <a:solidFill>
                   <a:srgbClr val="F6F8FF"/>
                 </a:solidFill>
                 <a:latin typeface="Aptos"/>
               </a:rPr>
-              <a:t>OpenAI embeddings are stored in ChromaDB for similarity search.</a:t>
+              <a:t>OpenAI embeddings are stored in </a:t>
+            </a:r>
+            <a:r>
+              <a:rPr sz="1700" dirty="0" err="1">
+                <a:solidFill>
+                  <a:srgbClr val="F6F8FF"/>
+                </a:solidFill>
+                <a:latin typeface="Aptos"/>
+              </a:rPr>
+              <a:t>ChromaDB</a:t>
+            </a:r>
+            <a:r>
+              <a:rPr sz="1700" dirty="0">
+                <a:solidFill>
+                  <a:srgbClr val="F6F8FF"/>
+                </a:solidFill>
+                <a:latin typeface="Aptos"/>
+              </a:rPr>
+              <a:t> for similarity search.</a:t>
             </a:r>
           </a:p>
         </p:txBody>
@@ -9546,6 +9604,7 @@
           <a:lstStyle/>
           <a:p>
             <a:pPr algn="ctr"/>
+            <a:endParaRPr/>
           </a:p>
         </p:txBody>
       </p:sp>
@@ -9608,7 +9667,7 @@
           <a:p>
             <a:pPr algn="l"/>
             <a:r>
-              <a:rPr sz="1900" b="0">
+              <a:rPr sz="1900" b="0" dirty="0">
                 <a:solidFill>
                   <a:srgbClr val="F6F8FF"/>
                 </a:solidFill>
@@ -9618,7 +9677,25 @@
 transcript
 chunking
 embeddings
-vector_storage
+</a:t>
+            </a:r>
+            <a:r>
+              <a:rPr sz="1900" b="0" dirty="0" err="1">
+                <a:solidFill>
+                  <a:srgbClr val="F6F8FF"/>
+                </a:solidFill>
+                <a:latin typeface="Aptos"/>
+              </a:rPr>
+              <a:t>vector_storage</a:t>
+            </a:r>
+            <a:r>
+              <a:rPr sz="1900" b="0" dirty="0">
+                <a:solidFill>
+                  <a:srgbClr val="F6F8FF"/>
+                </a:solidFill>
+                <a:latin typeface="Aptos"/>
+              </a:rPr>
+              <a:t>
 ready / error</a:t>
             </a:r>
           </a:p>
@@ -9668,7 +9745,7 @@
 </file>
 
 <file path=ppt/slides/slide6.xml><?xml version="1.0" encoding="utf-8"?>
-<p:sld xmlns:a="http://schemas.openxmlformats.org/drawingml/2006/main" xmlns:p="http://schemas.openxmlformats.org/presentationml/2006/main" xmlns:r="http://schemas.openxmlformats.org/officeDocument/2006/relationships">
+<p:sld xmlns:a="http://schemas.openxmlformats.org/drawingml/2006/main" xmlns:r="http://schemas.openxmlformats.org/officeDocument/2006/relationships" xmlns:p="http://schemas.openxmlformats.org/presentationml/2006/main">
   <p:cSld>
     <p:bg>
       <p:bgPr>
@@ -9684,7 +9761,14 @@
         <p:cNvGrpSpPr/>
         <p:nvPr/>
       </p:nvGrpSpPr>
-      <p:grpSpPr/>
+      <p:grpSpPr>
+        <a:xfrm>
+          <a:off x="0" y="0"/>
+          <a:ext cx="0" cy="0"/>
+          <a:chOff x="0" y="0"/>
+          <a:chExt cx="0" cy="0"/>
+        </a:xfrm>
+      </p:grpSpPr>
       <p:sp>
         <p:nvSpPr>
           <p:cNvPr id="2" name="Rounded Rectangle 1"/>
@@ -9725,6 +9809,7 @@
           <a:lstStyle/>
           <a:p>
             <a:pPr algn="ctr"/>
+            <a:endParaRPr/>
           </a:p>
         </p:txBody>
       </p:sp>
@@ -9768,6 +9853,7 @@
           <a:lstStyle/>
           <a:p>
             <a:pPr algn="ctr"/>
+            <a:endParaRPr/>
           </a:p>
         </p:txBody>
       </p:sp>
@@ -9811,6 +9897,7 @@
           <a:lstStyle/>
           <a:p>
             <a:pPr algn="ctr"/>
+            <a:endParaRPr/>
           </a:p>
         </p:txBody>
       </p:sp>
@@ -9927,7 +10014,7 @@
         </p:nvSpPr>
         <p:spPr>
           <a:xfrm>
-            <a:off x="658368" y="1600200"/>
+            <a:off x="658368" y="1926771"/>
             <a:ext cx="9875520" cy="329184"/>
           </a:xfrm>
           <a:prstGeom prst="rect">
@@ -9943,13 +10030,58 @@
           <a:p>
             <a:pPr algn="l"/>
             <a:r>
-              <a:rPr sz="1600" b="0">
+              <a:rPr sz="1600" b="0" dirty="0" err="1">
                 <a:solidFill>
                   <a:srgbClr val="94A3B8"/>
                 </a:solidFill>
                 <a:latin typeface="Aptos"/>
               </a:rPr>
-              <a:t>AgentService binds StructuredTool objects to the LLM and returns answer, citations, tool steps, and session_id.</a:t>
+              <a:t>AgentService</a:t>
+            </a:r>
+            <a:r>
+              <a:rPr sz="1600" b="0" dirty="0">
+                <a:solidFill>
+                  <a:srgbClr val="94A3B8"/>
+                </a:solidFill>
+                <a:latin typeface="Aptos"/>
+              </a:rPr>
+              <a:t> binds </a:t>
+            </a:r>
+            <a:r>
+              <a:rPr sz="1600" b="0" dirty="0" err="1">
+                <a:solidFill>
+                  <a:srgbClr val="94A3B8"/>
+                </a:solidFill>
+                <a:latin typeface="Aptos"/>
+              </a:rPr>
+              <a:t>StructuredTool</a:t>
+            </a:r>
+            <a:r>
+              <a:rPr sz="1600" b="0" dirty="0">
+                <a:solidFill>
+                  <a:srgbClr val="94A3B8"/>
+                </a:solidFill>
+                <a:latin typeface="Aptos"/>
+              </a:rPr>
+              <a:t> objects to the LLM and returns answer, citations, tool steps, and </a:t>
+            </a:r>
+            <a:r>
+              <a:rPr sz="1600" b="0" dirty="0" err="1">
+                <a:solidFill>
+                  <a:srgbClr val="94A3B8"/>
+                </a:solidFill>
+                <a:latin typeface="Aptos"/>
+              </a:rPr>
+              <a:t>session_id</a:t>
+            </a:r>
+            <a:r>
+              <a:rPr sz="1600" b="0" dirty="0">
+                <a:solidFill>
+                  <a:srgbClr val="94A3B8"/>
+                </a:solidFill>
+                <a:latin typeface="Aptos"/>
+              </a:rPr>
+              <a:t>.</a:t>
             </a:r>
           </a:p>
         </p:txBody>
@@ -9962,7 +10094,7 @@
         </p:nvSpPr>
         <p:spPr>
           <a:xfrm>
-            <a:off x="777240" y="2148840"/>
+            <a:off x="777240" y="2399215"/>
             <a:ext cx="2880360" cy="438912"/>
           </a:xfrm>
           <a:prstGeom prst="roundRect">
@@ -9996,6 +10128,7 @@
           <a:lstStyle/>
           <a:p>
             <a:pPr algn="ctr"/>
+            <a:endParaRPr/>
           </a:p>
         </p:txBody>
       </p:sp>
@@ -10007,7 +10140,7 @@
         </p:nvSpPr>
         <p:spPr>
           <a:xfrm>
-            <a:off x="960120" y="2258568"/>
+            <a:off x="960120" y="2508943"/>
             <a:ext cx="2514600" cy="201168"/>
           </a:xfrm>
           <a:prstGeom prst="rect">
@@ -10042,7 +10175,7 @@
         </p:nvSpPr>
         <p:spPr>
           <a:xfrm>
-            <a:off x="4023359" y="2148840"/>
+            <a:off x="4023359" y="2399215"/>
             <a:ext cx="2880360" cy="438912"/>
           </a:xfrm>
           <a:prstGeom prst="roundRect">
@@ -10076,6 +10209,7 @@
           <a:lstStyle/>
           <a:p>
             <a:pPr algn="ctr"/>
+            <a:endParaRPr/>
           </a:p>
         </p:txBody>
       </p:sp>
@@ -10087,7 +10221,7 @@
         </p:nvSpPr>
         <p:spPr>
           <a:xfrm>
-            <a:off x="4206240" y="2258568"/>
+            <a:off x="4206240" y="2508943"/>
             <a:ext cx="2514600" cy="201168"/>
           </a:xfrm>
           <a:prstGeom prst="rect">
@@ -10122,7 +10256,7 @@
         </p:nvSpPr>
         <p:spPr>
           <a:xfrm>
-            <a:off x="777240" y="2807208"/>
+            <a:off x="777240" y="3057583"/>
             <a:ext cx="2880360" cy="438912"/>
           </a:xfrm>
           <a:prstGeom prst="roundRect">
@@ -10156,6 +10290,7 @@
           <a:lstStyle/>
           <a:p>
             <a:pPr algn="ctr"/>
+            <a:endParaRPr/>
           </a:p>
         </p:txBody>
       </p:sp>
@@ -10167,7 +10302,7 @@
         </p:nvSpPr>
         <p:spPr>
           <a:xfrm>
-            <a:off x="960120" y="2916936"/>
+            <a:off x="960120" y="3167311"/>
             <a:ext cx="2514600" cy="201168"/>
           </a:xfrm>
           <a:prstGeom prst="rect">
@@ -10202,7 +10337,7 @@
         </p:nvSpPr>
         <p:spPr>
           <a:xfrm>
-            <a:off x="4023359" y="2807208"/>
+            <a:off x="4023359" y="3057583"/>
             <a:ext cx="2880360" cy="438912"/>
           </a:xfrm>
           <a:prstGeom prst="roundRect">
@@ -10236,6 +10371,7 @@
           <a:lstStyle/>
           <a:p>
             <a:pPr algn="ctr"/>
+            <a:endParaRPr/>
           </a:p>
         </p:txBody>
       </p:sp>
@@ -10247,7 +10383,7 @@
         </p:nvSpPr>
         <p:spPr>
           <a:xfrm>
-            <a:off x="4206240" y="2916936"/>
+            <a:off x="4206240" y="3167311"/>
             <a:ext cx="2514600" cy="201168"/>
           </a:xfrm>
           <a:prstGeom prst="rect">
@@ -10282,7 +10418,7 @@
         </p:nvSpPr>
         <p:spPr>
           <a:xfrm>
-            <a:off x="777240" y="3465576"/>
+            <a:off x="777240" y="3715951"/>
             <a:ext cx="2880360" cy="438912"/>
           </a:xfrm>
           <a:prstGeom prst="roundRect">
@@ -10316,6 +10452,7 @@
           <a:lstStyle/>
           <a:p>
             <a:pPr algn="ctr"/>
+            <a:endParaRPr/>
           </a:p>
         </p:txBody>
       </p:sp>
@@ -10327,7 +10464,7 @@
         </p:nvSpPr>
         <p:spPr>
           <a:xfrm>
-            <a:off x="960120" y="3575304"/>
+            <a:off x="960120" y="3825679"/>
             <a:ext cx="2514600" cy="201168"/>
           </a:xfrm>
           <a:prstGeom prst="rect">
@@ -10362,7 +10499,7 @@
         </p:nvSpPr>
         <p:spPr>
           <a:xfrm>
-            <a:off x="4023359" y="3465576"/>
+            <a:off x="4023359" y="3715951"/>
             <a:ext cx="2880360" cy="438912"/>
           </a:xfrm>
           <a:prstGeom prst="roundRect">
@@ -10396,6 +10533,7 @@
           <a:lstStyle/>
           <a:p>
             <a:pPr algn="ctr"/>
+            <a:endParaRPr/>
           </a:p>
         </p:txBody>
       </p:sp>
@@ -10407,7 +10545,7 @@
         </p:nvSpPr>
         <p:spPr>
           <a:xfrm>
-            <a:off x="4206240" y="3575304"/>
+            <a:off x="4206240" y="3825679"/>
             <a:ext cx="2514600" cy="201168"/>
           </a:xfrm>
           <a:prstGeom prst="rect">
@@ -10442,7 +10580,7 @@
         </p:nvSpPr>
         <p:spPr>
           <a:xfrm>
-            <a:off x="777240" y="4123944"/>
+            <a:off x="777240" y="4374319"/>
             <a:ext cx="2880360" cy="438912"/>
           </a:xfrm>
           <a:prstGeom prst="roundRect">
@@ -10476,6 +10614,7 @@
           <a:lstStyle/>
           <a:p>
             <a:pPr algn="ctr"/>
+            <a:endParaRPr/>
           </a:p>
         </p:txBody>
       </p:sp>
@@ -10487,7 +10626,7 @@
         </p:nvSpPr>
         <p:spPr>
           <a:xfrm>
-            <a:off x="960120" y="4233672"/>
+            <a:off x="960120" y="4484047"/>
             <a:ext cx="2514600" cy="201168"/>
           </a:xfrm>
           <a:prstGeom prst="rect">
@@ -10556,6 +10695,7 @@
           <a:lstStyle/>
           <a:p>
             <a:pPr algn="ctr"/>
+            <a:endParaRPr/>
           </a:p>
         </p:txBody>
       </p:sp>
@@ -10599,6 +10739,7 @@
           <a:lstStyle/>
           <a:p>
             <a:pPr algn="ctr"/>
+            <a:endParaRPr/>
           </a:p>
         </p:txBody>
       </p:sp>
@@ -10714,6 +10855,7 @@
           <a:lstStyle/>
           <a:p>
             <a:pPr algn="ctr"/>
+            <a:endParaRPr/>
           </a:p>
         </p:txBody>
       </p:sp>
@@ -10757,6 +10899,7 @@
           <a:lstStyle/>
           <a:p>
             <a:pPr algn="ctr"/>
+            <a:endParaRPr/>
           </a:p>
         </p:txBody>
       </p:sp>
@@ -10839,7 +10982,7 @@
 </file>
 
 <file path=ppt/slides/slide7.xml><?xml version="1.0" encoding="utf-8"?>
-<p:sld xmlns:a="http://schemas.openxmlformats.org/drawingml/2006/main" xmlns:p="http://schemas.openxmlformats.org/presentationml/2006/main" xmlns:r="http://schemas.openxmlformats.org/officeDocument/2006/relationships">
+<p:sld xmlns:a="http://schemas.openxmlformats.org/drawingml/2006/main" xmlns:r="http://schemas.openxmlformats.org/officeDocument/2006/relationships" xmlns:p="http://schemas.openxmlformats.org/presentationml/2006/main">
   <p:cSld>
     <p:bg>
       <p:bgPr>
@@ -10855,7 +10998,14 @@
         <p:cNvGrpSpPr/>
         <p:nvPr/>
       </p:nvGrpSpPr>
-      <p:grpSpPr/>
+      <p:grpSpPr>
+        <a:xfrm>
+          <a:off x="0" y="0"/>
+          <a:ext cx="0" cy="0"/>
+          <a:chOff x="0" y="0"/>
+          <a:chExt cx="0" cy="0"/>
+        </a:xfrm>
+      </p:grpSpPr>
       <p:sp>
         <p:nvSpPr>
           <p:cNvPr id="2" name="Rounded Rectangle 1"/>
@@ -10896,6 +11046,7 @@
           <a:lstStyle/>
           <a:p>
             <a:pPr algn="ctr"/>
+            <a:endParaRPr/>
           </a:p>
         </p:txBody>
       </p:sp>
@@ -10939,6 +11090,7 @@
           <a:lstStyle/>
           <a:p>
             <a:pPr algn="ctr"/>
+            <a:endParaRPr/>
           </a:p>
         </p:txBody>
       </p:sp>
@@ -10982,6 +11134,7 @@
           <a:lstStyle/>
           <a:p>
             <a:pPr algn="ctr"/>
+            <a:endParaRPr/>
           </a:p>
         </p:txBody>
       </p:sp>
@@ -11098,7 +11251,7 @@
         </p:nvSpPr>
         <p:spPr>
           <a:xfrm>
-            <a:off x="777240" y="2011680"/>
+            <a:off x="777240" y="2708366"/>
             <a:ext cx="2057400" cy="1325880"/>
           </a:xfrm>
           <a:prstGeom prst="roundRect">
@@ -11132,6 +11285,7 @@
           <a:lstStyle/>
           <a:p>
             <a:pPr algn="ctr"/>
+            <a:endParaRPr/>
           </a:p>
         </p:txBody>
       </p:sp>
@@ -11143,7 +11297,7 @@
         </p:nvSpPr>
         <p:spPr>
           <a:xfrm>
-            <a:off x="941832" y="2176272"/>
+            <a:off x="941832" y="2872958"/>
             <a:ext cx="384048" cy="384048"/>
           </a:xfrm>
           <a:prstGeom prst="roundRect">
@@ -11175,6 +11329,7 @@
           <a:lstStyle/>
           <a:p>
             <a:pPr algn="ctr"/>
+            <a:endParaRPr/>
           </a:p>
         </p:txBody>
       </p:sp>
@@ -11186,7 +11341,7 @@
         </p:nvSpPr>
         <p:spPr>
           <a:xfrm>
-            <a:off x="1042415" y="2258568"/>
+            <a:off x="1042415" y="2955254"/>
             <a:ext cx="182880" cy="182880"/>
           </a:xfrm>
           <a:prstGeom prst="rect">
@@ -11221,7 +11376,7 @@
         </p:nvSpPr>
         <p:spPr>
           <a:xfrm>
-            <a:off x="1435607" y="2194560"/>
+            <a:off x="1435607" y="2891246"/>
             <a:ext cx="1234440" cy="228600"/>
           </a:xfrm>
           <a:prstGeom prst="rect">
@@ -11256,7 +11411,7 @@
         </p:nvSpPr>
         <p:spPr>
           <a:xfrm>
-            <a:off x="960120" y="2670048"/>
+            <a:off x="960120" y="3366734"/>
             <a:ext cx="1691640" cy="411480"/>
           </a:xfrm>
           <a:prstGeom prst="rect">
@@ -11291,7 +11446,7 @@
         </p:nvSpPr>
         <p:spPr>
           <a:xfrm>
-            <a:off x="3246120" y="2011680"/>
+            <a:off x="3246120" y="2708366"/>
             <a:ext cx="2057400" cy="1325880"/>
           </a:xfrm>
           <a:prstGeom prst="roundRect">
@@ -11325,6 +11480,7 @@
           <a:lstStyle/>
           <a:p>
             <a:pPr algn="ctr"/>
+            <a:endParaRPr/>
           </a:p>
         </p:txBody>
       </p:sp>
@@ -11336,7 +11492,7 @@
         </p:nvSpPr>
         <p:spPr>
           <a:xfrm>
-            <a:off x="3410712" y="2176272"/>
+            <a:off x="3410712" y="2872958"/>
             <a:ext cx="384048" cy="384048"/>
           </a:xfrm>
           <a:prstGeom prst="roundRect">
@@ -11368,6 +11524,7 @@
           <a:lstStyle/>
           <a:p>
             <a:pPr algn="ctr"/>
+            <a:endParaRPr/>
           </a:p>
         </p:txBody>
       </p:sp>
@@ -11379,7 +11536,7 @@
         </p:nvSpPr>
         <p:spPr>
           <a:xfrm>
-            <a:off x="3511296" y="2258568"/>
+            <a:off x="3511296" y="2955254"/>
             <a:ext cx="182880" cy="182880"/>
           </a:xfrm>
           <a:prstGeom prst="rect">
@@ -11414,7 +11571,7 @@
         </p:nvSpPr>
         <p:spPr>
           <a:xfrm>
-            <a:off x="3904487" y="2194560"/>
+            <a:off x="3904487" y="2891246"/>
             <a:ext cx="1234440" cy="228600"/>
           </a:xfrm>
           <a:prstGeom prst="rect">
@@ -11449,7 +11606,7 @@
         </p:nvSpPr>
         <p:spPr>
           <a:xfrm>
-            <a:off x="3429000" y="2670048"/>
+            <a:off x="3429000" y="3366734"/>
             <a:ext cx="1691640" cy="411480"/>
           </a:xfrm>
           <a:prstGeom prst="rect">
@@ -11484,7 +11641,7 @@
         </p:nvSpPr>
         <p:spPr>
           <a:xfrm>
-            <a:off x="5715000" y="2011680"/>
+            <a:off x="5715000" y="2708366"/>
             <a:ext cx="2057400" cy="1325880"/>
           </a:xfrm>
           <a:prstGeom prst="roundRect">
@@ -11518,6 +11675,7 @@
           <a:lstStyle/>
           <a:p>
             <a:pPr algn="ctr"/>
+            <a:endParaRPr/>
           </a:p>
         </p:txBody>
       </p:sp>
@@ -11529,7 +11687,7 @@
         </p:nvSpPr>
         <p:spPr>
           <a:xfrm>
-            <a:off x="5879592" y="2176272"/>
+            <a:off x="5879592" y="2872958"/>
             <a:ext cx="384048" cy="384048"/>
           </a:xfrm>
           <a:prstGeom prst="roundRect">
@@ -11561,6 +11719,7 @@
           <a:lstStyle/>
           <a:p>
             <a:pPr algn="ctr"/>
+            <a:endParaRPr/>
           </a:p>
         </p:txBody>
       </p:sp>
@@ -11572,7 +11731,7 @@
         </p:nvSpPr>
         <p:spPr>
           <a:xfrm>
-            <a:off x="5980176" y="2258568"/>
+            <a:off x="5980176" y="2955254"/>
             <a:ext cx="182880" cy="182880"/>
           </a:xfrm>
           <a:prstGeom prst="rect">
@@ -11607,7 +11766,7 @@
         </p:nvSpPr>
         <p:spPr>
           <a:xfrm>
-            <a:off x="6373368" y="2194560"/>
+            <a:off x="6373368" y="2891246"/>
             <a:ext cx="1234440" cy="228600"/>
           </a:xfrm>
           <a:prstGeom prst="rect">
@@ -11642,7 +11801,7 @@
         </p:nvSpPr>
         <p:spPr>
           <a:xfrm>
-            <a:off x="5897880" y="2670048"/>
+            <a:off x="5897880" y="3366734"/>
             <a:ext cx="1691640" cy="411480"/>
           </a:xfrm>
           <a:prstGeom prst="rect">
@@ -11677,7 +11836,7 @@
         </p:nvSpPr>
         <p:spPr>
           <a:xfrm>
-            <a:off x="8183879" y="2011680"/>
+            <a:off x="8183879" y="2708366"/>
             <a:ext cx="2057400" cy="1325880"/>
           </a:xfrm>
           <a:prstGeom prst="roundRect">
@@ -11711,6 +11870,7 @@
           <a:lstStyle/>
           <a:p>
             <a:pPr algn="ctr"/>
+            <a:endParaRPr/>
           </a:p>
         </p:txBody>
       </p:sp>
@@ -11722,7 +11882,7 @@
         </p:nvSpPr>
         <p:spPr>
           <a:xfrm>
-            <a:off x="8348471" y="2176272"/>
+            <a:off x="8348471" y="2872958"/>
             <a:ext cx="384048" cy="384048"/>
           </a:xfrm>
           <a:prstGeom prst="roundRect">
@@ -11754,6 +11914,7 @@
           <a:lstStyle/>
           <a:p>
             <a:pPr algn="ctr"/>
+            <a:endParaRPr/>
           </a:p>
         </p:txBody>
       </p:sp>
@@ -11765,7 +11926,7 @@
         </p:nvSpPr>
         <p:spPr>
           <a:xfrm>
-            <a:off x="8449055" y="2258568"/>
+            <a:off x="8449055" y="2955254"/>
             <a:ext cx="182880" cy="182880"/>
           </a:xfrm>
           <a:prstGeom prst="rect">
@@ -11800,7 +11961,7 @@
         </p:nvSpPr>
         <p:spPr>
           <a:xfrm>
-            <a:off x="8842248" y="2194560"/>
+            <a:off x="8842248" y="2891246"/>
             <a:ext cx="1234440" cy="228600"/>
           </a:xfrm>
           <a:prstGeom prst="rect">
@@ -11835,7 +11996,7 @@
         </p:nvSpPr>
         <p:spPr>
           <a:xfrm>
-            <a:off x="8366759" y="2670048"/>
+            <a:off x="8366759" y="3366734"/>
             <a:ext cx="1691640" cy="411480"/>
           </a:xfrm>
           <a:prstGeom prst="rect">
@@ -11870,7 +12031,7 @@
         </p:nvCxnSpPr>
         <p:spPr>
           <a:xfrm>
-            <a:off x="2971800" y="2670048"/>
+            <a:off x="2971800" y="3366734"/>
             <a:ext cx="201168" cy="0"/>
           </a:xfrm>
           <a:prstGeom prst="line">
@@ -11905,7 +12066,7 @@
         </p:nvCxnSpPr>
         <p:spPr>
           <a:xfrm>
-            <a:off x="5440680" y="2670048"/>
+            <a:off x="5440680" y="3366734"/>
             <a:ext cx="201168" cy="0"/>
           </a:xfrm>
           <a:prstGeom prst="line">
@@ -11940,7 +12101,7 @@
         </p:nvCxnSpPr>
         <p:spPr>
           <a:xfrm>
-            <a:off x="7909560" y="2670048"/>
+            <a:off x="7909560" y="3366734"/>
             <a:ext cx="201168" cy="0"/>
           </a:xfrm>
           <a:prstGeom prst="line">
@@ -12011,7 +12172,7 @@
 </file>
 
 <file path=ppt/slides/slide8.xml><?xml version="1.0" encoding="utf-8"?>
-<p:sld xmlns:a="http://schemas.openxmlformats.org/drawingml/2006/main" xmlns:p="http://schemas.openxmlformats.org/presentationml/2006/main" xmlns:r="http://schemas.openxmlformats.org/officeDocument/2006/relationships">
+<p:sld xmlns:a="http://schemas.openxmlformats.org/drawingml/2006/main" xmlns:r="http://schemas.openxmlformats.org/officeDocument/2006/relationships" xmlns:p="http://schemas.openxmlformats.org/presentationml/2006/main">
   <p:cSld>
     <p:bg>
       <p:bgPr>
@@ -12027,7 +12188,14 @@
         <p:cNvGrpSpPr/>
         <p:nvPr/>
       </p:nvGrpSpPr>
-      <p:grpSpPr/>
+      <p:grpSpPr>
+        <a:xfrm>
+          <a:off x="0" y="0"/>
+          <a:ext cx="0" cy="0"/>
+          <a:chOff x="0" y="0"/>
+          <a:chExt cx="0" cy="0"/>
+        </a:xfrm>
+      </p:grpSpPr>
       <p:sp>
         <p:nvSpPr>
           <p:cNvPr id="2" name="Rounded Rectangle 1"/>
@@ -12068,6 +12236,7 @@
           <a:lstStyle/>
           <a:p>
             <a:pPr algn="ctr"/>
+            <a:endParaRPr/>
           </a:p>
         </p:txBody>
       </p:sp>
@@ -12111,6 +12280,7 @@
           <a:lstStyle/>
           <a:p>
             <a:pPr algn="ctr"/>
+            <a:endParaRPr/>
           </a:p>
         </p:txBody>
       </p:sp>
@@ -12154,6 +12324,7 @@
           <a:lstStyle/>
           <a:p>
             <a:pPr algn="ctr"/>
+            <a:endParaRPr/>
           </a:p>
         </p:txBody>
       </p:sp>
@@ -12270,7 +12441,7 @@
         </p:nvSpPr>
         <p:spPr>
           <a:xfrm>
-            <a:off x="685800" y="1920240"/>
+            <a:off x="685800" y="2486298"/>
             <a:ext cx="3337560" cy="1828800"/>
           </a:xfrm>
           <a:prstGeom prst="roundRect">
@@ -12304,6 +12475,7 @@
           <a:lstStyle/>
           <a:p>
             <a:pPr algn="ctr"/>
+            <a:endParaRPr/>
           </a:p>
         </p:txBody>
       </p:sp>
@@ -12315,7 +12487,7 @@
         </p:nvSpPr>
         <p:spPr>
           <a:xfrm>
-            <a:off x="685800" y="1920240"/>
+            <a:off x="685800" y="2486298"/>
             <a:ext cx="73152" cy="1828800"/>
           </a:xfrm>
           <a:prstGeom prst="rect">
@@ -12347,6 +12519,7 @@
           <a:lstStyle/>
           <a:p>
             <a:pPr algn="ctr"/>
+            <a:endParaRPr/>
           </a:p>
         </p:txBody>
       </p:sp>
@@ -12358,7 +12531,7 @@
         </p:nvSpPr>
         <p:spPr>
           <a:xfrm>
-            <a:off x="886968" y="2084832"/>
+            <a:off x="886968" y="2650890"/>
             <a:ext cx="3017520" cy="228600"/>
           </a:xfrm>
           <a:prstGeom prst="rect">
@@ -12393,7 +12566,7 @@
         </p:nvSpPr>
         <p:spPr>
           <a:xfrm>
-            <a:off x="886968" y="2423160"/>
+            <a:off x="886968" y="2989218"/>
             <a:ext cx="3017520" cy="1188720"/>
           </a:xfrm>
           <a:prstGeom prst="rect">
@@ -12428,7 +12601,7 @@
         </p:nvSpPr>
         <p:spPr>
           <a:xfrm>
-            <a:off x="4434840" y="1920240"/>
+            <a:off x="4434840" y="2486298"/>
             <a:ext cx="3337560" cy="1828800"/>
           </a:xfrm>
           <a:prstGeom prst="roundRect">
@@ -12462,6 +12635,7 @@
           <a:lstStyle/>
           <a:p>
             <a:pPr algn="ctr"/>
+            <a:endParaRPr/>
           </a:p>
         </p:txBody>
       </p:sp>
@@ -12473,7 +12647,7 @@
         </p:nvSpPr>
         <p:spPr>
           <a:xfrm>
-            <a:off x="4434840" y="1920240"/>
+            <a:off x="4434840" y="2486298"/>
             <a:ext cx="73152" cy="1828800"/>
           </a:xfrm>
           <a:prstGeom prst="rect">
@@ -12505,6 +12679,7 @@
           <a:lstStyle/>
           <a:p>
             <a:pPr algn="ctr"/>
+            <a:endParaRPr/>
           </a:p>
         </p:txBody>
       </p:sp>
@@ -12516,7 +12691,7 @@
         </p:nvSpPr>
         <p:spPr>
           <a:xfrm>
-            <a:off x="4636007" y="2084832"/>
+            <a:off x="4636007" y="2650890"/>
             <a:ext cx="3017520" cy="228600"/>
           </a:xfrm>
           <a:prstGeom prst="rect">
@@ -12551,7 +12726,7 @@
         </p:nvSpPr>
         <p:spPr>
           <a:xfrm>
-            <a:off x="4636007" y="2423160"/>
+            <a:off x="4636007" y="2989218"/>
             <a:ext cx="3017520" cy="1188720"/>
           </a:xfrm>
           <a:prstGeom prst="rect">
@@ -12586,7 +12761,7 @@
         </p:nvSpPr>
         <p:spPr>
           <a:xfrm>
-            <a:off x="8183879" y="1920240"/>
+            <a:off x="8183879" y="2486298"/>
             <a:ext cx="3337560" cy="1828800"/>
           </a:xfrm>
           <a:prstGeom prst="roundRect">
@@ -12620,6 +12795,7 @@
           <a:lstStyle/>
           <a:p>
             <a:pPr algn="ctr"/>
+            <a:endParaRPr/>
           </a:p>
         </p:txBody>
       </p:sp>
@@ -12631,7 +12807,7 @@
         </p:nvSpPr>
         <p:spPr>
           <a:xfrm>
-            <a:off x="8183879" y="1920240"/>
+            <a:off x="8183879" y="2486298"/>
             <a:ext cx="73152" cy="1828800"/>
           </a:xfrm>
           <a:prstGeom prst="rect">
@@ -12663,6 +12839,7 @@
           <a:lstStyle/>
           <a:p>
             <a:pPr algn="ctr"/>
+            <a:endParaRPr/>
           </a:p>
         </p:txBody>
       </p:sp>
@@ -12674,7 +12851,7 @@
         </p:nvSpPr>
         <p:spPr>
           <a:xfrm>
-            <a:off x="8385048" y="2084832"/>
+            <a:off x="8385048" y="2650890"/>
             <a:ext cx="3017520" cy="228600"/>
           </a:xfrm>
           <a:prstGeom prst="rect">
@@ -12709,7 +12886,7 @@
         </p:nvSpPr>
         <p:spPr>
           <a:xfrm>
-            <a:off x="8385048" y="2423160"/>
+            <a:off x="8385048" y="2989218"/>
             <a:ext cx="3017520" cy="1188720"/>
           </a:xfrm>
           <a:prstGeom prst="rect">
@@ -12780,7 +12957,7 @@
 </file>
 
 <file path=ppt/slides/slide9.xml><?xml version="1.0" encoding="utf-8"?>
-<p:sld xmlns:a="http://schemas.openxmlformats.org/drawingml/2006/main" xmlns:p="http://schemas.openxmlformats.org/presentationml/2006/main" xmlns:r="http://schemas.openxmlformats.org/officeDocument/2006/relationships">
+<p:sld xmlns:a="http://schemas.openxmlformats.org/drawingml/2006/main" xmlns:r="http://schemas.openxmlformats.org/officeDocument/2006/relationships" xmlns:p="http://schemas.openxmlformats.org/presentationml/2006/main">
   <p:cSld>
     <p:bg>
       <p:bgPr>
@@ -12796,7 +12973,14 @@
         <p:cNvGrpSpPr/>
         <p:nvPr/>
       </p:nvGrpSpPr>
-      <p:grpSpPr/>
+      <p:grpSpPr>
+        <a:xfrm>
+          <a:off x="0" y="0"/>
+          <a:ext cx="0" cy="0"/>
+          <a:chOff x="0" y="0"/>
+          <a:chExt cx="0" cy="0"/>
+        </a:xfrm>
+      </p:grpSpPr>
       <p:sp>
         <p:nvSpPr>
           <p:cNvPr id="2" name="Rounded Rectangle 1"/>
@@ -12837,6 +13021,7 @@
           <a:lstStyle/>
           <a:p>
             <a:pPr algn="ctr"/>
+            <a:endParaRPr/>
           </a:p>
         </p:txBody>
       </p:sp>
@@ -12880,6 +13065,7 @@
           <a:lstStyle/>
           <a:p>
             <a:pPr algn="ctr"/>
+            <a:endParaRPr/>
           </a:p>
         </p:txBody>
       </p:sp>
@@ -12923,6 +13109,7 @@
           <a:lstStyle/>
           <a:p>
             <a:pPr algn="ctr"/>
+            <a:endParaRPr/>
           </a:p>
         </p:txBody>
       </p:sp>
@@ -13039,7 +13226,7 @@
         </p:nvSpPr>
         <p:spPr>
           <a:xfrm>
-            <a:off x="822960" y="1965960"/>
+            <a:off x="822960" y="2314304"/>
             <a:ext cx="1828800" cy="594360"/>
           </a:xfrm>
           <a:prstGeom prst="rect">
@@ -13074,7 +13261,7 @@
         </p:nvSpPr>
         <p:spPr>
           <a:xfrm>
-            <a:off x="822960" y="2532888"/>
+            <a:off x="822960" y="2881232"/>
             <a:ext cx="1828800" cy="320040"/>
           </a:xfrm>
           <a:prstGeom prst="rect">
@@ -13109,7 +13296,7 @@
         </p:nvSpPr>
         <p:spPr>
           <a:xfrm>
-            <a:off x="3063240" y="1965960"/>
+            <a:off x="3063240" y="2314304"/>
             <a:ext cx="2011680" cy="594360"/>
           </a:xfrm>
           <a:prstGeom prst="rect">
@@ -13144,7 +13331,7 @@
         </p:nvSpPr>
         <p:spPr>
           <a:xfrm>
-            <a:off x="3063240" y="2532888"/>
+            <a:off x="3063240" y="2881232"/>
             <a:ext cx="2011680" cy="320040"/>
           </a:xfrm>
           <a:prstGeom prst="rect">
@@ -13179,7 +13366,7 @@
         </p:nvSpPr>
         <p:spPr>
           <a:xfrm>
-            <a:off x="5486400" y="1965960"/>
+            <a:off x="5486400" y="2314304"/>
             <a:ext cx="2011680" cy="594360"/>
           </a:xfrm>
           <a:prstGeom prst="rect">
@@ -13214,7 +13401,7 @@
         </p:nvSpPr>
         <p:spPr>
           <a:xfrm>
-            <a:off x="5486400" y="2532888"/>
+            <a:off x="5486400" y="2881232"/>
             <a:ext cx="2011680" cy="320040"/>
           </a:xfrm>
           <a:prstGeom prst="rect">
@@ -13249,7 +13436,7 @@
         </p:nvSpPr>
         <p:spPr>
           <a:xfrm>
-            <a:off x="7726679" y="1965960"/>
+            <a:off x="7726679" y="2314304"/>
             <a:ext cx="2011680" cy="594360"/>
           </a:xfrm>
           <a:prstGeom prst="rect">
@@ -13284,7 +13471,7 @@
         </p:nvSpPr>
         <p:spPr>
           <a:xfrm>
-            <a:off x="7726679" y="2532888"/>
+            <a:off x="7726679" y="2881232"/>
             <a:ext cx="2011680" cy="320040"/>
           </a:xfrm>
           <a:prstGeom prst="rect">
@@ -13757,44 +13944,44 @@
         <a:sysClr val="window" lastClr="FFFFFF"/>
       </a:lt1>
       <a:dk2>
-        <a:srgbClr val="1F497D"/>
+        <a:srgbClr val="0E2841"/>
       </a:dk2>
       <a:lt2>
-        <a:srgbClr val="EEECE1"/>
+        <a:srgbClr val="E8E8E8"/>
       </a:lt2>
       <a:accent1>
-        <a:srgbClr val="4F81BD"/>
+        <a:srgbClr val="156082"/>
       </a:accent1>
       <a:accent2>
-        <a:srgbClr val="C0504D"/>
+        <a:srgbClr val="E97132"/>
       </a:accent2>
       <a:accent3>
-        <a:srgbClr val="9BBB59"/>
+        <a:srgbClr val="196B24"/>
       </a:accent3>
       <a:accent4>
-        <a:srgbClr val="8064A2"/>
+        <a:srgbClr val="0F9ED5"/>
       </a:accent4>
       <a:accent5>
-        <a:srgbClr val="4BACC6"/>
+        <a:srgbClr val="A02B93"/>
       </a:accent5>
       <a:accent6>
-        <a:srgbClr val="F79646"/>
+        <a:srgbClr val="4EA72E"/>
       </a:accent6>
       <a:hlink>
-        <a:srgbClr val="0000FF"/>
+        <a:srgbClr val="467886"/>
       </a:hlink>
       <a:folHlink>
-        <a:srgbClr val="800080"/>
+        <a:srgbClr val="96607D"/>
       </a:folHlink>
     </a:clrScheme>
     <a:fontScheme name="Office">
       <a:majorFont>
-        <a:latin typeface="Calibri"/>
+        <a:latin typeface="Aptos Display" panose="02110004020202020204"/>
         <a:ea typeface=""/>
         <a:cs typeface=""/>
-        <a:font script="Jpan" typeface="ＭＳ Ｐゴシック"/>
+        <a:font script="Jpan" typeface="游ゴシック Light"/>
         <a:font script="Hang" typeface="맑은 고딕"/>
-        <a:font script="Hans" typeface="宋体"/>
+        <a:font script="Hans" typeface="等线 Light"/>
         <a:font script="Hant" typeface="新細明體"/>
         <a:font script="Arab" typeface="Times New Roman"/>
         <a:font script="Hebr" typeface="Times New Roman"/>
@@ -13822,14 +14009,31 @@
         <a:font script="Viet" typeface="Times New Roman"/>
         <a:font script="Uigh" typeface="Microsoft Uighur"/>
         <a:font script="Geor" typeface="Sylfaen"/>
+        <a:font script="Armn" typeface="Arial"/>
+        <a:font script="Bugi" typeface="Leelawadee UI"/>
+        <a:font script="Bopo" typeface="Microsoft JhengHei"/>
+        <a:font script="Java" typeface="Javanese Text"/>
+        <a:font script="Lisu" typeface="Segoe UI"/>
+        <a:font script="Mymr" typeface="Myanmar Text"/>
+        <a:font script="Nkoo" typeface="Ebrima"/>
+        <a:font script="Olck" typeface="Nirmala UI"/>
+        <a:font script="Osma" typeface="Ebrima"/>
+        <a:font script="Phag" typeface="Phagspa"/>
+        <a:font script="Syrn" typeface="Estrangelo Edessa"/>
+        <a:font script="Syrj" typeface="Estrangelo Edessa"/>
+        <a:font script="Syre" typeface="Estrangelo Edessa"/>
+        <a:font script="Sora" typeface="Nirmala UI"/>
+        <a:font script="Tale" typeface="Microsoft Tai Le"/>
+        <a:font script="Talu" typeface="Microsoft New Tai Lue"/>
+        <a:font script="Tfng" typeface="Ebrima"/>
       </a:majorFont>
       <a:minorFont>
-        <a:latin typeface="Calibri"/>
+        <a:latin typeface="Aptos" panose="02110004020202020204"/>
         <a:ea typeface=""/>
         <a:cs typeface=""/>
-        <a:font script="Jpan" typeface="ＭＳ Ｐゴシック"/>
+        <a:font script="Jpan" typeface="游ゴシック"/>
         <a:font script="Hang" typeface="맑은 고딕"/>
-        <a:font script="Hans" typeface="宋体"/>
+        <a:font script="Hans" typeface="等线"/>
         <a:font script="Hant" typeface="新細明體"/>
         <a:font script="Arab" typeface="Arial"/>
         <a:font script="Hebr" typeface="Arial"/>
@@ -13857,6 +14061,23 @@
         <a:font script="Viet" typeface="Arial"/>
         <a:font script="Uigh" typeface="Microsoft Uighur"/>
         <a:font script="Geor" typeface="Sylfaen"/>
+        <a:font script="Armn" typeface="Arial"/>
+        <a:font script="Bugi" typeface="Leelawadee UI"/>
+        <a:font script="Bopo" typeface="Microsoft JhengHei"/>
+        <a:font script="Java" typeface="Javanese Text"/>
+        <a:font script="Lisu" typeface="Segoe UI"/>
+        <a:font script="Mymr" typeface="Myanmar Text"/>
+        <a:font script="Nkoo" typeface="Ebrima"/>
+        <a:font script="Olck" typeface="Nirmala UI"/>
+        <a:font script="Osma" typeface="Ebrima"/>
+        <a:font script="Phag" typeface="Phagspa"/>
+        <a:font script="Syrn" typeface="Estrangelo Edessa"/>
+        <a:font script="Syrj" typeface="Estrangelo Edessa"/>
+        <a:font script="Syre" typeface="Estrangelo Edessa"/>
+        <a:font script="Sora" typeface="Nirmala UI"/>
+        <a:font script="Tale" typeface="Microsoft Tai Le"/>
+        <a:font script="Talu" typeface="Microsoft New Tai Lue"/>
+        <a:font script="Tfng" typeface="Ebrima"/>
       </a:minorFont>
     </a:fontScheme>
     <a:fmtScheme name="Office">
@@ -13868,180 +14089,136 @@
           <a:gsLst>
             <a:gs pos="0">
               <a:schemeClr val="phClr">
-                <a:tint val="50000"/>
-                <a:satMod val="300000"/>
+                <a:lumMod val="110000"/>
+                <a:satMod val="105000"/>
+                <a:tint val="67000"/>
               </a:schemeClr>
             </a:gs>
-            <a:gs pos="35000">
+            <a:gs pos="50000">
               <a:schemeClr val="phClr">
-                <a:tint val="37000"/>
-                <a:satMod val="300000"/>
+                <a:lumMod val="105000"/>
+                <a:satMod val="103000"/>
+                <a:tint val="73000"/>
               </a:schemeClr>
             </a:gs>
             <a:gs pos="100000">
               <a:schemeClr val="phClr">
-                <a:tint val="15000"/>
-                <a:satMod val="350000"/>
+                <a:lumMod val="105000"/>
+                <a:satMod val="109000"/>
+                <a:tint val="81000"/>
               </a:schemeClr>
             </a:gs>
           </a:gsLst>
-          <a:lin ang="16200000" scaled="1"/>
+          <a:lin ang="5400000" scaled="0"/>
         </a:gradFill>
         <a:gradFill rotWithShape="1">
           <a:gsLst>
             <a:gs pos="0">
               <a:schemeClr val="phClr">
-                <a:tint val="100000"/>
+                <a:satMod val="103000"/>
+                <a:lumMod val="102000"/>
+                <a:tint val="94000"/>
+              </a:schemeClr>
+            </a:gs>
+            <a:gs pos="50000">
+              <a:schemeClr val="phClr">
+                <a:satMod val="110000"/>
+                <a:lumMod val="100000"/>
                 <a:shade val="100000"/>
-                <a:satMod val="130000"/>
               </a:schemeClr>
             </a:gs>
             <a:gs pos="100000">
               <a:schemeClr val="phClr">
-                <a:tint val="50000"/>
-                <a:shade val="100000"/>
-                <a:satMod val="350000"/>
+                <a:lumMod val="99000"/>
+                <a:satMod val="120000"/>
+                <a:shade val="78000"/>
               </a:schemeClr>
             </a:gs>
           </a:gsLst>
-          <a:lin ang="16200000" scaled="0"/>
+          <a:lin ang="5400000" scaled="0"/>
         </a:gradFill>
       </a:fillStyleLst>
       <a:lnStyleLst>
-        <a:ln w="9525" cap="flat" cmpd="sng" algn="ctr">
+        <a:ln w="12700" cap="flat" cmpd="sng" algn="ctr">
           <a:solidFill>
-            <a:schemeClr val="phClr">
-              <a:shade val="95000"/>
-              <a:satMod val="105000"/>
-            </a:schemeClr>
+            <a:schemeClr val="phClr"/>
           </a:solidFill>
           <a:prstDash val="solid"/>
+          <a:miter lim="800000"/>
+        </a:ln>
+        <a:ln w="19050" cap="flat" cmpd="sng" algn="ctr">
+          <a:solidFill>
+            <a:schemeClr val="phClr"/>
+          </a:solidFill>
+          <a:prstDash val="solid"/>
+          <a:miter lim="800000"/>
         </a:ln>
         <a:ln w="25400" cap="flat" cmpd="sng" algn="ctr">
           <a:solidFill>
             <a:schemeClr val="phClr"/>
           </a:solidFill>
           <a:prstDash val="solid"/>
-        </a:ln>
-        <a:ln w="38100" cap="flat" cmpd="sng" algn="ctr">
-          <a:solidFill>
-            <a:schemeClr val="phClr"/>
-          </a:solidFill>
-          <a:prstDash val="solid"/>
+          <a:miter lim="800000"/>
         </a:ln>
       </a:lnStyleLst>
       <a:effectStyleLst>
         <a:effectStyle>
+          <a:effectLst/>
+        </a:effectStyle>
+        <a:effectStyle>
+          <a:effectLst/>
+        </a:effectStyle>
+        <a:effectStyle>
           <a:effectLst>
-            <a:outerShdw blurRad="40000" dist="20000" dir="5400000" rotWithShape="0">
+            <a:outerShdw blurRad="57150" dist="19050" dir="5400000" algn="ctr" rotWithShape="0">
               <a:srgbClr val="000000">
-                <a:alpha val="38000"/>
+                <a:alpha val="63000"/>
               </a:srgbClr>
             </a:outerShdw>
           </a:effectLst>
-        </a:effectStyle>
-        <a:effectStyle>
-          <a:effectLst>
-            <a:outerShdw blurRad="40000" dist="23000" dir="5400000" rotWithShape="0">
-              <a:srgbClr val="000000">
-                <a:alpha val="35000"/>
-              </a:srgbClr>
-            </a:outerShdw>
-          </a:effectLst>
-        </a:effectStyle>
-        <a:effectStyle>
-          <a:effectLst>
-            <a:outerShdw blurRad="40000" dist="23000" dir="5400000" rotWithShape="0">
-              <a:srgbClr val="000000">
-                <a:alpha val="35000"/>
-              </a:srgbClr>
-            </a:outerShdw>
-          </a:effectLst>
-          <a:scene3d>
-            <a:camera prst="orthographicFront">
-              <a:rot lat="0" lon="0" rev="0"/>
-            </a:camera>
-            <a:lightRig rig="threePt" dir="t">
-              <a:rot lat="0" lon="0" rev="1200000"/>
-            </a:lightRig>
-          </a:scene3d>
-          <a:sp3d>
-            <a:bevelT w="63500" h="25400"/>
-          </a:sp3d>
         </a:effectStyle>
       </a:effectStyleLst>
       <a:bgFillStyleLst>
         <a:solidFill>
           <a:schemeClr val="phClr"/>
         </a:solidFill>
+        <a:solidFill>
+          <a:schemeClr val="phClr">
+            <a:tint val="95000"/>
+            <a:satMod val="170000"/>
+          </a:schemeClr>
+        </a:solidFill>
         <a:gradFill rotWithShape="1">
           <a:gsLst>
             <a:gs pos="0">
               <a:schemeClr val="phClr">
-                <a:tint val="40000"/>
-                <a:satMod val="350000"/>
+                <a:tint val="93000"/>
+                <a:satMod val="150000"/>
+                <a:shade val="98000"/>
+                <a:lumMod val="102000"/>
               </a:schemeClr>
             </a:gs>
-            <a:gs pos="40000">
+            <a:gs pos="50000">
               <a:schemeClr val="phClr">
-                <a:tint val="45000"/>
-                <a:shade val="99000"/>
-                <a:satMod val="350000"/>
+                <a:tint val="98000"/>
+                <a:satMod val="130000"/>
+                <a:shade val="90000"/>
+                <a:lumMod val="103000"/>
               </a:schemeClr>
             </a:gs>
             <a:gs pos="100000">
               <a:schemeClr val="phClr">
-                <a:shade val="20000"/>
-                <a:satMod val="255000"/>
+                <a:shade val="63000"/>
+                <a:satMod val="120000"/>
               </a:schemeClr>
             </a:gs>
           </a:gsLst>
-          <a:path path="circle">
-            <a:fillToRect l="50000" t="-80000" r="50000" b="180000"/>
-          </a:path>
-        </a:gradFill>
-        <a:gradFill rotWithShape="1">
-          <a:gsLst>
-            <a:gs pos="0">
-              <a:schemeClr val="phClr">
-                <a:tint val="80000"/>
-                <a:satMod val="300000"/>
-              </a:schemeClr>
-            </a:gs>
-            <a:gs pos="100000">
-              <a:schemeClr val="phClr">
-                <a:shade val="30000"/>
-                <a:satMod val="200000"/>
-              </a:schemeClr>
-            </a:gs>
-          </a:gsLst>
-          <a:path path="circle">
-            <a:fillToRect l="50000" t="50000" r="50000" b="50000"/>
-          </a:path>
+          <a:lin ang="5400000" scaled="0"/>
         </a:gradFill>
       </a:bgFillStyleLst>
     </a:fmtScheme>
   </a:themeElements>
   <a:objectDefaults>
-    <a:spDef>
-      <a:spPr/>
-      <a:bodyPr/>
-      <a:lstStyle/>
-      <a:style>
-        <a:lnRef idx="1">
-          <a:schemeClr val="accent1"/>
-        </a:lnRef>
-        <a:fillRef idx="3">
-          <a:schemeClr val="accent1"/>
-        </a:fillRef>
-        <a:effectRef idx="2">
-          <a:schemeClr val="accent1"/>
-        </a:effectRef>
-        <a:fontRef idx="minor">
-          <a:schemeClr val="lt1"/>
-        </a:fontRef>
-      </a:style>
-    </a:spDef>
     <a:lnDef>
       <a:spPr/>
       <a:bodyPr/>
@@ -14063,5 +14240,10 @@
     </a:lnDef>
   </a:objectDefaults>
   <a:extraClrSchemeLst/>
+  <a:extLst>
+    <a:ext uri="{05A4C25C-085E-4340-85A3-A5531E510DB2}">
+      <thm15:themeFamily xmlns:thm15="http://schemas.microsoft.com/office/thememl/2012/main" name="Office Theme" id="{2E142A2C-CD16-42D6-873A-C26D2A0506FA}" vid="{1BDDFF52-6CD6-40A5-AB3C-68EB2F1E4D0A}"/>
+    </a:ext>
+  </a:extLst>
 </a:theme>
 </file>
</xml_diff>

<commit_message>
docs: add speaker notes to presentation and export PDF
</commit_message>
<xml_diff>
--- a/docs/AskTube_AI_Presentation.pptx
+++ b/docs/AskTube_AI_Presentation.pptx
@@ -6363,8 +6363,8 @@
         </p:nvSpPr>
         <p:spPr>
           <a:xfrm>
-            <a:off x="7360920" y="1874519"/>
-            <a:ext cx="3566160" cy="3429000"/>
+            <a:off x="7360920" y="1874518"/>
+            <a:ext cx="3566160" cy="4233673"/>
           </a:xfrm>
           <a:prstGeom prst="roundRect">
             <a:avLst/>
@@ -6479,7 +6479,7 @@
         </p:nvSpPr>
         <p:spPr>
           <a:xfrm>
-            <a:off x="7662672" y="4251960"/>
+            <a:off x="7662672" y="4890938"/>
             <a:ext cx="2834640" cy="822960"/>
           </a:xfrm>
           <a:prstGeom prst="rect">
@@ -6495,7 +6495,7 @@
           <a:p>
             <a:pPr algn="l"/>
             <a:r>
-              <a:rPr sz="1100" b="0">
+              <a:rPr sz="1100" b="0" dirty="0">
                 <a:solidFill>
                   <a:srgbClr val="94A3B8"/>
                 </a:solidFill>
@@ -9228,7 +9228,7 @@
         </p:nvSpPr>
         <p:spPr>
           <a:xfrm>
-            <a:off x="731520" y="4800600"/>
+            <a:off x="731520" y="5065008"/>
             <a:ext cx="10424160" cy="502920"/>
           </a:xfrm>
           <a:prstGeom prst="rect">
@@ -10083,7 +10083,7 @@
         </p:nvSpPr>
         <p:spPr>
           <a:xfrm>
-            <a:off x="914400" y="4892040"/>
+            <a:off x="914400" y="4980176"/>
             <a:ext cx="9875520" cy="411480"/>
           </a:xfrm>
           <a:prstGeom prst="rect">
@@ -10099,13 +10099,31 @@
           <a:p>
             <a:pPr algn="l"/>
             <a:r>
-              <a:rPr sz="1700" b="0">
+              <a:rPr sz="1700" b="0" dirty="0">
                 <a:solidFill>
                   <a:srgbClr val="94A3B8"/>
                 </a:solidFill>
                 <a:latin typeface="Aptos"/>
               </a:rPr>
-              <a:t>Docker Compose runs frontend, backend, ChromaDB, and analytics storage together for local development and deployment testing.</a:t>
+              <a:t>Docker Compose runs frontend, backend, </a:t>
+            </a:r>
+            <a:r>
+              <a:rPr sz="1700" b="0" dirty="0" err="1">
+                <a:solidFill>
+                  <a:srgbClr val="94A3B8"/>
+                </a:solidFill>
+                <a:latin typeface="Aptos"/>
+              </a:rPr>
+              <a:t>ChromaDB</a:t>
+            </a:r>
+            <a:r>
+              <a:rPr sz="1700" b="0" dirty="0">
+                <a:solidFill>
+                  <a:srgbClr val="94A3B8"/>
+                </a:solidFill>
+                <a:latin typeface="Aptos"/>
+              </a:rPr>
+              <a:t>, and analytics storage together for local development and deployment testing.</a:t>
             </a:r>
           </a:p>
         </p:txBody>
@@ -10726,7 +10744,7 @@
         </p:nvSpPr>
         <p:spPr>
           <a:xfrm>
-            <a:off x="7772400" y="4663440"/>
+            <a:off x="7772400" y="4526280"/>
             <a:ext cx="2743200" cy="329184"/>
           </a:xfrm>
           <a:prstGeom prst="rect">
@@ -10742,7 +10760,7 @@
           <a:p>
             <a:pPr algn="l"/>
             <a:r>
-              <a:rPr sz="1100" b="0">
+              <a:rPr sz="1100" b="0" dirty="0">
                 <a:solidFill>
                   <a:srgbClr val="94A3B8"/>
                 </a:solidFill>
@@ -13153,7 +13171,7 @@
         </p:nvSpPr>
         <p:spPr>
           <a:xfrm>
-            <a:off x="868680" y="4800600"/>
+            <a:off x="868680" y="4943821"/>
             <a:ext cx="9875520" cy="457200"/>
           </a:xfrm>
           <a:prstGeom prst="rect">
@@ -13169,7 +13187,7 @@
           <a:p>
             <a:pPr algn="l"/>
             <a:r>
-              <a:rPr sz="1800" b="0">
+              <a:rPr sz="1800" b="0" dirty="0">
                 <a:solidFill>
                   <a:srgbClr val="94A3B8"/>
                 </a:solidFill>
@@ -13938,7 +13956,7 @@
         </p:nvSpPr>
         <p:spPr>
           <a:xfrm>
-            <a:off x="868680" y="4800600"/>
+            <a:off x="868680" y="4943821"/>
             <a:ext cx="9875520" cy="457200"/>
           </a:xfrm>
           <a:prstGeom prst="rect">
@@ -14243,7 +14261,7 @@
         </p:nvSpPr>
         <p:spPr>
           <a:xfrm>
-            <a:off x="658368" y="1996808"/>
+            <a:off x="658368" y="2371386"/>
             <a:ext cx="9692640" cy="329184"/>
           </a:xfrm>
           <a:prstGeom prst="rect">
@@ -14278,7 +14296,7 @@
         </p:nvSpPr>
         <p:spPr>
           <a:xfrm>
-            <a:off x="685800" y="2545448"/>
+            <a:off x="685800" y="2920026"/>
             <a:ext cx="3246120" cy="1691640"/>
           </a:xfrm>
           <a:prstGeom prst="roundRect">
@@ -14324,7 +14342,7 @@
         </p:nvSpPr>
         <p:spPr>
           <a:xfrm>
-            <a:off x="685800" y="2545448"/>
+            <a:off x="685800" y="2920026"/>
             <a:ext cx="73152" cy="1691640"/>
           </a:xfrm>
           <a:prstGeom prst="rect">
@@ -14368,7 +14386,7 @@
         </p:nvSpPr>
         <p:spPr>
           <a:xfrm>
-            <a:off x="886968" y="2710040"/>
+            <a:off x="886968" y="3084618"/>
             <a:ext cx="2926079" cy="228600"/>
           </a:xfrm>
           <a:prstGeom prst="rect">
@@ -14403,7 +14421,7 @@
         </p:nvSpPr>
         <p:spPr>
           <a:xfrm>
-            <a:off x="886968" y="3048368"/>
+            <a:off x="886968" y="3422946"/>
             <a:ext cx="2926079" cy="1051560"/>
           </a:xfrm>
           <a:prstGeom prst="rect">
@@ -14438,7 +14456,7 @@
         </p:nvSpPr>
         <p:spPr>
           <a:xfrm>
-            <a:off x="4160520" y="2545448"/>
+            <a:off x="4160520" y="2920026"/>
             <a:ext cx="3246120" cy="1691640"/>
           </a:xfrm>
           <a:prstGeom prst="roundRect">
@@ -14484,7 +14502,7 @@
         </p:nvSpPr>
         <p:spPr>
           <a:xfrm>
-            <a:off x="4160520" y="2545448"/>
+            <a:off x="4160520" y="2920026"/>
             <a:ext cx="73152" cy="1691640"/>
           </a:xfrm>
           <a:prstGeom prst="rect">
@@ -14528,7 +14546,7 @@
         </p:nvSpPr>
         <p:spPr>
           <a:xfrm>
-            <a:off x="4361688" y="2710040"/>
+            <a:off x="4361688" y="3084618"/>
             <a:ext cx="2926079" cy="228600"/>
           </a:xfrm>
           <a:prstGeom prst="rect">
@@ -14563,7 +14581,7 @@
         </p:nvSpPr>
         <p:spPr>
           <a:xfrm>
-            <a:off x="4361688" y="3048368"/>
+            <a:off x="4361688" y="3422946"/>
             <a:ext cx="2926079" cy="1051560"/>
           </a:xfrm>
           <a:prstGeom prst="rect">
@@ -14598,7 +14616,7 @@
         </p:nvSpPr>
         <p:spPr>
           <a:xfrm>
-            <a:off x="7635240" y="2545448"/>
+            <a:off x="7635240" y="2920026"/>
             <a:ext cx="3246120" cy="1691640"/>
           </a:xfrm>
           <a:prstGeom prst="roundRect">
@@ -14644,7 +14662,7 @@
         </p:nvSpPr>
         <p:spPr>
           <a:xfrm>
-            <a:off x="7635240" y="2545448"/>
+            <a:off x="7635240" y="2920026"/>
             <a:ext cx="73152" cy="1691640"/>
           </a:xfrm>
           <a:prstGeom prst="rect">
@@ -14688,7 +14706,7 @@
         </p:nvSpPr>
         <p:spPr>
           <a:xfrm>
-            <a:off x="7836408" y="2710040"/>
+            <a:off x="7836408" y="3084618"/>
             <a:ext cx="2926079" cy="228600"/>
           </a:xfrm>
           <a:prstGeom prst="rect">
@@ -14723,7 +14741,7 @@
         </p:nvSpPr>
         <p:spPr>
           <a:xfrm>
-            <a:off x="7836408" y="3048368"/>
+            <a:off x="7836408" y="3422946"/>
             <a:ext cx="2926079" cy="1051560"/>
           </a:xfrm>
           <a:prstGeom prst="rect">

</xml_diff>

<commit_message>
docs: add demo video link to README, demo script, and presentation slide 11
</commit_message>
<xml_diff>
--- a/docs/AskTube_AI_Presentation.pptx
+++ b/docs/AskTube_AI_Presentation.pptx
@@ -6171,6 +6171,25 @@
                 <a:latin typeface="Aptos"/>
               </a:rPr>
               <a:t>Show EC2 health endpoint and explain the YouTube cloud-IP transcript limitation.</a:t>
+            </a:r>
+          </a:p>
+          <a:p>
+            <a:pPr>
+              <a:lnSpc>
+                <a:spcPct val="105000"/>
+              </a:lnSpc>
+              <a:spcAft>
+                <a:spcPts val="800"/>
+              </a:spcAft>
+            </a:pPr>
+            <a:r>
+              <a:rPr sz="1700" b="1">
+                <a:solidFill>
+                  <a:srgbClr val="22D3EE"/>
+                </a:solidFill>
+                <a:latin typeface="Aptos"/>
+              </a:rPr>
+              <a:t>- Demo video: https://youtu.be/hSB3AvbUahY</a:t>
             </a:r>
           </a:p>
         </p:txBody>

</xml_diff>

<commit_message>
docs: add requirements checklist and video link to presentation slide 11
</commit_message>
<xml_diff>
--- a/docs/AskTube_AI_Presentation.pptx
+++ b/docs/AskTube_AI_Presentation.pptx
@@ -481,46 +481,86 @@
           <a:lstStyle/>
           <a:p>
             <a:r>
+              <a:rPr dirty="0"/>
               <a:t>~90 seconds</a:t>
             </a:r>
           </a:p>
           <a:p>
-            <a:endParaRPr/>
-          </a:p>
-          <a:p>
-            <a:r>
-              <a:t>Let me show you the live app. Open https://asktube-ai.duckdns.org/ — this is running on AWS EC2 behind Nginx with a DuckDNS domain and Let's Encrypt HTTPS, so Chrome can allow microphone access. The backend also includes proxy support because YouTube sometimes blocks transcript requests from cloud IP ranges.</a:t>
-            </a:r>
-          </a:p>
-          <a:p>
-            <a:endParaRPr/>
-          </a:p>
-          <a:p>
-            <a:r>
-              <a:t>[Search] I'll use voice or type 'python tutorial for beginners', then apply a duration filter. I want to show that the product starts with a normal user search, not a technical backend screen.</a:t>
-            </a:r>
-          </a:p>
-          <a:p>
-            <a:endParaRPr/>
-          </a:p>
-          <a:p>
-            <a:r>
+            <a:endParaRPr dirty="0"/>
+          </a:p>
+          <a:p>
+            <a:r>
+              <a:rPr dirty="0"/>
+              <a:t>Let me show you the live app. Open https://asktube-ai.duckdns.org/ — this is running on AWS EC2 behind Nginx with a </a:t>
+            </a:r>
+            <a:r>
+              <a:rPr dirty="0" err="1"/>
+              <a:t>DuckDNS</a:t>
+            </a:r>
+            <a:r>
+              <a:rPr dirty="0"/>
+              <a:t> domain and Let's Encrypt HTTPS, so Chrome can allow microphone access. The backend also includes proxy support because YouTube sometimes blocks transcript requests from cloud IP ranges.</a:t>
+            </a:r>
+          </a:p>
+          <a:p>
+            <a:endParaRPr dirty="0"/>
+          </a:p>
+          <a:p>
+            <a:r>
+              <a:rPr dirty="0"/>
+              <a:t>[Search] I'll use voice or type 'python tutorial for beginners', then apply a duration filter</a:t>
+            </a:r>
+            <a:r>
+              <a:rPr lang="de-DE" dirty="0"/>
+              <a:t> &lt;10 </a:t>
+            </a:r>
+            <a:r>
+              <a:rPr lang="de-DE" dirty="0" err="1"/>
+              <a:t>mins</a:t>
+            </a:r>
+            <a:r>
+              <a:rPr dirty="0"/>
+              <a:t>. I want to show that the product starts with a normal user search, not a technical backend screen.</a:t>
+            </a:r>
+          </a:p>
+          <a:p>
+            <a:endParaRPr dirty="0"/>
+          </a:p>
+          <a:p>
+            <a:r>
+              <a:rPr dirty="0"/>
               <a:t>[Prepare] I pick one video and click Prepare. The progress screen shows real backend stages: metadata, transcript, chunking, embeddings, and vector storage.</a:t>
             </a:r>
           </a:p>
           <a:p>
-            <a:endParaRPr/>
-          </a:p>
-          <a:p>
-            <a:r>
-              <a:t>[Ask] Now I ask: 'What is Python used for?' The answer appears with timestamp chips. This is the most important part of the demo: every claim links back to the source video.</a:t>
-            </a:r>
-          </a:p>
-          <a:p>
-            <a:endParaRPr/>
-          </a:p>
-          <a:p>
-            <a:r>
+            <a:endParaRPr dirty="0"/>
+          </a:p>
+          <a:p>
+            <a:r>
+              <a:rPr dirty="0"/>
+              <a:t>[Ask] Now I ask: 'What is </a:t>
+            </a:r>
+            <a:r>
+              <a:rPr lang="en-US" b="0" i="0" dirty="0">
+                <a:solidFill>
+                  <a:srgbClr val="F1F5F9"/>
+                </a:solidFill>
+                <a:effectLst/>
+                <a:latin typeface="__Inter_f367f3"/>
+              </a:rPr>
+              <a:t>PyCharm</a:t>
+            </a:r>
+            <a:r>
+              <a:rPr dirty="0"/>
+              <a:t> used for?' The answer appears with timestamp chips. This is the most important part of the demo: every claim links back to the source video.</a:t>
+            </a:r>
+          </a:p>
+          <a:p>
+            <a:endParaRPr dirty="0"/>
+          </a:p>
+          <a:p>
+            <a:r>
+              <a:rPr dirty="0"/>
               <a:t>[Verify] I click a timestamp to show that the citation jumps to the exact moment. If there is time, I ask a follow-up to show memory, or an unrelated question to show refusal behavior.</a:t>
             </a:r>
           </a:p>
@@ -871,23 +911,87 @@
           <a:lstStyle/>
           <a:p>
             <a:r>
+              <a:rPr dirty="0"/>
               <a:t>~40 seconds</a:t>
             </a:r>
           </a:p>
           <a:p>
-            <a:endParaRPr/>
-          </a:p>
-          <a:p>
-            <a:r>
-              <a:t>Three layers. Frontend: Next.js 14, TypeScript, TailwindCSS, Framer Motion, and Three.js for the 3D robot. Backend: FastAPI with async routes for search, transcripts, chunking, vector storage, chat, agent, speech, and analytics. AI layer: LangChain tools, OpenAI GPT-4o-mini for chat and text-embedding-3-small for vectors, ChromaDB as the vector store, and Whisper as a fallback for videos without captions.</a:t>
-            </a:r>
-          </a:p>
-          <a:p>
-            <a:endParaRPr/>
-          </a:p>
-          <a:p>
-            <a:r>
-              <a:t>There is also an observability layer: analytics tables, a dashboard, Prometheus metrics, and optional LangSmith tracing.</a:t>
+            <a:endParaRPr dirty="0"/>
+          </a:p>
+          <a:p>
+            <a:r>
+              <a:rPr dirty="0"/>
+              <a:t>Three layers. </a:t>
+            </a:r>
+            <a:endParaRPr lang="de-DE" dirty="0"/>
+          </a:p>
+          <a:p>
+            <a:r>
+              <a:rPr dirty="0"/>
+              <a:t>Frontend: Next.js 14, TypeScript, </a:t>
+            </a:r>
+            <a:r>
+              <a:rPr dirty="0" err="1"/>
+              <a:t>TailwindCSS</a:t>
+            </a:r>
+            <a:r>
+              <a:rPr dirty="0"/>
+              <a:t>, Framer Motion, and Three.js for the 3D robot. </a:t>
+            </a:r>
+            <a:endParaRPr lang="de-DE" dirty="0"/>
+          </a:p>
+          <a:p>
+            <a:r>
+              <a:rPr dirty="0"/>
+              <a:t>Backend: </a:t>
+            </a:r>
+            <a:r>
+              <a:rPr dirty="0" err="1"/>
+              <a:t>FastAPI</a:t>
+            </a:r>
+            <a:r>
+              <a:rPr dirty="0"/>
+              <a:t> with async routes for search, transcripts, chunking, vector storage, chat, agent, speech, and analytics. </a:t>
+            </a:r>
+            <a:endParaRPr lang="de-DE" dirty="0"/>
+          </a:p>
+          <a:p>
+            <a:r>
+              <a:rPr dirty="0"/>
+              <a:t>AI layer: </a:t>
+            </a:r>
+            <a:r>
+              <a:rPr dirty="0" err="1"/>
+              <a:t>LangChain</a:t>
+            </a:r>
+            <a:r>
+              <a:rPr dirty="0"/>
+              <a:t> tools, OpenAI GPT-4o-mini for chat and text-embedding-3-small for vectors, </a:t>
+            </a:r>
+            <a:r>
+              <a:rPr dirty="0" err="1"/>
+              <a:t>ChromaDB</a:t>
+            </a:r>
+            <a:r>
+              <a:rPr dirty="0"/>
+              <a:t> as the vector store, and Whisper as a fallback for videos without captions.</a:t>
+            </a:r>
+          </a:p>
+          <a:p>
+            <a:endParaRPr dirty="0"/>
+          </a:p>
+          <a:p>
+            <a:r>
+              <a:rPr dirty="0"/>
+              <a:t>There is also an observability layer: analytics tables, a dashboard, Prometheus metrics, and optional </a:t>
+            </a:r>
+            <a:r>
+              <a:rPr dirty="0" err="1"/>
+              <a:t>LangSmith</a:t>
+            </a:r>
+            <a:r>
+              <a:rPr dirty="0"/>
+              <a:t> tracing.</a:t>
             </a:r>
           </a:p>
         </p:txBody>
@@ -1043,31 +1147,75 @@
           <a:lstStyle/>
           <a:p>
             <a:r>
+              <a:rPr dirty="0"/>
               <a:t>~50 seconds</a:t>
             </a:r>
           </a:p>
           <a:p>
-            <a:endParaRPr/>
-          </a:p>
-          <a:p>
-            <a:r>
-              <a:t>The chat is not just a single prompt — it uses a real tool-calling agent. I built seven LangChain StructuredTools: search YouTube, extract transcript, chunk, store vectors, full ingest, retrieve context, and answer question.</a:t>
-            </a:r>
-          </a:p>
-          <a:p>
-            <a:endParaRPr/>
-          </a:p>
-          <a:p>
-            <a:r>
-              <a:t>The agent decides which tools to call based on the question. For a chat question it calls retrieve_context then answer_question. For a new video request it chains through the full ingestion flow automatically.</a:t>
-            </a:r>
-          </a:p>
-          <a:p>
-            <a:endParaRPr/>
-          </a:p>
-          <a:p>
-            <a:r>
-              <a:t>Two guardrails are enforced: answers must come from the transcript only, and off-topic questions must be refused. ConversationMemoryService keeps session history so follow-up questions stay coherent.</a:t>
+            <a:endParaRPr dirty="0"/>
+          </a:p>
+          <a:p>
+            <a:r>
+              <a:rPr dirty="0"/>
+              <a:t>The chat is not just a single prompt — it uses a real tool-calling agent. I built seven </a:t>
+            </a:r>
+            <a:r>
+              <a:rPr dirty="0" err="1"/>
+              <a:t>LangChain</a:t>
+            </a:r>
+            <a:r>
+              <a:rPr dirty="0"/>
+              <a:t> </a:t>
+            </a:r>
+            <a:r>
+              <a:rPr dirty="0" err="1"/>
+              <a:t>StructuredTools</a:t>
+            </a:r>
+            <a:r>
+              <a:rPr dirty="0"/>
+              <a:t>: search YouTube, extract transcript, chunk, store vectors, full ingest, retrieve context, and answer question.</a:t>
+            </a:r>
+          </a:p>
+          <a:p>
+            <a:endParaRPr dirty="0"/>
+          </a:p>
+          <a:p>
+            <a:r>
+              <a:rPr dirty="0"/>
+              <a:t>The agent decides which tools to call based on the question. For a chat question it calls </a:t>
+            </a:r>
+            <a:r>
+              <a:rPr dirty="0" err="1"/>
+              <a:t>retrieve_context</a:t>
+            </a:r>
+            <a:r>
+              <a:rPr dirty="0"/>
+              <a:t> then </a:t>
+            </a:r>
+            <a:r>
+              <a:rPr dirty="0" err="1"/>
+              <a:t>answer_question</a:t>
+            </a:r>
+            <a:r>
+              <a:rPr dirty="0"/>
+              <a:t>. For a new video request it chains through the full ingestion flow automatically.</a:t>
+            </a:r>
+          </a:p>
+          <a:p>
+            <a:endParaRPr dirty="0"/>
+          </a:p>
+          <a:p>
+            <a:r>
+              <a:rPr dirty="0"/>
+              <a:t>Two guardrails are enforced: answers must come from the transcript only, and off-topic questions must be refused. </a:t>
+            </a:r>
+            <a:r>
+              <a:rPr dirty="0" err="1"/>
+              <a:t>ConversationMemoryService</a:t>
+            </a:r>
+            <a:r>
+              <a:rPr dirty="0"/>
+              <a:t> keeps session history so follow-up questions stay coherent.</a:t>
             </a:r>
           </a:p>
         </p:txBody>
@@ -1137,22 +1285,61 @@
           <a:lstStyle/>
           <a:p>
             <a:r>
+              <a:rPr dirty="0"/>
               <a:t>~45 seconds</a:t>
             </a:r>
           </a:p>
           <a:p>
-            <a:endParaRPr/>
-          </a:p>
-          <a:p>
-            <a:r>
-              <a:t>The RAG pipeline is four steps. Retrieve: ChromaDB finds the most relevant transcript chunks by semantic similarity. Inject: the prompt receives those chunks, the conversation memory, and strict grounding rules. Generate: GPT-4o-mini writes an answer using only what is in the context. Cite: the response includes timestamp chips that link to the exact moment in the video.</a:t>
-            </a:r>
-          </a:p>
-          <a:p>
-            <a:endParaRPr/>
-          </a:p>
-          <a:p>
-            <a:r>
+            <a:endParaRPr dirty="0"/>
+          </a:p>
+          <a:p>
+            <a:r>
+              <a:rPr dirty="0"/>
+              <a:t>The RAG pipeline is four steps. </a:t>
+            </a:r>
+            <a:endParaRPr lang="de-DE" dirty="0"/>
+          </a:p>
+          <a:p>
+            <a:r>
+              <a:rPr dirty="0"/>
+              <a:t>Retrieve: </a:t>
+            </a:r>
+            <a:r>
+              <a:rPr dirty="0" err="1"/>
+              <a:t>ChromaDB</a:t>
+            </a:r>
+            <a:r>
+              <a:rPr dirty="0"/>
+              <a:t> finds the most relevant transcript chunks by semantic similarity. </a:t>
+            </a:r>
+            <a:endParaRPr lang="de-DE" dirty="0"/>
+          </a:p>
+          <a:p>
+            <a:r>
+              <a:rPr dirty="0"/>
+              <a:t>Inject: the prompt receives those chunks, the conversation memory, and strict grounding rules. </a:t>
+            </a:r>
+            <a:endParaRPr lang="de-DE" dirty="0"/>
+          </a:p>
+          <a:p>
+            <a:r>
+              <a:rPr dirty="0"/>
+              <a:t>Generate: GPT-4o-mini writes an answer using only what is in the context. </a:t>
+            </a:r>
+            <a:endParaRPr lang="de-DE" dirty="0"/>
+          </a:p>
+          <a:p>
+            <a:r>
+              <a:rPr dirty="0"/>
+              <a:t>Cite: the response includes timestamp chips that link to the exact moment in the video.</a:t>
+            </a:r>
+          </a:p>
+          <a:p>
+            <a:endParaRPr dirty="0"/>
+          </a:p>
+          <a:p>
+            <a:r>
+              <a:rPr dirty="0"/>
               <a:t>If the answer is not in the transcript, the system says it cannot answer from this video. That refusal is the core anti-hallucination mechanism.</a:t>
             </a:r>
           </a:p>
@@ -4578,7 +4765,7 @@
           <a:p>
             <a:pPr algn="l"/>
             <a:r>
-              <a:rPr sz="1200" b="1">
+              <a:rPr sz="1200" b="1" dirty="0">
                 <a:solidFill>
                   <a:srgbClr val="22D3EE"/>
                 </a:solidFill>

</xml_diff>